<commit_message>
Improve README example reconstruction
</commit_message>
<xml_diff>
--- a/docs/examples/one-pun-editable.pptx
+++ b/docs/examples/one-pun-editable.pptx
@@ -3309,1729 +3309,27 @@
           </a:p>
         </p:txBody>
       </p:sp>
-      <p:pic>
-        <p:nvPicPr>
-          <p:cNvPr id="7" name="Picture 6" descr="image.png"/>
-          <p:cNvPicPr>
-            <a:picLocks noChangeAspect="1"/>
-          </p:cNvPicPr>
-          <p:nvPr/>
-        </p:nvPicPr>
-        <p:blipFill>
-          <a:blip r:embed="rId2"/>
-          <a:stretch>
-            <a:fillRect/>
-          </a:stretch>
-        </p:blipFill>
-        <p:spPr>
-          <a:xfrm>
-            <a:off x="8202229" y="0"/>
-            <a:ext cx="3935515" cy="6858000"/>
-          </a:xfrm>
-          <a:prstGeom prst="rect">
-            <a:avLst/>
-          </a:prstGeom>
-        </p:spPr>
-      </p:pic>
-      <p:pic>
-        <p:nvPicPr>
-          <p:cNvPr id="8" name="Picture 7" descr="residual-114.png"/>
-          <p:cNvPicPr>
-            <a:picLocks noChangeAspect="1"/>
-          </p:cNvPicPr>
-          <p:nvPr/>
-        </p:nvPicPr>
-        <p:blipFill>
-          <a:blip r:embed="rId3"/>
-          <a:stretch>
-            <a:fillRect/>
-          </a:stretch>
-        </p:blipFill>
-        <p:spPr>
-          <a:xfrm>
-            <a:off x="323910" y="1676238"/>
-            <a:ext cx="685071" cy="736087"/>
-          </a:xfrm>
-          <a:prstGeom prst="rect">
-            <a:avLst/>
-          </a:prstGeom>
-        </p:spPr>
-      </p:pic>
-      <p:pic>
-        <p:nvPicPr>
-          <p:cNvPr id="9" name="Picture 8" descr="image.png"/>
-          <p:cNvPicPr>
-            <a:picLocks noChangeAspect="1"/>
-          </p:cNvPicPr>
-          <p:nvPr/>
-        </p:nvPicPr>
-        <p:blipFill>
-          <a:blip r:embed="rId4"/>
-          <a:stretch>
-            <a:fillRect/>
-          </a:stretch>
-        </p:blipFill>
-        <p:spPr>
-          <a:xfrm>
-            <a:off x="4274001" y="1763693"/>
-            <a:ext cx="4270763" cy="2186397"/>
-          </a:xfrm>
-          <a:prstGeom prst="rect">
-            <a:avLst/>
-          </a:prstGeom>
-        </p:spPr>
-      </p:pic>
-      <p:pic>
-        <p:nvPicPr>
-          <p:cNvPr id="10" name="Picture 9" descr="residual-94.png"/>
-          <p:cNvPicPr>
-            <a:picLocks noChangeAspect="1"/>
-          </p:cNvPicPr>
-          <p:nvPr/>
-        </p:nvPicPr>
-        <p:blipFill>
-          <a:blip r:embed="rId5"/>
-          <a:stretch>
-            <a:fillRect/>
-          </a:stretch>
-        </p:blipFill>
-        <p:spPr>
-          <a:xfrm>
-            <a:off x="323910" y="2550797"/>
-            <a:ext cx="699647" cy="670495"/>
-          </a:xfrm>
-          <a:prstGeom prst="rect">
-            <a:avLst/>
-          </a:prstGeom>
-        </p:spPr>
-      </p:pic>
-      <p:pic>
-        <p:nvPicPr>
-          <p:cNvPr id="11" name="Picture 10" descr="residual-81.png"/>
-          <p:cNvPicPr>
-            <a:picLocks noChangeAspect="1"/>
-          </p:cNvPicPr>
-          <p:nvPr/>
-        </p:nvPicPr>
-        <p:blipFill>
-          <a:blip r:embed="rId6"/>
-          <a:stretch>
-            <a:fillRect/>
-          </a:stretch>
-        </p:blipFill>
-        <p:spPr>
-          <a:xfrm>
-            <a:off x="323910" y="3330612"/>
-            <a:ext cx="699647" cy="714223"/>
-          </a:xfrm>
-          <a:prstGeom prst="rect">
-            <a:avLst/>
-          </a:prstGeom>
-        </p:spPr>
-      </p:pic>
-      <p:pic>
-        <p:nvPicPr>
-          <p:cNvPr id="12" name="Picture 11" descr="image.png"/>
-          <p:cNvPicPr>
-            <a:picLocks noChangeAspect="1"/>
-          </p:cNvPicPr>
-          <p:nvPr/>
-        </p:nvPicPr>
-        <p:blipFill>
-          <a:blip r:embed="rId7"/>
-          <a:stretch>
-            <a:fillRect/>
-          </a:stretch>
-        </p:blipFill>
-        <p:spPr>
-          <a:xfrm>
-            <a:off x="4237562" y="4117715"/>
-            <a:ext cx="3920939" cy="1719965"/>
-          </a:xfrm>
-          <a:prstGeom prst="rect">
-            <a:avLst/>
-          </a:prstGeom>
-        </p:spPr>
-      </p:pic>
-      <p:pic>
-        <p:nvPicPr>
-          <p:cNvPr id="13" name="Picture 12" descr="residual-48.png"/>
-          <p:cNvPicPr>
-            <a:picLocks noChangeAspect="1"/>
-          </p:cNvPicPr>
-          <p:nvPr/>
-        </p:nvPicPr>
-        <p:blipFill>
-          <a:blip r:embed="rId8"/>
-          <a:stretch>
-            <a:fillRect/>
-          </a:stretch>
-        </p:blipFill>
-        <p:spPr>
-          <a:xfrm>
-            <a:off x="323910" y="4205171"/>
-            <a:ext cx="685071" cy="663207"/>
-          </a:xfrm>
-          <a:prstGeom prst="rect">
-            <a:avLst/>
-          </a:prstGeom>
-        </p:spPr>
-      </p:pic>
-      <p:pic>
-        <p:nvPicPr>
-          <p:cNvPr id="14" name="Picture 13" descr="residual-28.png"/>
-          <p:cNvPicPr>
-            <a:picLocks noChangeAspect="1"/>
-          </p:cNvPicPr>
-          <p:nvPr/>
-        </p:nvPicPr>
-        <p:blipFill>
-          <a:blip r:embed="rId9"/>
-          <a:stretch>
-            <a:fillRect/>
-          </a:stretch>
-        </p:blipFill>
-        <p:spPr>
-          <a:xfrm>
-            <a:off x="323910" y="4977698"/>
-            <a:ext cx="692359" cy="728799"/>
-          </a:xfrm>
-          <a:prstGeom prst="rect">
-            <a:avLst/>
-          </a:prstGeom>
-        </p:spPr>
-      </p:pic>
-      <p:sp>
-        <p:nvSpPr>
-          <p:cNvPr id="15" name="TextBox 14"/>
-          <p:cNvSpPr txBox="1"/>
-          <p:nvPr/>
-        </p:nvSpPr>
-        <p:spPr>
-          <a:xfrm>
-            <a:off x="148998" y="7287"/>
-            <a:ext cx="1909453" cy="983878"/>
-          </a:xfrm>
-          <a:prstGeom prst="rect">
-            <a:avLst/>
-          </a:prstGeom>
-          <a:noFill/>
-        </p:spPr>
-        <p:txBody>
-          <a:bodyPr wrap="none" lIns="0" rIns="0" tIns="0" bIns="0" anchor="ctr">
-            <a:spAutoFit/>
-          </a:bodyPr>
-          <a:lstStyle/>
-          <a:p>
-            <a:pPr>
-              <a:defRPr sz="2000">
-                <a:solidFill>
-                  <a:srgbClr val="FFFFFF"/>
-                </a:solidFill>
-                <a:latin typeface="Malgun Gothic"/>
-              </a:defRPr>
-            </a:pPr>
-            <a:r>
-              <a:t>Why Is</a:t>
-            </a:r>
-          </a:p>
-        </p:txBody>
-      </p:sp>
-      <p:sp>
-        <p:nvSpPr>
-          <p:cNvPr id="16" name="TextBox 15"/>
-          <p:cNvSpPr txBox="1"/>
-          <p:nvPr/>
-        </p:nvSpPr>
-        <p:spPr>
-          <a:xfrm>
-            <a:off x="4514505" y="36439"/>
-            <a:ext cx="1246246" cy="859982"/>
-          </a:xfrm>
-          <a:prstGeom prst="rect">
-            <a:avLst/>
-          </a:prstGeom>
-          <a:noFill/>
-        </p:spPr>
-        <p:txBody>
-          <a:bodyPr wrap="none" lIns="0" rIns="0" tIns="0" bIns="0" anchor="ctr">
-            <a:spAutoFit/>
-          </a:bodyPr>
-          <a:lstStyle/>
-          <a:p>
-            <a:pPr>
-              <a:defRPr sz="2000">
-                <a:solidFill>
-                  <a:srgbClr val="FFFFFF"/>
-                </a:solidFill>
-                <a:latin typeface="Malgun Gothic"/>
-              </a:defRPr>
-            </a:pPr>
-            <a:r>
-              <a:t>Man</a:t>
-            </a:r>
-          </a:p>
-        </p:txBody>
-      </p:sp>
-      <p:sp>
-        <p:nvSpPr>
-          <p:cNvPr id="17" name="TextBox 16"/>
-          <p:cNvSpPr txBox="1"/>
-          <p:nvPr/>
-        </p:nvSpPr>
-        <p:spPr>
-          <a:xfrm>
-            <a:off x="6351079" y="36439"/>
-            <a:ext cx="2077077" cy="925574"/>
-          </a:xfrm>
-          <a:prstGeom prst="rect">
-            <a:avLst/>
-          </a:prstGeom>
-          <a:noFill/>
-        </p:spPr>
-        <p:txBody>
-          <a:bodyPr wrap="none" lIns="0" rIns="0" tIns="0" bIns="0" anchor="ctr">
-            <a:spAutoFit/>
-          </a:bodyPr>
-          <a:lstStyle/>
-          <a:p>
-            <a:pPr>
-              <a:defRPr sz="2000">
-                <a:solidFill>
-                  <a:srgbClr val="FFFFFF"/>
-                </a:solidFill>
-                <a:latin typeface="Malgun Gothic"/>
-              </a:defRPr>
-            </a:pPr>
-            <a:r>
-              <a:t>Strong?</a:t>
-            </a:r>
-          </a:p>
-        </p:txBody>
-      </p:sp>
-      <p:sp>
-        <p:nvSpPr>
-          <p:cNvPr id="18" name="TextBox 17"/>
-          <p:cNvSpPr txBox="1"/>
-          <p:nvPr/>
-        </p:nvSpPr>
-        <p:spPr>
-          <a:xfrm>
-            <a:off x="5666008" y="51015"/>
-            <a:ext cx="1027606" cy="852695"/>
-          </a:xfrm>
-          <a:prstGeom prst="rect">
-            <a:avLst/>
-          </a:prstGeom>
-          <a:noFill/>
-        </p:spPr>
-        <p:txBody>
-          <a:bodyPr wrap="none" lIns="0" rIns="0" tIns="0" bIns="0" anchor="ctr">
-            <a:spAutoFit/>
-          </a:bodyPr>
-          <a:lstStyle/>
-          <a:p>
-            <a:pPr>
-              <a:defRPr sz="2000">
-                <a:solidFill>
-                  <a:srgbClr val="FFFFFF"/>
-                </a:solidFill>
-                <a:latin typeface="Malgun Gothic"/>
-              </a:defRPr>
-            </a:pPr>
-            <a:r>
-              <a:t>S0 S</a:t>
-            </a:r>
-          </a:p>
-        </p:txBody>
-      </p:sp>
-      <p:sp>
-        <p:nvSpPr>
-          <p:cNvPr id="19" name="TextBox 18"/>
-          <p:cNvSpPr txBox="1"/>
-          <p:nvPr/>
-        </p:nvSpPr>
-        <p:spPr>
-          <a:xfrm>
-            <a:off x="1898116" y="80167"/>
-            <a:ext cx="1071334" cy="787103"/>
-          </a:xfrm>
-          <a:prstGeom prst="rect">
-            <a:avLst/>
-          </a:prstGeom>
-          <a:noFill/>
-        </p:spPr>
-        <p:txBody>
-          <a:bodyPr wrap="none" lIns="0" rIns="0" tIns="0" bIns="0" anchor="ctr">
-            <a:spAutoFit/>
-          </a:bodyPr>
-          <a:lstStyle/>
-          <a:p>
-            <a:pPr>
-              <a:defRPr sz="2000">
-                <a:solidFill>
-                  <a:srgbClr val="FFFFFF"/>
-                </a:solidFill>
-                <a:latin typeface="Malgun Gothic"/>
-              </a:defRPr>
-            </a:pPr>
-            <a:r>
-              <a:t>One</a:t>
-            </a:r>
-          </a:p>
-        </p:txBody>
-      </p:sp>
-      <p:sp>
-        <p:nvSpPr>
-          <p:cNvPr id="20" name="TextBox 19"/>
-          <p:cNvSpPr txBox="1"/>
-          <p:nvPr/>
-        </p:nvSpPr>
-        <p:spPr>
-          <a:xfrm>
-            <a:off x="2976739" y="94743"/>
-            <a:ext cx="1574206" cy="750663"/>
-          </a:xfrm>
-          <a:prstGeom prst="rect">
-            <a:avLst/>
-          </a:prstGeom>
-          <a:noFill/>
-        </p:spPr>
-        <p:txBody>
-          <a:bodyPr wrap="none" lIns="0" rIns="0" tIns="0" bIns="0" anchor="ctr">
-            <a:spAutoFit/>
-          </a:bodyPr>
-          <a:lstStyle/>
-          <a:p>
-            <a:pPr>
-              <a:defRPr sz="2000">
-                <a:solidFill>
-                  <a:srgbClr val="FEFEFD"/>
-                </a:solidFill>
-                <a:latin typeface="Malgun Gothic"/>
-              </a:defRPr>
-            </a:pPr>
-            <a:r>
-              <a:t>Punch</a:t>
-            </a:r>
-          </a:p>
-        </p:txBody>
-      </p:sp>
-      <p:sp>
-        <p:nvSpPr>
-          <p:cNvPr id="21" name="TextBox 20"/>
-          <p:cNvSpPr txBox="1"/>
-          <p:nvPr/>
-        </p:nvSpPr>
-        <p:spPr>
-          <a:xfrm>
-            <a:off x="4587385" y="998454"/>
-            <a:ext cx="2485205" cy="218639"/>
-          </a:xfrm>
-          <a:prstGeom prst="rect">
-            <a:avLst/>
-          </a:prstGeom>
-          <a:noFill/>
-        </p:spPr>
-        <p:txBody>
-          <a:bodyPr wrap="none" lIns="0" rIns="0" tIns="0" bIns="0" anchor="ctr">
-            <a:spAutoFit/>
-          </a:bodyPr>
-          <a:lstStyle/>
-          <a:p>
-            <a:pPr>
-              <a:defRPr sz="1153">
-                <a:solidFill>
-                  <a:srgbClr val="010101"/>
-                </a:solidFill>
-                <a:latin typeface="Malgun Gothic"/>
-              </a:defRPr>
-            </a:pPr>
-            <a:r>
-              <a:t>Saitama's overwhelming power</a:t>
-            </a:r>
-          </a:p>
-        </p:txBody>
-      </p:sp>
-      <p:sp>
-        <p:nvSpPr>
-          <p:cNvPr id="22" name="TextBox 21"/>
-          <p:cNvSpPr txBox="1"/>
-          <p:nvPr/>
-        </p:nvSpPr>
-        <p:spPr>
-          <a:xfrm>
-            <a:off x="294758" y="1027606"/>
-            <a:ext cx="1938605" cy="201168"/>
-          </a:xfrm>
-          <a:prstGeom prst="rect">
-            <a:avLst/>
-          </a:prstGeom>
-          <a:noFill/>
-        </p:spPr>
-        <p:txBody>
-          <a:bodyPr wrap="none" lIns="0" rIns="0" tIns="0" bIns="0" anchor="ctr">
-            <a:spAutoFit/>
-          </a:bodyPr>
-          <a:lstStyle/>
-          <a:p>
-            <a:pPr>
-              <a:defRPr sz="1007">
-                <a:solidFill>
-                  <a:srgbClr val="000000"/>
-                </a:solidFill>
-                <a:latin typeface="Malgun Gothic"/>
-              </a:defRPr>
-            </a:pPr>
-            <a:r>
-              <a:t>Narrative, psychological,</a:t>
-            </a:r>
-          </a:p>
-        </p:txBody>
-      </p:sp>
-      <p:sp>
-        <p:nvSpPr>
-          <p:cNvPr id="23" name="TextBox 22"/>
-          <p:cNvSpPr txBox="1"/>
-          <p:nvPr/>
-        </p:nvSpPr>
-        <p:spPr>
-          <a:xfrm>
-            <a:off x="2255228" y="1034894"/>
-            <a:ext cx="1770981" cy="201168"/>
-          </a:xfrm>
-          <a:prstGeom prst="rect">
-            <a:avLst/>
-          </a:prstGeom>
-          <a:noFill/>
-        </p:spPr>
-        <p:txBody>
-          <a:bodyPr wrap="none" lIns="0" rIns="0" tIns="0" bIns="0" anchor="ctr">
-            <a:spAutoFit/>
-          </a:bodyPr>
-          <a:lstStyle/>
-          <a:p>
-            <a:pPr>
-              <a:defRPr sz="903">
-                <a:solidFill>
-                  <a:srgbClr val="010101"/>
-                </a:solidFill>
-                <a:latin typeface="Malgun Gothic"/>
-              </a:defRPr>
-            </a:pPr>
-            <a:r>
-              <a:t>and structural reasons</a:t>
-            </a:r>
-          </a:p>
-        </p:txBody>
-      </p:sp>
-      <p:sp>
-        <p:nvSpPr>
-          <p:cNvPr id="24" name="TextBox 23"/>
-          <p:cNvSpPr txBox="1"/>
-          <p:nvPr/>
-        </p:nvSpPr>
-        <p:spPr>
-          <a:xfrm>
-            <a:off x="4011634" y="1034894"/>
-            <a:ext cx="590327" cy="201168"/>
-          </a:xfrm>
-          <a:prstGeom prst="rect">
-            <a:avLst/>
-          </a:prstGeom>
-          <a:noFill/>
-        </p:spPr>
-        <p:txBody>
-          <a:bodyPr wrap="none" lIns="0" rIns="0" tIns="0" bIns="0" anchor="ctr">
-            <a:spAutoFit/>
-          </a:bodyPr>
-          <a:lstStyle/>
-          <a:p>
-            <a:pPr>
-              <a:defRPr sz="903">
-                <a:solidFill>
-                  <a:srgbClr val="000000"/>
-                </a:solidFill>
-                <a:latin typeface="Malgun Gothic"/>
-              </a:defRPr>
-            </a:pPr>
-            <a:r>
-              <a:t>behind</a:t>
-            </a:r>
-          </a:p>
-        </p:txBody>
-      </p:sp>
-      <p:sp>
-        <p:nvSpPr>
-          <p:cNvPr id="25" name="TextBox 24"/>
-          <p:cNvSpPr txBox="1"/>
-          <p:nvPr/>
-        </p:nvSpPr>
-        <p:spPr>
-          <a:xfrm>
-            <a:off x="549838" y="1355566"/>
-            <a:ext cx="1268110" cy="225927"/>
-          </a:xfrm>
-          <a:prstGeom prst="rect">
-            <a:avLst/>
-          </a:prstGeom>
-          <a:noFill/>
-        </p:spPr>
-        <p:txBody>
-          <a:bodyPr wrap="none" lIns="0" rIns="0" tIns="0" bIns="0" anchor="ctr">
-            <a:spAutoFit/>
-          </a:bodyPr>
-          <a:lstStyle/>
-          <a:p>
-            <a:pPr>
-              <a:defRPr sz="1334">
-                <a:solidFill>
-                  <a:srgbClr val="F6F6F6"/>
-                </a:solidFill>
-                <a:latin typeface="Malgun Gothic"/>
-              </a:defRPr>
-            </a:pPr>
-            <a:r>
-              <a:t>CORE REASONS</a:t>
-            </a:r>
-          </a:p>
-        </p:txBody>
-      </p:sp>
-      <p:sp>
-        <p:nvSpPr>
-          <p:cNvPr id="26" name="TextBox 25"/>
-          <p:cNvSpPr txBox="1"/>
-          <p:nvPr/>
-        </p:nvSpPr>
-        <p:spPr>
-          <a:xfrm>
-            <a:off x="331198" y="1377430"/>
-            <a:ext cx="306095" cy="201168"/>
-          </a:xfrm>
-          <a:prstGeom prst="rect">
-            <a:avLst/>
-          </a:prstGeom>
-          <a:noFill/>
-        </p:spPr>
-        <p:txBody>
-          <a:bodyPr wrap="none" lIns="0" rIns="0" tIns="0" bIns="0" anchor="ctr">
-            <a:spAutoFit/>
-          </a:bodyPr>
-          <a:lstStyle/>
-          <a:p>
-            <a:pPr>
-              <a:defRPr sz="1162">
-                <a:solidFill>
-                  <a:srgbClr val="FFFFFF"/>
-                </a:solidFill>
-                <a:latin typeface="Malgun Gothic"/>
-              </a:defRPr>
-            </a:pPr>
-            <a:r>
-              <a:t>A)(</a:t>
-            </a:r>
-          </a:p>
-        </p:txBody>
-      </p:sp>
-      <p:sp>
-        <p:nvSpPr>
-          <p:cNvPr id="27" name="TextBox 26"/>
-          <p:cNvSpPr txBox="1"/>
-          <p:nvPr/>
-        </p:nvSpPr>
-        <p:spPr>
-          <a:xfrm>
-            <a:off x="4536369" y="1399294"/>
-            <a:ext cx="3133836" cy="201168"/>
-          </a:xfrm>
-          <a:prstGeom prst="rect">
-            <a:avLst/>
-          </a:prstGeom>
-          <a:noFill/>
-        </p:spPr>
-        <p:txBody>
-          <a:bodyPr wrap="none" lIns="0" rIns="0" tIns="0" bIns="0" anchor="ctr">
-            <a:spAutoFit/>
-          </a:bodyPr>
-          <a:lstStyle/>
-          <a:p>
-            <a:pPr>
-              <a:defRPr sz="993">
-                <a:solidFill>
-                  <a:srgbClr val="FFFFFF"/>
-                </a:solidFill>
-                <a:latin typeface="Malgun Gothic"/>
-              </a:defRPr>
-            </a:pPr>
-            <a:r>
-              <a:t>HOW HE DIFFERS FROM TYPICAL SHONEN HEROES</a:t>
-            </a:r>
-          </a:p>
-        </p:txBody>
-      </p:sp>
-      <p:sp>
-        <p:nvSpPr>
-          <p:cNvPr id="28" name="TextBox 27"/>
-          <p:cNvSpPr txBox="1"/>
-          <p:nvPr/>
-        </p:nvSpPr>
-        <p:spPr>
-          <a:xfrm>
-            <a:off x="4354169" y="1413870"/>
-            <a:ext cx="167623" cy="201168"/>
-          </a:xfrm>
-          <a:prstGeom prst="rect">
-            <a:avLst/>
-          </a:prstGeom>
-          <a:noFill/>
-        </p:spPr>
-        <p:txBody>
-          <a:bodyPr wrap="none" lIns="0" rIns="0" tIns="0" bIns="0" anchor="ctr">
-            <a:spAutoFit/>
-          </a:bodyPr>
-          <a:lstStyle/>
-          <a:p>
-            <a:pPr>
-              <a:defRPr sz="946">
-                <a:solidFill>
-                  <a:srgbClr val="F8D264"/>
-                </a:solidFill>
-                <a:latin typeface="Malgun Gothic"/>
-              </a:defRPr>
-            </a:pPr>
-            <a:r>
-              <a:t>B</a:t>
-            </a:r>
-          </a:p>
-        </p:txBody>
-      </p:sp>
-      <p:sp>
-        <p:nvSpPr>
-          <p:cNvPr id="29" name="TextBox 28"/>
-          <p:cNvSpPr txBox="1"/>
-          <p:nvPr/>
-        </p:nvSpPr>
-        <p:spPr>
-          <a:xfrm>
-            <a:off x="1577445" y="1770981"/>
-            <a:ext cx="1340990" cy="201168"/>
-          </a:xfrm>
-          <a:prstGeom prst="rect">
-            <a:avLst/>
-          </a:prstGeom>
-          <a:noFill/>
-        </p:spPr>
-        <p:txBody>
-          <a:bodyPr wrap="none" lIns="0" rIns="0" tIns="0" bIns="0" anchor="ctr">
-            <a:spAutoFit/>
-          </a:bodyPr>
-          <a:lstStyle/>
-          <a:p>
-            <a:pPr>
-              <a:defRPr sz="946">
-                <a:solidFill>
-                  <a:srgbClr val="F7F7F7"/>
-                </a:solidFill>
-                <a:latin typeface="Malgun Gothic"/>
-              </a:defRPr>
-            </a:pPr>
-            <a:r>
-              <a:t>BUILT AS A SATIRE</a:t>
-            </a:r>
-          </a:p>
-        </p:txBody>
-      </p:sp>
-      <p:sp>
-        <p:nvSpPr>
-          <p:cNvPr id="30" name="TextBox 29"/>
-          <p:cNvSpPr txBox="1"/>
-          <p:nvPr/>
-        </p:nvSpPr>
-        <p:spPr>
-          <a:xfrm>
-            <a:off x="1140165" y="1865725"/>
-            <a:ext cx="218639" cy="400839"/>
-          </a:xfrm>
-          <a:prstGeom prst="rect">
-            <a:avLst/>
-          </a:prstGeom>
-          <a:noFill/>
-        </p:spPr>
-        <p:txBody>
-          <a:bodyPr wrap="none" lIns="0" rIns="0" tIns="0" bIns="0" anchor="ctr">
-            <a:spAutoFit/>
-          </a:bodyPr>
-          <a:lstStyle/>
-          <a:p>
-            <a:pPr>
-              <a:defRPr sz="2000">
-                <a:solidFill>
-                  <a:srgbClr val="050400"/>
-                </a:solidFill>
-                <a:latin typeface="Malgun Gothic"/>
-              </a:defRPr>
-            </a:pPr>
-            <a:r>
-              <a:t>1</a:t>
-            </a:r>
-          </a:p>
-        </p:txBody>
-      </p:sp>
-      <p:sp>
-        <p:nvSpPr>
-          <p:cNvPr id="31" name="TextBox 30"/>
-          <p:cNvSpPr txBox="1"/>
-          <p:nvPr/>
-        </p:nvSpPr>
-        <p:spPr>
-          <a:xfrm>
-            <a:off x="1562869" y="1967757"/>
-            <a:ext cx="2368597" cy="201168"/>
-          </a:xfrm>
-          <a:prstGeom prst="rect">
-            <a:avLst/>
-          </a:prstGeom>
-          <a:noFill/>
-        </p:spPr>
-        <p:txBody>
-          <a:bodyPr wrap="none" lIns="0" rIns="0" tIns="0" bIns="0" anchor="ctr">
-            <a:spAutoFit/>
-          </a:bodyPr>
-          <a:lstStyle/>
-          <a:p>
-            <a:pPr>
-              <a:defRPr sz="700">
-                <a:solidFill>
-                  <a:srgbClr val="040303"/>
-                </a:solidFill>
-                <a:latin typeface="Malgun Gothic"/>
-              </a:defRPr>
-            </a:pPr>
-            <a:r>
-              <a:t>Saitama was designed to parody power-scaling</a:t>
-            </a:r>
-          </a:p>
-        </p:txBody>
-      </p:sp>
-      <p:sp>
-        <p:nvSpPr>
-          <p:cNvPr id="32" name="TextBox 31"/>
-          <p:cNvSpPr txBox="1"/>
-          <p:nvPr/>
-        </p:nvSpPr>
-        <p:spPr>
-          <a:xfrm>
-            <a:off x="1577445" y="2142669"/>
-            <a:ext cx="2171821" cy="201168"/>
-          </a:xfrm>
-          <a:prstGeom prst="rect">
-            <a:avLst/>
-          </a:prstGeom>
-          <a:noFill/>
-        </p:spPr>
-        <p:txBody>
-          <a:bodyPr wrap="none" lIns="0" rIns="0" tIns="0" bIns="0" anchor="ctr">
-            <a:spAutoFit/>
-          </a:bodyPr>
-          <a:lstStyle/>
-          <a:p>
-            <a:pPr>
-              <a:defRPr sz="700">
-                <a:solidFill>
-                  <a:srgbClr val="040303"/>
-                </a:solidFill>
-                <a:latin typeface="Malgun Gothic"/>
-              </a:defRPr>
-            </a:pPr>
-            <a:r>
-              <a:t>stories—his absurd strength is the premise</a:t>
-            </a:r>
-          </a:p>
-        </p:txBody>
-      </p:sp>
-      <p:sp>
-        <p:nvSpPr>
-          <p:cNvPr id="33" name="TextBox 32"/>
-          <p:cNvSpPr txBox="1"/>
-          <p:nvPr/>
-        </p:nvSpPr>
-        <p:spPr>
-          <a:xfrm>
-            <a:off x="1562869" y="2273853"/>
-            <a:ext cx="816255" cy="201168"/>
-          </a:xfrm>
-          <a:prstGeom prst="rect">
-            <a:avLst/>
-          </a:prstGeom>
-          <a:noFill/>
-        </p:spPr>
-        <p:txBody>
-          <a:bodyPr wrap="none" lIns="0" rIns="0" tIns="0" bIns="0" anchor="ctr">
-            <a:spAutoFit/>
-          </a:bodyPr>
-          <a:lstStyle/>
-          <a:p>
-            <a:pPr>
-              <a:defRPr sz="706">
-                <a:solidFill>
-                  <a:srgbClr val="000000"/>
-                </a:solidFill>
-                <a:latin typeface="Malgun Gothic"/>
-              </a:defRPr>
-            </a:pPr>
-            <a:r>
-              <a:t>not the reward.</a:t>
-            </a:r>
-          </a:p>
-        </p:txBody>
-      </p:sp>
-      <p:sp>
-        <p:nvSpPr>
-          <p:cNvPr id="34" name="TextBox 33"/>
-          <p:cNvSpPr txBox="1"/>
-          <p:nvPr/>
-        </p:nvSpPr>
-        <p:spPr>
-          <a:xfrm>
-            <a:off x="1570157" y="2601812"/>
-            <a:ext cx="2040637" cy="201168"/>
-          </a:xfrm>
-          <a:prstGeom prst="rect">
-            <a:avLst/>
-          </a:prstGeom>
-          <a:noFill/>
-        </p:spPr>
-        <p:txBody>
-          <a:bodyPr wrap="none" lIns="0" rIns="0" tIns="0" bIns="0" anchor="ctr">
-            <a:spAutoFit/>
-          </a:bodyPr>
-          <a:lstStyle/>
-          <a:p>
-            <a:pPr>
-              <a:defRPr sz="989">
-                <a:solidFill>
-                  <a:srgbClr val="020202"/>
-                </a:solidFill>
-                <a:latin typeface="Malgun Gothic"/>
-              </a:defRPr>
-            </a:pPr>
-            <a:r>
-              <a:t>ALREADY AT THE FINISH LINE</a:t>
-            </a:r>
-          </a:p>
-        </p:txBody>
-      </p:sp>
-      <p:sp>
-        <p:nvSpPr>
-          <p:cNvPr id="35" name="TextBox 34"/>
-          <p:cNvSpPr txBox="1"/>
-          <p:nvPr/>
-        </p:nvSpPr>
-        <p:spPr>
-          <a:xfrm>
-            <a:off x="1096437" y="2667404"/>
-            <a:ext cx="342535" cy="451855"/>
-          </a:xfrm>
-          <a:prstGeom prst="rect">
-            <a:avLst/>
-          </a:prstGeom>
-          <a:noFill/>
-        </p:spPr>
-        <p:txBody>
-          <a:bodyPr wrap="none" lIns="0" rIns="0" tIns="0" bIns="0" anchor="ctr">
-            <a:spAutoFit/>
-          </a:bodyPr>
-          <a:lstStyle/>
-          <a:p>
-            <a:pPr>
-              <a:defRPr sz="2000">
-                <a:solidFill>
-                  <a:srgbClr val="050400"/>
-                </a:solidFill>
-                <a:latin typeface="Malgun Gothic"/>
-              </a:defRPr>
-            </a:pPr>
-            <a:r>
-              <a:t>2</a:t>
-            </a:r>
-          </a:p>
-        </p:txBody>
-      </p:sp>
-      <p:sp>
-        <p:nvSpPr>
-          <p:cNvPr id="36" name="TextBox 35"/>
-          <p:cNvSpPr txBox="1"/>
-          <p:nvPr/>
-        </p:nvSpPr>
-        <p:spPr>
-          <a:xfrm>
-            <a:off x="1562869" y="2798588"/>
-            <a:ext cx="2346733" cy="201168"/>
-          </a:xfrm>
-          <a:prstGeom prst="rect">
-            <a:avLst/>
-          </a:prstGeom>
-          <a:noFill/>
-        </p:spPr>
-        <p:txBody>
-          <a:bodyPr wrap="none" lIns="0" rIns="0" tIns="0" bIns="0" anchor="ctr">
-            <a:spAutoFit/>
-          </a:bodyPr>
-          <a:lstStyle/>
-          <a:p>
-            <a:pPr>
-              <a:defRPr sz="700">
-                <a:solidFill>
-                  <a:srgbClr val="030303"/>
-                </a:solidFill>
-                <a:latin typeface="Malgun Gothic"/>
-              </a:defRPr>
-            </a:pPr>
-            <a:r>
-              <a:t>While others train and climb for years to reach</a:t>
-            </a:r>
-          </a:p>
-        </p:txBody>
-      </p:sp>
-      <p:sp>
-        <p:nvSpPr>
-          <p:cNvPr id="37" name="TextBox 36"/>
-          <p:cNvSpPr txBox="1"/>
-          <p:nvPr/>
-        </p:nvSpPr>
-        <p:spPr>
-          <a:xfrm>
-            <a:off x="1555581" y="2951636"/>
-            <a:ext cx="2215549" cy="201168"/>
-          </a:xfrm>
-          <a:prstGeom prst="rect">
-            <a:avLst/>
-          </a:prstGeom>
-          <a:noFill/>
-        </p:spPr>
-        <p:txBody>
-          <a:bodyPr wrap="none" lIns="0" rIns="0" tIns="0" bIns="0" anchor="ctr">
-            <a:spAutoFit/>
-          </a:bodyPr>
-          <a:lstStyle/>
-          <a:p>
-            <a:pPr>
-              <a:defRPr sz="700">
-                <a:solidFill>
-                  <a:srgbClr val="050404"/>
-                </a:solidFill>
-                <a:latin typeface="Malgun Gothic"/>
-              </a:defRPr>
-            </a:pPr>
-            <a:r>
-              <a:t>the top, he begins where most protagonists</a:t>
-            </a:r>
-          </a:p>
-        </p:txBody>
-      </p:sp>
-      <p:sp>
-        <p:nvSpPr>
-          <p:cNvPr id="38" name="TextBox 37"/>
-          <p:cNvSpPr txBox="1"/>
-          <p:nvPr/>
-        </p:nvSpPr>
-        <p:spPr>
-          <a:xfrm>
-            <a:off x="1570157" y="3126548"/>
-            <a:ext cx="1078622" cy="201168"/>
-          </a:xfrm>
-          <a:prstGeom prst="rect">
-            <a:avLst/>
-          </a:prstGeom>
-          <a:noFill/>
-        </p:spPr>
-        <p:txBody>
-          <a:bodyPr wrap="none" lIns="0" rIns="0" tIns="0" bIns="0" anchor="ctr">
-            <a:spAutoFit/>
-          </a:bodyPr>
-          <a:lstStyle/>
-          <a:p>
-            <a:pPr>
-              <a:defRPr sz="700">
-                <a:solidFill>
-                  <a:srgbClr val="030302"/>
-                </a:solidFill>
-                <a:latin typeface="Malgun Gothic"/>
-              </a:defRPr>
-            </a:pPr>
-            <a:r>
-              <a:t>are supposed to end.</a:t>
-            </a:r>
-          </a:p>
-        </p:txBody>
-      </p:sp>
-      <p:sp>
-        <p:nvSpPr>
-          <p:cNvPr id="39" name="TextBox 38"/>
-          <p:cNvSpPr txBox="1"/>
-          <p:nvPr/>
-        </p:nvSpPr>
-        <p:spPr>
-          <a:xfrm>
-            <a:off x="1562869" y="3418068"/>
-            <a:ext cx="1996909" cy="201168"/>
-          </a:xfrm>
-          <a:prstGeom prst="rect">
-            <a:avLst/>
-          </a:prstGeom>
-          <a:noFill/>
-        </p:spPr>
-        <p:txBody>
-          <a:bodyPr wrap="none" lIns="0" rIns="0" tIns="0" bIns="0" anchor="ctr">
-            <a:spAutoFit/>
-          </a:bodyPr>
-          <a:lstStyle/>
-          <a:p>
-            <a:pPr>
-              <a:defRPr sz="1032">
-                <a:solidFill>
-                  <a:srgbClr val="FFFFFF"/>
-                </a:solidFill>
-                <a:latin typeface="Malgun Gothic"/>
-              </a:defRPr>
-            </a:pPr>
-            <a:r>
-              <a:t>LIMIT-BREAKING SIMPLICITY</a:t>
-            </a:r>
-          </a:p>
-        </p:txBody>
-      </p:sp>
-      <p:sp>
-        <p:nvSpPr>
-          <p:cNvPr id="40" name="TextBox 39"/>
-          <p:cNvSpPr txBox="1"/>
-          <p:nvPr/>
-        </p:nvSpPr>
-        <p:spPr>
-          <a:xfrm>
-            <a:off x="1132877" y="3512811"/>
-            <a:ext cx="269655" cy="400839"/>
-          </a:xfrm>
-          <a:prstGeom prst="rect">
-            <a:avLst/>
-          </a:prstGeom>
-          <a:noFill/>
-        </p:spPr>
-        <p:txBody>
-          <a:bodyPr wrap="none" lIns="0" rIns="0" tIns="0" bIns="0" anchor="ctr">
-            <a:spAutoFit/>
-          </a:bodyPr>
-          <a:lstStyle/>
-          <a:p>
-            <a:pPr>
-              <a:defRPr sz="2000">
-                <a:solidFill>
-                  <a:srgbClr val="050400"/>
-                </a:solidFill>
-                <a:latin typeface="Malgun Gothic"/>
-              </a:defRPr>
-            </a:pPr>
-            <a:r>
-              <a:t>3</a:t>
-            </a:r>
-          </a:p>
-        </p:txBody>
-      </p:sp>
-      <p:sp>
-        <p:nvSpPr>
-          <p:cNvPr id="41" name="TextBox 40"/>
-          <p:cNvSpPr txBox="1"/>
-          <p:nvPr/>
-        </p:nvSpPr>
-        <p:spPr>
-          <a:xfrm>
-            <a:off x="1562869" y="3643995"/>
-            <a:ext cx="2470629" cy="201168"/>
-          </a:xfrm>
-          <a:prstGeom prst="rect">
-            <a:avLst/>
-          </a:prstGeom>
-          <a:noFill/>
-        </p:spPr>
-        <p:txBody>
-          <a:bodyPr wrap="none" lIns="0" rIns="0" tIns="0" bIns="0" anchor="ctr">
-            <a:spAutoFit/>
-          </a:bodyPr>
-          <a:lstStyle/>
-          <a:p>
-            <a:pPr>
-              <a:defRPr sz="700">
-                <a:solidFill>
-                  <a:srgbClr val="050504"/>
-                </a:solidFill>
-                <a:latin typeface="Malgun Gothic"/>
-              </a:defRPr>
-            </a:pPr>
-            <a:r>
-              <a:t>His routine is both disciplined and comically extreme:</a:t>
-            </a:r>
-          </a:p>
-        </p:txBody>
-      </p:sp>
-      <p:sp>
-        <p:nvSpPr>
-          <p:cNvPr id="42" name="TextBox 41"/>
-          <p:cNvSpPr txBox="1"/>
-          <p:nvPr/>
-        </p:nvSpPr>
-        <p:spPr>
-          <a:xfrm>
-            <a:off x="1555581" y="3775179"/>
-            <a:ext cx="2011485" cy="201168"/>
-          </a:xfrm>
-          <a:prstGeom prst="rect">
-            <a:avLst/>
-          </a:prstGeom>
-          <a:noFill/>
-        </p:spPr>
-        <p:txBody>
-          <a:bodyPr wrap="none" lIns="0" rIns="0" tIns="0" bIns="0" anchor="ctr">
-            <a:spAutoFit/>
-          </a:bodyPr>
-          <a:lstStyle/>
-          <a:p>
-            <a:pPr>
-              <a:defRPr sz="700">
-                <a:solidFill>
-                  <a:srgbClr val="010101"/>
-                </a:solidFill>
-                <a:latin typeface="Malgun Gothic"/>
-              </a:defRPr>
-            </a:pPr>
-            <a:r>
-              <a:t>100 push-ups, 100 sit-ups, 100 squats,</a:t>
-            </a:r>
-          </a:p>
-        </p:txBody>
-      </p:sp>
-      <p:sp>
-        <p:nvSpPr>
-          <p:cNvPr id="43" name="TextBox 42"/>
-          <p:cNvSpPr txBox="1"/>
-          <p:nvPr/>
-        </p:nvSpPr>
-        <p:spPr>
-          <a:xfrm>
-            <a:off x="1562869" y="3942803"/>
-            <a:ext cx="1399294" cy="201168"/>
-          </a:xfrm>
-          <a:prstGeom prst="rect">
-            <a:avLst/>
-          </a:prstGeom>
-          <a:noFill/>
-        </p:spPr>
-        <p:txBody>
-          <a:bodyPr wrap="none" lIns="0" rIns="0" tIns="0" bIns="0" anchor="ctr">
-            <a:spAutoFit/>
-          </a:bodyPr>
-          <a:lstStyle/>
-          <a:p>
-            <a:pPr>
-              <a:defRPr sz="700">
-                <a:solidFill>
-                  <a:srgbClr val="020201"/>
-                </a:solidFill>
-                <a:latin typeface="Malgun Gothic"/>
-              </a:defRPr>
-            </a:pPr>
-            <a:r>
-              <a:t>and a 10 km run every day.</a:t>
-            </a:r>
-          </a:p>
-        </p:txBody>
-      </p:sp>
-      <p:sp>
-        <p:nvSpPr>
-          <p:cNvPr id="44" name="TextBox 43"/>
-          <p:cNvSpPr txBox="1"/>
-          <p:nvPr/>
-        </p:nvSpPr>
-        <p:spPr>
-          <a:xfrm>
-            <a:off x="1577445" y="4263475"/>
-            <a:ext cx="1792845" cy="201168"/>
-          </a:xfrm>
-          <a:prstGeom prst="rect">
-            <a:avLst/>
-          </a:prstGeom>
-          <a:noFill/>
-        </p:spPr>
-        <p:txBody>
-          <a:bodyPr wrap="none" lIns="0" rIns="0" tIns="0" bIns="0" anchor="ctr">
-            <a:spAutoFit/>
-          </a:bodyPr>
-          <a:lstStyle/>
-          <a:p>
-            <a:pPr>
-              <a:defRPr sz="903">
-                <a:solidFill>
-                  <a:srgbClr val="FFFFFF"/>
-                </a:solidFill>
-                <a:latin typeface="Malgun Gothic"/>
-              </a:defRPr>
-            </a:pPr>
-            <a:r>
-              <a:t>EMOTIONALLY UNSHAKEN</a:t>
-            </a:r>
-          </a:p>
-        </p:txBody>
-      </p:sp>
-      <p:sp>
-        <p:nvSpPr>
-          <p:cNvPr id="45" name="TextBox 44"/>
-          <p:cNvSpPr txBox="1"/>
-          <p:nvPr/>
-        </p:nvSpPr>
-        <p:spPr>
-          <a:xfrm>
-            <a:off x="1103725" y="4299914"/>
-            <a:ext cx="327959" cy="466431"/>
-          </a:xfrm>
-          <a:prstGeom prst="rect">
-            <a:avLst/>
-          </a:prstGeom>
-          <a:noFill/>
-        </p:spPr>
-        <p:txBody>
-          <a:bodyPr wrap="none" lIns="0" rIns="0" tIns="0" bIns="0" anchor="ctr">
-            <a:spAutoFit/>
-          </a:bodyPr>
-          <a:lstStyle/>
-          <a:p>
-            <a:pPr>
-              <a:defRPr sz="2000">
-                <a:solidFill>
-                  <a:srgbClr val="040300"/>
-                </a:solidFill>
-                <a:latin typeface="Malgun Gothic"/>
-              </a:defRPr>
-            </a:pPr>
-            <a:r>
-              <a:t>4</a:t>
-            </a:r>
-          </a:p>
-        </p:txBody>
-      </p:sp>
-      <p:sp>
-        <p:nvSpPr>
-          <p:cNvPr id="46" name="TextBox 45"/>
-          <p:cNvSpPr txBox="1"/>
-          <p:nvPr/>
-        </p:nvSpPr>
-        <p:spPr>
-          <a:xfrm>
-            <a:off x="1555581" y="4445674"/>
-            <a:ext cx="2062501" cy="201168"/>
-          </a:xfrm>
-          <a:prstGeom prst="rect">
-            <a:avLst/>
-          </a:prstGeom>
-          <a:noFill/>
-        </p:spPr>
-        <p:txBody>
-          <a:bodyPr wrap="none" lIns="0" rIns="0" tIns="0" bIns="0" anchor="ctr">
-            <a:spAutoFit/>
-          </a:bodyPr>
-          <a:lstStyle/>
-          <a:p>
-            <a:pPr>
-              <a:defRPr sz="700">
-                <a:solidFill>
-                  <a:srgbClr val="030303"/>
-                </a:solidFill>
-                <a:latin typeface="Malgun Gothic"/>
-              </a:defRPr>
-            </a:pPr>
-            <a:r>
-              <a:t>He fights without fear, ego, or hesitation.</a:t>
-            </a:r>
-          </a:p>
-        </p:txBody>
-      </p:sp>
-      <p:sp>
-        <p:nvSpPr>
-          <p:cNvPr id="47" name="TextBox 46"/>
-          <p:cNvSpPr txBox="1"/>
-          <p:nvPr/>
-        </p:nvSpPr>
-        <p:spPr>
-          <a:xfrm>
-            <a:off x="1548293" y="4598722"/>
-            <a:ext cx="2033349" cy="201168"/>
-          </a:xfrm>
-          <a:prstGeom prst="rect">
-            <a:avLst/>
-          </a:prstGeom>
-          <a:noFill/>
-        </p:spPr>
-        <p:txBody>
-          <a:bodyPr wrap="none" lIns="0" rIns="0" tIns="0" bIns="0" anchor="ctr">
-            <a:spAutoFit/>
-          </a:bodyPr>
-          <a:lstStyle/>
-          <a:p>
-            <a:pPr>
-              <a:defRPr sz="713">
-                <a:solidFill>
-                  <a:srgbClr val="030303"/>
-                </a:solidFill>
-                <a:latin typeface="Malgun Gothic"/>
-              </a:defRPr>
-            </a:pPr>
-            <a:r>
-              <a:t>No need to prove himself—he's already</a:t>
-            </a:r>
-          </a:p>
-        </p:txBody>
-      </p:sp>
-      <p:sp>
-        <p:nvSpPr>
-          <p:cNvPr id="48" name="TextBox 47"/>
-          <p:cNvSpPr txBox="1"/>
-          <p:nvPr/>
-        </p:nvSpPr>
-        <p:spPr>
-          <a:xfrm>
-            <a:off x="1562869" y="4766346"/>
-            <a:ext cx="1610646" cy="201168"/>
-          </a:xfrm>
-          <a:prstGeom prst="rect">
-            <a:avLst/>
-          </a:prstGeom>
-          <a:noFill/>
-        </p:spPr>
-        <p:txBody>
-          <a:bodyPr wrap="none" lIns="0" rIns="0" tIns="0" bIns="0" anchor="ctr">
-            <a:spAutoFit/>
-          </a:bodyPr>
-          <a:lstStyle/>
-          <a:p>
-            <a:pPr>
-              <a:defRPr sz="700">
-                <a:solidFill>
-                  <a:srgbClr val="040303"/>
-                </a:solidFill>
-                <a:latin typeface="Malgun Gothic"/>
-              </a:defRPr>
-            </a:pPr>
-            <a:r>
-              <a:t>beyond the need for validation.</a:t>
-            </a:r>
-          </a:p>
-        </p:txBody>
-      </p:sp>
-      <p:sp>
-        <p:nvSpPr>
-          <p:cNvPr id="49" name="TextBox 48"/>
-          <p:cNvSpPr txBox="1"/>
-          <p:nvPr/>
-        </p:nvSpPr>
-        <p:spPr>
-          <a:xfrm>
-            <a:off x="1570157" y="5094306"/>
-            <a:ext cx="2434189" cy="201168"/>
-          </a:xfrm>
-          <a:prstGeom prst="rect">
-            <a:avLst/>
-          </a:prstGeom>
-          <a:noFill/>
-        </p:spPr>
-        <p:txBody>
-          <a:bodyPr wrap="none" lIns="0" rIns="0" tIns="0" bIns="0" anchor="ctr">
-            <a:spAutoFit/>
-          </a:bodyPr>
-          <a:lstStyle/>
-          <a:p>
-            <a:pPr>
-              <a:defRPr sz="930">
-                <a:solidFill>
-                  <a:srgbClr val="000000"/>
-                </a:solidFill>
-                <a:latin typeface="Malgun Gothic"/>
-              </a:defRPr>
-            </a:pPr>
-            <a:r>
-              <a:t>THE STORY NEEDS AN UNBEATABLE HERO</a:t>
-            </a:r>
-          </a:p>
-        </p:txBody>
-      </p:sp>
-      <p:sp>
-        <p:nvSpPr>
-          <p:cNvPr id="50" name="TextBox 49"/>
-          <p:cNvSpPr txBox="1"/>
-          <p:nvPr/>
-        </p:nvSpPr>
-        <p:spPr>
-          <a:xfrm>
-            <a:off x="1111013" y="5145321"/>
-            <a:ext cx="298807" cy="429991"/>
-          </a:xfrm>
-          <a:prstGeom prst="rect">
-            <a:avLst/>
-          </a:prstGeom>
-          <a:noFill/>
-        </p:spPr>
-        <p:txBody>
-          <a:bodyPr wrap="none" lIns="0" rIns="0" tIns="0" bIns="0" anchor="ctr">
-            <a:spAutoFit/>
-          </a:bodyPr>
-          <a:lstStyle/>
-          <a:p>
-            <a:pPr>
-              <a:defRPr sz="2000">
-                <a:solidFill>
-                  <a:srgbClr val="040300"/>
-                </a:solidFill>
-                <a:latin typeface="Malgun Gothic"/>
-              </a:defRPr>
-            </a:pPr>
-            <a:r>
-              <a:t>5</a:t>
-            </a:r>
-          </a:p>
-        </p:txBody>
-      </p:sp>
-      <p:sp>
-        <p:nvSpPr>
-          <p:cNvPr id="51" name="TextBox 50"/>
-          <p:cNvSpPr txBox="1"/>
-          <p:nvPr/>
-        </p:nvSpPr>
-        <p:spPr>
-          <a:xfrm>
-            <a:off x="1562869" y="5291081"/>
-            <a:ext cx="2222837" cy="201168"/>
-          </a:xfrm>
-          <a:prstGeom prst="rect">
-            <a:avLst/>
-          </a:prstGeom>
-          <a:noFill/>
-        </p:spPr>
-        <p:txBody>
-          <a:bodyPr wrap="none" lIns="0" rIns="0" tIns="0" bIns="0" anchor="ctr">
-            <a:spAutoFit/>
-          </a:bodyPr>
-          <a:lstStyle/>
-          <a:p>
-            <a:pPr>
-              <a:defRPr sz="700">
-                <a:solidFill>
-                  <a:srgbClr val="020102"/>
-                </a:solidFill>
-                <a:latin typeface="Malgun Gothic"/>
-              </a:defRPr>
-            </a:pPr>
-            <a:r>
-              <a:t>His power lets the series go beyond battles</a:t>
-            </a:r>
-          </a:p>
-        </p:txBody>
-      </p:sp>
-      <p:sp>
-        <p:nvSpPr>
-          <p:cNvPr id="52" name="TextBox 51"/>
-          <p:cNvSpPr txBox="1"/>
-          <p:nvPr/>
-        </p:nvSpPr>
-        <p:spPr>
-          <a:xfrm>
-            <a:off x="1548293" y="5444129"/>
-            <a:ext cx="2244701" cy="201168"/>
-          </a:xfrm>
-          <a:prstGeom prst="rect">
-            <a:avLst/>
-          </a:prstGeom>
-          <a:noFill/>
-        </p:spPr>
-        <p:txBody>
-          <a:bodyPr wrap="none" lIns="0" rIns="0" tIns="0" bIns="0" anchor="ctr">
-            <a:spAutoFit/>
-          </a:bodyPr>
-          <a:lstStyle/>
-          <a:p>
-            <a:pPr>
-              <a:defRPr sz="711">
-                <a:solidFill>
-                  <a:srgbClr val="010101"/>
-                </a:solidFill>
-                <a:latin typeface="Malgun Gothic"/>
-              </a:defRPr>
-            </a:pPr>
-            <a:r>
-              <a:t>to explore boredom, meaning, and identity</a:t>
-            </a:r>
-          </a:p>
-        </p:txBody>
-      </p:sp>
-      <p:sp>
-        <p:nvSpPr>
-          <p:cNvPr id="53" name="TextBox 52"/>
-          <p:cNvSpPr txBox="1"/>
-          <p:nvPr/>
-        </p:nvSpPr>
-        <p:spPr>
-          <a:xfrm>
-            <a:off x="1562869" y="5589889"/>
-            <a:ext cx="1173366" cy="201168"/>
-          </a:xfrm>
-          <a:prstGeom prst="rect">
-            <a:avLst/>
-          </a:prstGeom>
-          <a:noFill/>
-        </p:spPr>
-        <p:txBody>
-          <a:bodyPr wrap="none" lIns="0" rIns="0" tIns="0" bIns="0" anchor="ctr">
-            <a:spAutoFit/>
-          </a:bodyPr>
-          <a:lstStyle/>
-          <a:p>
-            <a:pPr>
-              <a:defRPr sz="700">
-                <a:solidFill>
-                  <a:srgbClr val="020202"/>
-                </a:solidFill>
-                <a:latin typeface="Malgun Gothic"/>
-              </a:defRPr>
-            </a:pPr>
-            <a:r>
-              <a:t>after absolute victory.</a:t>
-            </a:r>
-          </a:p>
-        </p:txBody>
-      </p:sp>
-      <p:sp>
-        <p:nvSpPr>
-          <p:cNvPr id="54" name="TextBox 53"/>
-          <p:cNvSpPr txBox="1"/>
-          <p:nvPr/>
-        </p:nvSpPr>
-        <p:spPr>
-          <a:xfrm>
-            <a:off x="3384867" y="6070896"/>
-            <a:ext cx="4197883" cy="218639"/>
-          </a:xfrm>
-          <a:prstGeom prst="rect">
-            <a:avLst/>
-          </a:prstGeom>
-          <a:noFill/>
-        </p:spPr>
-        <p:txBody>
-          <a:bodyPr wrap="none" lIns="0" rIns="0" tIns="0" bIns="0" anchor="ctr">
-            <a:spAutoFit/>
-          </a:bodyPr>
-          <a:lstStyle/>
-          <a:p>
-            <a:pPr>
-              <a:defRPr sz="1136">
-                <a:solidFill>
-                  <a:srgbClr val="020202"/>
-                </a:solidFill>
-                <a:latin typeface="Malgun Gothic"/>
-              </a:defRPr>
-            </a:pPr>
-            <a:r>
-              <a:t>One Punch Man is powerful as a character because</a:t>
-            </a:r>
-          </a:p>
-        </p:txBody>
-      </p:sp>
-      <p:sp>
-        <p:nvSpPr>
-          <p:cNvPr id="55" name="TextBox 54"/>
-          <p:cNvSpPr txBox="1"/>
-          <p:nvPr/>
-        </p:nvSpPr>
-        <p:spPr>
-          <a:xfrm>
-            <a:off x="1285925" y="6136488"/>
-            <a:ext cx="1596070" cy="357111"/>
-          </a:xfrm>
-          <a:prstGeom prst="rect">
-            <a:avLst/>
-          </a:prstGeom>
-          <a:noFill/>
-        </p:spPr>
-        <p:txBody>
-          <a:bodyPr wrap="none" lIns="0" rIns="0" tIns="0" bIns="0" anchor="ctr">
-            <a:spAutoFit/>
-          </a:bodyPr>
-          <a:lstStyle/>
-          <a:p>
-            <a:pPr>
-              <a:defRPr sz="1382">
-                <a:solidFill>
-                  <a:srgbClr val="FFFFFF"/>
-                </a:solidFill>
-                <a:latin typeface="Malgun Gothic"/>
-              </a:defRPr>
-            </a:pPr>
-            <a:r>
-              <a:t>D) KEY TAKEAWAY</a:t>
-            </a:r>
-          </a:p>
-        </p:txBody>
-      </p:sp>
-      <p:sp>
-        <p:nvSpPr>
-          <p:cNvPr id="56" name="TextBox 55"/>
-          <p:cNvSpPr txBox="1"/>
-          <p:nvPr/>
-        </p:nvSpPr>
-        <p:spPr>
-          <a:xfrm>
-            <a:off x="3370291" y="6318688"/>
-            <a:ext cx="4256187" cy="240503"/>
-          </a:xfrm>
-          <a:prstGeom prst="rect">
-            <a:avLst/>
-          </a:prstGeom>
-          <a:noFill/>
-        </p:spPr>
-        <p:txBody>
-          <a:bodyPr wrap="none" lIns="0" rIns="0" tIns="0" bIns="0" anchor="ctr">
-            <a:spAutoFit/>
-          </a:bodyPr>
-          <a:lstStyle/>
-          <a:p>
-            <a:pPr>
-              <a:defRPr sz="1024">
-                <a:solidFill>
-                  <a:srgbClr val="020202"/>
-                </a:solidFill>
-                <a:latin typeface="Malgun Gothic"/>
-              </a:defRPr>
-            </a:pPr>
-            <a:r>
-              <a:t>his strength is both a joke and a storytelling device.</a:t>
-            </a:r>
-          </a:p>
-        </p:txBody>
-      </p:sp>
-      <p:sp>
-        <p:nvSpPr>
-          <p:cNvPr id="57" name="Rectangle 56"/>
+      <p:sp>
+        <p:nvSpPr>
+          <p:cNvPr id="7" name="Rectangle 6"/>
           <p:cNvSpPr/>
           <p:nvPr/>
         </p:nvSpPr>
         <p:spPr>
           <a:xfrm>
-            <a:off x="374926" y="1333702"/>
-            <a:ext cx="1617934" cy="291519"/>
+            <a:off x="8355277" y="5932425"/>
+            <a:ext cx="313383" cy="240503"/>
           </a:xfrm>
           <a:prstGeom prst="rect">
             <a:avLst/>
           </a:prstGeom>
           <a:solidFill>
-            <a:srgbClr val="020201"/>
+            <a:srgbClr val="FEFEFE"/>
           </a:solidFill>
-          <a:ln>
-            <a:noFill/>
+          <a:ln w="15875">
+            <a:solidFill>
+              <a:srgbClr val="252625"/>
+            </a:solidFill>
           </a:ln>
         </p:spPr>
         <p:style>
@@ -5058,23 +3356,25 @@
       </p:sp>
       <p:sp>
         <p:nvSpPr>
-          <p:cNvPr id="58" name="Rectangle 57"/>
+          <p:cNvPr id="8" name="Rectangle 7"/>
           <p:cNvSpPr/>
           <p:nvPr/>
         </p:nvSpPr>
         <p:spPr>
           <a:xfrm>
-            <a:off x="1592021" y="1792845"/>
-            <a:ext cx="1319126" cy="211351"/>
+            <a:off x="8384429" y="6107336"/>
+            <a:ext cx="371687" cy="422703"/>
           </a:xfrm>
           <a:prstGeom prst="rect">
             <a:avLst/>
           </a:prstGeom>
           <a:solidFill>
-            <a:srgbClr val="010101"/>
+            <a:srgbClr val="FDFDFD"/>
           </a:solidFill>
-          <a:ln>
-            <a:noFill/>
+          <a:ln w="15875">
+            <a:solidFill>
+              <a:srgbClr val="020101"/>
+            </a:solidFill>
           </a:ln>
         </p:spPr>
         <p:style>
@@ -5099,22 +3399,1390 @@
           </a:p>
         </p:txBody>
       </p:sp>
-      <p:sp>
-        <p:nvSpPr>
-          <p:cNvPr id="59" name="Rectangle 58"/>
+      <p:pic>
+        <p:nvPicPr>
+          <p:cNvPr id="9" name="Picture 8" descr="image.png"/>
+          <p:cNvPicPr>
+            <a:picLocks noChangeAspect="1"/>
+          </p:cNvPicPr>
+          <p:nvPr/>
+        </p:nvPicPr>
+        <p:blipFill>
+          <a:blip r:embed="rId2"/>
+          <a:stretch>
+            <a:fillRect/>
+          </a:stretch>
+        </p:blipFill>
+        <p:spPr>
+          <a:xfrm>
+            <a:off x="8151213" y="0"/>
+            <a:ext cx="4037547" cy="6858000"/>
+          </a:xfrm>
+          <a:prstGeom prst="rect">
+            <a:avLst/>
+          </a:prstGeom>
+        </p:spPr>
+      </p:pic>
+      <p:pic>
+        <p:nvPicPr>
+          <p:cNvPr id="10" name="Picture 9" descr="residual-154.png"/>
+          <p:cNvPicPr>
+            <a:picLocks noChangeAspect="1"/>
+          </p:cNvPicPr>
+          <p:nvPr/>
+        </p:nvPicPr>
+        <p:blipFill>
+          <a:blip r:embed="rId3"/>
+          <a:stretch>
+            <a:fillRect/>
+          </a:stretch>
+        </p:blipFill>
+        <p:spPr>
+          <a:xfrm>
+            <a:off x="8712388" y="0"/>
+            <a:ext cx="597615" cy="947438"/>
+          </a:xfrm>
+          <a:prstGeom prst="rect">
+            <a:avLst/>
+          </a:prstGeom>
+        </p:spPr>
+      </p:pic>
+      <p:pic>
+        <p:nvPicPr>
+          <p:cNvPr id="11" name="Picture 10" descr="residual-114.png"/>
+          <p:cNvPicPr>
+            <a:picLocks noChangeAspect="1"/>
+          </p:cNvPicPr>
+          <p:nvPr/>
+        </p:nvPicPr>
+        <p:blipFill>
+          <a:blip r:embed="rId4"/>
+          <a:stretch>
+            <a:fillRect/>
+          </a:stretch>
+        </p:blipFill>
+        <p:spPr>
+          <a:xfrm>
+            <a:off x="323910" y="1676238"/>
+            <a:ext cx="685071" cy="736087"/>
+          </a:xfrm>
+          <a:prstGeom prst="rect">
+            <a:avLst/>
+          </a:prstGeom>
+        </p:spPr>
+      </p:pic>
+      <p:pic>
+        <p:nvPicPr>
+          <p:cNvPr id="12" name="Picture 11" descr="image.png"/>
+          <p:cNvPicPr>
+            <a:picLocks noChangeAspect="1"/>
+          </p:cNvPicPr>
+          <p:nvPr/>
+        </p:nvPicPr>
+        <p:blipFill>
+          <a:blip r:embed="rId5"/>
+          <a:stretch>
+            <a:fillRect/>
+          </a:stretch>
+        </p:blipFill>
+        <p:spPr>
+          <a:xfrm>
+            <a:off x="4274001" y="1763693"/>
+            <a:ext cx="4270763" cy="2186397"/>
+          </a:xfrm>
+          <a:prstGeom prst="rect">
+            <a:avLst/>
+          </a:prstGeom>
+        </p:spPr>
+      </p:pic>
+      <p:pic>
+        <p:nvPicPr>
+          <p:cNvPr id="13" name="Picture 12" descr="residual-94.png"/>
+          <p:cNvPicPr>
+            <a:picLocks noChangeAspect="1"/>
+          </p:cNvPicPr>
+          <p:nvPr/>
+        </p:nvPicPr>
+        <p:blipFill>
+          <a:blip r:embed="rId6"/>
+          <a:stretch>
+            <a:fillRect/>
+          </a:stretch>
+        </p:blipFill>
+        <p:spPr>
+          <a:xfrm>
+            <a:off x="323910" y="2550797"/>
+            <a:ext cx="699647" cy="670495"/>
+          </a:xfrm>
+          <a:prstGeom prst="rect">
+            <a:avLst/>
+          </a:prstGeom>
+        </p:spPr>
+      </p:pic>
+      <p:pic>
+        <p:nvPicPr>
+          <p:cNvPr id="14" name="Picture 13" descr="residual-81.png"/>
+          <p:cNvPicPr>
+            <a:picLocks noChangeAspect="1"/>
+          </p:cNvPicPr>
+          <p:nvPr/>
+        </p:nvPicPr>
+        <p:blipFill>
+          <a:blip r:embed="rId7"/>
+          <a:stretch>
+            <a:fillRect/>
+          </a:stretch>
+        </p:blipFill>
+        <p:spPr>
+          <a:xfrm>
+            <a:off x="323910" y="3330612"/>
+            <a:ext cx="699647" cy="714223"/>
+          </a:xfrm>
+          <a:prstGeom prst="rect">
+            <a:avLst/>
+          </a:prstGeom>
+        </p:spPr>
+      </p:pic>
+      <p:pic>
+        <p:nvPicPr>
+          <p:cNvPr id="15" name="Picture 14" descr="image.png"/>
+          <p:cNvPicPr>
+            <a:picLocks noChangeAspect="1"/>
+          </p:cNvPicPr>
+          <p:nvPr/>
+        </p:nvPicPr>
+        <p:blipFill>
+          <a:blip r:embed="rId8"/>
+          <a:stretch>
+            <a:fillRect/>
+          </a:stretch>
+        </p:blipFill>
+        <p:spPr>
+          <a:xfrm>
+            <a:off x="4237562" y="4117715"/>
+            <a:ext cx="3920939" cy="1719965"/>
+          </a:xfrm>
+          <a:prstGeom prst="rect">
+            <a:avLst/>
+          </a:prstGeom>
+        </p:spPr>
+      </p:pic>
+      <p:pic>
+        <p:nvPicPr>
+          <p:cNvPr id="16" name="Picture 15" descr="residual-48.png"/>
+          <p:cNvPicPr>
+            <a:picLocks noChangeAspect="1"/>
+          </p:cNvPicPr>
+          <p:nvPr/>
+        </p:nvPicPr>
+        <p:blipFill>
+          <a:blip r:embed="rId9"/>
+          <a:stretch>
+            <a:fillRect/>
+          </a:stretch>
+        </p:blipFill>
+        <p:spPr>
+          <a:xfrm>
+            <a:off x="323910" y="4205171"/>
+            <a:ext cx="685071" cy="663207"/>
+          </a:xfrm>
+          <a:prstGeom prst="rect">
+            <a:avLst/>
+          </a:prstGeom>
+        </p:spPr>
+      </p:pic>
+      <p:pic>
+        <p:nvPicPr>
+          <p:cNvPr id="17" name="Picture 16" descr="residual-28.png"/>
+          <p:cNvPicPr>
+            <a:picLocks noChangeAspect="1"/>
+          </p:cNvPicPr>
+          <p:nvPr/>
+        </p:nvPicPr>
+        <p:blipFill>
+          <a:blip r:embed="rId10"/>
+          <a:stretch>
+            <a:fillRect/>
+          </a:stretch>
+        </p:blipFill>
+        <p:spPr>
+          <a:xfrm>
+            <a:off x="323910" y="4977698"/>
+            <a:ext cx="692359" cy="728799"/>
+          </a:xfrm>
+          <a:prstGeom prst="rect">
+            <a:avLst/>
+          </a:prstGeom>
+        </p:spPr>
+      </p:pic>
+      <p:sp>
+        <p:nvSpPr>
+          <p:cNvPr id="18" name="TextBox 17"/>
+          <p:cNvSpPr txBox="1"/>
+          <p:nvPr/>
+        </p:nvSpPr>
+        <p:spPr>
+          <a:xfrm>
+            <a:off x="148998" y="7287"/>
+            <a:ext cx="8279158" cy="983878"/>
+          </a:xfrm>
+          <a:prstGeom prst="rect">
+            <a:avLst/>
+          </a:prstGeom>
+          <a:noFill/>
+        </p:spPr>
+        <p:txBody>
+          <a:bodyPr wrap="none" lIns="0" rIns="0" tIns="0" bIns="0" anchor="ctr">
+            <a:spAutoFit/>
+          </a:bodyPr>
+          <a:lstStyle/>
+          <a:p>
+            <a:pPr>
+              <a:defRPr sz="2000">
+                <a:solidFill>
+                  <a:srgbClr val="030303"/>
+                </a:solidFill>
+                <a:latin typeface="Malgun Gothic"/>
+              </a:defRPr>
+            </a:pPr>
+            <a:r>
+              <a:t>Why Is One Punch Man So Strong?</a:t>
+            </a:r>
+          </a:p>
+        </p:txBody>
+      </p:sp>
+      <p:sp>
+        <p:nvSpPr>
+          <p:cNvPr id="19" name="TextBox 18"/>
+          <p:cNvSpPr txBox="1"/>
+          <p:nvPr/>
+        </p:nvSpPr>
+        <p:spPr>
+          <a:xfrm>
+            <a:off x="294758" y="998454"/>
+            <a:ext cx="6777832" cy="218639"/>
+          </a:xfrm>
+          <a:prstGeom prst="rect">
+            <a:avLst/>
+          </a:prstGeom>
+          <a:noFill/>
+        </p:spPr>
+        <p:txBody>
+          <a:bodyPr wrap="none" lIns="0" rIns="0" tIns="0" bIns="0" anchor="ctr">
+            <a:spAutoFit/>
+          </a:bodyPr>
+          <a:lstStyle/>
+          <a:p>
+            <a:pPr>
+              <a:defRPr sz="1048">
+                <a:solidFill>
+                  <a:srgbClr val="000000"/>
+                </a:solidFill>
+                <a:latin typeface="Malgun Gothic"/>
+              </a:defRPr>
+            </a:pPr>
+            <a:r>
+              <a:t>Narrative, psychological, and structural reasons behind Saitama's overwhelming power</a:t>
+            </a:r>
+          </a:p>
+        </p:txBody>
+      </p:sp>
+      <p:sp>
+        <p:nvSpPr>
+          <p:cNvPr id="20" name="TextBox 19"/>
+          <p:cNvSpPr txBox="1"/>
+          <p:nvPr/>
+        </p:nvSpPr>
+        <p:spPr>
+          <a:xfrm>
+            <a:off x="331198" y="1355566"/>
+            <a:ext cx="1486750" cy="225927"/>
+          </a:xfrm>
+          <a:prstGeom prst="rect">
+            <a:avLst/>
+          </a:prstGeom>
+          <a:noFill/>
+        </p:spPr>
+        <p:txBody>
+          <a:bodyPr wrap="none" lIns="0" rIns="0" tIns="0" bIns="0" anchor="ctr">
+            <a:spAutoFit/>
+          </a:bodyPr>
+          <a:lstStyle/>
+          <a:p>
+            <a:pPr>
+              <a:defRPr sz="1287">
+                <a:solidFill>
+                  <a:srgbClr val="FFFFFF"/>
+                </a:solidFill>
+                <a:latin typeface="Malgun Gothic"/>
+              </a:defRPr>
+            </a:pPr>
+            <a:r>
+              <a:t>A) CORE REASONS</a:t>
+            </a:r>
+          </a:p>
+        </p:txBody>
+      </p:sp>
+      <p:sp>
+        <p:nvSpPr>
+          <p:cNvPr id="21" name="TextBox 20"/>
+          <p:cNvSpPr txBox="1"/>
+          <p:nvPr/>
+        </p:nvSpPr>
+        <p:spPr>
+          <a:xfrm>
+            <a:off x="4354169" y="1399294"/>
+            <a:ext cx="3316036" cy="201168"/>
+          </a:xfrm>
+          <a:prstGeom prst="rect">
+            <a:avLst/>
+          </a:prstGeom>
+          <a:noFill/>
+        </p:spPr>
+        <p:txBody>
+          <a:bodyPr wrap="none" lIns="0" rIns="0" tIns="0" bIns="0" anchor="ctr">
+            <a:spAutoFit/>
+          </a:bodyPr>
+          <a:lstStyle/>
+          <a:p>
+            <a:pPr>
+              <a:defRPr sz="1001">
+                <a:solidFill>
+                  <a:srgbClr val="F8D264"/>
+                </a:solidFill>
+                <a:latin typeface="Malgun Gothic"/>
+              </a:defRPr>
+            </a:pPr>
+            <a:r>
+              <a:t>B HOW HE DIFFERS FROM TYPICAL SHONEN HEROES</a:t>
+            </a:r>
+          </a:p>
+        </p:txBody>
+      </p:sp>
+      <p:sp>
+        <p:nvSpPr>
+          <p:cNvPr id="22" name="TextBox 21"/>
+          <p:cNvSpPr txBox="1"/>
+          <p:nvPr/>
+        </p:nvSpPr>
+        <p:spPr>
+          <a:xfrm>
+            <a:off x="1577445" y="1770981"/>
+            <a:ext cx="1340990" cy="201168"/>
+          </a:xfrm>
+          <a:prstGeom prst="rect">
+            <a:avLst/>
+          </a:prstGeom>
+          <a:noFill/>
+        </p:spPr>
+        <p:txBody>
+          <a:bodyPr wrap="none" lIns="0" rIns="0" tIns="0" bIns="0" anchor="ctr">
+            <a:spAutoFit/>
+          </a:bodyPr>
+          <a:lstStyle/>
+          <a:p>
+            <a:pPr>
+              <a:defRPr sz="946">
+                <a:solidFill>
+                  <a:srgbClr val="010101"/>
+                </a:solidFill>
+                <a:latin typeface="Malgun Gothic"/>
+              </a:defRPr>
+            </a:pPr>
+            <a:r>
+              <a:t>BUILT AS A SATIRE</a:t>
+            </a:r>
+          </a:p>
+        </p:txBody>
+      </p:sp>
+      <p:sp>
+        <p:nvSpPr>
+          <p:cNvPr id="23" name="TextBox 22"/>
+          <p:cNvSpPr txBox="1"/>
+          <p:nvPr/>
+        </p:nvSpPr>
+        <p:spPr>
+          <a:xfrm>
+            <a:off x="1140165" y="1865725"/>
+            <a:ext cx="218639" cy="400839"/>
+          </a:xfrm>
+          <a:prstGeom prst="rect">
+            <a:avLst/>
+          </a:prstGeom>
+          <a:noFill/>
+        </p:spPr>
+        <p:txBody>
+          <a:bodyPr wrap="none" lIns="0" rIns="0" tIns="0" bIns="0" anchor="ctr">
+            <a:spAutoFit/>
+          </a:bodyPr>
+          <a:lstStyle/>
+          <a:p>
+            <a:pPr>
+              <a:defRPr sz="2000">
+                <a:solidFill>
+                  <a:srgbClr val="050400"/>
+                </a:solidFill>
+                <a:latin typeface="Malgun Gothic"/>
+              </a:defRPr>
+            </a:pPr>
+            <a:r>
+              <a:t>1</a:t>
+            </a:r>
+          </a:p>
+        </p:txBody>
+      </p:sp>
+      <p:sp>
+        <p:nvSpPr>
+          <p:cNvPr id="24" name="TextBox 23"/>
+          <p:cNvSpPr txBox="1"/>
+          <p:nvPr/>
+        </p:nvSpPr>
+        <p:spPr>
+          <a:xfrm>
+            <a:off x="1562869" y="1967757"/>
+            <a:ext cx="2368597" cy="201168"/>
+          </a:xfrm>
+          <a:prstGeom prst="rect">
+            <a:avLst/>
+          </a:prstGeom>
+          <a:noFill/>
+        </p:spPr>
+        <p:txBody>
+          <a:bodyPr wrap="none" lIns="0" rIns="0" tIns="0" bIns="0" anchor="ctr">
+            <a:spAutoFit/>
+          </a:bodyPr>
+          <a:lstStyle/>
+          <a:p>
+            <a:pPr>
+              <a:defRPr sz="700">
+                <a:solidFill>
+                  <a:srgbClr val="040303"/>
+                </a:solidFill>
+                <a:latin typeface="Malgun Gothic"/>
+              </a:defRPr>
+            </a:pPr>
+            <a:r>
+              <a:t>Saitama was designed to parody power-scaling</a:t>
+            </a:r>
+          </a:p>
+        </p:txBody>
+      </p:sp>
+      <p:sp>
+        <p:nvSpPr>
+          <p:cNvPr id="25" name="TextBox 24"/>
+          <p:cNvSpPr txBox="1"/>
+          <p:nvPr/>
+        </p:nvSpPr>
+        <p:spPr>
+          <a:xfrm>
+            <a:off x="1577445" y="2142669"/>
+            <a:ext cx="2171821" cy="201168"/>
+          </a:xfrm>
+          <a:prstGeom prst="rect">
+            <a:avLst/>
+          </a:prstGeom>
+          <a:noFill/>
+        </p:spPr>
+        <p:txBody>
+          <a:bodyPr wrap="none" lIns="0" rIns="0" tIns="0" bIns="0" anchor="ctr">
+            <a:spAutoFit/>
+          </a:bodyPr>
+          <a:lstStyle/>
+          <a:p>
+            <a:pPr>
+              <a:defRPr sz="700">
+                <a:solidFill>
+                  <a:srgbClr val="040303"/>
+                </a:solidFill>
+                <a:latin typeface="Malgun Gothic"/>
+              </a:defRPr>
+            </a:pPr>
+            <a:r>
+              <a:t>stories—his absurd strength is the premise</a:t>
+            </a:r>
+          </a:p>
+        </p:txBody>
+      </p:sp>
+      <p:sp>
+        <p:nvSpPr>
+          <p:cNvPr id="26" name="TextBox 25"/>
+          <p:cNvSpPr txBox="1"/>
+          <p:nvPr/>
+        </p:nvSpPr>
+        <p:spPr>
+          <a:xfrm>
+            <a:off x="1562869" y="2273853"/>
+            <a:ext cx="816255" cy="201168"/>
+          </a:xfrm>
+          <a:prstGeom prst="rect">
+            <a:avLst/>
+          </a:prstGeom>
+          <a:noFill/>
+        </p:spPr>
+        <p:txBody>
+          <a:bodyPr wrap="none" lIns="0" rIns="0" tIns="0" bIns="0" anchor="ctr">
+            <a:spAutoFit/>
+          </a:bodyPr>
+          <a:lstStyle/>
+          <a:p>
+            <a:pPr>
+              <a:defRPr sz="706">
+                <a:solidFill>
+                  <a:srgbClr val="000000"/>
+                </a:solidFill>
+                <a:latin typeface="Malgun Gothic"/>
+              </a:defRPr>
+            </a:pPr>
+            <a:r>
+              <a:t>not the reward.</a:t>
+            </a:r>
+          </a:p>
+        </p:txBody>
+      </p:sp>
+      <p:sp>
+        <p:nvSpPr>
+          <p:cNvPr id="27" name="TextBox 26"/>
+          <p:cNvSpPr txBox="1"/>
+          <p:nvPr/>
+        </p:nvSpPr>
+        <p:spPr>
+          <a:xfrm>
+            <a:off x="1570157" y="2601812"/>
+            <a:ext cx="2040637" cy="201168"/>
+          </a:xfrm>
+          <a:prstGeom prst="rect">
+            <a:avLst/>
+          </a:prstGeom>
+          <a:noFill/>
+        </p:spPr>
+        <p:txBody>
+          <a:bodyPr wrap="none" lIns="0" rIns="0" tIns="0" bIns="0" anchor="ctr">
+            <a:spAutoFit/>
+          </a:bodyPr>
+          <a:lstStyle/>
+          <a:p>
+            <a:pPr>
+              <a:defRPr sz="989">
+                <a:solidFill>
+                  <a:srgbClr val="020202"/>
+                </a:solidFill>
+                <a:latin typeface="Malgun Gothic"/>
+              </a:defRPr>
+            </a:pPr>
+            <a:r>
+              <a:t>ALREADY AT THE FINISH LINE</a:t>
+            </a:r>
+          </a:p>
+        </p:txBody>
+      </p:sp>
+      <p:sp>
+        <p:nvSpPr>
+          <p:cNvPr id="28" name="TextBox 27"/>
+          <p:cNvSpPr txBox="1"/>
+          <p:nvPr/>
+        </p:nvSpPr>
+        <p:spPr>
+          <a:xfrm>
+            <a:off x="1096437" y="2667404"/>
+            <a:ext cx="342535" cy="451855"/>
+          </a:xfrm>
+          <a:prstGeom prst="rect">
+            <a:avLst/>
+          </a:prstGeom>
+          <a:noFill/>
+        </p:spPr>
+        <p:txBody>
+          <a:bodyPr wrap="none" lIns="0" rIns="0" tIns="0" bIns="0" anchor="ctr">
+            <a:spAutoFit/>
+          </a:bodyPr>
+          <a:lstStyle/>
+          <a:p>
+            <a:pPr>
+              <a:defRPr sz="2000">
+                <a:solidFill>
+                  <a:srgbClr val="050400"/>
+                </a:solidFill>
+                <a:latin typeface="Malgun Gothic"/>
+              </a:defRPr>
+            </a:pPr>
+            <a:r>
+              <a:t>2</a:t>
+            </a:r>
+          </a:p>
+        </p:txBody>
+      </p:sp>
+      <p:sp>
+        <p:nvSpPr>
+          <p:cNvPr id="29" name="TextBox 28"/>
+          <p:cNvSpPr txBox="1"/>
+          <p:nvPr/>
+        </p:nvSpPr>
+        <p:spPr>
+          <a:xfrm>
+            <a:off x="1562869" y="2798588"/>
+            <a:ext cx="2346733" cy="201168"/>
+          </a:xfrm>
+          <a:prstGeom prst="rect">
+            <a:avLst/>
+          </a:prstGeom>
+          <a:noFill/>
+        </p:spPr>
+        <p:txBody>
+          <a:bodyPr wrap="none" lIns="0" rIns="0" tIns="0" bIns="0" anchor="ctr">
+            <a:spAutoFit/>
+          </a:bodyPr>
+          <a:lstStyle/>
+          <a:p>
+            <a:pPr>
+              <a:defRPr sz="700">
+                <a:solidFill>
+                  <a:srgbClr val="030303"/>
+                </a:solidFill>
+                <a:latin typeface="Malgun Gothic"/>
+              </a:defRPr>
+            </a:pPr>
+            <a:r>
+              <a:t>While others train and climb for years to reach</a:t>
+            </a:r>
+          </a:p>
+        </p:txBody>
+      </p:sp>
+      <p:sp>
+        <p:nvSpPr>
+          <p:cNvPr id="30" name="TextBox 29"/>
+          <p:cNvSpPr txBox="1"/>
+          <p:nvPr/>
+        </p:nvSpPr>
+        <p:spPr>
+          <a:xfrm>
+            <a:off x="1555581" y="2951636"/>
+            <a:ext cx="2215549" cy="201168"/>
+          </a:xfrm>
+          <a:prstGeom prst="rect">
+            <a:avLst/>
+          </a:prstGeom>
+          <a:noFill/>
+        </p:spPr>
+        <p:txBody>
+          <a:bodyPr wrap="none" lIns="0" rIns="0" tIns="0" bIns="0" anchor="ctr">
+            <a:spAutoFit/>
+          </a:bodyPr>
+          <a:lstStyle/>
+          <a:p>
+            <a:pPr>
+              <a:defRPr sz="700">
+                <a:solidFill>
+                  <a:srgbClr val="050404"/>
+                </a:solidFill>
+                <a:latin typeface="Malgun Gothic"/>
+              </a:defRPr>
+            </a:pPr>
+            <a:r>
+              <a:t>the top, he begins where most protagonists</a:t>
+            </a:r>
+          </a:p>
+        </p:txBody>
+      </p:sp>
+      <p:sp>
+        <p:nvSpPr>
+          <p:cNvPr id="31" name="TextBox 30"/>
+          <p:cNvSpPr txBox="1"/>
+          <p:nvPr/>
+        </p:nvSpPr>
+        <p:spPr>
+          <a:xfrm>
+            <a:off x="1570157" y="3126548"/>
+            <a:ext cx="1078622" cy="201168"/>
+          </a:xfrm>
+          <a:prstGeom prst="rect">
+            <a:avLst/>
+          </a:prstGeom>
+          <a:noFill/>
+        </p:spPr>
+        <p:txBody>
+          <a:bodyPr wrap="none" lIns="0" rIns="0" tIns="0" bIns="0" anchor="ctr">
+            <a:spAutoFit/>
+          </a:bodyPr>
+          <a:lstStyle/>
+          <a:p>
+            <a:pPr>
+              <a:defRPr sz="700">
+                <a:solidFill>
+                  <a:srgbClr val="030302"/>
+                </a:solidFill>
+                <a:latin typeface="Malgun Gothic"/>
+              </a:defRPr>
+            </a:pPr>
+            <a:r>
+              <a:t>are supposed to end.</a:t>
+            </a:r>
+          </a:p>
+        </p:txBody>
+      </p:sp>
+      <p:sp>
+        <p:nvSpPr>
+          <p:cNvPr id="32" name="TextBox 31"/>
+          <p:cNvSpPr txBox="1"/>
+          <p:nvPr/>
+        </p:nvSpPr>
+        <p:spPr>
+          <a:xfrm>
+            <a:off x="1562869" y="3418068"/>
+            <a:ext cx="1996909" cy="201168"/>
+          </a:xfrm>
+          <a:prstGeom prst="rect">
+            <a:avLst/>
+          </a:prstGeom>
+          <a:noFill/>
+        </p:spPr>
+        <p:txBody>
+          <a:bodyPr wrap="none" lIns="0" rIns="0" tIns="0" bIns="0" anchor="ctr">
+            <a:spAutoFit/>
+          </a:bodyPr>
+          <a:lstStyle/>
+          <a:p>
+            <a:pPr>
+              <a:defRPr sz="1032">
+                <a:solidFill>
+                  <a:srgbClr val="000000"/>
+                </a:solidFill>
+                <a:latin typeface="Malgun Gothic"/>
+              </a:defRPr>
+            </a:pPr>
+            <a:r>
+              <a:t>LIMIT-BREAKING SIMPLICITY</a:t>
+            </a:r>
+          </a:p>
+        </p:txBody>
+      </p:sp>
+      <p:sp>
+        <p:nvSpPr>
+          <p:cNvPr id="33" name="TextBox 32"/>
+          <p:cNvSpPr txBox="1"/>
+          <p:nvPr/>
+        </p:nvSpPr>
+        <p:spPr>
+          <a:xfrm>
+            <a:off x="1132877" y="3512811"/>
+            <a:ext cx="269655" cy="400839"/>
+          </a:xfrm>
+          <a:prstGeom prst="rect">
+            <a:avLst/>
+          </a:prstGeom>
+          <a:noFill/>
+        </p:spPr>
+        <p:txBody>
+          <a:bodyPr wrap="none" lIns="0" rIns="0" tIns="0" bIns="0" anchor="ctr">
+            <a:spAutoFit/>
+          </a:bodyPr>
+          <a:lstStyle/>
+          <a:p>
+            <a:pPr>
+              <a:defRPr sz="2000">
+                <a:solidFill>
+                  <a:srgbClr val="050400"/>
+                </a:solidFill>
+                <a:latin typeface="Malgun Gothic"/>
+              </a:defRPr>
+            </a:pPr>
+            <a:r>
+              <a:t>3</a:t>
+            </a:r>
+          </a:p>
+        </p:txBody>
+      </p:sp>
+      <p:sp>
+        <p:nvSpPr>
+          <p:cNvPr id="34" name="TextBox 33"/>
+          <p:cNvSpPr txBox="1"/>
+          <p:nvPr/>
+        </p:nvSpPr>
+        <p:spPr>
+          <a:xfrm>
+            <a:off x="1562869" y="3643995"/>
+            <a:ext cx="2470629" cy="201168"/>
+          </a:xfrm>
+          <a:prstGeom prst="rect">
+            <a:avLst/>
+          </a:prstGeom>
+          <a:noFill/>
+        </p:spPr>
+        <p:txBody>
+          <a:bodyPr wrap="none" lIns="0" rIns="0" tIns="0" bIns="0" anchor="ctr">
+            <a:spAutoFit/>
+          </a:bodyPr>
+          <a:lstStyle/>
+          <a:p>
+            <a:pPr>
+              <a:defRPr sz="700">
+                <a:solidFill>
+                  <a:srgbClr val="050504"/>
+                </a:solidFill>
+                <a:latin typeface="Malgun Gothic"/>
+              </a:defRPr>
+            </a:pPr>
+            <a:r>
+              <a:t>His routine is both disciplined and comically extreme:</a:t>
+            </a:r>
+          </a:p>
+        </p:txBody>
+      </p:sp>
+      <p:sp>
+        <p:nvSpPr>
+          <p:cNvPr id="35" name="TextBox 34"/>
+          <p:cNvSpPr txBox="1"/>
+          <p:nvPr/>
+        </p:nvSpPr>
+        <p:spPr>
+          <a:xfrm>
+            <a:off x="1555581" y="3775179"/>
+            <a:ext cx="2011485" cy="201168"/>
+          </a:xfrm>
+          <a:prstGeom prst="rect">
+            <a:avLst/>
+          </a:prstGeom>
+          <a:noFill/>
+        </p:spPr>
+        <p:txBody>
+          <a:bodyPr wrap="none" lIns="0" rIns="0" tIns="0" bIns="0" anchor="ctr">
+            <a:spAutoFit/>
+          </a:bodyPr>
+          <a:lstStyle/>
+          <a:p>
+            <a:pPr>
+              <a:defRPr sz="700">
+                <a:solidFill>
+                  <a:srgbClr val="010101"/>
+                </a:solidFill>
+                <a:latin typeface="Malgun Gothic"/>
+              </a:defRPr>
+            </a:pPr>
+            <a:r>
+              <a:t>100 push-ups, 100 sit-ups, 100 squats,</a:t>
+            </a:r>
+          </a:p>
+        </p:txBody>
+      </p:sp>
+      <p:sp>
+        <p:nvSpPr>
+          <p:cNvPr id="36" name="TextBox 35"/>
+          <p:cNvSpPr txBox="1"/>
+          <p:nvPr/>
+        </p:nvSpPr>
+        <p:spPr>
+          <a:xfrm>
+            <a:off x="1562869" y="3942803"/>
+            <a:ext cx="1399294" cy="201168"/>
+          </a:xfrm>
+          <a:prstGeom prst="rect">
+            <a:avLst/>
+          </a:prstGeom>
+          <a:noFill/>
+        </p:spPr>
+        <p:txBody>
+          <a:bodyPr wrap="none" lIns="0" rIns="0" tIns="0" bIns="0" anchor="ctr">
+            <a:spAutoFit/>
+          </a:bodyPr>
+          <a:lstStyle/>
+          <a:p>
+            <a:pPr>
+              <a:defRPr sz="700">
+                <a:solidFill>
+                  <a:srgbClr val="020201"/>
+                </a:solidFill>
+                <a:latin typeface="Malgun Gothic"/>
+              </a:defRPr>
+            </a:pPr>
+            <a:r>
+              <a:t>and a 10 km run every day.</a:t>
+            </a:r>
+          </a:p>
+        </p:txBody>
+      </p:sp>
+      <p:sp>
+        <p:nvSpPr>
+          <p:cNvPr id="37" name="TextBox 36"/>
+          <p:cNvSpPr txBox="1"/>
+          <p:nvPr/>
+        </p:nvSpPr>
+        <p:spPr>
+          <a:xfrm>
+            <a:off x="1577445" y="4263475"/>
+            <a:ext cx="1792845" cy="201168"/>
+          </a:xfrm>
+          <a:prstGeom prst="rect">
+            <a:avLst/>
+          </a:prstGeom>
+          <a:noFill/>
+        </p:spPr>
+        <p:txBody>
+          <a:bodyPr wrap="none" lIns="0" rIns="0" tIns="0" bIns="0" anchor="ctr">
+            <a:spAutoFit/>
+          </a:bodyPr>
+          <a:lstStyle/>
+          <a:p>
+            <a:pPr>
+              <a:defRPr sz="903">
+                <a:solidFill>
+                  <a:srgbClr val="010101"/>
+                </a:solidFill>
+                <a:latin typeface="Malgun Gothic"/>
+              </a:defRPr>
+            </a:pPr>
+            <a:r>
+              <a:t>EMOTIONALLY UNSHAKEN</a:t>
+            </a:r>
+          </a:p>
+        </p:txBody>
+      </p:sp>
+      <p:sp>
+        <p:nvSpPr>
+          <p:cNvPr id="38" name="TextBox 37"/>
+          <p:cNvSpPr txBox="1"/>
+          <p:nvPr/>
+        </p:nvSpPr>
+        <p:spPr>
+          <a:xfrm>
+            <a:off x="1103725" y="4299914"/>
+            <a:ext cx="327959" cy="466431"/>
+          </a:xfrm>
+          <a:prstGeom prst="rect">
+            <a:avLst/>
+          </a:prstGeom>
+          <a:noFill/>
+        </p:spPr>
+        <p:txBody>
+          <a:bodyPr wrap="none" lIns="0" rIns="0" tIns="0" bIns="0" anchor="ctr">
+            <a:spAutoFit/>
+          </a:bodyPr>
+          <a:lstStyle/>
+          <a:p>
+            <a:pPr>
+              <a:defRPr sz="2000">
+                <a:solidFill>
+                  <a:srgbClr val="040300"/>
+                </a:solidFill>
+                <a:latin typeface="Malgun Gothic"/>
+              </a:defRPr>
+            </a:pPr>
+            <a:r>
+              <a:t>4</a:t>
+            </a:r>
+          </a:p>
+        </p:txBody>
+      </p:sp>
+      <p:sp>
+        <p:nvSpPr>
+          <p:cNvPr id="39" name="TextBox 38"/>
+          <p:cNvSpPr txBox="1"/>
+          <p:nvPr/>
+        </p:nvSpPr>
+        <p:spPr>
+          <a:xfrm>
+            <a:off x="1555581" y="4445674"/>
+            <a:ext cx="2062501" cy="201168"/>
+          </a:xfrm>
+          <a:prstGeom prst="rect">
+            <a:avLst/>
+          </a:prstGeom>
+          <a:noFill/>
+        </p:spPr>
+        <p:txBody>
+          <a:bodyPr wrap="none" lIns="0" rIns="0" tIns="0" bIns="0" anchor="ctr">
+            <a:spAutoFit/>
+          </a:bodyPr>
+          <a:lstStyle/>
+          <a:p>
+            <a:pPr>
+              <a:defRPr sz="700">
+                <a:solidFill>
+                  <a:srgbClr val="030303"/>
+                </a:solidFill>
+                <a:latin typeface="Malgun Gothic"/>
+              </a:defRPr>
+            </a:pPr>
+            <a:r>
+              <a:t>He fights without fear, ego, or hesitation.</a:t>
+            </a:r>
+          </a:p>
+        </p:txBody>
+      </p:sp>
+      <p:sp>
+        <p:nvSpPr>
+          <p:cNvPr id="40" name="TextBox 39"/>
+          <p:cNvSpPr txBox="1"/>
+          <p:nvPr/>
+        </p:nvSpPr>
+        <p:spPr>
+          <a:xfrm>
+            <a:off x="1548293" y="4598722"/>
+            <a:ext cx="2033349" cy="201168"/>
+          </a:xfrm>
+          <a:prstGeom prst="rect">
+            <a:avLst/>
+          </a:prstGeom>
+          <a:noFill/>
+        </p:spPr>
+        <p:txBody>
+          <a:bodyPr wrap="none" lIns="0" rIns="0" tIns="0" bIns="0" anchor="ctr">
+            <a:spAutoFit/>
+          </a:bodyPr>
+          <a:lstStyle/>
+          <a:p>
+            <a:pPr>
+              <a:defRPr sz="713">
+                <a:solidFill>
+                  <a:srgbClr val="030303"/>
+                </a:solidFill>
+                <a:latin typeface="Malgun Gothic"/>
+              </a:defRPr>
+            </a:pPr>
+            <a:r>
+              <a:t>No need to prove himself—he's already</a:t>
+            </a:r>
+          </a:p>
+        </p:txBody>
+      </p:sp>
+      <p:sp>
+        <p:nvSpPr>
+          <p:cNvPr id="41" name="TextBox 40"/>
+          <p:cNvSpPr txBox="1"/>
+          <p:nvPr/>
+        </p:nvSpPr>
+        <p:spPr>
+          <a:xfrm>
+            <a:off x="1562869" y="4766346"/>
+            <a:ext cx="1610646" cy="201168"/>
+          </a:xfrm>
+          <a:prstGeom prst="rect">
+            <a:avLst/>
+          </a:prstGeom>
+          <a:noFill/>
+        </p:spPr>
+        <p:txBody>
+          <a:bodyPr wrap="none" lIns="0" rIns="0" tIns="0" bIns="0" anchor="ctr">
+            <a:spAutoFit/>
+          </a:bodyPr>
+          <a:lstStyle/>
+          <a:p>
+            <a:pPr>
+              <a:defRPr sz="700">
+                <a:solidFill>
+                  <a:srgbClr val="040303"/>
+                </a:solidFill>
+                <a:latin typeface="Malgun Gothic"/>
+              </a:defRPr>
+            </a:pPr>
+            <a:r>
+              <a:t>beyond the need for validation.</a:t>
+            </a:r>
+          </a:p>
+        </p:txBody>
+      </p:sp>
+      <p:sp>
+        <p:nvSpPr>
+          <p:cNvPr id="42" name="TextBox 41"/>
+          <p:cNvSpPr txBox="1"/>
+          <p:nvPr/>
+        </p:nvSpPr>
+        <p:spPr>
+          <a:xfrm>
+            <a:off x="1570157" y="5094306"/>
+            <a:ext cx="2434189" cy="201168"/>
+          </a:xfrm>
+          <a:prstGeom prst="rect">
+            <a:avLst/>
+          </a:prstGeom>
+          <a:noFill/>
+        </p:spPr>
+        <p:txBody>
+          <a:bodyPr wrap="none" lIns="0" rIns="0" tIns="0" bIns="0" anchor="ctr">
+            <a:spAutoFit/>
+          </a:bodyPr>
+          <a:lstStyle/>
+          <a:p>
+            <a:pPr>
+              <a:defRPr sz="930">
+                <a:solidFill>
+                  <a:srgbClr val="000000"/>
+                </a:solidFill>
+                <a:latin typeface="Malgun Gothic"/>
+              </a:defRPr>
+            </a:pPr>
+            <a:r>
+              <a:t>THE STORY NEEDS AN UNBEATABLE HERO</a:t>
+            </a:r>
+          </a:p>
+        </p:txBody>
+      </p:sp>
+      <p:sp>
+        <p:nvSpPr>
+          <p:cNvPr id="43" name="TextBox 42"/>
+          <p:cNvSpPr txBox="1"/>
+          <p:nvPr/>
+        </p:nvSpPr>
+        <p:spPr>
+          <a:xfrm>
+            <a:off x="1111013" y="5145321"/>
+            <a:ext cx="298807" cy="429991"/>
+          </a:xfrm>
+          <a:prstGeom prst="rect">
+            <a:avLst/>
+          </a:prstGeom>
+          <a:noFill/>
+        </p:spPr>
+        <p:txBody>
+          <a:bodyPr wrap="none" lIns="0" rIns="0" tIns="0" bIns="0" anchor="ctr">
+            <a:spAutoFit/>
+          </a:bodyPr>
+          <a:lstStyle/>
+          <a:p>
+            <a:pPr>
+              <a:defRPr sz="2000">
+                <a:solidFill>
+                  <a:srgbClr val="040300"/>
+                </a:solidFill>
+                <a:latin typeface="Malgun Gothic"/>
+              </a:defRPr>
+            </a:pPr>
+            <a:r>
+              <a:t>5</a:t>
+            </a:r>
+          </a:p>
+        </p:txBody>
+      </p:sp>
+      <p:sp>
+        <p:nvSpPr>
+          <p:cNvPr id="44" name="TextBox 43"/>
+          <p:cNvSpPr txBox="1"/>
+          <p:nvPr/>
+        </p:nvSpPr>
+        <p:spPr>
+          <a:xfrm>
+            <a:off x="1562869" y="5291081"/>
+            <a:ext cx="2222837" cy="201168"/>
+          </a:xfrm>
+          <a:prstGeom prst="rect">
+            <a:avLst/>
+          </a:prstGeom>
+          <a:noFill/>
+        </p:spPr>
+        <p:txBody>
+          <a:bodyPr wrap="none" lIns="0" rIns="0" tIns="0" bIns="0" anchor="ctr">
+            <a:spAutoFit/>
+          </a:bodyPr>
+          <a:lstStyle/>
+          <a:p>
+            <a:pPr>
+              <a:defRPr sz="700">
+                <a:solidFill>
+                  <a:srgbClr val="020102"/>
+                </a:solidFill>
+                <a:latin typeface="Malgun Gothic"/>
+              </a:defRPr>
+            </a:pPr>
+            <a:r>
+              <a:t>His power lets the series go beyond battles</a:t>
+            </a:r>
+          </a:p>
+        </p:txBody>
+      </p:sp>
+      <p:sp>
+        <p:nvSpPr>
+          <p:cNvPr id="45" name="TextBox 44"/>
+          <p:cNvSpPr txBox="1"/>
+          <p:nvPr/>
+        </p:nvSpPr>
+        <p:spPr>
+          <a:xfrm>
+            <a:off x="1548293" y="5444129"/>
+            <a:ext cx="2244701" cy="201168"/>
+          </a:xfrm>
+          <a:prstGeom prst="rect">
+            <a:avLst/>
+          </a:prstGeom>
+          <a:noFill/>
+        </p:spPr>
+        <p:txBody>
+          <a:bodyPr wrap="none" lIns="0" rIns="0" tIns="0" bIns="0" anchor="ctr">
+            <a:spAutoFit/>
+          </a:bodyPr>
+          <a:lstStyle/>
+          <a:p>
+            <a:pPr>
+              <a:defRPr sz="711">
+                <a:solidFill>
+                  <a:srgbClr val="010101"/>
+                </a:solidFill>
+                <a:latin typeface="Malgun Gothic"/>
+              </a:defRPr>
+            </a:pPr>
+            <a:r>
+              <a:t>to explore boredom, meaning, and identity</a:t>
+            </a:r>
+          </a:p>
+        </p:txBody>
+      </p:sp>
+      <p:sp>
+        <p:nvSpPr>
+          <p:cNvPr id="46" name="TextBox 45"/>
+          <p:cNvSpPr txBox="1"/>
+          <p:nvPr/>
+        </p:nvSpPr>
+        <p:spPr>
+          <a:xfrm>
+            <a:off x="1562869" y="5589889"/>
+            <a:ext cx="1173366" cy="201168"/>
+          </a:xfrm>
+          <a:prstGeom prst="rect">
+            <a:avLst/>
+          </a:prstGeom>
+          <a:noFill/>
+        </p:spPr>
+        <p:txBody>
+          <a:bodyPr wrap="none" lIns="0" rIns="0" tIns="0" bIns="0" anchor="ctr">
+            <a:spAutoFit/>
+          </a:bodyPr>
+          <a:lstStyle/>
+          <a:p>
+            <a:pPr>
+              <a:defRPr sz="700">
+                <a:solidFill>
+                  <a:srgbClr val="020202"/>
+                </a:solidFill>
+                <a:latin typeface="Malgun Gothic"/>
+              </a:defRPr>
+            </a:pPr>
+            <a:r>
+              <a:t>after absolute victory.</a:t>
+            </a:r>
+          </a:p>
+        </p:txBody>
+      </p:sp>
+      <p:sp>
+        <p:nvSpPr>
+          <p:cNvPr id="47" name="TextBox 46"/>
+          <p:cNvSpPr txBox="1"/>
+          <p:nvPr/>
+        </p:nvSpPr>
+        <p:spPr>
+          <a:xfrm>
+            <a:off x="3384867" y="6070896"/>
+            <a:ext cx="4197883" cy="218639"/>
+          </a:xfrm>
+          <a:prstGeom prst="rect">
+            <a:avLst/>
+          </a:prstGeom>
+          <a:noFill/>
+        </p:spPr>
+        <p:txBody>
+          <a:bodyPr wrap="none" lIns="0" rIns="0" tIns="0" bIns="0" anchor="ctr">
+            <a:spAutoFit/>
+          </a:bodyPr>
+          <a:lstStyle/>
+          <a:p>
+            <a:pPr>
+              <a:defRPr sz="1136">
+                <a:solidFill>
+                  <a:srgbClr val="020202"/>
+                </a:solidFill>
+                <a:latin typeface="Malgun Gothic"/>
+              </a:defRPr>
+            </a:pPr>
+            <a:r>
+              <a:t>One Punch Man is powerful as a character because</a:t>
+            </a:r>
+          </a:p>
+        </p:txBody>
+      </p:sp>
+      <p:sp>
+        <p:nvSpPr>
+          <p:cNvPr id="48" name="TextBox 47"/>
+          <p:cNvSpPr txBox="1"/>
+          <p:nvPr/>
+        </p:nvSpPr>
+        <p:spPr>
+          <a:xfrm>
+            <a:off x="1285925" y="6136488"/>
+            <a:ext cx="1596070" cy="357111"/>
+          </a:xfrm>
+          <a:prstGeom prst="rect">
+            <a:avLst/>
+          </a:prstGeom>
+          <a:noFill/>
+        </p:spPr>
+        <p:txBody>
+          <a:bodyPr wrap="none" lIns="0" rIns="0" tIns="0" bIns="0" anchor="ctr">
+            <a:spAutoFit/>
+          </a:bodyPr>
+          <a:lstStyle/>
+          <a:p>
+            <a:pPr>
+              <a:defRPr sz="1382">
+                <a:solidFill>
+                  <a:srgbClr val="FFFFFF"/>
+                </a:solidFill>
+                <a:latin typeface="Malgun Gothic"/>
+              </a:defRPr>
+            </a:pPr>
+            <a:r>
+              <a:t>D) KEY TAKEAWAY</a:t>
+            </a:r>
+          </a:p>
+        </p:txBody>
+      </p:sp>
+      <p:sp>
+        <p:nvSpPr>
+          <p:cNvPr id="49" name="TextBox 48"/>
+          <p:cNvSpPr txBox="1"/>
+          <p:nvPr/>
+        </p:nvSpPr>
+        <p:spPr>
+          <a:xfrm>
+            <a:off x="3370291" y="6318688"/>
+            <a:ext cx="4256187" cy="240503"/>
+          </a:xfrm>
+          <a:prstGeom prst="rect">
+            <a:avLst/>
+          </a:prstGeom>
+          <a:noFill/>
+        </p:spPr>
+        <p:txBody>
+          <a:bodyPr wrap="none" lIns="0" rIns="0" tIns="0" bIns="0" anchor="ctr">
+            <a:spAutoFit/>
+          </a:bodyPr>
+          <a:lstStyle/>
+          <a:p>
+            <a:pPr>
+              <a:defRPr sz="1024">
+                <a:solidFill>
+                  <a:srgbClr val="020202"/>
+                </a:solidFill>
+                <a:latin typeface="Malgun Gothic"/>
+              </a:defRPr>
+            </a:pPr>
+            <a:r>
+              <a:t>his strength is both a joke and a storytelling device.</a:t>
+            </a:r>
+          </a:p>
+        </p:txBody>
+      </p:sp>
+      <p:sp>
+        <p:nvSpPr>
+          <p:cNvPr id="50" name="Rectangle 49"/>
           <p:cNvSpPr/>
           <p:nvPr/>
         </p:nvSpPr>
         <p:spPr>
           <a:xfrm>
-            <a:off x="1592021" y="3447219"/>
-            <a:ext cx="1967757" cy="218639"/>
+            <a:off x="236454" y="1333702"/>
+            <a:ext cx="1756405" cy="291519"/>
           </a:xfrm>
           <a:prstGeom prst="rect">
             <a:avLst/>
           </a:prstGeom>
           <a:solidFill>
-            <a:srgbClr val="010000"/>
+            <a:srgbClr val="020201"/>
           </a:solidFill>
           <a:ln>
             <a:noFill/>
@@ -5144,20 +4812,20 @@
       </p:sp>
       <p:sp>
         <p:nvSpPr>
-          <p:cNvPr id="60" name="Rectangle 59"/>
+          <p:cNvPr id="51" name="Rectangle 50"/>
           <p:cNvSpPr/>
           <p:nvPr/>
         </p:nvSpPr>
         <p:spPr>
           <a:xfrm>
-            <a:off x="1592021" y="4278051"/>
-            <a:ext cx="1770981" cy="211351"/>
+            <a:off x="1111013" y="6063608"/>
+            <a:ext cx="1945893" cy="502871"/>
           </a:xfrm>
           <a:prstGeom prst="rect">
             <a:avLst/>
           </a:prstGeom>
           <a:solidFill>
-            <a:srgbClr val="010101"/>
+            <a:srgbClr val="BD0F0E"/>
           </a:solidFill>
           <a:ln>
             <a:noFill/>
@@ -5187,50 +4855,7 @@
       </p:sp>
       <p:sp>
         <p:nvSpPr>
-          <p:cNvPr id="61" name="Rectangle 60"/>
-          <p:cNvSpPr/>
-          <p:nvPr/>
-        </p:nvSpPr>
-        <p:spPr>
-          <a:xfrm>
-            <a:off x="1111013" y="6063608"/>
-            <a:ext cx="1945893" cy="502871"/>
-          </a:xfrm>
-          <a:prstGeom prst="rect">
-            <a:avLst/>
-          </a:prstGeom>
-          <a:solidFill>
-            <a:srgbClr val="BD0F0E"/>
-          </a:solidFill>
-          <a:ln>
-            <a:noFill/>
-          </a:ln>
-        </p:spPr>
-        <p:style>
-          <a:lnRef idx="1">
-            <a:schemeClr val="accent1"/>
-          </a:lnRef>
-          <a:fillRef idx="3">
-            <a:schemeClr val="accent1"/>
-          </a:fillRef>
-          <a:effectRef idx="2">
-            <a:schemeClr val="accent1"/>
-          </a:effectRef>
-          <a:fontRef idx="minor">
-            <a:schemeClr val="lt1"/>
-          </a:fontRef>
-        </p:style>
-        <p:txBody>
-          <a:bodyPr rtlCol="0" anchor="ctr"/>
-          <a:lstStyle/>
-          <a:p>
-            <a:pPr algn="ctr"/>
-          </a:p>
-        </p:txBody>
-      </p:sp>
-      <p:sp>
-        <p:nvSpPr>
-          <p:cNvPr id="62" name="TextBox 61"/>
+          <p:cNvPr id="52" name="TextBox 51"/>
           <p:cNvSpPr txBox="1"/>
           <p:nvPr/>
         </p:nvSpPr>
@@ -5266,7 +4891,7 @@
       </p:sp>
       <p:sp>
         <p:nvSpPr>
-          <p:cNvPr id="63" name="TextBox 62"/>
+          <p:cNvPr id="53" name="TextBox 52"/>
           <p:cNvSpPr txBox="1"/>
           <p:nvPr/>
         </p:nvSpPr>
@@ -5302,7 +4927,7 @@
       </p:sp>
       <p:sp>
         <p:nvSpPr>
-          <p:cNvPr id="64" name="TextBox 63"/>
+          <p:cNvPr id="54" name="TextBox 53"/>
           <p:cNvSpPr txBox="1"/>
           <p:nvPr/>
         </p:nvSpPr>

</xml_diff>

<commit_message>
Improve high-fidelity slide reconstruction
</commit_message>
<xml_diff>
--- a/docs/examples/one-pun-editable.pptx
+++ b/docs/examples/one-pun-editable.pptx
@@ -3096,137 +3096,6 @@
         </p:nvSpPr>
         <p:spPr>
           <a:xfrm>
-            <a:off x="229166" y="1297262"/>
-            <a:ext cx="2368597" cy="393551"/>
-          </a:xfrm>
-          <a:prstGeom prst="rect">
-            <a:avLst/>
-          </a:prstGeom>
-          <a:solidFill>
-            <a:srgbClr val="FDFDFD"/>
-          </a:solidFill>
-          <a:ln w="15875">
-            <a:solidFill>
-              <a:srgbClr val="010101"/>
-            </a:solidFill>
-          </a:ln>
-        </p:spPr>
-        <p:style>
-          <a:lnRef idx="1">
-            <a:schemeClr val="accent1"/>
-          </a:lnRef>
-          <a:fillRef idx="3">
-            <a:schemeClr val="accent1"/>
-          </a:fillRef>
-          <a:effectRef idx="2">
-            <a:schemeClr val="accent1"/>
-          </a:effectRef>
-          <a:fontRef idx="minor">
-            <a:schemeClr val="lt1"/>
-          </a:fontRef>
-        </p:style>
-        <p:txBody>
-          <a:bodyPr rtlCol="0" anchor="ctr"/>
-          <a:lstStyle/>
-          <a:p>
-            <a:pPr algn="ctr"/>
-          </a:p>
-        </p:txBody>
-      </p:sp>
-      <p:sp>
-        <p:nvSpPr>
-          <p:cNvPr id="3" name="Rectangle 2"/>
-          <p:cNvSpPr/>
-          <p:nvPr/>
-        </p:nvSpPr>
-        <p:spPr>
-          <a:xfrm>
-            <a:off x="4237562" y="1355566"/>
-            <a:ext cx="3833483" cy="276943"/>
-          </a:xfrm>
-          <a:prstGeom prst="rect">
-            <a:avLst/>
-          </a:prstGeom>
-          <a:solidFill>
-            <a:srgbClr val="030303"/>
-          </a:solidFill>
-          <a:ln>
-            <a:noFill/>
-          </a:ln>
-        </p:spPr>
-        <p:style>
-          <a:lnRef idx="1">
-            <a:schemeClr val="accent1"/>
-          </a:lnRef>
-          <a:fillRef idx="3">
-            <a:schemeClr val="accent1"/>
-          </a:fillRef>
-          <a:effectRef idx="2">
-            <a:schemeClr val="accent1"/>
-          </a:effectRef>
-          <a:fontRef idx="minor">
-            <a:schemeClr val="lt1"/>
-          </a:fontRef>
-        </p:style>
-        <p:txBody>
-          <a:bodyPr rtlCol="0" anchor="ctr"/>
-          <a:lstStyle/>
-          <a:p>
-            <a:pPr algn="ctr"/>
-          </a:p>
-        </p:txBody>
-      </p:sp>
-      <p:sp>
-        <p:nvSpPr>
-          <p:cNvPr id="4" name="Rectangle 3"/>
-          <p:cNvSpPr/>
-          <p:nvPr/>
-        </p:nvSpPr>
-        <p:spPr>
-          <a:xfrm>
-            <a:off x="1089149" y="1785557"/>
-            <a:ext cx="364399" cy="568463"/>
-          </a:xfrm>
-          <a:prstGeom prst="rect">
-            <a:avLst/>
-          </a:prstGeom>
-          <a:solidFill>
-            <a:srgbClr val="FDC104"/>
-          </a:solidFill>
-          <a:ln>
-            <a:noFill/>
-          </a:ln>
-        </p:spPr>
-        <p:style>
-          <a:lnRef idx="1">
-            <a:schemeClr val="accent1"/>
-          </a:lnRef>
-          <a:fillRef idx="3">
-            <a:schemeClr val="accent1"/>
-          </a:fillRef>
-          <a:effectRef idx="2">
-            <a:schemeClr val="accent1"/>
-          </a:effectRef>
-          <a:fontRef idx="minor">
-            <a:schemeClr val="lt1"/>
-          </a:fontRef>
-        </p:style>
-        <p:txBody>
-          <a:bodyPr rtlCol="0" anchor="ctr"/>
-          <a:lstStyle/>
-          <a:p>
-            <a:pPr algn="ctr"/>
-          </a:p>
-        </p:txBody>
-      </p:sp>
-      <p:sp>
-        <p:nvSpPr>
-          <p:cNvPr id="5" name="Rectangle 4"/>
-          <p:cNvSpPr/>
-          <p:nvPr/>
-        </p:nvSpPr>
-        <p:spPr>
-          <a:xfrm>
             <a:off x="7349534" y="3979243"/>
             <a:ext cx="736087" cy="58303"/>
           </a:xfrm>
@@ -3266,52 +3135,7 @@
       </p:sp>
       <p:sp>
         <p:nvSpPr>
-          <p:cNvPr id="6" name="Rectangle 5"/>
-          <p:cNvSpPr/>
-          <p:nvPr/>
-        </p:nvSpPr>
-        <p:spPr>
-          <a:xfrm>
-            <a:off x="119846" y="5932425"/>
-            <a:ext cx="7994926" cy="794391"/>
-          </a:xfrm>
-          <a:prstGeom prst="rect">
-            <a:avLst/>
-          </a:prstGeom>
-          <a:solidFill>
-            <a:srgbClr val="FEFEFD"/>
-          </a:solidFill>
-          <a:ln w="15875">
-            <a:solidFill>
-              <a:srgbClr val="BD110D"/>
-            </a:solidFill>
-          </a:ln>
-        </p:spPr>
-        <p:style>
-          <a:lnRef idx="1">
-            <a:schemeClr val="accent1"/>
-          </a:lnRef>
-          <a:fillRef idx="3">
-            <a:schemeClr val="accent1"/>
-          </a:fillRef>
-          <a:effectRef idx="2">
-            <a:schemeClr val="accent1"/>
-          </a:effectRef>
-          <a:fontRef idx="minor">
-            <a:schemeClr val="lt1"/>
-          </a:fontRef>
-        </p:style>
-        <p:txBody>
-          <a:bodyPr rtlCol="0" anchor="ctr"/>
-          <a:lstStyle/>
-          <a:p>
-            <a:pPr algn="ctr"/>
-          </a:p>
-        </p:txBody>
-      </p:sp>
-      <p:sp>
-        <p:nvSpPr>
-          <p:cNvPr id="7" name="Rectangle 6"/>
+          <p:cNvPr id="3" name="Rectangle 2"/>
           <p:cNvSpPr/>
           <p:nvPr/>
         </p:nvSpPr>
@@ -3354,54 +3178,9 @@
           </a:p>
         </p:txBody>
       </p:sp>
-      <p:sp>
-        <p:nvSpPr>
-          <p:cNvPr id="8" name="Rectangle 7"/>
-          <p:cNvSpPr/>
-          <p:nvPr/>
-        </p:nvSpPr>
-        <p:spPr>
-          <a:xfrm>
-            <a:off x="8384429" y="6107336"/>
-            <a:ext cx="371687" cy="422703"/>
-          </a:xfrm>
-          <a:prstGeom prst="rect">
-            <a:avLst/>
-          </a:prstGeom>
-          <a:solidFill>
-            <a:srgbClr val="FDFDFD"/>
-          </a:solidFill>
-          <a:ln w="15875">
-            <a:solidFill>
-              <a:srgbClr val="020101"/>
-            </a:solidFill>
-          </a:ln>
-        </p:spPr>
-        <p:style>
-          <a:lnRef idx="1">
-            <a:schemeClr val="accent1"/>
-          </a:lnRef>
-          <a:fillRef idx="3">
-            <a:schemeClr val="accent1"/>
-          </a:fillRef>
-          <a:effectRef idx="2">
-            <a:schemeClr val="accent1"/>
-          </a:effectRef>
-          <a:fontRef idx="minor">
-            <a:schemeClr val="lt1"/>
-          </a:fontRef>
-        </p:style>
-        <p:txBody>
-          <a:bodyPr rtlCol="0" anchor="ctr"/>
-          <a:lstStyle/>
-          <a:p>
-            <a:pPr algn="ctr"/>
-          </a:p>
-        </p:txBody>
-      </p:sp>
       <p:pic>
         <p:nvPicPr>
-          <p:cNvPr id="9" name="Picture 8" descr="image.png"/>
+          <p:cNvPr id="4" name="Picture 3" descr="residual-153.png"/>
           <p:cNvPicPr>
             <a:picLocks noChangeAspect="1"/>
           </p:cNvPicPr>
@@ -3425,7 +3204,7 @@
       </p:pic>
       <p:pic>
         <p:nvPicPr>
-          <p:cNvPr id="10" name="Picture 9" descr="residual-154.png"/>
+          <p:cNvPr id="5" name="Picture 4" descr="residual-154.png"/>
           <p:cNvPicPr>
             <a:picLocks noChangeAspect="1"/>
           </p:cNvPicPr>
@@ -3449,7 +3228,7 @@
       </p:pic>
       <p:pic>
         <p:nvPicPr>
-          <p:cNvPr id="11" name="Picture 10" descr="residual-114.png"/>
+          <p:cNvPr id="6" name="Picture 5" descr="image.png"/>
           <p:cNvPicPr>
             <a:picLocks noChangeAspect="1"/>
           </p:cNvPicPr>
@@ -3457,30 +3236,6 @@
         </p:nvPicPr>
         <p:blipFill>
           <a:blip r:embed="rId4"/>
-          <a:stretch>
-            <a:fillRect/>
-          </a:stretch>
-        </p:blipFill>
-        <p:spPr>
-          <a:xfrm>
-            <a:off x="323910" y="1676238"/>
-            <a:ext cx="685071" cy="736087"/>
-          </a:xfrm>
-          <a:prstGeom prst="rect">
-            <a:avLst/>
-          </a:prstGeom>
-        </p:spPr>
-      </p:pic>
-      <p:pic>
-        <p:nvPicPr>
-          <p:cNvPr id="12" name="Picture 11" descr="image.png"/>
-          <p:cNvPicPr>
-            <a:picLocks noChangeAspect="1"/>
-          </p:cNvPicPr>
-          <p:nvPr/>
-        </p:nvPicPr>
-        <p:blipFill>
-          <a:blip r:embed="rId5"/>
           <a:stretch>
             <a:fillRect/>
           </a:stretch>
@@ -3497,62 +3252,14 @@
       </p:pic>
       <p:pic>
         <p:nvPicPr>
-          <p:cNvPr id="13" name="Picture 12" descr="residual-94.png"/>
+          <p:cNvPr id="7" name="Picture 6" descr="image.png"/>
           <p:cNvPicPr>
             <a:picLocks noChangeAspect="1"/>
           </p:cNvPicPr>
           <p:nvPr/>
         </p:nvPicPr>
         <p:blipFill>
-          <a:blip r:embed="rId6"/>
-          <a:stretch>
-            <a:fillRect/>
-          </a:stretch>
-        </p:blipFill>
-        <p:spPr>
-          <a:xfrm>
-            <a:off x="323910" y="2550797"/>
-            <a:ext cx="699647" cy="670495"/>
-          </a:xfrm>
-          <a:prstGeom prst="rect">
-            <a:avLst/>
-          </a:prstGeom>
-        </p:spPr>
-      </p:pic>
-      <p:pic>
-        <p:nvPicPr>
-          <p:cNvPr id="14" name="Picture 13" descr="residual-81.png"/>
-          <p:cNvPicPr>
-            <a:picLocks noChangeAspect="1"/>
-          </p:cNvPicPr>
-          <p:nvPr/>
-        </p:nvPicPr>
-        <p:blipFill>
-          <a:blip r:embed="rId7"/>
-          <a:stretch>
-            <a:fillRect/>
-          </a:stretch>
-        </p:blipFill>
-        <p:spPr>
-          <a:xfrm>
-            <a:off x="323910" y="3330612"/>
-            <a:ext cx="699647" cy="714223"/>
-          </a:xfrm>
-          <a:prstGeom prst="rect">
-            <a:avLst/>
-          </a:prstGeom>
-        </p:spPr>
-      </p:pic>
-      <p:pic>
-        <p:nvPicPr>
-          <p:cNvPr id="15" name="Picture 14" descr="image.png"/>
-          <p:cNvPicPr>
-            <a:picLocks noChangeAspect="1"/>
-          </p:cNvPicPr>
-          <p:nvPr/>
-        </p:nvPicPr>
-        <p:blipFill>
-          <a:blip r:embed="rId8"/>
+          <a:blip r:embed="rId5"/>
           <a:stretch>
             <a:fillRect/>
           </a:stretch>
@@ -3567,9 +3274,153 @@
           </a:prstGeom>
         </p:spPr>
       </p:pic>
+      <p:sp>
+        <p:nvSpPr>
+          <p:cNvPr id="8" name="TextBox 7"/>
+          <p:cNvSpPr txBox="1"/>
+          <p:nvPr/>
+        </p:nvSpPr>
+        <p:spPr>
+          <a:xfrm>
+            <a:off x="148998" y="7287"/>
+            <a:ext cx="7958486" cy="983878"/>
+          </a:xfrm>
+          <a:prstGeom prst="rect">
+            <a:avLst/>
+          </a:prstGeom>
+          <a:noFill/>
+        </p:spPr>
+        <p:txBody>
+          <a:bodyPr wrap="none" lIns="0" rIns="0" tIns="0" bIns="0" anchor="ctr">
+            <a:spAutoFit/>
+          </a:bodyPr>
+          <a:lstStyle/>
+          <a:p>
+            <a:pPr>
+              <a:defRPr sz="5419" b="1" i="0">
+                <a:solidFill>
+                  <a:srgbClr val="030303"/>
+                </a:solidFill>
+                <a:latin typeface="Impact"/>
+              </a:defRPr>
+            </a:pPr>
+            <a:r>
+              <a:t>Why Is One Punch Man So Strong?</a:t>
+            </a:r>
+          </a:p>
+        </p:txBody>
+      </p:sp>
+      <p:sp>
+        <p:nvSpPr>
+          <p:cNvPr id="9" name="TextBox 8"/>
+          <p:cNvSpPr txBox="1"/>
+          <p:nvPr/>
+        </p:nvSpPr>
+        <p:spPr>
+          <a:xfrm>
+            <a:off x="294758" y="998454"/>
+            <a:ext cx="6777832" cy="218639"/>
+          </a:xfrm>
+          <a:prstGeom prst="rect">
+            <a:avLst/>
+          </a:prstGeom>
+          <a:noFill/>
+        </p:spPr>
+        <p:txBody>
+          <a:bodyPr wrap="none" lIns="0" rIns="0" tIns="0" bIns="0" anchor="ctr">
+            <a:spAutoFit/>
+          </a:bodyPr>
+          <a:lstStyle/>
+          <a:p>
+            <a:pPr>
+              <a:defRPr sz="1080" b="0" i="1">
+                <a:solidFill>
+                  <a:srgbClr val="000000"/>
+                </a:solidFill>
+                <a:latin typeface="Arial"/>
+              </a:defRPr>
+            </a:pPr>
+            <a:r>
+              <a:t>Narrative, psychological, and structural reasons behind Saitama's overwhelming power</a:t>
+            </a:r>
+          </a:p>
+        </p:txBody>
+      </p:sp>
       <p:pic>
         <p:nvPicPr>
-          <p:cNvPr id="16" name="Picture 15" descr="residual-48.png"/>
+          <p:cNvPr id="10" name="Picture 9" descr="image.png"/>
+          <p:cNvPicPr>
+            <a:picLocks noChangeAspect="1"/>
+          </p:cNvPicPr>
+          <p:nvPr/>
+        </p:nvPicPr>
+        <p:blipFill>
+          <a:blip r:embed="rId6"/>
+          <a:stretch>
+            <a:fillRect/>
+          </a:stretch>
+        </p:blipFill>
+        <p:spPr>
+          <a:xfrm>
+            <a:off x="119846" y="5932425"/>
+            <a:ext cx="7994926" cy="794391"/>
+          </a:xfrm>
+          <a:prstGeom prst="rect">
+            <a:avLst/>
+          </a:prstGeom>
+        </p:spPr>
+      </p:pic>
+      <p:pic>
+        <p:nvPicPr>
+          <p:cNvPr id="11" name="Picture 10" descr="image.png"/>
+          <p:cNvPicPr>
+            <a:picLocks noChangeAspect="1"/>
+          </p:cNvPicPr>
+          <p:nvPr/>
+        </p:nvPicPr>
+        <p:blipFill>
+          <a:blip r:embed="rId7"/>
+          <a:stretch>
+            <a:fillRect/>
+          </a:stretch>
+        </p:blipFill>
+        <p:spPr>
+          <a:xfrm>
+            <a:off x="4237562" y="1355566"/>
+            <a:ext cx="3833483" cy="276943"/>
+          </a:xfrm>
+          <a:prstGeom prst="rect">
+            <a:avLst/>
+          </a:prstGeom>
+        </p:spPr>
+      </p:pic>
+      <p:pic>
+        <p:nvPicPr>
+          <p:cNvPr id="12" name="Picture 11" descr="image.png"/>
+          <p:cNvPicPr>
+            <a:picLocks noChangeAspect="1"/>
+          </p:cNvPicPr>
+          <p:nvPr/>
+        </p:nvPicPr>
+        <p:blipFill>
+          <a:blip r:embed="rId8"/>
+          <a:stretch>
+            <a:fillRect/>
+          </a:stretch>
+        </p:blipFill>
+        <p:spPr>
+          <a:xfrm>
+            <a:off x="8384429" y="6107336"/>
+            <a:ext cx="371687" cy="422703"/>
+          </a:xfrm>
+          <a:prstGeom prst="rect">
+            <a:avLst/>
+          </a:prstGeom>
+        </p:spPr>
+      </p:pic>
+      <p:pic>
+        <p:nvPicPr>
+          <p:cNvPr id="13" name="Picture 12" descr="image.png"/>
           <p:cNvPicPr>
             <a:picLocks noChangeAspect="1"/>
           </p:cNvPicPr>
@@ -3583,1384 +3434,14 @@
         </p:blipFill>
         <p:spPr>
           <a:xfrm>
-            <a:off x="323910" y="4205171"/>
-            <a:ext cx="685071" cy="663207"/>
+            <a:off x="97982" y="1209806"/>
+            <a:ext cx="4066699" cy="4649738"/>
           </a:xfrm>
           <a:prstGeom prst="rect">
             <a:avLst/>
           </a:prstGeom>
         </p:spPr>
       </p:pic>
-      <p:pic>
-        <p:nvPicPr>
-          <p:cNvPr id="17" name="Picture 16" descr="residual-28.png"/>
-          <p:cNvPicPr>
-            <a:picLocks noChangeAspect="1"/>
-          </p:cNvPicPr>
-          <p:nvPr/>
-        </p:nvPicPr>
-        <p:blipFill>
-          <a:blip r:embed="rId10"/>
-          <a:stretch>
-            <a:fillRect/>
-          </a:stretch>
-        </p:blipFill>
-        <p:spPr>
-          <a:xfrm>
-            <a:off x="323910" y="4977698"/>
-            <a:ext cx="692359" cy="728799"/>
-          </a:xfrm>
-          <a:prstGeom prst="rect">
-            <a:avLst/>
-          </a:prstGeom>
-        </p:spPr>
-      </p:pic>
-      <p:sp>
-        <p:nvSpPr>
-          <p:cNvPr id="18" name="TextBox 17"/>
-          <p:cNvSpPr txBox="1"/>
-          <p:nvPr/>
-        </p:nvSpPr>
-        <p:spPr>
-          <a:xfrm>
-            <a:off x="148998" y="7287"/>
-            <a:ext cx="8279158" cy="983878"/>
-          </a:xfrm>
-          <a:prstGeom prst="rect">
-            <a:avLst/>
-          </a:prstGeom>
-          <a:noFill/>
-        </p:spPr>
-        <p:txBody>
-          <a:bodyPr wrap="none" lIns="0" rIns="0" tIns="0" bIns="0" anchor="ctr">
-            <a:spAutoFit/>
-          </a:bodyPr>
-          <a:lstStyle/>
-          <a:p>
-            <a:pPr>
-              <a:defRPr sz="2000">
-                <a:solidFill>
-                  <a:srgbClr val="030303"/>
-                </a:solidFill>
-                <a:latin typeface="Malgun Gothic"/>
-              </a:defRPr>
-            </a:pPr>
-            <a:r>
-              <a:t>Why Is One Punch Man So Strong?</a:t>
-            </a:r>
-          </a:p>
-        </p:txBody>
-      </p:sp>
-      <p:sp>
-        <p:nvSpPr>
-          <p:cNvPr id="19" name="TextBox 18"/>
-          <p:cNvSpPr txBox="1"/>
-          <p:nvPr/>
-        </p:nvSpPr>
-        <p:spPr>
-          <a:xfrm>
-            <a:off x="294758" y="998454"/>
-            <a:ext cx="6777832" cy="218639"/>
-          </a:xfrm>
-          <a:prstGeom prst="rect">
-            <a:avLst/>
-          </a:prstGeom>
-          <a:noFill/>
-        </p:spPr>
-        <p:txBody>
-          <a:bodyPr wrap="none" lIns="0" rIns="0" tIns="0" bIns="0" anchor="ctr">
-            <a:spAutoFit/>
-          </a:bodyPr>
-          <a:lstStyle/>
-          <a:p>
-            <a:pPr>
-              <a:defRPr sz="1048">
-                <a:solidFill>
-                  <a:srgbClr val="000000"/>
-                </a:solidFill>
-                <a:latin typeface="Malgun Gothic"/>
-              </a:defRPr>
-            </a:pPr>
-            <a:r>
-              <a:t>Narrative, psychological, and structural reasons behind Saitama's overwhelming power</a:t>
-            </a:r>
-          </a:p>
-        </p:txBody>
-      </p:sp>
-      <p:sp>
-        <p:nvSpPr>
-          <p:cNvPr id="20" name="TextBox 19"/>
-          <p:cNvSpPr txBox="1"/>
-          <p:nvPr/>
-        </p:nvSpPr>
-        <p:spPr>
-          <a:xfrm>
-            <a:off x="331198" y="1355566"/>
-            <a:ext cx="1486750" cy="225927"/>
-          </a:xfrm>
-          <a:prstGeom prst="rect">
-            <a:avLst/>
-          </a:prstGeom>
-          <a:noFill/>
-        </p:spPr>
-        <p:txBody>
-          <a:bodyPr wrap="none" lIns="0" rIns="0" tIns="0" bIns="0" anchor="ctr">
-            <a:spAutoFit/>
-          </a:bodyPr>
-          <a:lstStyle/>
-          <a:p>
-            <a:pPr>
-              <a:defRPr sz="1287">
-                <a:solidFill>
-                  <a:srgbClr val="FFFFFF"/>
-                </a:solidFill>
-                <a:latin typeface="Malgun Gothic"/>
-              </a:defRPr>
-            </a:pPr>
-            <a:r>
-              <a:t>A) CORE REASONS</a:t>
-            </a:r>
-          </a:p>
-        </p:txBody>
-      </p:sp>
-      <p:sp>
-        <p:nvSpPr>
-          <p:cNvPr id="21" name="TextBox 20"/>
-          <p:cNvSpPr txBox="1"/>
-          <p:nvPr/>
-        </p:nvSpPr>
-        <p:spPr>
-          <a:xfrm>
-            <a:off x="4354169" y="1399294"/>
-            <a:ext cx="3316036" cy="201168"/>
-          </a:xfrm>
-          <a:prstGeom prst="rect">
-            <a:avLst/>
-          </a:prstGeom>
-          <a:noFill/>
-        </p:spPr>
-        <p:txBody>
-          <a:bodyPr wrap="none" lIns="0" rIns="0" tIns="0" bIns="0" anchor="ctr">
-            <a:spAutoFit/>
-          </a:bodyPr>
-          <a:lstStyle/>
-          <a:p>
-            <a:pPr>
-              <a:defRPr sz="1001">
-                <a:solidFill>
-                  <a:srgbClr val="F8D264"/>
-                </a:solidFill>
-                <a:latin typeface="Malgun Gothic"/>
-              </a:defRPr>
-            </a:pPr>
-            <a:r>
-              <a:t>B HOW HE DIFFERS FROM TYPICAL SHONEN HEROES</a:t>
-            </a:r>
-          </a:p>
-        </p:txBody>
-      </p:sp>
-      <p:sp>
-        <p:nvSpPr>
-          <p:cNvPr id="22" name="TextBox 21"/>
-          <p:cNvSpPr txBox="1"/>
-          <p:nvPr/>
-        </p:nvSpPr>
-        <p:spPr>
-          <a:xfrm>
-            <a:off x="1577445" y="1770981"/>
-            <a:ext cx="1340990" cy="201168"/>
-          </a:xfrm>
-          <a:prstGeom prst="rect">
-            <a:avLst/>
-          </a:prstGeom>
-          <a:noFill/>
-        </p:spPr>
-        <p:txBody>
-          <a:bodyPr wrap="none" lIns="0" rIns="0" tIns="0" bIns="0" anchor="ctr">
-            <a:spAutoFit/>
-          </a:bodyPr>
-          <a:lstStyle/>
-          <a:p>
-            <a:pPr>
-              <a:defRPr sz="946">
-                <a:solidFill>
-                  <a:srgbClr val="010101"/>
-                </a:solidFill>
-                <a:latin typeface="Malgun Gothic"/>
-              </a:defRPr>
-            </a:pPr>
-            <a:r>
-              <a:t>BUILT AS A SATIRE</a:t>
-            </a:r>
-          </a:p>
-        </p:txBody>
-      </p:sp>
-      <p:sp>
-        <p:nvSpPr>
-          <p:cNvPr id="23" name="TextBox 22"/>
-          <p:cNvSpPr txBox="1"/>
-          <p:nvPr/>
-        </p:nvSpPr>
-        <p:spPr>
-          <a:xfrm>
-            <a:off x="1140165" y="1865725"/>
-            <a:ext cx="218639" cy="400839"/>
-          </a:xfrm>
-          <a:prstGeom prst="rect">
-            <a:avLst/>
-          </a:prstGeom>
-          <a:noFill/>
-        </p:spPr>
-        <p:txBody>
-          <a:bodyPr wrap="none" lIns="0" rIns="0" tIns="0" bIns="0" anchor="ctr">
-            <a:spAutoFit/>
-          </a:bodyPr>
-          <a:lstStyle/>
-          <a:p>
-            <a:pPr>
-              <a:defRPr sz="2000">
-                <a:solidFill>
-                  <a:srgbClr val="050400"/>
-                </a:solidFill>
-                <a:latin typeface="Malgun Gothic"/>
-              </a:defRPr>
-            </a:pPr>
-            <a:r>
-              <a:t>1</a:t>
-            </a:r>
-          </a:p>
-        </p:txBody>
-      </p:sp>
-      <p:sp>
-        <p:nvSpPr>
-          <p:cNvPr id="24" name="TextBox 23"/>
-          <p:cNvSpPr txBox="1"/>
-          <p:nvPr/>
-        </p:nvSpPr>
-        <p:spPr>
-          <a:xfrm>
-            <a:off x="1562869" y="1967757"/>
-            <a:ext cx="2368597" cy="201168"/>
-          </a:xfrm>
-          <a:prstGeom prst="rect">
-            <a:avLst/>
-          </a:prstGeom>
-          <a:noFill/>
-        </p:spPr>
-        <p:txBody>
-          <a:bodyPr wrap="none" lIns="0" rIns="0" tIns="0" bIns="0" anchor="ctr">
-            <a:spAutoFit/>
-          </a:bodyPr>
-          <a:lstStyle/>
-          <a:p>
-            <a:pPr>
-              <a:defRPr sz="700">
-                <a:solidFill>
-                  <a:srgbClr val="040303"/>
-                </a:solidFill>
-                <a:latin typeface="Malgun Gothic"/>
-              </a:defRPr>
-            </a:pPr>
-            <a:r>
-              <a:t>Saitama was designed to parody power-scaling</a:t>
-            </a:r>
-          </a:p>
-        </p:txBody>
-      </p:sp>
-      <p:sp>
-        <p:nvSpPr>
-          <p:cNvPr id="25" name="TextBox 24"/>
-          <p:cNvSpPr txBox="1"/>
-          <p:nvPr/>
-        </p:nvSpPr>
-        <p:spPr>
-          <a:xfrm>
-            <a:off x="1577445" y="2142669"/>
-            <a:ext cx="2171821" cy="201168"/>
-          </a:xfrm>
-          <a:prstGeom prst="rect">
-            <a:avLst/>
-          </a:prstGeom>
-          <a:noFill/>
-        </p:spPr>
-        <p:txBody>
-          <a:bodyPr wrap="none" lIns="0" rIns="0" tIns="0" bIns="0" anchor="ctr">
-            <a:spAutoFit/>
-          </a:bodyPr>
-          <a:lstStyle/>
-          <a:p>
-            <a:pPr>
-              <a:defRPr sz="700">
-                <a:solidFill>
-                  <a:srgbClr val="040303"/>
-                </a:solidFill>
-                <a:latin typeface="Malgun Gothic"/>
-              </a:defRPr>
-            </a:pPr>
-            <a:r>
-              <a:t>stories—his absurd strength is the premise</a:t>
-            </a:r>
-          </a:p>
-        </p:txBody>
-      </p:sp>
-      <p:sp>
-        <p:nvSpPr>
-          <p:cNvPr id="26" name="TextBox 25"/>
-          <p:cNvSpPr txBox="1"/>
-          <p:nvPr/>
-        </p:nvSpPr>
-        <p:spPr>
-          <a:xfrm>
-            <a:off x="1562869" y="2273853"/>
-            <a:ext cx="816255" cy="201168"/>
-          </a:xfrm>
-          <a:prstGeom prst="rect">
-            <a:avLst/>
-          </a:prstGeom>
-          <a:noFill/>
-        </p:spPr>
-        <p:txBody>
-          <a:bodyPr wrap="none" lIns="0" rIns="0" tIns="0" bIns="0" anchor="ctr">
-            <a:spAutoFit/>
-          </a:bodyPr>
-          <a:lstStyle/>
-          <a:p>
-            <a:pPr>
-              <a:defRPr sz="706">
-                <a:solidFill>
-                  <a:srgbClr val="000000"/>
-                </a:solidFill>
-                <a:latin typeface="Malgun Gothic"/>
-              </a:defRPr>
-            </a:pPr>
-            <a:r>
-              <a:t>not the reward.</a:t>
-            </a:r>
-          </a:p>
-        </p:txBody>
-      </p:sp>
-      <p:sp>
-        <p:nvSpPr>
-          <p:cNvPr id="27" name="TextBox 26"/>
-          <p:cNvSpPr txBox="1"/>
-          <p:nvPr/>
-        </p:nvSpPr>
-        <p:spPr>
-          <a:xfrm>
-            <a:off x="1570157" y="2601812"/>
-            <a:ext cx="2040637" cy="201168"/>
-          </a:xfrm>
-          <a:prstGeom prst="rect">
-            <a:avLst/>
-          </a:prstGeom>
-          <a:noFill/>
-        </p:spPr>
-        <p:txBody>
-          <a:bodyPr wrap="none" lIns="0" rIns="0" tIns="0" bIns="0" anchor="ctr">
-            <a:spAutoFit/>
-          </a:bodyPr>
-          <a:lstStyle/>
-          <a:p>
-            <a:pPr>
-              <a:defRPr sz="989">
-                <a:solidFill>
-                  <a:srgbClr val="020202"/>
-                </a:solidFill>
-                <a:latin typeface="Malgun Gothic"/>
-              </a:defRPr>
-            </a:pPr>
-            <a:r>
-              <a:t>ALREADY AT THE FINISH LINE</a:t>
-            </a:r>
-          </a:p>
-        </p:txBody>
-      </p:sp>
-      <p:sp>
-        <p:nvSpPr>
-          <p:cNvPr id="28" name="TextBox 27"/>
-          <p:cNvSpPr txBox="1"/>
-          <p:nvPr/>
-        </p:nvSpPr>
-        <p:spPr>
-          <a:xfrm>
-            <a:off x="1096437" y="2667404"/>
-            <a:ext cx="342535" cy="451855"/>
-          </a:xfrm>
-          <a:prstGeom prst="rect">
-            <a:avLst/>
-          </a:prstGeom>
-          <a:noFill/>
-        </p:spPr>
-        <p:txBody>
-          <a:bodyPr wrap="none" lIns="0" rIns="0" tIns="0" bIns="0" anchor="ctr">
-            <a:spAutoFit/>
-          </a:bodyPr>
-          <a:lstStyle/>
-          <a:p>
-            <a:pPr>
-              <a:defRPr sz="2000">
-                <a:solidFill>
-                  <a:srgbClr val="050400"/>
-                </a:solidFill>
-                <a:latin typeface="Malgun Gothic"/>
-              </a:defRPr>
-            </a:pPr>
-            <a:r>
-              <a:t>2</a:t>
-            </a:r>
-          </a:p>
-        </p:txBody>
-      </p:sp>
-      <p:sp>
-        <p:nvSpPr>
-          <p:cNvPr id="29" name="TextBox 28"/>
-          <p:cNvSpPr txBox="1"/>
-          <p:nvPr/>
-        </p:nvSpPr>
-        <p:spPr>
-          <a:xfrm>
-            <a:off x="1562869" y="2798588"/>
-            <a:ext cx="2346733" cy="201168"/>
-          </a:xfrm>
-          <a:prstGeom prst="rect">
-            <a:avLst/>
-          </a:prstGeom>
-          <a:noFill/>
-        </p:spPr>
-        <p:txBody>
-          <a:bodyPr wrap="none" lIns="0" rIns="0" tIns="0" bIns="0" anchor="ctr">
-            <a:spAutoFit/>
-          </a:bodyPr>
-          <a:lstStyle/>
-          <a:p>
-            <a:pPr>
-              <a:defRPr sz="700">
-                <a:solidFill>
-                  <a:srgbClr val="030303"/>
-                </a:solidFill>
-                <a:latin typeface="Malgun Gothic"/>
-              </a:defRPr>
-            </a:pPr>
-            <a:r>
-              <a:t>While others train and climb for years to reach</a:t>
-            </a:r>
-          </a:p>
-        </p:txBody>
-      </p:sp>
-      <p:sp>
-        <p:nvSpPr>
-          <p:cNvPr id="30" name="TextBox 29"/>
-          <p:cNvSpPr txBox="1"/>
-          <p:nvPr/>
-        </p:nvSpPr>
-        <p:spPr>
-          <a:xfrm>
-            <a:off x="1555581" y="2951636"/>
-            <a:ext cx="2215549" cy="201168"/>
-          </a:xfrm>
-          <a:prstGeom prst="rect">
-            <a:avLst/>
-          </a:prstGeom>
-          <a:noFill/>
-        </p:spPr>
-        <p:txBody>
-          <a:bodyPr wrap="none" lIns="0" rIns="0" tIns="0" bIns="0" anchor="ctr">
-            <a:spAutoFit/>
-          </a:bodyPr>
-          <a:lstStyle/>
-          <a:p>
-            <a:pPr>
-              <a:defRPr sz="700">
-                <a:solidFill>
-                  <a:srgbClr val="050404"/>
-                </a:solidFill>
-                <a:latin typeface="Malgun Gothic"/>
-              </a:defRPr>
-            </a:pPr>
-            <a:r>
-              <a:t>the top, he begins where most protagonists</a:t>
-            </a:r>
-          </a:p>
-        </p:txBody>
-      </p:sp>
-      <p:sp>
-        <p:nvSpPr>
-          <p:cNvPr id="31" name="TextBox 30"/>
-          <p:cNvSpPr txBox="1"/>
-          <p:nvPr/>
-        </p:nvSpPr>
-        <p:spPr>
-          <a:xfrm>
-            <a:off x="1570157" y="3126548"/>
-            <a:ext cx="1078622" cy="201168"/>
-          </a:xfrm>
-          <a:prstGeom prst="rect">
-            <a:avLst/>
-          </a:prstGeom>
-          <a:noFill/>
-        </p:spPr>
-        <p:txBody>
-          <a:bodyPr wrap="none" lIns="0" rIns="0" tIns="0" bIns="0" anchor="ctr">
-            <a:spAutoFit/>
-          </a:bodyPr>
-          <a:lstStyle/>
-          <a:p>
-            <a:pPr>
-              <a:defRPr sz="700">
-                <a:solidFill>
-                  <a:srgbClr val="030302"/>
-                </a:solidFill>
-                <a:latin typeface="Malgun Gothic"/>
-              </a:defRPr>
-            </a:pPr>
-            <a:r>
-              <a:t>are supposed to end.</a:t>
-            </a:r>
-          </a:p>
-        </p:txBody>
-      </p:sp>
-      <p:sp>
-        <p:nvSpPr>
-          <p:cNvPr id="32" name="TextBox 31"/>
-          <p:cNvSpPr txBox="1"/>
-          <p:nvPr/>
-        </p:nvSpPr>
-        <p:spPr>
-          <a:xfrm>
-            <a:off x="1562869" y="3418068"/>
-            <a:ext cx="1996909" cy="201168"/>
-          </a:xfrm>
-          <a:prstGeom prst="rect">
-            <a:avLst/>
-          </a:prstGeom>
-          <a:noFill/>
-        </p:spPr>
-        <p:txBody>
-          <a:bodyPr wrap="none" lIns="0" rIns="0" tIns="0" bIns="0" anchor="ctr">
-            <a:spAutoFit/>
-          </a:bodyPr>
-          <a:lstStyle/>
-          <a:p>
-            <a:pPr>
-              <a:defRPr sz="1032">
-                <a:solidFill>
-                  <a:srgbClr val="000000"/>
-                </a:solidFill>
-                <a:latin typeface="Malgun Gothic"/>
-              </a:defRPr>
-            </a:pPr>
-            <a:r>
-              <a:t>LIMIT-BREAKING SIMPLICITY</a:t>
-            </a:r>
-          </a:p>
-        </p:txBody>
-      </p:sp>
-      <p:sp>
-        <p:nvSpPr>
-          <p:cNvPr id="33" name="TextBox 32"/>
-          <p:cNvSpPr txBox="1"/>
-          <p:nvPr/>
-        </p:nvSpPr>
-        <p:spPr>
-          <a:xfrm>
-            <a:off x="1132877" y="3512811"/>
-            <a:ext cx="269655" cy="400839"/>
-          </a:xfrm>
-          <a:prstGeom prst="rect">
-            <a:avLst/>
-          </a:prstGeom>
-          <a:noFill/>
-        </p:spPr>
-        <p:txBody>
-          <a:bodyPr wrap="none" lIns="0" rIns="0" tIns="0" bIns="0" anchor="ctr">
-            <a:spAutoFit/>
-          </a:bodyPr>
-          <a:lstStyle/>
-          <a:p>
-            <a:pPr>
-              <a:defRPr sz="2000">
-                <a:solidFill>
-                  <a:srgbClr val="050400"/>
-                </a:solidFill>
-                <a:latin typeface="Malgun Gothic"/>
-              </a:defRPr>
-            </a:pPr>
-            <a:r>
-              <a:t>3</a:t>
-            </a:r>
-          </a:p>
-        </p:txBody>
-      </p:sp>
-      <p:sp>
-        <p:nvSpPr>
-          <p:cNvPr id="34" name="TextBox 33"/>
-          <p:cNvSpPr txBox="1"/>
-          <p:nvPr/>
-        </p:nvSpPr>
-        <p:spPr>
-          <a:xfrm>
-            <a:off x="1562869" y="3643995"/>
-            <a:ext cx="2470629" cy="201168"/>
-          </a:xfrm>
-          <a:prstGeom prst="rect">
-            <a:avLst/>
-          </a:prstGeom>
-          <a:noFill/>
-        </p:spPr>
-        <p:txBody>
-          <a:bodyPr wrap="none" lIns="0" rIns="0" tIns="0" bIns="0" anchor="ctr">
-            <a:spAutoFit/>
-          </a:bodyPr>
-          <a:lstStyle/>
-          <a:p>
-            <a:pPr>
-              <a:defRPr sz="700">
-                <a:solidFill>
-                  <a:srgbClr val="050504"/>
-                </a:solidFill>
-                <a:latin typeface="Malgun Gothic"/>
-              </a:defRPr>
-            </a:pPr>
-            <a:r>
-              <a:t>His routine is both disciplined and comically extreme:</a:t>
-            </a:r>
-          </a:p>
-        </p:txBody>
-      </p:sp>
-      <p:sp>
-        <p:nvSpPr>
-          <p:cNvPr id="35" name="TextBox 34"/>
-          <p:cNvSpPr txBox="1"/>
-          <p:nvPr/>
-        </p:nvSpPr>
-        <p:spPr>
-          <a:xfrm>
-            <a:off x="1555581" y="3775179"/>
-            <a:ext cx="2011485" cy="201168"/>
-          </a:xfrm>
-          <a:prstGeom prst="rect">
-            <a:avLst/>
-          </a:prstGeom>
-          <a:noFill/>
-        </p:spPr>
-        <p:txBody>
-          <a:bodyPr wrap="none" lIns="0" rIns="0" tIns="0" bIns="0" anchor="ctr">
-            <a:spAutoFit/>
-          </a:bodyPr>
-          <a:lstStyle/>
-          <a:p>
-            <a:pPr>
-              <a:defRPr sz="700">
-                <a:solidFill>
-                  <a:srgbClr val="010101"/>
-                </a:solidFill>
-                <a:latin typeface="Malgun Gothic"/>
-              </a:defRPr>
-            </a:pPr>
-            <a:r>
-              <a:t>100 push-ups, 100 sit-ups, 100 squats,</a:t>
-            </a:r>
-          </a:p>
-        </p:txBody>
-      </p:sp>
-      <p:sp>
-        <p:nvSpPr>
-          <p:cNvPr id="36" name="TextBox 35"/>
-          <p:cNvSpPr txBox="1"/>
-          <p:nvPr/>
-        </p:nvSpPr>
-        <p:spPr>
-          <a:xfrm>
-            <a:off x="1562869" y="3942803"/>
-            <a:ext cx="1399294" cy="201168"/>
-          </a:xfrm>
-          <a:prstGeom prst="rect">
-            <a:avLst/>
-          </a:prstGeom>
-          <a:noFill/>
-        </p:spPr>
-        <p:txBody>
-          <a:bodyPr wrap="none" lIns="0" rIns="0" tIns="0" bIns="0" anchor="ctr">
-            <a:spAutoFit/>
-          </a:bodyPr>
-          <a:lstStyle/>
-          <a:p>
-            <a:pPr>
-              <a:defRPr sz="700">
-                <a:solidFill>
-                  <a:srgbClr val="020201"/>
-                </a:solidFill>
-                <a:latin typeface="Malgun Gothic"/>
-              </a:defRPr>
-            </a:pPr>
-            <a:r>
-              <a:t>and a 10 km run every day.</a:t>
-            </a:r>
-          </a:p>
-        </p:txBody>
-      </p:sp>
-      <p:sp>
-        <p:nvSpPr>
-          <p:cNvPr id="37" name="TextBox 36"/>
-          <p:cNvSpPr txBox="1"/>
-          <p:nvPr/>
-        </p:nvSpPr>
-        <p:spPr>
-          <a:xfrm>
-            <a:off x="1577445" y="4263475"/>
-            <a:ext cx="1792845" cy="201168"/>
-          </a:xfrm>
-          <a:prstGeom prst="rect">
-            <a:avLst/>
-          </a:prstGeom>
-          <a:noFill/>
-        </p:spPr>
-        <p:txBody>
-          <a:bodyPr wrap="none" lIns="0" rIns="0" tIns="0" bIns="0" anchor="ctr">
-            <a:spAutoFit/>
-          </a:bodyPr>
-          <a:lstStyle/>
-          <a:p>
-            <a:pPr>
-              <a:defRPr sz="903">
-                <a:solidFill>
-                  <a:srgbClr val="010101"/>
-                </a:solidFill>
-                <a:latin typeface="Malgun Gothic"/>
-              </a:defRPr>
-            </a:pPr>
-            <a:r>
-              <a:t>EMOTIONALLY UNSHAKEN</a:t>
-            </a:r>
-          </a:p>
-        </p:txBody>
-      </p:sp>
-      <p:sp>
-        <p:nvSpPr>
-          <p:cNvPr id="38" name="TextBox 37"/>
-          <p:cNvSpPr txBox="1"/>
-          <p:nvPr/>
-        </p:nvSpPr>
-        <p:spPr>
-          <a:xfrm>
-            <a:off x="1103725" y="4299914"/>
-            <a:ext cx="327959" cy="466431"/>
-          </a:xfrm>
-          <a:prstGeom prst="rect">
-            <a:avLst/>
-          </a:prstGeom>
-          <a:noFill/>
-        </p:spPr>
-        <p:txBody>
-          <a:bodyPr wrap="none" lIns="0" rIns="0" tIns="0" bIns="0" anchor="ctr">
-            <a:spAutoFit/>
-          </a:bodyPr>
-          <a:lstStyle/>
-          <a:p>
-            <a:pPr>
-              <a:defRPr sz="2000">
-                <a:solidFill>
-                  <a:srgbClr val="040300"/>
-                </a:solidFill>
-                <a:latin typeface="Malgun Gothic"/>
-              </a:defRPr>
-            </a:pPr>
-            <a:r>
-              <a:t>4</a:t>
-            </a:r>
-          </a:p>
-        </p:txBody>
-      </p:sp>
-      <p:sp>
-        <p:nvSpPr>
-          <p:cNvPr id="39" name="TextBox 38"/>
-          <p:cNvSpPr txBox="1"/>
-          <p:nvPr/>
-        </p:nvSpPr>
-        <p:spPr>
-          <a:xfrm>
-            <a:off x="1555581" y="4445674"/>
-            <a:ext cx="2062501" cy="201168"/>
-          </a:xfrm>
-          <a:prstGeom prst="rect">
-            <a:avLst/>
-          </a:prstGeom>
-          <a:noFill/>
-        </p:spPr>
-        <p:txBody>
-          <a:bodyPr wrap="none" lIns="0" rIns="0" tIns="0" bIns="0" anchor="ctr">
-            <a:spAutoFit/>
-          </a:bodyPr>
-          <a:lstStyle/>
-          <a:p>
-            <a:pPr>
-              <a:defRPr sz="700">
-                <a:solidFill>
-                  <a:srgbClr val="030303"/>
-                </a:solidFill>
-                <a:latin typeface="Malgun Gothic"/>
-              </a:defRPr>
-            </a:pPr>
-            <a:r>
-              <a:t>He fights without fear, ego, or hesitation.</a:t>
-            </a:r>
-          </a:p>
-        </p:txBody>
-      </p:sp>
-      <p:sp>
-        <p:nvSpPr>
-          <p:cNvPr id="40" name="TextBox 39"/>
-          <p:cNvSpPr txBox="1"/>
-          <p:nvPr/>
-        </p:nvSpPr>
-        <p:spPr>
-          <a:xfrm>
-            <a:off x="1548293" y="4598722"/>
-            <a:ext cx="2033349" cy="201168"/>
-          </a:xfrm>
-          <a:prstGeom prst="rect">
-            <a:avLst/>
-          </a:prstGeom>
-          <a:noFill/>
-        </p:spPr>
-        <p:txBody>
-          <a:bodyPr wrap="none" lIns="0" rIns="0" tIns="0" bIns="0" anchor="ctr">
-            <a:spAutoFit/>
-          </a:bodyPr>
-          <a:lstStyle/>
-          <a:p>
-            <a:pPr>
-              <a:defRPr sz="713">
-                <a:solidFill>
-                  <a:srgbClr val="030303"/>
-                </a:solidFill>
-                <a:latin typeface="Malgun Gothic"/>
-              </a:defRPr>
-            </a:pPr>
-            <a:r>
-              <a:t>No need to prove himself—he's already</a:t>
-            </a:r>
-          </a:p>
-        </p:txBody>
-      </p:sp>
-      <p:sp>
-        <p:nvSpPr>
-          <p:cNvPr id="41" name="TextBox 40"/>
-          <p:cNvSpPr txBox="1"/>
-          <p:nvPr/>
-        </p:nvSpPr>
-        <p:spPr>
-          <a:xfrm>
-            <a:off x="1562869" y="4766346"/>
-            <a:ext cx="1610646" cy="201168"/>
-          </a:xfrm>
-          <a:prstGeom prst="rect">
-            <a:avLst/>
-          </a:prstGeom>
-          <a:noFill/>
-        </p:spPr>
-        <p:txBody>
-          <a:bodyPr wrap="none" lIns="0" rIns="0" tIns="0" bIns="0" anchor="ctr">
-            <a:spAutoFit/>
-          </a:bodyPr>
-          <a:lstStyle/>
-          <a:p>
-            <a:pPr>
-              <a:defRPr sz="700">
-                <a:solidFill>
-                  <a:srgbClr val="040303"/>
-                </a:solidFill>
-                <a:latin typeface="Malgun Gothic"/>
-              </a:defRPr>
-            </a:pPr>
-            <a:r>
-              <a:t>beyond the need for validation.</a:t>
-            </a:r>
-          </a:p>
-        </p:txBody>
-      </p:sp>
-      <p:sp>
-        <p:nvSpPr>
-          <p:cNvPr id="42" name="TextBox 41"/>
-          <p:cNvSpPr txBox="1"/>
-          <p:nvPr/>
-        </p:nvSpPr>
-        <p:spPr>
-          <a:xfrm>
-            <a:off x="1570157" y="5094306"/>
-            <a:ext cx="2434189" cy="201168"/>
-          </a:xfrm>
-          <a:prstGeom prst="rect">
-            <a:avLst/>
-          </a:prstGeom>
-          <a:noFill/>
-        </p:spPr>
-        <p:txBody>
-          <a:bodyPr wrap="none" lIns="0" rIns="0" tIns="0" bIns="0" anchor="ctr">
-            <a:spAutoFit/>
-          </a:bodyPr>
-          <a:lstStyle/>
-          <a:p>
-            <a:pPr>
-              <a:defRPr sz="930">
-                <a:solidFill>
-                  <a:srgbClr val="000000"/>
-                </a:solidFill>
-                <a:latin typeface="Malgun Gothic"/>
-              </a:defRPr>
-            </a:pPr>
-            <a:r>
-              <a:t>THE STORY NEEDS AN UNBEATABLE HERO</a:t>
-            </a:r>
-          </a:p>
-        </p:txBody>
-      </p:sp>
-      <p:sp>
-        <p:nvSpPr>
-          <p:cNvPr id="43" name="TextBox 42"/>
-          <p:cNvSpPr txBox="1"/>
-          <p:nvPr/>
-        </p:nvSpPr>
-        <p:spPr>
-          <a:xfrm>
-            <a:off x="1111013" y="5145321"/>
-            <a:ext cx="298807" cy="429991"/>
-          </a:xfrm>
-          <a:prstGeom prst="rect">
-            <a:avLst/>
-          </a:prstGeom>
-          <a:noFill/>
-        </p:spPr>
-        <p:txBody>
-          <a:bodyPr wrap="none" lIns="0" rIns="0" tIns="0" bIns="0" anchor="ctr">
-            <a:spAutoFit/>
-          </a:bodyPr>
-          <a:lstStyle/>
-          <a:p>
-            <a:pPr>
-              <a:defRPr sz="2000">
-                <a:solidFill>
-                  <a:srgbClr val="040300"/>
-                </a:solidFill>
-                <a:latin typeface="Malgun Gothic"/>
-              </a:defRPr>
-            </a:pPr>
-            <a:r>
-              <a:t>5</a:t>
-            </a:r>
-          </a:p>
-        </p:txBody>
-      </p:sp>
-      <p:sp>
-        <p:nvSpPr>
-          <p:cNvPr id="44" name="TextBox 43"/>
-          <p:cNvSpPr txBox="1"/>
-          <p:nvPr/>
-        </p:nvSpPr>
-        <p:spPr>
-          <a:xfrm>
-            <a:off x="1562869" y="5291081"/>
-            <a:ext cx="2222837" cy="201168"/>
-          </a:xfrm>
-          <a:prstGeom prst="rect">
-            <a:avLst/>
-          </a:prstGeom>
-          <a:noFill/>
-        </p:spPr>
-        <p:txBody>
-          <a:bodyPr wrap="none" lIns="0" rIns="0" tIns="0" bIns="0" anchor="ctr">
-            <a:spAutoFit/>
-          </a:bodyPr>
-          <a:lstStyle/>
-          <a:p>
-            <a:pPr>
-              <a:defRPr sz="700">
-                <a:solidFill>
-                  <a:srgbClr val="020102"/>
-                </a:solidFill>
-                <a:latin typeface="Malgun Gothic"/>
-              </a:defRPr>
-            </a:pPr>
-            <a:r>
-              <a:t>His power lets the series go beyond battles</a:t>
-            </a:r>
-          </a:p>
-        </p:txBody>
-      </p:sp>
-      <p:sp>
-        <p:nvSpPr>
-          <p:cNvPr id="45" name="TextBox 44"/>
-          <p:cNvSpPr txBox="1"/>
-          <p:nvPr/>
-        </p:nvSpPr>
-        <p:spPr>
-          <a:xfrm>
-            <a:off x="1548293" y="5444129"/>
-            <a:ext cx="2244701" cy="201168"/>
-          </a:xfrm>
-          <a:prstGeom prst="rect">
-            <a:avLst/>
-          </a:prstGeom>
-          <a:noFill/>
-        </p:spPr>
-        <p:txBody>
-          <a:bodyPr wrap="none" lIns="0" rIns="0" tIns="0" bIns="0" anchor="ctr">
-            <a:spAutoFit/>
-          </a:bodyPr>
-          <a:lstStyle/>
-          <a:p>
-            <a:pPr>
-              <a:defRPr sz="711">
-                <a:solidFill>
-                  <a:srgbClr val="010101"/>
-                </a:solidFill>
-                <a:latin typeface="Malgun Gothic"/>
-              </a:defRPr>
-            </a:pPr>
-            <a:r>
-              <a:t>to explore boredom, meaning, and identity</a:t>
-            </a:r>
-          </a:p>
-        </p:txBody>
-      </p:sp>
-      <p:sp>
-        <p:nvSpPr>
-          <p:cNvPr id="46" name="TextBox 45"/>
-          <p:cNvSpPr txBox="1"/>
-          <p:nvPr/>
-        </p:nvSpPr>
-        <p:spPr>
-          <a:xfrm>
-            <a:off x="1562869" y="5589889"/>
-            <a:ext cx="1173366" cy="201168"/>
-          </a:xfrm>
-          <a:prstGeom prst="rect">
-            <a:avLst/>
-          </a:prstGeom>
-          <a:noFill/>
-        </p:spPr>
-        <p:txBody>
-          <a:bodyPr wrap="none" lIns="0" rIns="0" tIns="0" bIns="0" anchor="ctr">
-            <a:spAutoFit/>
-          </a:bodyPr>
-          <a:lstStyle/>
-          <a:p>
-            <a:pPr>
-              <a:defRPr sz="700">
-                <a:solidFill>
-                  <a:srgbClr val="020202"/>
-                </a:solidFill>
-                <a:latin typeface="Malgun Gothic"/>
-              </a:defRPr>
-            </a:pPr>
-            <a:r>
-              <a:t>after absolute victory.</a:t>
-            </a:r>
-          </a:p>
-        </p:txBody>
-      </p:sp>
-      <p:sp>
-        <p:nvSpPr>
-          <p:cNvPr id="47" name="TextBox 46"/>
-          <p:cNvSpPr txBox="1"/>
-          <p:nvPr/>
-        </p:nvSpPr>
-        <p:spPr>
-          <a:xfrm>
-            <a:off x="3384867" y="6070896"/>
-            <a:ext cx="4197883" cy="218639"/>
-          </a:xfrm>
-          <a:prstGeom prst="rect">
-            <a:avLst/>
-          </a:prstGeom>
-          <a:noFill/>
-        </p:spPr>
-        <p:txBody>
-          <a:bodyPr wrap="none" lIns="0" rIns="0" tIns="0" bIns="0" anchor="ctr">
-            <a:spAutoFit/>
-          </a:bodyPr>
-          <a:lstStyle/>
-          <a:p>
-            <a:pPr>
-              <a:defRPr sz="1136">
-                <a:solidFill>
-                  <a:srgbClr val="020202"/>
-                </a:solidFill>
-                <a:latin typeface="Malgun Gothic"/>
-              </a:defRPr>
-            </a:pPr>
-            <a:r>
-              <a:t>One Punch Man is powerful as a character because</a:t>
-            </a:r>
-          </a:p>
-        </p:txBody>
-      </p:sp>
-      <p:sp>
-        <p:nvSpPr>
-          <p:cNvPr id="48" name="TextBox 47"/>
-          <p:cNvSpPr txBox="1"/>
-          <p:nvPr/>
-        </p:nvSpPr>
-        <p:spPr>
-          <a:xfrm>
-            <a:off x="1285925" y="6136488"/>
-            <a:ext cx="1596070" cy="357111"/>
-          </a:xfrm>
-          <a:prstGeom prst="rect">
-            <a:avLst/>
-          </a:prstGeom>
-          <a:noFill/>
-        </p:spPr>
-        <p:txBody>
-          <a:bodyPr wrap="none" lIns="0" rIns="0" tIns="0" bIns="0" anchor="ctr">
-            <a:spAutoFit/>
-          </a:bodyPr>
-          <a:lstStyle/>
-          <a:p>
-            <a:pPr>
-              <a:defRPr sz="1382">
-                <a:solidFill>
-                  <a:srgbClr val="FFFFFF"/>
-                </a:solidFill>
-                <a:latin typeface="Malgun Gothic"/>
-              </a:defRPr>
-            </a:pPr>
-            <a:r>
-              <a:t>D) KEY TAKEAWAY</a:t>
-            </a:r>
-          </a:p>
-        </p:txBody>
-      </p:sp>
-      <p:sp>
-        <p:nvSpPr>
-          <p:cNvPr id="49" name="TextBox 48"/>
-          <p:cNvSpPr txBox="1"/>
-          <p:nvPr/>
-        </p:nvSpPr>
-        <p:spPr>
-          <a:xfrm>
-            <a:off x="3370291" y="6318688"/>
-            <a:ext cx="4256187" cy="240503"/>
-          </a:xfrm>
-          <a:prstGeom prst="rect">
-            <a:avLst/>
-          </a:prstGeom>
-          <a:noFill/>
-        </p:spPr>
-        <p:txBody>
-          <a:bodyPr wrap="none" lIns="0" rIns="0" tIns="0" bIns="0" anchor="ctr">
-            <a:spAutoFit/>
-          </a:bodyPr>
-          <a:lstStyle/>
-          <a:p>
-            <a:pPr>
-              <a:defRPr sz="1024">
-                <a:solidFill>
-                  <a:srgbClr val="020202"/>
-                </a:solidFill>
-                <a:latin typeface="Malgun Gothic"/>
-              </a:defRPr>
-            </a:pPr>
-            <a:r>
-              <a:t>his strength is both a joke and a storytelling device.</a:t>
-            </a:r>
-          </a:p>
-        </p:txBody>
-      </p:sp>
-      <p:sp>
-        <p:nvSpPr>
-          <p:cNvPr id="50" name="Rectangle 49"/>
-          <p:cNvSpPr/>
-          <p:nvPr/>
-        </p:nvSpPr>
-        <p:spPr>
-          <a:xfrm>
-            <a:off x="236454" y="1333702"/>
-            <a:ext cx="1756405" cy="291519"/>
-          </a:xfrm>
-          <a:prstGeom prst="rect">
-            <a:avLst/>
-          </a:prstGeom>
-          <a:solidFill>
-            <a:srgbClr val="020201"/>
-          </a:solidFill>
-          <a:ln>
-            <a:noFill/>
-          </a:ln>
-        </p:spPr>
-        <p:style>
-          <a:lnRef idx="1">
-            <a:schemeClr val="accent1"/>
-          </a:lnRef>
-          <a:fillRef idx="3">
-            <a:schemeClr val="accent1"/>
-          </a:fillRef>
-          <a:effectRef idx="2">
-            <a:schemeClr val="accent1"/>
-          </a:effectRef>
-          <a:fontRef idx="minor">
-            <a:schemeClr val="lt1"/>
-          </a:fontRef>
-        </p:style>
-        <p:txBody>
-          <a:bodyPr rtlCol="0" anchor="ctr"/>
-          <a:lstStyle/>
-          <a:p>
-            <a:pPr algn="ctr"/>
-          </a:p>
-        </p:txBody>
-      </p:sp>
-      <p:sp>
-        <p:nvSpPr>
-          <p:cNvPr id="51" name="Rectangle 50"/>
-          <p:cNvSpPr/>
-          <p:nvPr/>
-        </p:nvSpPr>
-        <p:spPr>
-          <a:xfrm>
-            <a:off x="1111013" y="6063608"/>
-            <a:ext cx="1945893" cy="502871"/>
-          </a:xfrm>
-          <a:prstGeom prst="rect">
-            <a:avLst/>
-          </a:prstGeom>
-          <a:solidFill>
-            <a:srgbClr val="BD0F0E"/>
-          </a:solidFill>
-          <a:ln>
-            <a:noFill/>
-          </a:ln>
-        </p:spPr>
-        <p:style>
-          <a:lnRef idx="1">
-            <a:schemeClr val="accent1"/>
-          </a:lnRef>
-          <a:fillRef idx="3">
-            <a:schemeClr val="accent1"/>
-          </a:fillRef>
-          <a:effectRef idx="2">
-            <a:schemeClr val="accent1"/>
-          </a:effectRef>
-          <a:fontRef idx="minor">
-            <a:schemeClr val="lt1"/>
-          </a:fontRef>
-        </p:style>
-        <p:txBody>
-          <a:bodyPr rtlCol="0" anchor="ctr"/>
-          <a:lstStyle/>
-          <a:p>
-            <a:pPr algn="ctr"/>
-          </a:p>
-        </p:txBody>
-      </p:sp>
-      <p:sp>
-        <p:nvSpPr>
-          <p:cNvPr id="52" name="TextBox 51"/>
-          <p:cNvSpPr txBox="1"/>
-          <p:nvPr/>
-        </p:nvSpPr>
-        <p:spPr>
-          <a:xfrm>
-            <a:off x="1196137" y="1967757"/>
-            <a:ext cx="96930" cy="201168"/>
-          </a:xfrm>
-          <a:prstGeom prst="rect">
-            <a:avLst/>
-          </a:prstGeom>
-          <a:noFill/>
-        </p:spPr>
-        <p:txBody>
-          <a:bodyPr wrap="none" lIns="0" rIns="0" tIns="0" bIns="0" anchor="ctr">
-            <a:spAutoFit/>
-          </a:bodyPr>
-          <a:lstStyle/>
-          <a:p>
-            <a:pPr>
-              <a:defRPr sz="817">
-                <a:solidFill>
-                  <a:srgbClr val="111111"/>
-                </a:solidFill>
-                <a:latin typeface="Malgun Gothic"/>
-              </a:defRPr>
-            </a:pPr>
-            <a:r>
-              <a:t>•</a:t>
-            </a:r>
-          </a:p>
-        </p:txBody>
-      </p:sp>
-      <p:sp>
-        <p:nvSpPr>
-          <p:cNvPr id="53" name="TextBox 52"/>
-          <p:cNvSpPr txBox="1"/>
-          <p:nvPr/>
-        </p:nvSpPr>
-        <p:spPr>
-          <a:xfrm>
-            <a:off x="1241322" y="2142669"/>
-            <a:ext cx="72879" cy="201168"/>
-          </a:xfrm>
-          <a:prstGeom prst="rect">
-            <a:avLst/>
-          </a:prstGeom>
-          <a:noFill/>
-        </p:spPr>
-        <p:txBody>
-          <a:bodyPr wrap="none" lIns="0" rIns="0" tIns="0" bIns="0" anchor="ctr">
-            <a:spAutoFit/>
-          </a:bodyPr>
-          <a:lstStyle/>
-          <a:p>
-            <a:pPr>
-              <a:defRPr sz="700">
-                <a:solidFill>
-                  <a:srgbClr val="111111"/>
-                </a:solidFill>
-                <a:latin typeface="Malgun Gothic"/>
-              </a:defRPr>
-            </a:pPr>
-            <a:r>
-              <a:t>•</a:t>
-            </a:r>
-          </a:p>
-        </p:txBody>
-      </p:sp>
-      <p:sp>
-        <p:nvSpPr>
-          <p:cNvPr id="54" name="TextBox 53"/>
-          <p:cNvSpPr txBox="1"/>
-          <p:nvPr/>
-        </p:nvSpPr>
-        <p:spPr>
-          <a:xfrm>
-            <a:off x="1229370" y="3643995"/>
-            <a:ext cx="86727" cy="201168"/>
-          </a:xfrm>
-          <a:prstGeom prst="rect">
-            <a:avLst/>
-          </a:prstGeom>
-          <a:noFill/>
-        </p:spPr>
-        <p:txBody>
-          <a:bodyPr wrap="none" lIns="0" rIns="0" tIns="0" bIns="0" anchor="ctr">
-            <a:spAutoFit/>
-          </a:bodyPr>
-          <a:lstStyle/>
-          <a:p>
-            <a:pPr>
-              <a:defRPr sz="731">
-                <a:solidFill>
-                  <a:srgbClr val="111111"/>
-                </a:solidFill>
-                <a:latin typeface="Malgun Gothic"/>
-              </a:defRPr>
-            </a:pPr>
-            <a:r>
-              <a:t>•</a:t>
-            </a:r>
-          </a:p>
-        </p:txBody>
-      </p:sp>
     </p:spTree>
   </p:cSld>
   <p:clrMapOvr>

</xml_diff>

<commit_message>
Prioritize editable text reconstruction
</commit_message>
<xml_diff>
--- a/docs/examples/one-pun-editable.pptx
+++ b/docs/examples/one-pun-editable.pptx
@@ -3228,7 +3228,7 @@
       </p:pic>
       <p:pic>
         <p:nvPicPr>
-          <p:cNvPr id="6" name="Picture 5" descr="image.png"/>
+          <p:cNvPr id="6" name="Picture 5" descr="residual-114.png"/>
           <p:cNvPicPr>
             <a:picLocks noChangeAspect="1"/>
           </p:cNvPicPr>
@@ -3242,8 +3242,8 @@
         </p:blipFill>
         <p:spPr>
           <a:xfrm>
-            <a:off x="4274001" y="1763693"/>
-            <a:ext cx="4270763" cy="2186397"/>
+            <a:off x="323910" y="1676238"/>
+            <a:ext cx="685071" cy="736087"/>
           </a:xfrm>
           <a:prstGeom prst="rect">
             <a:avLst/>
@@ -3266,89 +3266,17 @@
         </p:blipFill>
         <p:spPr>
           <a:xfrm>
-            <a:off x="4237562" y="4117715"/>
-            <a:ext cx="3920939" cy="1719965"/>
+            <a:off x="4274001" y="1763693"/>
+            <a:ext cx="4270763" cy="2186397"/>
           </a:xfrm>
           <a:prstGeom prst="rect">
             <a:avLst/>
           </a:prstGeom>
         </p:spPr>
       </p:pic>
-      <p:sp>
-        <p:nvSpPr>
-          <p:cNvPr id="8" name="TextBox 7"/>
-          <p:cNvSpPr txBox="1"/>
-          <p:nvPr/>
-        </p:nvSpPr>
-        <p:spPr>
-          <a:xfrm>
-            <a:off x="148998" y="7287"/>
-            <a:ext cx="7958486" cy="983878"/>
-          </a:xfrm>
-          <a:prstGeom prst="rect">
-            <a:avLst/>
-          </a:prstGeom>
-          <a:noFill/>
-        </p:spPr>
-        <p:txBody>
-          <a:bodyPr wrap="none" lIns="0" rIns="0" tIns="0" bIns="0" anchor="ctr">
-            <a:spAutoFit/>
-          </a:bodyPr>
-          <a:lstStyle/>
-          <a:p>
-            <a:pPr>
-              <a:defRPr sz="5419" b="1" i="0">
-                <a:solidFill>
-                  <a:srgbClr val="030303"/>
-                </a:solidFill>
-                <a:latin typeface="Impact"/>
-              </a:defRPr>
-            </a:pPr>
-            <a:r>
-              <a:t>Why Is One Punch Man So Strong?</a:t>
-            </a:r>
-          </a:p>
-        </p:txBody>
-      </p:sp>
-      <p:sp>
-        <p:nvSpPr>
-          <p:cNvPr id="9" name="TextBox 8"/>
-          <p:cNvSpPr txBox="1"/>
-          <p:nvPr/>
-        </p:nvSpPr>
-        <p:spPr>
-          <a:xfrm>
-            <a:off x="294758" y="998454"/>
-            <a:ext cx="6777832" cy="218639"/>
-          </a:xfrm>
-          <a:prstGeom prst="rect">
-            <a:avLst/>
-          </a:prstGeom>
-          <a:noFill/>
-        </p:spPr>
-        <p:txBody>
-          <a:bodyPr wrap="none" lIns="0" rIns="0" tIns="0" bIns="0" anchor="ctr">
-            <a:spAutoFit/>
-          </a:bodyPr>
-          <a:lstStyle/>
-          <a:p>
-            <a:pPr>
-              <a:defRPr sz="1080" b="0" i="1">
-                <a:solidFill>
-                  <a:srgbClr val="000000"/>
-                </a:solidFill>
-                <a:latin typeface="Arial"/>
-              </a:defRPr>
-            </a:pPr>
-            <a:r>
-              <a:t>Narrative, psychological, and structural reasons behind Saitama's overwhelming power</a:t>
-            </a:r>
-          </a:p>
-        </p:txBody>
-      </p:sp>
       <p:pic>
         <p:nvPicPr>
-          <p:cNvPr id="10" name="Picture 9" descr="image.png"/>
+          <p:cNvPr id="8" name="Picture 7" descr="residual-94.png"/>
           <p:cNvPicPr>
             <a:picLocks noChangeAspect="1"/>
           </p:cNvPicPr>
@@ -3362,8 +3290,8 @@
         </p:blipFill>
         <p:spPr>
           <a:xfrm>
-            <a:off x="119846" y="5932425"/>
-            <a:ext cx="7994926" cy="794391"/>
+            <a:off x="323910" y="2550797"/>
+            <a:ext cx="699647" cy="670495"/>
           </a:xfrm>
           <a:prstGeom prst="rect">
             <a:avLst/>
@@ -3372,7 +3300,7 @@
       </p:pic>
       <p:pic>
         <p:nvPicPr>
-          <p:cNvPr id="11" name="Picture 10" descr="image.png"/>
+          <p:cNvPr id="9" name="Picture 8" descr="residual-81.png"/>
           <p:cNvPicPr>
             <a:picLocks noChangeAspect="1"/>
           </p:cNvPicPr>
@@ -3386,8 +3314,8 @@
         </p:blipFill>
         <p:spPr>
           <a:xfrm>
-            <a:off x="4237562" y="1355566"/>
-            <a:ext cx="3833483" cy="276943"/>
+            <a:off x="323910" y="3330612"/>
+            <a:ext cx="699647" cy="714223"/>
           </a:xfrm>
           <a:prstGeom prst="rect">
             <a:avLst/>
@@ -3396,7 +3324,7 @@
       </p:pic>
       <p:pic>
         <p:nvPicPr>
-          <p:cNvPr id="12" name="Picture 11" descr="image.png"/>
+          <p:cNvPr id="10" name="Picture 9" descr="image.png"/>
           <p:cNvPicPr>
             <a:picLocks noChangeAspect="1"/>
           </p:cNvPicPr>
@@ -3410,8 +3338,8 @@
         </p:blipFill>
         <p:spPr>
           <a:xfrm>
-            <a:off x="8384429" y="6107336"/>
-            <a:ext cx="371687" cy="422703"/>
+            <a:off x="4237562" y="4117715"/>
+            <a:ext cx="3920939" cy="1719965"/>
           </a:xfrm>
           <a:prstGeom prst="rect">
             <a:avLst/>
@@ -3420,7 +3348,7 @@
       </p:pic>
       <p:pic>
         <p:nvPicPr>
-          <p:cNvPr id="13" name="Picture 12" descr="image.png"/>
+          <p:cNvPr id="11" name="Picture 10" descr="residual-48.png"/>
           <p:cNvPicPr>
             <a:picLocks noChangeAspect="1"/>
           </p:cNvPicPr>
@@ -3434,14 +3362,2576 @@
         </p:blipFill>
         <p:spPr>
           <a:xfrm>
-            <a:off x="97982" y="1209806"/>
-            <a:ext cx="4066699" cy="4649738"/>
+            <a:off x="323910" y="4205171"/>
+            <a:ext cx="685071" cy="663207"/>
           </a:xfrm>
           <a:prstGeom prst="rect">
             <a:avLst/>
           </a:prstGeom>
         </p:spPr>
       </p:pic>
+      <p:pic>
+        <p:nvPicPr>
+          <p:cNvPr id="12" name="Picture 11" descr="residual-28.png"/>
+          <p:cNvPicPr>
+            <a:picLocks noChangeAspect="1"/>
+          </p:cNvPicPr>
+          <p:nvPr/>
+        </p:nvPicPr>
+        <p:blipFill>
+          <a:blip r:embed="rId10"/>
+          <a:stretch>
+            <a:fillRect/>
+          </a:stretch>
+        </p:blipFill>
+        <p:spPr>
+          <a:xfrm>
+            <a:off x="323910" y="4977698"/>
+            <a:ext cx="692359" cy="728799"/>
+          </a:xfrm>
+          <a:prstGeom prst="rect">
+            <a:avLst/>
+          </a:prstGeom>
+        </p:spPr>
+      </p:pic>
+      <p:sp>
+        <p:nvSpPr>
+          <p:cNvPr id="13" name="TextBox 12"/>
+          <p:cNvSpPr txBox="1"/>
+          <p:nvPr/>
+        </p:nvSpPr>
+        <p:spPr>
+          <a:xfrm>
+            <a:off x="148998" y="7287"/>
+            <a:ext cx="7958486" cy="983878"/>
+          </a:xfrm>
+          <a:prstGeom prst="rect">
+            <a:avLst/>
+          </a:prstGeom>
+          <a:noFill/>
+        </p:spPr>
+        <p:txBody>
+          <a:bodyPr wrap="none" lIns="0" rIns="0" tIns="0" bIns="0" anchor="ctr">
+            <a:spAutoFit/>
+          </a:bodyPr>
+          <a:lstStyle/>
+          <a:p>
+            <a:pPr>
+              <a:defRPr sz="5419" b="1" i="0">
+                <a:solidFill>
+                  <a:srgbClr val="030303"/>
+                </a:solidFill>
+                <a:latin typeface="Impact"/>
+              </a:defRPr>
+            </a:pPr>
+            <a:r>
+              <a:t>Why Is One Punch Man So Strong?</a:t>
+            </a:r>
+          </a:p>
+        </p:txBody>
+      </p:sp>
+      <p:sp>
+        <p:nvSpPr>
+          <p:cNvPr id="14" name="TextBox 13"/>
+          <p:cNvSpPr txBox="1"/>
+          <p:nvPr/>
+        </p:nvSpPr>
+        <p:spPr>
+          <a:xfrm>
+            <a:off x="294758" y="998454"/>
+            <a:ext cx="6777832" cy="218639"/>
+          </a:xfrm>
+          <a:prstGeom prst="rect">
+            <a:avLst/>
+          </a:prstGeom>
+          <a:noFill/>
+        </p:spPr>
+        <p:txBody>
+          <a:bodyPr wrap="none" lIns="0" rIns="0" tIns="0" bIns="0" anchor="ctr">
+            <a:spAutoFit/>
+          </a:bodyPr>
+          <a:lstStyle/>
+          <a:p>
+            <a:pPr>
+              <a:defRPr sz="1080" b="0" i="1">
+                <a:solidFill>
+                  <a:srgbClr val="000000"/>
+                </a:solidFill>
+                <a:latin typeface="Arial"/>
+              </a:defRPr>
+            </a:pPr>
+            <a:r>
+              <a:t>Narrative, psychological, and structural reasons behind Saitama's overwhelming power</a:t>
+            </a:r>
+          </a:p>
+        </p:txBody>
+      </p:sp>
+      <p:sp>
+        <p:nvSpPr>
+          <p:cNvPr id="15" name="TextBox 14"/>
+          <p:cNvSpPr txBox="1"/>
+          <p:nvPr/>
+        </p:nvSpPr>
+        <p:spPr>
+          <a:xfrm>
+            <a:off x="331198" y="1355566"/>
+            <a:ext cx="1486750" cy="225927"/>
+          </a:xfrm>
+          <a:prstGeom prst="rect">
+            <a:avLst/>
+          </a:prstGeom>
+          <a:noFill/>
+        </p:spPr>
+        <p:txBody>
+          <a:bodyPr wrap="none" lIns="0" rIns="0" tIns="0" bIns="0" anchor="ctr">
+            <a:spAutoFit/>
+          </a:bodyPr>
+          <a:lstStyle/>
+          <a:p>
+            <a:pPr>
+              <a:defRPr sz="1334" b="1" i="0">
+                <a:solidFill>
+                  <a:srgbClr val="FFFFFF"/>
+                </a:solidFill>
+                <a:latin typeface="Arial"/>
+              </a:defRPr>
+            </a:pPr>
+            <a:r>
+              <a:t>A) CORE REASONS</a:t>
+            </a:r>
+          </a:p>
+        </p:txBody>
+      </p:sp>
+      <p:sp>
+        <p:nvSpPr>
+          <p:cNvPr id="16" name="TextBox 15"/>
+          <p:cNvSpPr txBox="1"/>
+          <p:nvPr/>
+        </p:nvSpPr>
+        <p:spPr>
+          <a:xfrm>
+            <a:off x="4354169" y="1399294"/>
+            <a:ext cx="3316036" cy="201168"/>
+          </a:xfrm>
+          <a:prstGeom prst="rect">
+            <a:avLst/>
+          </a:prstGeom>
+          <a:noFill/>
+        </p:spPr>
+        <p:txBody>
+          <a:bodyPr wrap="none" lIns="0" rIns="0" tIns="0" bIns="0" anchor="ctr">
+            <a:spAutoFit/>
+          </a:bodyPr>
+          <a:lstStyle/>
+          <a:p>
+            <a:pPr>
+              <a:defRPr sz="1038" b="1" i="0">
+                <a:solidFill>
+                  <a:srgbClr val="F8D264"/>
+                </a:solidFill>
+                <a:latin typeface="Arial"/>
+              </a:defRPr>
+            </a:pPr>
+            <a:r>
+              <a:t>B) HOW HE DIFFERS FROM TYPICAL SHONEN HEROES</a:t>
+            </a:r>
+          </a:p>
+        </p:txBody>
+      </p:sp>
+      <p:sp>
+        <p:nvSpPr>
+          <p:cNvPr id="17" name="TextBox 16"/>
+          <p:cNvSpPr txBox="1"/>
+          <p:nvPr/>
+        </p:nvSpPr>
+        <p:spPr>
+          <a:xfrm>
+            <a:off x="1577445" y="1770981"/>
+            <a:ext cx="1340990" cy="201168"/>
+          </a:xfrm>
+          <a:prstGeom prst="rect">
+            <a:avLst/>
+          </a:prstGeom>
+          <a:noFill/>
+        </p:spPr>
+        <p:txBody>
+          <a:bodyPr wrap="none" lIns="0" rIns="0" tIns="0" bIns="0" anchor="ctr">
+            <a:spAutoFit/>
+          </a:bodyPr>
+          <a:lstStyle/>
+          <a:p>
+            <a:pPr>
+              <a:defRPr sz="946" b="1" i="0">
+                <a:solidFill>
+                  <a:srgbClr val="010101"/>
+                </a:solidFill>
+                <a:latin typeface="Arial"/>
+              </a:defRPr>
+            </a:pPr>
+            <a:r>
+              <a:t>BUILT AS A SATIRE</a:t>
+            </a:r>
+          </a:p>
+        </p:txBody>
+      </p:sp>
+      <p:sp>
+        <p:nvSpPr>
+          <p:cNvPr id="18" name="TextBox 17"/>
+          <p:cNvSpPr txBox="1"/>
+          <p:nvPr/>
+        </p:nvSpPr>
+        <p:spPr>
+          <a:xfrm>
+            <a:off x="1140165" y="1865725"/>
+            <a:ext cx="218639" cy="400839"/>
+          </a:xfrm>
+          <a:prstGeom prst="rect">
+            <a:avLst/>
+          </a:prstGeom>
+          <a:noFill/>
+        </p:spPr>
+        <p:txBody>
+          <a:bodyPr wrap="none" lIns="0" rIns="0" tIns="0" bIns="0" anchor="ctr">
+            <a:spAutoFit/>
+          </a:bodyPr>
+          <a:lstStyle/>
+          <a:p>
+            <a:pPr>
+              <a:defRPr sz="1687" b="0" i="0">
+                <a:solidFill>
+                  <a:srgbClr val="050400"/>
+                </a:solidFill>
+                <a:latin typeface="Arial"/>
+              </a:defRPr>
+            </a:pPr>
+            <a:r>
+              <a:t>1</a:t>
+            </a:r>
+          </a:p>
+        </p:txBody>
+      </p:sp>
+      <p:sp>
+        <p:nvSpPr>
+          <p:cNvPr id="19" name="TextBox 18"/>
+          <p:cNvSpPr txBox="1"/>
+          <p:nvPr/>
+        </p:nvSpPr>
+        <p:spPr>
+          <a:xfrm>
+            <a:off x="1562869" y="1967757"/>
+            <a:ext cx="2368597" cy="201168"/>
+          </a:xfrm>
+          <a:prstGeom prst="rect">
+            <a:avLst/>
+          </a:prstGeom>
+          <a:noFill/>
+        </p:spPr>
+        <p:txBody>
+          <a:bodyPr wrap="none" lIns="0" rIns="0" tIns="0" bIns="0" anchor="ctr">
+            <a:spAutoFit/>
+          </a:bodyPr>
+          <a:lstStyle/>
+          <a:p>
+            <a:pPr>
+              <a:defRPr sz="726" b="0" i="0">
+                <a:solidFill>
+                  <a:srgbClr val="040303"/>
+                </a:solidFill>
+                <a:latin typeface="Arial"/>
+              </a:defRPr>
+            </a:pPr>
+            <a:r>
+              <a:t>Saitama was designed to parody power-scaling</a:t>
+            </a:r>
+          </a:p>
+        </p:txBody>
+      </p:sp>
+      <p:sp>
+        <p:nvSpPr>
+          <p:cNvPr id="20" name="TextBox 19"/>
+          <p:cNvSpPr txBox="1"/>
+          <p:nvPr/>
+        </p:nvSpPr>
+        <p:spPr>
+          <a:xfrm>
+            <a:off x="4813313" y="1916741"/>
+            <a:ext cx="1319126" cy="201168"/>
+          </a:xfrm>
+          <a:prstGeom prst="rect">
+            <a:avLst/>
+          </a:prstGeom>
+          <a:noFill/>
+        </p:spPr>
+        <p:txBody>
+          <a:bodyPr wrap="none" lIns="0" rIns="0" tIns="0" bIns="0" anchor="ctr">
+            <a:spAutoFit/>
+          </a:bodyPr>
+          <a:lstStyle/>
+          <a:p>
+            <a:pPr>
+              <a:defRPr sz="903" b="1" i="0">
+                <a:solidFill>
+                  <a:srgbClr val="000000"/>
+                </a:solidFill>
+                <a:latin typeface="Arial"/>
+              </a:defRPr>
+            </a:pPr>
+            <a:r>
+              <a:t>TYPICAL SHONEN HERO</a:t>
+            </a:r>
+          </a:p>
+        </p:txBody>
+      </p:sp>
+      <p:sp>
+        <p:nvSpPr>
+          <p:cNvPr id="21" name="TextBox 20"/>
+          <p:cNvSpPr txBox="1"/>
+          <p:nvPr/>
+        </p:nvSpPr>
+        <p:spPr>
+          <a:xfrm>
+            <a:off x="6351079" y="1807421"/>
+            <a:ext cx="378975" cy="357111"/>
+          </a:xfrm>
+          <a:prstGeom prst="rect">
+            <a:avLst/>
+          </a:prstGeom>
+          <a:noFill/>
+        </p:spPr>
+        <p:txBody>
+          <a:bodyPr wrap="none" lIns="0" rIns="0" tIns="0" bIns="0" anchor="ctr">
+            <a:spAutoFit/>
+          </a:bodyPr>
+          <a:lstStyle/>
+          <a:p>
+            <a:pPr>
+              <a:defRPr sz="1624" b="1" i="0">
+                <a:solidFill>
+                  <a:srgbClr val="F7C403"/>
+                </a:solidFill>
+                <a:latin typeface="Arial"/>
+              </a:defRPr>
+            </a:pPr>
+            <a:r>
+              <a:t>VS.</a:t>
+            </a:r>
+          </a:p>
+        </p:txBody>
+      </p:sp>
+      <p:sp>
+        <p:nvSpPr>
+          <p:cNvPr id="22" name="TextBox 21"/>
+          <p:cNvSpPr txBox="1"/>
+          <p:nvPr/>
+        </p:nvSpPr>
+        <p:spPr>
+          <a:xfrm>
+            <a:off x="6985134" y="1902165"/>
+            <a:ext cx="612191" cy="201168"/>
+          </a:xfrm>
+          <a:prstGeom prst="rect">
+            <a:avLst/>
+          </a:prstGeom>
+          <a:noFill/>
+        </p:spPr>
+        <p:txBody>
+          <a:bodyPr wrap="none" lIns="0" rIns="0" tIns="0" bIns="0" anchor="ctr">
+            <a:spAutoFit/>
+          </a:bodyPr>
+          <a:lstStyle/>
+          <a:p>
+            <a:pPr>
+              <a:defRPr sz="1075" b="1" i="0">
+                <a:solidFill>
+                  <a:srgbClr val="FFFFFF"/>
+                </a:solidFill>
+                <a:latin typeface="Arial"/>
+              </a:defRPr>
+            </a:pPr>
+            <a:r>
+              <a:t>SAITAMA</a:t>
+            </a:r>
+          </a:p>
+        </p:txBody>
+      </p:sp>
+      <p:sp>
+        <p:nvSpPr>
+          <p:cNvPr id="23" name="TextBox 22"/>
+          <p:cNvSpPr txBox="1"/>
+          <p:nvPr/>
+        </p:nvSpPr>
+        <p:spPr>
+          <a:xfrm>
+            <a:off x="1577445" y="2142669"/>
+            <a:ext cx="2171821" cy="201168"/>
+          </a:xfrm>
+          <a:prstGeom prst="rect">
+            <a:avLst/>
+          </a:prstGeom>
+          <a:noFill/>
+        </p:spPr>
+        <p:txBody>
+          <a:bodyPr wrap="none" lIns="0" rIns="0" tIns="0" bIns="0" anchor="ctr">
+            <a:spAutoFit/>
+          </a:bodyPr>
+          <a:lstStyle/>
+          <a:p>
+            <a:pPr>
+              <a:defRPr sz="700" b="0" i="0">
+                <a:solidFill>
+                  <a:srgbClr val="040303"/>
+                </a:solidFill>
+                <a:latin typeface="Arial"/>
+              </a:defRPr>
+            </a:pPr>
+            <a:r>
+              <a:t>stories—his absurd strength is the premise</a:t>
+            </a:r>
+          </a:p>
+        </p:txBody>
+      </p:sp>
+      <p:sp>
+        <p:nvSpPr>
+          <p:cNvPr id="24" name="TextBox 23"/>
+          <p:cNvSpPr txBox="1"/>
+          <p:nvPr/>
+        </p:nvSpPr>
+        <p:spPr>
+          <a:xfrm>
+            <a:off x="1562869" y="2273853"/>
+            <a:ext cx="816255" cy="201168"/>
+          </a:xfrm>
+          <a:prstGeom prst="rect">
+            <a:avLst/>
+          </a:prstGeom>
+          <a:noFill/>
+        </p:spPr>
+        <p:txBody>
+          <a:bodyPr wrap="none" lIns="0" rIns="0" tIns="0" bIns="0" anchor="ctr">
+            <a:spAutoFit/>
+          </a:bodyPr>
+          <a:lstStyle/>
+          <a:p>
+            <a:pPr>
+              <a:defRPr sz="741" b="0" i="0">
+                <a:solidFill>
+                  <a:srgbClr val="000000"/>
+                </a:solidFill>
+                <a:latin typeface="Arial"/>
+              </a:defRPr>
+            </a:pPr>
+            <a:r>
+              <a:t>not the reward.</a:t>
+            </a:r>
+          </a:p>
+        </p:txBody>
+      </p:sp>
+      <p:sp>
+        <p:nvSpPr>
+          <p:cNvPr id="25" name="TextBox 24"/>
+          <p:cNvSpPr txBox="1"/>
+          <p:nvPr/>
+        </p:nvSpPr>
+        <p:spPr>
+          <a:xfrm>
+            <a:off x="5024665" y="2339445"/>
+            <a:ext cx="641343" cy="201168"/>
+          </a:xfrm>
+          <a:prstGeom prst="rect">
+            <a:avLst/>
+          </a:prstGeom>
+          <a:noFill/>
+        </p:spPr>
+        <p:txBody>
+          <a:bodyPr wrap="none" lIns="0" rIns="0" tIns="0" bIns="0" anchor="ctr">
+            <a:spAutoFit/>
+          </a:bodyPr>
+          <a:lstStyle/>
+          <a:p>
+            <a:pPr>
+              <a:defRPr sz="860" b="0" i="0">
+                <a:solidFill>
+                  <a:srgbClr val="000000"/>
+                </a:solidFill>
+                <a:latin typeface="Arial"/>
+              </a:defRPr>
+            </a:pPr>
+            <a:r>
+              <a:t>Growth arc</a:t>
+            </a:r>
+          </a:p>
+        </p:txBody>
+      </p:sp>
+      <p:sp>
+        <p:nvSpPr>
+          <p:cNvPr id="26" name="TextBox 25"/>
+          <p:cNvSpPr txBox="1"/>
+          <p:nvPr/>
+        </p:nvSpPr>
+        <p:spPr>
+          <a:xfrm>
+            <a:off x="6912254" y="2332157"/>
+            <a:ext cx="1034894" cy="201168"/>
+          </a:xfrm>
+          <a:prstGeom prst="rect">
+            <a:avLst/>
+          </a:prstGeom>
+          <a:noFill/>
+        </p:spPr>
+        <p:txBody>
+          <a:bodyPr wrap="none" lIns="0" rIns="0" tIns="0" bIns="0" anchor="ctr">
+            <a:spAutoFit/>
+          </a:bodyPr>
+          <a:lstStyle/>
+          <a:p>
+            <a:pPr>
+              <a:defRPr sz="854" b="0" i="0">
+                <a:solidFill>
+                  <a:srgbClr val="BB0000"/>
+                </a:solidFill>
+                <a:latin typeface="Arial"/>
+              </a:defRPr>
+            </a:pPr>
+            <a:r>
+              <a:t>Already complete</a:t>
+            </a:r>
+          </a:p>
+        </p:txBody>
+      </p:sp>
+      <p:sp>
+        <p:nvSpPr>
+          <p:cNvPr id="27" name="TextBox 26"/>
+          <p:cNvSpPr txBox="1"/>
+          <p:nvPr/>
+        </p:nvSpPr>
+        <p:spPr>
+          <a:xfrm>
+            <a:off x="1570157" y="2601812"/>
+            <a:ext cx="2040637" cy="201168"/>
+          </a:xfrm>
+          <a:prstGeom prst="rect">
+            <a:avLst/>
+          </a:prstGeom>
+          <a:noFill/>
+        </p:spPr>
+        <p:txBody>
+          <a:bodyPr wrap="none" lIns="0" rIns="0" tIns="0" bIns="0" anchor="ctr">
+            <a:spAutoFit/>
+          </a:bodyPr>
+          <a:lstStyle/>
+          <a:p>
+            <a:pPr>
+              <a:defRPr sz="989" b="1" i="0">
+                <a:solidFill>
+                  <a:srgbClr val="020202"/>
+                </a:solidFill>
+                <a:latin typeface="Arial"/>
+              </a:defRPr>
+            </a:pPr>
+            <a:r>
+              <a:t>ALREADY AT THE FINISH LINE</a:t>
+            </a:r>
+          </a:p>
+        </p:txBody>
+      </p:sp>
+      <p:sp>
+        <p:nvSpPr>
+          <p:cNvPr id="28" name="TextBox 27"/>
+          <p:cNvSpPr txBox="1"/>
+          <p:nvPr/>
+        </p:nvSpPr>
+        <p:spPr>
+          <a:xfrm>
+            <a:off x="1096437" y="2667404"/>
+            <a:ext cx="342535" cy="451855"/>
+          </a:xfrm>
+          <a:prstGeom prst="rect">
+            <a:avLst/>
+          </a:prstGeom>
+          <a:noFill/>
+        </p:spPr>
+        <p:txBody>
+          <a:bodyPr wrap="none" lIns="0" rIns="0" tIns="0" bIns="0" anchor="ctr">
+            <a:spAutoFit/>
+          </a:bodyPr>
+          <a:lstStyle/>
+          <a:p>
+            <a:pPr>
+              <a:defRPr sz="2643" b="0" i="0">
+                <a:solidFill>
+                  <a:srgbClr val="050400"/>
+                </a:solidFill>
+                <a:latin typeface="Arial"/>
+              </a:defRPr>
+            </a:pPr>
+            <a:r>
+              <a:t>2</a:t>
+            </a:r>
+          </a:p>
+        </p:txBody>
+      </p:sp>
+      <p:sp>
+        <p:nvSpPr>
+          <p:cNvPr id="29" name="TextBox 28"/>
+          <p:cNvSpPr txBox="1"/>
+          <p:nvPr/>
+        </p:nvSpPr>
+        <p:spPr>
+          <a:xfrm>
+            <a:off x="1562869" y="2798588"/>
+            <a:ext cx="2346733" cy="201168"/>
+          </a:xfrm>
+          <a:prstGeom prst="rect">
+            <a:avLst/>
+          </a:prstGeom>
+          <a:noFill/>
+        </p:spPr>
+        <p:txBody>
+          <a:bodyPr wrap="none" lIns="0" rIns="0" tIns="0" bIns="0" anchor="ctr">
+            <a:spAutoFit/>
+          </a:bodyPr>
+          <a:lstStyle/>
+          <a:p>
+            <a:pPr>
+              <a:defRPr sz="700" b="0" i="0">
+                <a:solidFill>
+                  <a:srgbClr val="030303"/>
+                </a:solidFill>
+                <a:latin typeface="Arial"/>
+              </a:defRPr>
+            </a:pPr>
+            <a:r>
+              <a:t>While others train and climb for years to reach</a:t>
+            </a:r>
+          </a:p>
+        </p:txBody>
+      </p:sp>
+      <p:sp>
+        <p:nvSpPr>
+          <p:cNvPr id="30" name="TextBox 29"/>
+          <p:cNvSpPr txBox="1"/>
+          <p:nvPr/>
+        </p:nvSpPr>
+        <p:spPr>
+          <a:xfrm>
+            <a:off x="5017377" y="2762148"/>
+            <a:ext cx="1217094" cy="201168"/>
+          </a:xfrm>
+          <a:prstGeom prst="rect">
+            <a:avLst/>
+          </a:prstGeom>
+          <a:noFill/>
+        </p:spPr>
+        <p:txBody>
+          <a:bodyPr wrap="none" lIns="0" rIns="0" tIns="0" bIns="0" anchor="ctr">
+            <a:spAutoFit/>
+          </a:bodyPr>
+          <a:lstStyle/>
+          <a:p>
+            <a:pPr>
+              <a:defRPr sz="776" b="0" i="0">
+                <a:solidFill>
+                  <a:srgbClr val="000000"/>
+                </a:solidFill>
+                <a:latin typeface="Arial"/>
+              </a:defRPr>
+            </a:pPr>
+            <a:r>
+              <a:t>Wins through struggle</a:t>
+            </a:r>
+          </a:p>
+        </p:txBody>
+      </p:sp>
+      <p:sp>
+        <p:nvSpPr>
+          <p:cNvPr id="31" name="TextBox 30"/>
+          <p:cNvSpPr txBox="1"/>
+          <p:nvPr/>
+        </p:nvSpPr>
+        <p:spPr>
+          <a:xfrm>
+            <a:off x="6912254" y="2769436"/>
+            <a:ext cx="816255" cy="201168"/>
+          </a:xfrm>
+          <a:prstGeom prst="rect">
+            <a:avLst/>
+          </a:prstGeom>
+          <a:noFill/>
+        </p:spPr>
+        <p:txBody>
+          <a:bodyPr wrap="none" lIns="0" rIns="0" tIns="0" bIns="0" anchor="ctr">
+            <a:spAutoFit/>
+          </a:bodyPr>
+          <a:lstStyle/>
+          <a:p>
+            <a:pPr>
+              <a:defRPr sz="772" b="0" i="0">
+                <a:solidFill>
+                  <a:srgbClr val="BA0000"/>
+                </a:solidFill>
+                <a:latin typeface="Arial"/>
+              </a:defRPr>
+            </a:pPr>
+            <a:r>
+              <a:t>Wins instantly</a:t>
+            </a:r>
+          </a:p>
+        </p:txBody>
+      </p:sp>
+      <p:sp>
+        <p:nvSpPr>
+          <p:cNvPr id="32" name="TextBox 31"/>
+          <p:cNvSpPr txBox="1"/>
+          <p:nvPr/>
+        </p:nvSpPr>
+        <p:spPr>
+          <a:xfrm>
+            <a:off x="1555581" y="2951636"/>
+            <a:ext cx="2215549" cy="201168"/>
+          </a:xfrm>
+          <a:prstGeom prst="rect">
+            <a:avLst/>
+          </a:prstGeom>
+          <a:noFill/>
+        </p:spPr>
+        <p:txBody>
+          <a:bodyPr wrap="none" lIns="0" rIns="0" tIns="0" bIns="0" anchor="ctr">
+            <a:spAutoFit/>
+          </a:bodyPr>
+          <a:lstStyle/>
+          <a:p>
+            <a:pPr>
+              <a:defRPr sz="721" b="0" i="0">
+                <a:solidFill>
+                  <a:srgbClr val="050404"/>
+                </a:solidFill>
+                <a:latin typeface="Arial"/>
+              </a:defRPr>
+            </a:pPr>
+            <a:r>
+              <a:t>the top, he begins where most protagonists</a:t>
+            </a:r>
+          </a:p>
+        </p:txBody>
+      </p:sp>
+      <p:sp>
+        <p:nvSpPr>
+          <p:cNvPr id="33" name="TextBox 32"/>
+          <p:cNvSpPr txBox="1"/>
+          <p:nvPr/>
+        </p:nvSpPr>
+        <p:spPr>
+          <a:xfrm>
+            <a:off x="1570157" y="3126548"/>
+            <a:ext cx="1078622" cy="201168"/>
+          </a:xfrm>
+          <a:prstGeom prst="rect">
+            <a:avLst/>
+          </a:prstGeom>
+          <a:noFill/>
+        </p:spPr>
+        <p:txBody>
+          <a:bodyPr wrap="none" lIns="0" rIns="0" tIns="0" bIns="0" anchor="ctr">
+            <a:spAutoFit/>
+          </a:bodyPr>
+          <a:lstStyle/>
+          <a:p>
+            <a:pPr>
+              <a:defRPr sz="731" b="0" i="0">
+                <a:solidFill>
+                  <a:srgbClr val="030302"/>
+                </a:solidFill>
+                <a:latin typeface="Arial"/>
+              </a:defRPr>
+            </a:pPr>
+            <a:r>
+              <a:t>are supposed to end.</a:t>
+            </a:r>
+          </a:p>
+        </p:txBody>
+      </p:sp>
+      <p:sp>
+        <p:nvSpPr>
+          <p:cNvPr id="34" name="TextBox 33"/>
+          <p:cNvSpPr txBox="1"/>
+          <p:nvPr/>
+        </p:nvSpPr>
+        <p:spPr>
+          <a:xfrm>
+            <a:off x="6904966" y="3126548"/>
+            <a:ext cx="750663" cy="201168"/>
+          </a:xfrm>
+          <a:prstGeom prst="rect">
+            <a:avLst/>
+          </a:prstGeom>
+          <a:noFill/>
+        </p:spPr>
+        <p:txBody>
+          <a:bodyPr wrap="none" lIns="0" rIns="0" tIns="0" bIns="0" anchor="ctr">
+            <a:spAutoFit/>
+          </a:bodyPr>
+          <a:lstStyle/>
+          <a:p>
+            <a:pPr>
+              <a:defRPr sz="864" b="0" i="0">
+                <a:solidFill>
+                  <a:srgbClr val="C50000"/>
+                </a:solidFill>
+                <a:latin typeface="Arial"/>
+              </a:defRPr>
+            </a:pPr>
+            <a:r>
+              <a:t>Power is the</a:t>
+            </a:r>
+          </a:p>
+        </p:txBody>
+      </p:sp>
+      <p:sp>
+        <p:nvSpPr>
+          <p:cNvPr id="35" name="TextBox 34"/>
+          <p:cNvSpPr txBox="1"/>
+          <p:nvPr/>
+        </p:nvSpPr>
+        <p:spPr>
+          <a:xfrm>
+            <a:off x="5010089" y="3214004"/>
+            <a:ext cx="867270" cy="201168"/>
+          </a:xfrm>
+          <a:prstGeom prst="rect">
+            <a:avLst/>
+          </a:prstGeom>
+          <a:noFill/>
+        </p:spPr>
+        <p:txBody>
+          <a:bodyPr wrap="none" lIns="0" rIns="0" tIns="0" bIns="0" anchor="ctr">
+            <a:spAutoFit/>
+          </a:bodyPr>
+          <a:lstStyle/>
+          <a:p>
+            <a:pPr>
+              <a:defRPr sz="811" b="0" i="0">
+                <a:solidFill>
+                  <a:srgbClr val="000000"/>
+                </a:solidFill>
+                <a:latin typeface="Arial"/>
+              </a:defRPr>
+            </a:pPr>
+            <a:r>
+              <a:t>Power is a goal</a:t>
+            </a:r>
+          </a:p>
+        </p:txBody>
+      </p:sp>
+      <p:sp>
+        <p:nvSpPr>
+          <p:cNvPr id="36" name="TextBox 35"/>
+          <p:cNvSpPr txBox="1"/>
+          <p:nvPr/>
+        </p:nvSpPr>
+        <p:spPr>
+          <a:xfrm>
+            <a:off x="6919542" y="3308748"/>
+            <a:ext cx="801679" cy="201168"/>
+          </a:xfrm>
+          <a:prstGeom prst="rect">
+            <a:avLst/>
+          </a:prstGeom>
+          <a:noFill/>
+        </p:spPr>
+        <p:txBody>
+          <a:bodyPr wrap="none" lIns="0" rIns="0" tIns="0" bIns="0" anchor="ctr">
+            <a:spAutoFit/>
+          </a:bodyPr>
+          <a:lstStyle/>
+          <a:p>
+            <a:pPr>
+              <a:defRPr sz="759" b="0" i="0">
+                <a:solidFill>
+                  <a:srgbClr val="C50102"/>
+                </a:solidFill>
+                <a:latin typeface="Arial"/>
+              </a:defRPr>
+            </a:pPr>
+            <a:r>
+              <a:t>starting point</a:t>
+            </a:r>
+          </a:p>
+        </p:txBody>
+      </p:sp>
+      <p:sp>
+        <p:nvSpPr>
+          <p:cNvPr id="37" name="TextBox 36"/>
+          <p:cNvSpPr txBox="1"/>
+          <p:nvPr/>
+        </p:nvSpPr>
+        <p:spPr>
+          <a:xfrm>
+            <a:off x="1562869" y="3418068"/>
+            <a:ext cx="1996909" cy="201168"/>
+          </a:xfrm>
+          <a:prstGeom prst="rect">
+            <a:avLst/>
+          </a:prstGeom>
+          <a:noFill/>
+        </p:spPr>
+        <p:txBody>
+          <a:bodyPr wrap="none" lIns="0" rIns="0" tIns="0" bIns="0" anchor="ctr">
+            <a:spAutoFit/>
+          </a:bodyPr>
+          <a:lstStyle/>
+          <a:p>
+            <a:pPr>
+              <a:defRPr sz="1032" b="1" i="0">
+                <a:solidFill>
+                  <a:srgbClr val="000000"/>
+                </a:solidFill>
+                <a:latin typeface="Arial"/>
+              </a:defRPr>
+            </a:pPr>
+            <a:r>
+              <a:t>LIMIT-BREAKING SIMPLICITY</a:t>
+            </a:r>
+          </a:p>
+        </p:txBody>
+      </p:sp>
+      <p:sp>
+        <p:nvSpPr>
+          <p:cNvPr id="38" name="TextBox 37"/>
+          <p:cNvSpPr txBox="1"/>
+          <p:nvPr/>
+        </p:nvSpPr>
+        <p:spPr>
+          <a:xfrm>
+            <a:off x="1132877" y="3512811"/>
+            <a:ext cx="269655" cy="400839"/>
+          </a:xfrm>
+          <a:prstGeom prst="rect">
+            <a:avLst/>
+          </a:prstGeom>
+          <a:noFill/>
+        </p:spPr>
+        <p:txBody>
+          <a:bodyPr wrap="none" lIns="0" rIns="0" tIns="0" bIns="0" anchor="ctr">
+            <a:spAutoFit/>
+          </a:bodyPr>
+          <a:lstStyle/>
+          <a:p>
+            <a:pPr>
+              <a:defRPr sz="2080" b="0" i="0">
+                <a:solidFill>
+                  <a:srgbClr val="050400"/>
+                </a:solidFill>
+                <a:latin typeface="Arial"/>
+              </a:defRPr>
+            </a:pPr>
+            <a:r>
+              <a:t>3</a:t>
+            </a:r>
+          </a:p>
+        </p:txBody>
+      </p:sp>
+      <p:sp>
+        <p:nvSpPr>
+          <p:cNvPr id="39" name="TextBox 38"/>
+          <p:cNvSpPr txBox="1"/>
+          <p:nvPr/>
+        </p:nvSpPr>
+        <p:spPr>
+          <a:xfrm>
+            <a:off x="1562869" y="3643995"/>
+            <a:ext cx="2470629" cy="201168"/>
+          </a:xfrm>
+          <a:prstGeom prst="rect">
+            <a:avLst/>
+          </a:prstGeom>
+          <a:noFill/>
+        </p:spPr>
+        <p:txBody>
+          <a:bodyPr wrap="none" lIns="0" rIns="0" tIns="0" bIns="0" anchor="ctr">
+            <a:spAutoFit/>
+          </a:bodyPr>
+          <a:lstStyle/>
+          <a:p>
+            <a:pPr>
+              <a:defRPr sz="700" b="0" i="0">
+                <a:solidFill>
+                  <a:srgbClr val="050504"/>
+                </a:solidFill>
+                <a:latin typeface="Arial"/>
+              </a:defRPr>
+            </a:pPr>
+            <a:r>
+              <a:t>His routine is both disciplined and comically extreme:</a:t>
+            </a:r>
+          </a:p>
+        </p:txBody>
+      </p:sp>
+      <p:sp>
+        <p:nvSpPr>
+          <p:cNvPr id="40" name="TextBox 39"/>
+          <p:cNvSpPr txBox="1"/>
+          <p:nvPr/>
+        </p:nvSpPr>
+        <p:spPr>
+          <a:xfrm>
+            <a:off x="5010089" y="3585691"/>
+            <a:ext cx="859982" cy="201168"/>
+          </a:xfrm>
+          <a:prstGeom prst="rect">
+            <a:avLst/>
+          </a:prstGeom>
+          <a:noFill/>
+        </p:spPr>
+        <p:txBody>
+          <a:bodyPr wrap="none" lIns="0" rIns="0" tIns="0" bIns="0" anchor="ctr">
+            <a:spAutoFit/>
+          </a:bodyPr>
+          <a:lstStyle/>
+          <a:p>
+            <a:pPr>
+              <a:defRPr sz="878" b="0" i="0">
+                <a:solidFill>
+                  <a:srgbClr val="000000"/>
+                </a:solidFill>
+                <a:latin typeface="Arial"/>
+              </a:defRPr>
+            </a:pPr>
+            <a:r>
+              <a:t>Tension comes</a:t>
+            </a:r>
+          </a:p>
+        </p:txBody>
+      </p:sp>
+      <p:sp>
+        <p:nvSpPr>
+          <p:cNvPr id="41" name="TextBox 40"/>
+          <p:cNvSpPr txBox="1"/>
+          <p:nvPr/>
+        </p:nvSpPr>
+        <p:spPr>
+          <a:xfrm>
+            <a:off x="6912254" y="3600267"/>
+            <a:ext cx="859982" cy="201168"/>
+          </a:xfrm>
+          <a:prstGeom prst="rect">
+            <a:avLst/>
+          </a:prstGeom>
+          <a:noFill/>
+        </p:spPr>
+        <p:txBody>
+          <a:bodyPr wrap="none" lIns="0" rIns="0" tIns="0" bIns="0" anchor="ctr">
+            <a:spAutoFit/>
+          </a:bodyPr>
+          <a:lstStyle/>
+          <a:p>
+            <a:pPr>
+              <a:defRPr sz="860" b="0" i="0">
+                <a:solidFill>
+                  <a:srgbClr val="BA0001"/>
+                </a:solidFill>
+                <a:latin typeface="Arial"/>
+              </a:defRPr>
+            </a:pPr>
+            <a:r>
+              <a:t>Tension comes</a:t>
+            </a:r>
+          </a:p>
+        </p:txBody>
+      </p:sp>
+      <p:sp>
+        <p:nvSpPr>
+          <p:cNvPr id="42" name="TextBox 41"/>
+          <p:cNvSpPr txBox="1"/>
+          <p:nvPr/>
+        </p:nvSpPr>
+        <p:spPr>
+          <a:xfrm>
+            <a:off x="1555581" y="3775179"/>
+            <a:ext cx="2011485" cy="201168"/>
+          </a:xfrm>
+          <a:prstGeom prst="rect">
+            <a:avLst/>
+          </a:prstGeom>
+          <a:noFill/>
+        </p:spPr>
+        <p:txBody>
+          <a:bodyPr wrap="none" lIns="0" rIns="0" tIns="0" bIns="0" anchor="ctr">
+            <a:spAutoFit/>
+          </a:bodyPr>
+          <a:lstStyle/>
+          <a:p>
+            <a:pPr>
+              <a:defRPr sz="720" b="0" i="0">
+                <a:solidFill>
+                  <a:srgbClr val="010101"/>
+                </a:solidFill>
+                <a:latin typeface="Arial"/>
+              </a:defRPr>
+            </a:pPr>
+            <a:r>
+              <a:t>100 push-ups, 100 sit-ups, 100 squats,</a:t>
+            </a:r>
+          </a:p>
+        </p:txBody>
+      </p:sp>
+      <p:sp>
+        <p:nvSpPr>
+          <p:cNvPr id="43" name="TextBox 42"/>
+          <p:cNvSpPr txBox="1"/>
+          <p:nvPr/>
+        </p:nvSpPr>
+        <p:spPr>
+          <a:xfrm>
+            <a:off x="5017377" y="3760603"/>
+            <a:ext cx="655919" cy="201168"/>
+          </a:xfrm>
+          <a:prstGeom prst="rect">
+            <a:avLst/>
+          </a:prstGeom>
+          <a:noFill/>
+        </p:spPr>
+        <p:txBody>
+          <a:bodyPr wrap="none" lIns="0" rIns="0" tIns="0" bIns="0" anchor="ctr">
+            <a:spAutoFit/>
+          </a:bodyPr>
+          <a:lstStyle/>
+          <a:p>
+            <a:pPr>
+              <a:defRPr sz="797" b="0" i="0">
+                <a:solidFill>
+                  <a:srgbClr val="000001"/>
+                </a:solidFill>
+                <a:latin typeface="Arial"/>
+              </a:defRPr>
+            </a:pPr>
+            <a:r>
+              <a:t>from battle</a:t>
+            </a:r>
+          </a:p>
+        </p:txBody>
+      </p:sp>
+      <p:sp>
+        <p:nvSpPr>
+          <p:cNvPr id="44" name="TextBox 43"/>
+          <p:cNvSpPr txBox="1"/>
+          <p:nvPr/>
+        </p:nvSpPr>
+        <p:spPr>
+          <a:xfrm>
+            <a:off x="6904966" y="3753315"/>
+            <a:ext cx="823543" cy="201168"/>
+          </a:xfrm>
+          <a:prstGeom prst="rect">
+            <a:avLst/>
+          </a:prstGeom>
+          <a:noFill/>
+        </p:spPr>
+        <p:txBody>
+          <a:bodyPr wrap="none" lIns="0" rIns="0" tIns="0" bIns="0" anchor="ctr">
+            <a:spAutoFit/>
+          </a:bodyPr>
+          <a:lstStyle/>
+          <a:p>
+            <a:pPr>
+              <a:defRPr sz="914" b="0" i="0">
+                <a:solidFill>
+                  <a:srgbClr val="BA0000"/>
+                </a:solidFill>
+                <a:latin typeface="Arial"/>
+              </a:defRPr>
+            </a:pPr>
+            <a:r>
+              <a:t>from meaning</a:t>
+            </a:r>
+          </a:p>
+        </p:txBody>
+      </p:sp>
+      <p:sp>
+        <p:nvSpPr>
+          <p:cNvPr id="45" name="TextBox 44"/>
+          <p:cNvSpPr txBox="1"/>
+          <p:nvPr/>
+        </p:nvSpPr>
+        <p:spPr>
+          <a:xfrm>
+            <a:off x="1562869" y="3942803"/>
+            <a:ext cx="1399294" cy="201168"/>
+          </a:xfrm>
+          <a:prstGeom prst="rect">
+            <a:avLst/>
+          </a:prstGeom>
+          <a:noFill/>
+        </p:spPr>
+        <p:txBody>
+          <a:bodyPr wrap="none" lIns="0" rIns="0" tIns="0" bIns="0" anchor="ctr">
+            <a:spAutoFit/>
+          </a:bodyPr>
+          <a:lstStyle/>
+          <a:p>
+            <a:pPr>
+              <a:defRPr sz="765" b="0" i="0">
+                <a:solidFill>
+                  <a:srgbClr val="020201"/>
+                </a:solidFill>
+                <a:latin typeface="Arial"/>
+              </a:defRPr>
+            </a:pPr>
+            <a:r>
+              <a:t>and a 10 km run every day.</a:t>
+            </a:r>
+          </a:p>
+        </p:txBody>
+      </p:sp>
+      <p:sp>
+        <p:nvSpPr>
+          <p:cNvPr id="46" name="TextBox 45"/>
+          <p:cNvSpPr txBox="1"/>
+          <p:nvPr/>
+        </p:nvSpPr>
+        <p:spPr>
+          <a:xfrm>
+            <a:off x="4303153" y="4117715"/>
+            <a:ext cx="1639798" cy="218639"/>
+          </a:xfrm>
+          <a:prstGeom prst="rect">
+            <a:avLst/>
+          </a:prstGeom>
+          <a:noFill/>
+        </p:spPr>
+        <p:txBody>
+          <a:bodyPr wrap="none" lIns="0" rIns="0" tIns="0" bIns="0" anchor="ctr">
+            <a:spAutoFit/>
+          </a:bodyPr>
+          <a:lstStyle/>
+          <a:p>
+            <a:pPr>
+              <a:defRPr sz="1160" b="1" i="0">
+                <a:solidFill>
+                  <a:srgbClr val="F7F7F7"/>
+                </a:solidFill>
+                <a:latin typeface="Arial"/>
+              </a:defRPr>
+            </a:pPr>
+            <a:r>
+              <a:t>C) NARRATIVE IMPACT</a:t>
+            </a:r>
+          </a:p>
+        </p:txBody>
+      </p:sp>
+      <p:sp>
+        <p:nvSpPr>
+          <p:cNvPr id="47" name="TextBox 46"/>
+          <p:cNvSpPr txBox="1"/>
+          <p:nvPr/>
+        </p:nvSpPr>
+        <p:spPr>
+          <a:xfrm>
+            <a:off x="1577445" y="4263475"/>
+            <a:ext cx="1792845" cy="201168"/>
+          </a:xfrm>
+          <a:prstGeom prst="rect">
+            <a:avLst/>
+          </a:prstGeom>
+          <a:noFill/>
+        </p:spPr>
+        <p:txBody>
+          <a:bodyPr wrap="none" lIns="0" rIns="0" tIns="0" bIns="0" anchor="ctr">
+            <a:spAutoFit/>
+          </a:bodyPr>
+          <a:lstStyle/>
+          <a:p>
+            <a:pPr>
+              <a:defRPr sz="903" b="1" i="0">
+                <a:solidFill>
+                  <a:srgbClr val="010101"/>
+                </a:solidFill>
+                <a:latin typeface="Arial"/>
+              </a:defRPr>
+            </a:pPr>
+            <a:r>
+              <a:t>EMOTIONALLY UNSHAKEN</a:t>
+            </a:r>
+          </a:p>
+        </p:txBody>
+      </p:sp>
+      <p:sp>
+        <p:nvSpPr>
+          <p:cNvPr id="48" name="TextBox 47"/>
+          <p:cNvSpPr txBox="1"/>
+          <p:nvPr/>
+        </p:nvSpPr>
+        <p:spPr>
+          <a:xfrm>
+            <a:off x="1103725" y="4299914"/>
+            <a:ext cx="327959" cy="466431"/>
+          </a:xfrm>
+          <a:prstGeom prst="rect">
+            <a:avLst/>
+          </a:prstGeom>
+          <a:noFill/>
+        </p:spPr>
+        <p:txBody>
+          <a:bodyPr wrap="none" lIns="0" rIns="0" tIns="0" bIns="0" anchor="ctr">
+            <a:spAutoFit/>
+          </a:bodyPr>
+          <a:lstStyle/>
+          <a:p>
+            <a:pPr>
+              <a:defRPr sz="2530" b="0" i="0">
+                <a:solidFill>
+                  <a:srgbClr val="040300"/>
+                </a:solidFill>
+                <a:latin typeface="Arial"/>
+              </a:defRPr>
+            </a:pPr>
+            <a:r>
+              <a:t>4</a:t>
+            </a:r>
+          </a:p>
+        </p:txBody>
+      </p:sp>
+      <p:sp>
+        <p:nvSpPr>
+          <p:cNvPr id="49" name="TextBox 48"/>
+          <p:cNvSpPr txBox="1"/>
+          <p:nvPr/>
+        </p:nvSpPr>
+        <p:spPr>
+          <a:xfrm>
+            <a:off x="1555581" y="4445674"/>
+            <a:ext cx="2062501" cy="201168"/>
+          </a:xfrm>
+          <a:prstGeom prst="rect">
+            <a:avLst/>
+          </a:prstGeom>
+          <a:noFill/>
+        </p:spPr>
+        <p:txBody>
+          <a:bodyPr wrap="none" lIns="0" rIns="0" tIns="0" bIns="0" anchor="ctr">
+            <a:spAutoFit/>
+          </a:bodyPr>
+          <a:lstStyle/>
+          <a:p>
+            <a:pPr>
+              <a:defRPr sz="700" b="0" i="0">
+                <a:solidFill>
+                  <a:srgbClr val="030303"/>
+                </a:solidFill>
+                <a:latin typeface="Arial"/>
+              </a:defRPr>
+            </a:pPr>
+            <a:r>
+              <a:t>He fights without fear, ego, or hesitation.</a:t>
+            </a:r>
+          </a:p>
+        </p:txBody>
+      </p:sp>
+      <p:sp>
+        <p:nvSpPr>
+          <p:cNvPr id="50" name="TextBox 49"/>
+          <p:cNvSpPr txBox="1"/>
+          <p:nvPr/>
+        </p:nvSpPr>
+        <p:spPr>
+          <a:xfrm>
+            <a:off x="5272456" y="4496690"/>
+            <a:ext cx="1158790" cy="201168"/>
+          </a:xfrm>
+          <a:prstGeom prst="rect">
+            <a:avLst/>
+          </a:prstGeom>
+          <a:noFill/>
+        </p:spPr>
+        <p:txBody>
+          <a:bodyPr wrap="none" lIns="0" rIns="0" tIns="0" bIns="0" anchor="ctr">
+            <a:spAutoFit/>
+          </a:bodyPr>
+          <a:lstStyle/>
+          <a:p>
+            <a:pPr>
+              <a:defRPr sz="1162" b="1" i="0">
+                <a:solidFill>
+                  <a:srgbClr val="020200"/>
+                </a:solidFill>
+                <a:latin typeface="Arial"/>
+              </a:defRPr>
+            </a:pPr>
+            <a:r>
+              <a:t>WHY IT WORKS</a:t>
+            </a:r>
+          </a:p>
+        </p:txBody>
+      </p:sp>
+      <p:sp>
+        <p:nvSpPr>
+          <p:cNvPr id="51" name="TextBox 50"/>
+          <p:cNvSpPr txBox="1"/>
+          <p:nvPr/>
+        </p:nvSpPr>
+        <p:spPr>
+          <a:xfrm>
+            <a:off x="1548293" y="4598722"/>
+            <a:ext cx="2033349" cy="201168"/>
+          </a:xfrm>
+          <a:prstGeom prst="rect">
+            <a:avLst/>
+          </a:prstGeom>
+          <a:noFill/>
+        </p:spPr>
+        <p:txBody>
+          <a:bodyPr wrap="none" lIns="0" rIns="0" tIns="0" bIns="0" anchor="ctr">
+            <a:spAutoFit/>
+          </a:bodyPr>
+          <a:lstStyle/>
+          <a:p>
+            <a:pPr>
+              <a:defRPr sz="748" b="0" i="0">
+                <a:solidFill>
+                  <a:srgbClr val="030303"/>
+                </a:solidFill>
+                <a:latin typeface="Arial"/>
+              </a:defRPr>
+            </a:pPr>
+            <a:r>
+              <a:t>No need to prove himself—he's already</a:t>
+            </a:r>
+          </a:p>
+        </p:txBody>
+      </p:sp>
+      <p:sp>
+        <p:nvSpPr>
+          <p:cNvPr id="52" name="TextBox 51"/>
+          <p:cNvSpPr txBox="1"/>
+          <p:nvPr/>
+        </p:nvSpPr>
+        <p:spPr>
+          <a:xfrm>
+            <a:off x="1562869" y="4766346"/>
+            <a:ext cx="1610646" cy="201168"/>
+          </a:xfrm>
+          <a:prstGeom prst="rect">
+            <a:avLst/>
+          </a:prstGeom>
+          <a:noFill/>
+        </p:spPr>
+        <p:txBody>
+          <a:bodyPr wrap="none" lIns="0" rIns="0" tIns="0" bIns="0" anchor="ctr">
+            <a:spAutoFit/>
+          </a:bodyPr>
+          <a:lstStyle/>
+          <a:p>
+            <a:pPr>
+              <a:defRPr sz="706" b="0" i="0">
+                <a:solidFill>
+                  <a:srgbClr val="040303"/>
+                </a:solidFill>
+                <a:latin typeface="Arial"/>
+              </a:defRPr>
+            </a:pPr>
+            <a:r>
+              <a:t>beyond the need for validation.</a:t>
+            </a:r>
+          </a:p>
+        </p:txBody>
+      </p:sp>
+      <p:sp>
+        <p:nvSpPr>
+          <p:cNvPr id="53" name="TextBox 52"/>
+          <p:cNvSpPr txBox="1"/>
+          <p:nvPr/>
+        </p:nvSpPr>
+        <p:spPr>
+          <a:xfrm>
+            <a:off x="5272456" y="4722618"/>
+            <a:ext cx="2579948" cy="201168"/>
+          </a:xfrm>
+          <a:prstGeom prst="rect">
+            <a:avLst/>
+          </a:prstGeom>
+          <a:noFill/>
+        </p:spPr>
+        <p:txBody>
+          <a:bodyPr wrap="none" lIns="0" rIns="0" tIns="0" bIns="0" anchor="ctr">
+            <a:spAutoFit/>
+          </a:bodyPr>
+          <a:lstStyle/>
+          <a:p>
+            <a:pPr>
+              <a:defRPr sz="759" b="0" i="0">
+                <a:solidFill>
+                  <a:srgbClr val="020100"/>
+                </a:solidFill>
+                <a:latin typeface="Arial"/>
+              </a:defRPr>
+            </a:pPr>
+            <a:r>
+              <a:t>Saitama is not just strong in a physical sense.</a:t>
+            </a:r>
+          </a:p>
+        </p:txBody>
+      </p:sp>
+      <p:sp>
+        <p:nvSpPr>
+          <p:cNvPr id="54" name="TextBox 53"/>
+          <p:cNvSpPr txBox="1"/>
+          <p:nvPr/>
+        </p:nvSpPr>
+        <p:spPr>
+          <a:xfrm>
+            <a:off x="5279744" y="4912106"/>
+            <a:ext cx="2485205" cy="201168"/>
+          </a:xfrm>
+          <a:prstGeom prst="rect">
+            <a:avLst/>
+          </a:prstGeom>
+          <a:noFill/>
+        </p:spPr>
+        <p:txBody>
+          <a:bodyPr wrap="none" lIns="0" rIns="0" tIns="0" bIns="0" anchor="ctr">
+            <a:spAutoFit/>
+          </a:bodyPr>
+          <a:lstStyle/>
+          <a:p>
+            <a:pPr>
+              <a:defRPr sz="817" b="0" i="0">
+                <a:solidFill>
+                  <a:srgbClr val="000000"/>
+                </a:solidFill>
+                <a:latin typeface="Arial"/>
+              </a:defRPr>
+            </a:pPr>
+            <a:r>
+              <a:t>He works because his power flips the usual</a:t>
+            </a:r>
+          </a:p>
+        </p:txBody>
+      </p:sp>
+      <p:sp>
+        <p:nvSpPr>
+          <p:cNvPr id="55" name="TextBox 54"/>
+          <p:cNvSpPr txBox="1"/>
+          <p:nvPr/>
+        </p:nvSpPr>
+        <p:spPr>
+          <a:xfrm>
+            <a:off x="1570157" y="5094306"/>
+            <a:ext cx="2434189" cy="201168"/>
+          </a:xfrm>
+          <a:prstGeom prst="rect">
+            <a:avLst/>
+          </a:prstGeom>
+          <a:noFill/>
+        </p:spPr>
+        <p:txBody>
+          <a:bodyPr wrap="none" lIns="0" rIns="0" tIns="0" bIns="0" anchor="ctr">
+            <a:spAutoFit/>
+          </a:bodyPr>
+          <a:lstStyle/>
+          <a:p>
+            <a:pPr>
+              <a:defRPr sz="980" b="1" i="0">
+                <a:solidFill>
+                  <a:srgbClr val="000000"/>
+                </a:solidFill>
+                <a:latin typeface="Arial"/>
+              </a:defRPr>
+            </a:pPr>
+            <a:r>
+              <a:t>THE STORY NEEDS AN UNBEATABLE HERO</a:t>
+            </a:r>
+          </a:p>
+        </p:txBody>
+      </p:sp>
+      <p:sp>
+        <p:nvSpPr>
+          <p:cNvPr id="56" name="TextBox 55"/>
+          <p:cNvSpPr txBox="1"/>
+          <p:nvPr/>
+        </p:nvSpPr>
+        <p:spPr>
+          <a:xfrm>
+            <a:off x="5279744" y="5101594"/>
+            <a:ext cx="2295717" cy="201168"/>
+          </a:xfrm>
+          <a:prstGeom prst="rect">
+            <a:avLst/>
+          </a:prstGeom>
+          <a:noFill/>
+        </p:spPr>
+        <p:txBody>
+          <a:bodyPr wrap="none" lIns="0" rIns="0" tIns="0" bIns="0" anchor="ctr">
+            <a:spAutoFit/>
+          </a:bodyPr>
+          <a:lstStyle/>
+          <a:p>
+            <a:pPr>
+              <a:defRPr sz="799" b="0" i="0">
+                <a:solidFill>
+                  <a:srgbClr val="020000"/>
+                </a:solidFill>
+                <a:latin typeface="Arial"/>
+              </a:defRPr>
+            </a:pPr>
+            <a:r>
+              <a:t>battle-anime formula and turns the real</a:t>
+            </a:r>
+          </a:p>
+        </p:txBody>
+      </p:sp>
+      <p:sp>
+        <p:nvSpPr>
+          <p:cNvPr id="57" name="TextBox 56"/>
+          <p:cNvSpPr txBox="1"/>
+          <p:nvPr/>
+        </p:nvSpPr>
+        <p:spPr>
+          <a:xfrm>
+            <a:off x="1111013" y="5145321"/>
+            <a:ext cx="298807" cy="429991"/>
+          </a:xfrm>
+          <a:prstGeom prst="rect">
+            <a:avLst/>
+          </a:prstGeom>
+          <a:noFill/>
+        </p:spPr>
+        <p:txBody>
+          <a:bodyPr wrap="none" lIns="0" rIns="0" tIns="0" bIns="0" anchor="ctr">
+            <a:spAutoFit/>
+          </a:bodyPr>
+          <a:lstStyle/>
+          <a:p>
+            <a:pPr>
+              <a:defRPr sz="2305" b="0" i="0">
+                <a:solidFill>
+                  <a:srgbClr val="040300"/>
+                </a:solidFill>
+                <a:latin typeface="Arial"/>
+              </a:defRPr>
+            </a:pPr>
+            <a:r>
+              <a:t>5</a:t>
+            </a:r>
+          </a:p>
+        </p:txBody>
+      </p:sp>
+      <p:sp>
+        <p:nvSpPr>
+          <p:cNvPr id="58" name="TextBox 57"/>
+          <p:cNvSpPr txBox="1"/>
+          <p:nvPr/>
+        </p:nvSpPr>
+        <p:spPr>
+          <a:xfrm>
+            <a:off x="1562869" y="5291081"/>
+            <a:ext cx="2222837" cy="201168"/>
+          </a:xfrm>
+          <a:prstGeom prst="rect">
+            <a:avLst/>
+          </a:prstGeom>
+          <a:noFill/>
+        </p:spPr>
+        <p:txBody>
+          <a:bodyPr wrap="none" lIns="0" rIns="0" tIns="0" bIns="0" anchor="ctr">
+            <a:spAutoFit/>
+          </a:bodyPr>
+          <a:lstStyle/>
+          <a:p>
+            <a:pPr>
+              <a:defRPr sz="713" b="0" i="0">
+                <a:solidFill>
+                  <a:srgbClr val="020102"/>
+                </a:solidFill>
+                <a:latin typeface="Arial"/>
+              </a:defRPr>
+            </a:pPr>
+            <a:r>
+              <a:t>His power lets the series go beyond battles</a:t>
+            </a:r>
+          </a:p>
+        </p:txBody>
+      </p:sp>
+      <p:sp>
+        <p:nvSpPr>
+          <p:cNvPr id="59" name="TextBox 58"/>
+          <p:cNvSpPr txBox="1"/>
+          <p:nvPr/>
+        </p:nvSpPr>
+        <p:spPr>
+          <a:xfrm>
+            <a:off x="5272456" y="5276505"/>
+            <a:ext cx="2244701" cy="201168"/>
+          </a:xfrm>
+          <a:prstGeom prst="rect">
+            <a:avLst/>
+          </a:prstGeom>
+          <a:noFill/>
+        </p:spPr>
+        <p:txBody>
+          <a:bodyPr wrap="none" lIns="0" rIns="0" tIns="0" bIns="0" anchor="ctr">
+            <a:spAutoFit/>
+          </a:bodyPr>
+          <a:lstStyle/>
+          <a:p>
+            <a:pPr>
+              <a:defRPr sz="855" b="0" i="0">
+                <a:solidFill>
+                  <a:srgbClr val="010000"/>
+                </a:solidFill>
+                <a:latin typeface="Arial"/>
+              </a:defRPr>
+            </a:pPr>
+            <a:r>
+              <a:t>conflict inward:: purpose, boredom,</a:t>
+            </a:r>
+          </a:p>
+        </p:txBody>
+      </p:sp>
+      <p:sp>
+        <p:nvSpPr>
+          <p:cNvPr id="60" name="TextBox 59"/>
+          <p:cNvSpPr txBox="1"/>
+          <p:nvPr/>
+        </p:nvSpPr>
+        <p:spPr>
+          <a:xfrm>
+            <a:off x="1548293" y="5444129"/>
+            <a:ext cx="2244701" cy="201168"/>
+          </a:xfrm>
+          <a:prstGeom prst="rect">
+            <a:avLst/>
+          </a:prstGeom>
+          <a:noFill/>
+        </p:spPr>
+        <p:txBody>
+          <a:bodyPr wrap="none" lIns="0" rIns="0" tIns="0" bIns="0" anchor="ctr">
+            <a:spAutoFit/>
+          </a:bodyPr>
+          <a:lstStyle/>
+          <a:p>
+            <a:pPr>
+              <a:defRPr sz="741" b="0" i="0">
+                <a:solidFill>
+                  <a:srgbClr val="010101"/>
+                </a:solidFill>
+                <a:latin typeface="Arial"/>
+              </a:defRPr>
+            </a:pPr>
+            <a:r>
+              <a:t>to explore boredom, meaning, and identity</a:t>
+            </a:r>
+          </a:p>
+        </p:txBody>
+      </p:sp>
+      <p:sp>
+        <p:nvSpPr>
+          <p:cNvPr id="61" name="TextBox 60"/>
+          <p:cNvSpPr txBox="1"/>
+          <p:nvPr/>
+        </p:nvSpPr>
+        <p:spPr>
+          <a:xfrm>
+            <a:off x="5265168" y="5451417"/>
+            <a:ext cx="1843861" cy="201168"/>
+          </a:xfrm>
+          <a:prstGeom prst="rect">
+            <a:avLst/>
+          </a:prstGeom>
+          <a:noFill/>
+        </p:spPr>
+        <p:txBody>
+          <a:bodyPr wrap="none" lIns="0" rIns="0" tIns="0" bIns="0" anchor="ctr">
+            <a:spAutoFit/>
+          </a:bodyPr>
+          <a:lstStyle/>
+          <a:p>
+            <a:pPr>
+              <a:defRPr sz="867" b="0" i="0">
+                <a:solidFill>
+                  <a:srgbClr val="000000"/>
+                </a:solidFill>
+                <a:latin typeface="Arial"/>
+              </a:defRPr>
+            </a:pPr>
+            <a:r>
+              <a:t>and the search for challenge.</a:t>
+            </a:r>
+          </a:p>
+        </p:txBody>
+      </p:sp>
+      <p:sp>
+        <p:nvSpPr>
+          <p:cNvPr id="62" name="TextBox 61"/>
+          <p:cNvSpPr txBox="1"/>
+          <p:nvPr/>
+        </p:nvSpPr>
+        <p:spPr>
+          <a:xfrm>
+            <a:off x="1562869" y="5589889"/>
+            <a:ext cx="1173366" cy="201168"/>
+          </a:xfrm>
+          <a:prstGeom prst="rect">
+            <a:avLst/>
+          </a:prstGeom>
+          <a:noFill/>
+        </p:spPr>
+        <p:txBody>
+          <a:bodyPr wrap="none" lIns="0" rIns="0" tIns="0" bIns="0" anchor="ctr">
+            <a:spAutoFit/>
+          </a:bodyPr>
+          <a:lstStyle/>
+          <a:p>
+            <a:pPr>
+              <a:defRPr sz="700" b="0" i="0">
+                <a:solidFill>
+                  <a:srgbClr val="020202"/>
+                </a:solidFill>
+                <a:latin typeface="Arial"/>
+              </a:defRPr>
+            </a:pPr>
+            <a:r>
+              <a:t>after absolute victory.</a:t>
+            </a:r>
+          </a:p>
+        </p:txBody>
+      </p:sp>
+      <p:sp>
+        <p:nvSpPr>
+          <p:cNvPr id="63" name="TextBox 62"/>
+          <p:cNvSpPr txBox="1"/>
+          <p:nvPr/>
+        </p:nvSpPr>
+        <p:spPr>
+          <a:xfrm>
+            <a:off x="9200684" y="4955834"/>
+            <a:ext cx="2820452" cy="1836573"/>
+          </a:xfrm>
+          <a:prstGeom prst="rect">
+            <a:avLst/>
+          </a:prstGeom>
+          <a:noFill/>
+        </p:spPr>
+        <p:txBody>
+          <a:bodyPr wrap="none" lIns="0" rIns="0" tIns="0" bIns="0" anchor="ctr">
+            <a:spAutoFit/>
+          </a:bodyPr>
+          <a:lstStyle/>
+          <a:p>
+            <a:pPr>
+              <a:defRPr sz="3400" b="1" i="0">
+                <a:solidFill>
+                  <a:srgbClr val="FEFEFE"/>
+                </a:solidFill>
+                <a:latin typeface="Arial"/>
+              </a:defRPr>
+            </a:pPr>
+            <a:r>
+              <a:t>BAM</a:t>
+            </a:r>
+          </a:p>
+        </p:txBody>
+      </p:sp>
+      <p:sp>
+        <p:nvSpPr>
+          <p:cNvPr id="64" name="TextBox 63"/>
+          <p:cNvSpPr txBox="1"/>
+          <p:nvPr/>
+        </p:nvSpPr>
+        <p:spPr>
+          <a:xfrm>
+            <a:off x="3384867" y="6070896"/>
+            <a:ext cx="4197883" cy="218639"/>
+          </a:xfrm>
+          <a:prstGeom prst="rect">
+            <a:avLst/>
+          </a:prstGeom>
+          <a:noFill/>
+        </p:spPr>
+        <p:txBody>
+          <a:bodyPr wrap="none" lIns="0" rIns="0" tIns="0" bIns="0" anchor="ctr">
+            <a:spAutoFit/>
+          </a:bodyPr>
+          <a:lstStyle/>
+          <a:p>
+            <a:pPr>
+              <a:defRPr sz="1208" b="0" i="0">
+                <a:solidFill>
+                  <a:srgbClr val="020202"/>
+                </a:solidFill>
+                <a:latin typeface="Arial"/>
+              </a:defRPr>
+            </a:pPr>
+            <a:r>
+              <a:t>One Punch Man is powerful as a character because</a:t>
+            </a:r>
+          </a:p>
+        </p:txBody>
+      </p:sp>
+      <p:sp>
+        <p:nvSpPr>
+          <p:cNvPr id="65" name="TextBox 64"/>
+          <p:cNvSpPr txBox="1"/>
+          <p:nvPr/>
+        </p:nvSpPr>
+        <p:spPr>
+          <a:xfrm>
+            <a:off x="1285925" y="6136488"/>
+            <a:ext cx="1596070" cy="357111"/>
+          </a:xfrm>
+          <a:prstGeom prst="rect">
+            <a:avLst/>
+          </a:prstGeom>
+          <a:noFill/>
+        </p:spPr>
+        <p:txBody>
+          <a:bodyPr wrap="none" lIns="0" rIns="0" tIns="0" bIns="0" anchor="ctr">
+            <a:spAutoFit/>
+          </a:bodyPr>
+          <a:lstStyle/>
+          <a:p>
+            <a:pPr>
+              <a:defRPr sz="2242" b="1" i="0">
+                <a:solidFill>
+                  <a:srgbClr val="FFFFFF"/>
+                </a:solidFill>
+                <a:latin typeface="Impact"/>
+              </a:defRPr>
+            </a:pPr>
+            <a:r>
+              <a:t>D) KEY TAKEAWAY</a:t>
+            </a:r>
+          </a:p>
+        </p:txBody>
+      </p:sp>
+      <p:sp>
+        <p:nvSpPr>
+          <p:cNvPr id="66" name="TextBox 65"/>
+          <p:cNvSpPr txBox="1"/>
+          <p:nvPr/>
+        </p:nvSpPr>
+        <p:spPr>
+          <a:xfrm>
+            <a:off x="3370291" y="6318688"/>
+            <a:ext cx="4256187" cy="240503"/>
+          </a:xfrm>
+          <a:prstGeom prst="rect">
+            <a:avLst/>
+          </a:prstGeom>
+          <a:noFill/>
+        </p:spPr>
+        <p:txBody>
+          <a:bodyPr wrap="none" lIns="0" rIns="0" tIns="0" bIns="0" anchor="ctr">
+            <a:spAutoFit/>
+          </a:bodyPr>
+          <a:lstStyle/>
+          <a:p>
+            <a:pPr>
+              <a:defRPr sz="1089" b="0" i="0">
+                <a:solidFill>
+                  <a:srgbClr val="020202"/>
+                </a:solidFill>
+                <a:latin typeface="Arial"/>
+              </a:defRPr>
+            </a:pPr>
+            <a:r>
+              <a:t>his strength is both a joke and a storytelling device.</a:t>
+            </a:r>
+          </a:p>
+        </p:txBody>
+      </p:sp>
+      <p:pic>
+        <p:nvPicPr>
+          <p:cNvPr id="67" name="Picture 66" descr="image.png"/>
+          <p:cNvPicPr>
+            <a:picLocks noChangeAspect="1"/>
+          </p:cNvPicPr>
+          <p:nvPr/>
+        </p:nvPicPr>
+        <p:blipFill>
+          <a:blip r:embed="rId11"/>
+          <a:stretch>
+            <a:fillRect/>
+          </a:stretch>
+        </p:blipFill>
+        <p:spPr>
+          <a:xfrm>
+            <a:off x="119846" y="5932425"/>
+            <a:ext cx="7994926" cy="794391"/>
+          </a:xfrm>
+          <a:prstGeom prst="rect">
+            <a:avLst/>
+          </a:prstGeom>
+        </p:spPr>
+      </p:pic>
+      <p:pic>
+        <p:nvPicPr>
+          <p:cNvPr id="68" name="Picture 67" descr="image.png"/>
+          <p:cNvPicPr>
+            <a:picLocks noChangeAspect="1"/>
+          </p:cNvPicPr>
+          <p:nvPr/>
+        </p:nvPicPr>
+        <p:blipFill>
+          <a:blip r:embed="rId12"/>
+          <a:stretch>
+            <a:fillRect/>
+          </a:stretch>
+        </p:blipFill>
+        <p:spPr>
+          <a:xfrm>
+            <a:off x="4237562" y="1355566"/>
+            <a:ext cx="3833483" cy="276943"/>
+          </a:xfrm>
+          <a:prstGeom prst="rect">
+            <a:avLst/>
+          </a:prstGeom>
+        </p:spPr>
+      </p:pic>
+      <p:pic>
+        <p:nvPicPr>
+          <p:cNvPr id="69" name="Picture 68" descr="image.png"/>
+          <p:cNvPicPr>
+            <a:picLocks noChangeAspect="1"/>
+          </p:cNvPicPr>
+          <p:nvPr/>
+        </p:nvPicPr>
+        <p:blipFill>
+          <a:blip r:embed="rId13"/>
+          <a:stretch>
+            <a:fillRect/>
+          </a:stretch>
+        </p:blipFill>
+        <p:spPr>
+          <a:xfrm>
+            <a:off x="229166" y="1297262"/>
+            <a:ext cx="2368597" cy="393551"/>
+          </a:xfrm>
+          <a:prstGeom prst="rect">
+            <a:avLst/>
+          </a:prstGeom>
+        </p:spPr>
+      </p:pic>
+      <p:pic>
+        <p:nvPicPr>
+          <p:cNvPr id="70" name="Picture 69" descr="image.png"/>
+          <p:cNvPicPr>
+            <a:picLocks noChangeAspect="1"/>
+          </p:cNvPicPr>
+          <p:nvPr/>
+        </p:nvPicPr>
+        <p:blipFill>
+          <a:blip r:embed="rId14"/>
+          <a:stretch>
+            <a:fillRect/>
+          </a:stretch>
+        </p:blipFill>
+        <p:spPr>
+          <a:xfrm>
+            <a:off x="1089149" y="1785557"/>
+            <a:ext cx="364399" cy="568463"/>
+          </a:xfrm>
+          <a:prstGeom prst="rect">
+            <a:avLst/>
+          </a:prstGeom>
+        </p:spPr>
+      </p:pic>
+      <p:pic>
+        <p:nvPicPr>
+          <p:cNvPr id="71" name="Picture 70" descr="image.png"/>
+          <p:cNvPicPr>
+            <a:picLocks noChangeAspect="1"/>
+          </p:cNvPicPr>
+          <p:nvPr/>
+        </p:nvPicPr>
+        <p:blipFill>
+          <a:blip r:embed="rId15"/>
+          <a:stretch>
+            <a:fillRect/>
+          </a:stretch>
+        </p:blipFill>
+        <p:spPr>
+          <a:xfrm>
+            <a:off x="8384429" y="6107336"/>
+            <a:ext cx="371687" cy="422703"/>
+          </a:xfrm>
+          <a:prstGeom prst="rect">
+            <a:avLst/>
+          </a:prstGeom>
+        </p:spPr>
+      </p:pic>
+      <p:sp>
+        <p:nvSpPr>
+          <p:cNvPr id="72" name="Rectangle 71"/>
+          <p:cNvSpPr/>
+          <p:nvPr/>
+        </p:nvSpPr>
+        <p:spPr>
+          <a:xfrm>
+            <a:off x="236454" y="1333702"/>
+            <a:ext cx="1756405" cy="291519"/>
+          </a:xfrm>
+          <a:prstGeom prst="rect">
+            <a:avLst/>
+          </a:prstGeom>
+          <a:solidFill>
+            <a:srgbClr val="020201"/>
+          </a:solidFill>
+          <a:ln>
+            <a:noFill/>
+          </a:ln>
+        </p:spPr>
+        <p:style>
+          <a:lnRef idx="1">
+            <a:schemeClr val="accent1"/>
+          </a:lnRef>
+          <a:fillRef idx="3">
+            <a:schemeClr val="accent1"/>
+          </a:fillRef>
+          <a:effectRef idx="2">
+            <a:schemeClr val="accent1"/>
+          </a:effectRef>
+          <a:fontRef idx="minor">
+            <a:schemeClr val="lt1"/>
+          </a:fontRef>
+        </p:style>
+        <p:txBody>
+          <a:bodyPr rtlCol="0" anchor="ctr"/>
+          <a:lstStyle/>
+          <a:p>
+            <a:pPr algn="ctr"/>
+          </a:p>
+        </p:txBody>
+      </p:sp>
+      <p:sp>
+        <p:nvSpPr>
+          <p:cNvPr id="73" name="Rectangle 72"/>
+          <p:cNvSpPr/>
+          <p:nvPr/>
+        </p:nvSpPr>
+        <p:spPr>
+          <a:xfrm>
+            <a:off x="4244850" y="1377430"/>
+            <a:ext cx="3600267" cy="247791"/>
+          </a:xfrm>
+          <a:prstGeom prst="rect">
+            <a:avLst/>
+          </a:prstGeom>
+          <a:solidFill>
+            <a:srgbClr val="030303"/>
+          </a:solidFill>
+          <a:ln>
+            <a:noFill/>
+          </a:ln>
+        </p:spPr>
+        <p:style>
+          <a:lnRef idx="1">
+            <a:schemeClr val="accent1"/>
+          </a:lnRef>
+          <a:fillRef idx="3">
+            <a:schemeClr val="accent1"/>
+          </a:fillRef>
+          <a:effectRef idx="2">
+            <a:schemeClr val="accent1"/>
+          </a:effectRef>
+          <a:fontRef idx="minor">
+            <a:schemeClr val="lt1"/>
+          </a:fontRef>
+        </p:style>
+        <p:txBody>
+          <a:bodyPr rtlCol="0" anchor="ctr"/>
+          <a:lstStyle/>
+          <a:p>
+            <a:pPr algn="ctr"/>
+          </a:p>
+        </p:txBody>
+      </p:sp>
+      <p:sp>
+        <p:nvSpPr>
+          <p:cNvPr id="74" name="Rectangle 73"/>
+          <p:cNvSpPr/>
+          <p:nvPr/>
+        </p:nvSpPr>
+        <p:spPr>
+          <a:xfrm>
+            <a:off x="6219895" y="1734541"/>
+            <a:ext cx="685071" cy="502871"/>
+          </a:xfrm>
+          <a:prstGeom prst="rect">
+            <a:avLst/>
+          </a:prstGeom>
+          <a:solidFill>
+            <a:srgbClr val="020201"/>
+          </a:solidFill>
+          <a:ln>
+            <a:noFill/>
+          </a:ln>
+        </p:spPr>
+        <p:style>
+          <a:lnRef idx="1">
+            <a:schemeClr val="accent1"/>
+          </a:lnRef>
+          <a:fillRef idx="3">
+            <a:schemeClr val="accent1"/>
+          </a:fillRef>
+          <a:effectRef idx="2">
+            <a:schemeClr val="accent1"/>
+          </a:effectRef>
+          <a:fontRef idx="minor">
+            <a:schemeClr val="lt1"/>
+          </a:fontRef>
+        </p:style>
+        <p:txBody>
+          <a:bodyPr rtlCol="0" anchor="ctr"/>
+          <a:lstStyle/>
+          <a:p>
+            <a:pPr algn="ctr"/>
+          </a:p>
+        </p:txBody>
+      </p:sp>
+      <p:sp>
+        <p:nvSpPr>
+          <p:cNvPr id="75" name="Rectangle 74"/>
+          <p:cNvSpPr/>
+          <p:nvPr/>
+        </p:nvSpPr>
+        <p:spPr>
+          <a:xfrm>
+            <a:off x="6810223" y="1829285"/>
+            <a:ext cx="962014" cy="327959"/>
+          </a:xfrm>
+          <a:prstGeom prst="rect">
+            <a:avLst/>
+          </a:prstGeom>
+          <a:solidFill>
+            <a:srgbClr val="BC0F0E"/>
+          </a:solidFill>
+          <a:ln>
+            <a:noFill/>
+          </a:ln>
+        </p:spPr>
+        <p:style>
+          <a:lnRef idx="1">
+            <a:schemeClr val="accent1"/>
+          </a:lnRef>
+          <a:fillRef idx="3">
+            <a:schemeClr val="accent1"/>
+          </a:fillRef>
+          <a:effectRef idx="2">
+            <a:schemeClr val="accent1"/>
+          </a:effectRef>
+          <a:fontRef idx="minor">
+            <a:schemeClr val="lt1"/>
+          </a:fontRef>
+        </p:style>
+        <p:txBody>
+          <a:bodyPr rtlCol="0" anchor="ctr"/>
+          <a:lstStyle/>
+          <a:p>
+            <a:pPr algn="ctr"/>
+          </a:p>
+        </p:txBody>
+      </p:sp>
+      <p:sp>
+        <p:nvSpPr>
+          <p:cNvPr id="76" name="Rectangle 75"/>
+          <p:cNvSpPr/>
+          <p:nvPr/>
+        </p:nvSpPr>
+        <p:spPr>
+          <a:xfrm>
+            <a:off x="4230274" y="4103139"/>
+            <a:ext cx="1887589" cy="306095"/>
+          </a:xfrm>
+          <a:prstGeom prst="rect">
+            <a:avLst/>
+          </a:prstGeom>
+          <a:solidFill>
+            <a:srgbClr val="030202"/>
+          </a:solidFill>
+          <a:ln>
+            <a:noFill/>
+          </a:ln>
+        </p:spPr>
+        <p:style>
+          <a:lnRef idx="1">
+            <a:schemeClr val="accent1"/>
+          </a:lnRef>
+          <a:fillRef idx="3">
+            <a:schemeClr val="accent1"/>
+          </a:fillRef>
+          <a:effectRef idx="2">
+            <a:schemeClr val="accent1"/>
+          </a:effectRef>
+          <a:fontRef idx="minor">
+            <a:schemeClr val="lt1"/>
+          </a:fontRef>
+        </p:style>
+        <p:txBody>
+          <a:bodyPr rtlCol="0" anchor="ctr"/>
+          <a:lstStyle/>
+          <a:p>
+            <a:pPr algn="ctr"/>
+          </a:p>
+        </p:txBody>
+      </p:sp>
+      <p:sp>
+        <p:nvSpPr>
+          <p:cNvPr id="77" name="Rectangle 76"/>
+          <p:cNvSpPr/>
+          <p:nvPr/>
+        </p:nvSpPr>
+        <p:spPr>
+          <a:xfrm>
+            <a:off x="1111013" y="6063608"/>
+            <a:ext cx="1945893" cy="502871"/>
+          </a:xfrm>
+          <a:prstGeom prst="rect">
+            <a:avLst/>
+          </a:prstGeom>
+          <a:solidFill>
+            <a:srgbClr val="BD0F0E"/>
+          </a:solidFill>
+          <a:ln>
+            <a:noFill/>
+          </a:ln>
+        </p:spPr>
+        <p:style>
+          <a:lnRef idx="1">
+            <a:schemeClr val="accent1"/>
+          </a:lnRef>
+          <a:fillRef idx="3">
+            <a:schemeClr val="accent1"/>
+          </a:fillRef>
+          <a:effectRef idx="2">
+            <a:schemeClr val="accent1"/>
+          </a:effectRef>
+          <a:fontRef idx="minor">
+            <a:schemeClr val="lt1"/>
+          </a:fontRef>
+        </p:style>
+        <p:txBody>
+          <a:bodyPr rtlCol="0" anchor="ctr"/>
+          <a:lstStyle/>
+          <a:p>
+            <a:pPr algn="ctr"/>
+          </a:p>
+        </p:txBody>
+      </p:sp>
+      <p:sp>
+        <p:nvSpPr>
+          <p:cNvPr id="78" name="TextBox 77"/>
+          <p:cNvSpPr txBox="1"/>
+          <p:nvPr/>
+        </p:nvSpPr>
+        <p:spPr>
+          <a:xfrm>
+            <a:off x="1196137" y="1967757"/>
+            <a:ext cx="96930" cy="201168"/>
+          </a:xfrm>
+          <a:prstGeom prst="rect">
+            <a:avLst/>
+          </a:prstGeom>
+          <a:noFill/>
+        </p:spPr>
+        <p:txBody>
+          <a:bodyPr wrap="none" lIns="0" rIns="0" tIns="0" bIns="0" anchor="ctr">
+            <a:spAutoFit/>
+          </a:bodyPr>
+          <a:lstStyle/>
+          <a:p>
+            <a:pPr>
+              <a:defRPr sz="747" b="0" i="0">
+                <a:solidFill>
+                  <a:srgbClr val="111111"/>
+                </a:solidFill>
+                <a:latin typeface="Malgun Gothic"/>
+              </a:defRPr>
+            </a:pPr>
+            <a:r>
+              <a:t>•</a:t>
+            </a:r>
+          </a:p>
+        </p:txBody>
+      </p:sp>
+      <p:sp>
+        <p:nvSpPr>
+          <p:cNvPr id="79" name="TextBox 78"/>
+          <p:cNvSpPr txBox="1"/>
+          <p:nvPr/>
+        </p:nvSpPr>
+        <p:spPr>
+          <a:xfrm>
+            <a:off x="1241322" y="2142669"/>
+            <a:ext cx="72879" cy="201168"/>
+          </a:xfrm>
+          <a:prstGeom prst="rect">
+            <a:avLst/>
+          </a:prstGeom>
+          <a:noFill/>
+        </p:spPr>
+        <p:txBody>
+          <a:bodyPr wrap="none" lIns="0" rIns="0" tIns="0" bIns="0" anchor="ctr">
+            <a:spAutoFit/>
+          </a:bodyPr>
+          <a:lstStyle/>
+          <a:p>
+            <a:pPr>
+              <a:defRPr sz="700" b="0" i="0">
+                <a:solidFill>
+                  <a:srgbClr val="111111"/>
+                </a:solidFill>
+                <a:latin typeface="Malgun Gothic"/>
+              </a:defRPr>
+            </a:pPr>
+            <a:r>
+              <a:t>•</a:t>
+            </a:r>
+          </a:p>
+        </p:txBody>
+      </p:sp>
+      <p:sp>
+        <p:nvSpPr>
+          <p:cNvPr id="80" name="TextBox 79"/>
+          <p:cNvSpPr txBox="1"/>
+          <p:nvPr/>
+        </p:nvSpPr>
+        <p:spPr>
+          <a:xfrm>
+            <a:off x="6524825" y="3308748"/>
+            <a:ext cx="112235" cy="201168"/>
+          </a:xfrm>
+          <a:prstGeom prst="rect">
+            <a:avLst/>
+          </a:prstGeom>
+          <a:noFill/>
+        </p:spPr>
+        <p:txBody>
+          <a:bodyPr wrap="none" lIns="0" rIns="0" tIns="0" bIns="0" anchor="ctr">
+            <a:spAutoFit/>
+          </a:bodyPr>
+          <a:lstStyle/>
+          <a:p>
+            <a:pPr>
+              <a:defRPr sz="866" b="0" i="0">
+                <a:solidFill>
+                  <a:srgbClr val="111111"/>
+                </a:solidFill>
+                <a:latin typeface="Malgun Gothic"/>
+              </a:defRPr>
+            </a:pPr>
+            <a:r>
+              <a:t>•</a:t>
+            </a:r>
+          </a:p>
+        </p:txBody>
+      </p:sp>
+      <p:sp>
+        <p:nvSpPr>
+          <p:cNvPr id="81" name="TextBox 80"/>
+          <p:cNvSpPr txBox="1"/>
+          <p:nvPr/>
+        </p:nvSpPr>
+        <p:spPr>
+          <a:xfrm>
+            <a:off x="1229370" y="3643995"/>
+            <a:ext cx="86727" cy="201168"/>
+          </a:xfrm>
+          <a:prstGeom prst="rect">
+            <a:avLst/>
+          </a:prstGeom>
+          <a:noFill/>
+        </p:spPr>
+        <p:txBody>
+          <a:bodyPr wrap="none" lIns="0" rIns="0" tIns="0" bIns="0" anchor="ctr">
+            <a:spAutoFit/>
+          </a:bodyPr>
+          <a:lstStyle/>
+          <a:p>
+            <a:pPr>
+              <a:defRPr sz="700" b="0" i="0">
+                <a:solidFill>
+                  <a:srgbClr val="111111"/>
+                </a:solidFill>
+                <a:latin typeface="Malgun Gothic"/>
+              </a:defRPr>
+            </a:pPr>
+            <a:r>
+              <a:t>•</a:t>
+            </a:r>
+          </a:p>
+        </p:txBody>
+      </p:sp>
+      <p:sp>
+        <p:nvSpPr>
+          <p:cNvPr id="82" name="TextBox 81"/>
+          <p:cNvSpPr txBox="1"/>
+          <p:nvPr/>
+        </p:nvSpPr>
+        <p:spPr>
+          <a:xfrm>
+            <a:off x="4515380" y="3760603"/>
+            <a:ext cx="107133" cy="201168"/>
+          </a:xfrm>
+          <a:prstGeom prst="rect">
+            <a:avLst/>
+          </a:prstGeom>
+          <a:noFill/>
+        </p:spPr>
+        <p:txBody>
+          <a:bodyPr wrap="none" lIns="0" rIns="0" tIns="0" bIns="0" anchor="ctr">
+            <a:spAutoFit/>
+          </a:bodyPr>
+          <a:lstStyle/>
+          <a:p>
+            <a:pPr>
+              <a:defRPr sz="826" b="0" i="0">
+                <a:solidFill>
+                  <a:srgbClr val="111111"/>
+                </a:solidFill>
+                <a:latin typeface="Malgun Gothic"/>
+              </a:defRPr>
+            </a:pPr>
+            <a:r>
+              <a:t>•</a:t>
+            </a:r>
+          </a:p>
+        </p:txBody>
+      </p:sp>
+      <p:sp>
+        <p:nvSpPr>
+          <p:cNvPr id="83" name="TextBox 82"/>
+          <p:cNvSpPr txBox="1"/>
+          <p:nvPr/>
+        </p:nvSpPr>
+        <p:spPr>
+          <a:xfrm>
+            <a:off x="6525991" y="3753315"/>
+            <a:ext cx="127539" cy="201168"/>
+          </a:xfrm>
+          <a:prstGeom prst="rect">
+            <a:avLst/>
+          </a:prstGeom>
+          <a:noFill/>
+        </p:spPr>
+        <p:txBody>
+          <a:bodyPr wrap="none" lIns="0" rIns="0" tIns="0" bIns="0" anchor="ctr">
+            <a:spAutoFit/>
+          </a:bodyPr>
+          <a:lstStyle/>
+          <a:p>
+            <a:pPr>
+              <a:defRPr sz="984" b="0" i="0">
+                <a:solidFill>
+                  <a:srgbClr val="111111"/>
+                </a:solidFill>
+                <a:latin typeface="Malgun Gothic"/>
+              </a:defRPr>
+            </a:pPr>
+            <a:r>
+              <a:t>•</a:t>
+            </a:r>
+          </a:p>
+        </p:txBody>
+      </p:sp>
     </p:spTree>
   </p:cSld>
   <p:clrMapOvr>

</xml_diff>

<commit_message>
Keep editable text above visual layers
</commit_message>
<xml_diff>
--- a/docs/examples/one-pun-editable.pptx
+++ b/docs/examples/one-pun-editable.pptx
@@ -3180,7 +3180,7 @@
       </p:sp>
       <p:pic>
         <p:nvPicPr>
-          <p:cNvPr id="4" name="Picture 3" descr="residual-153.png"/>
+          <p:cNvPr id="4" name="Picture 3" descr="image.png"/>
           <p:cNvPicPr>
             <a:picLocks noChangeAspect="1"/>
           </p:cNvPicPr>
@@ -3194,8 +3194,8 @@
         </p:blipFill>
         <p:spPr>
           <a:xfrm>
-            <a:off x="8151213" y="0"/>
-            <a:ext cx="4037547" cy="6858000"/>
+            <a:off x="229166" y="1297262"/>
+            <a:ext cx="2368597" cy="393551"/>
           </a:xfrm>
           <a:prstGeom prst="rect">
             <a:avLst/>
@@ -3204,7 +3204,7 @@
       </p:pic>
       <p:pic>
         <p:nvPicPr>
-          <p:cNvPr id="5" name="Picture 4" descr="residual-154.png"/>
+          <p:cNvPr id="5" name="Picture 4" descr="image.png"/>
           <p:cNvPicPr>
             <a:picLocks noChangeAspect="1"/>
           </p:cNvPicPr>
@@ -3218,8 +3218,8 @@
         </p:blipFill>
         <p:spPr>
           <a:xfrm>
-            <a:off x="8712388" y="0"/>
-            <a:ext cx="597615" cy="947438"/>
+            <a:off x="4237562" y="1355566"/>
+            <a:ext cx="3833483" cy="276943"/>
           </a:xfrm>
           <a:prstGeom prst="rect">
             <a:avLst/>
@@ -3228,7 +3228,7 @@
       </p:pic>
       <p:pic>
         <p:nvPicPr>
-          <p:cNvPr id="6" name="Picture 5" descr="residual-114.png"/>
+          <p:cNvPr id="6" name="Picture 5" descr="image.png"/>
           <p:cNvPicPr>
             <a:picLocks noChangeAspect="1"/>
           </p:cNvPicPr>
@@ -3242,8 +3242,8 @@
         </p:blipFill>
         <p:spPr>
           <a:xfrm>
-            <a:off x="323910" y="1676238"/>
-            <a:ext cx="685071" cy="736087"/>
+            <a:off x="1089149" y="1785557"/>
+            <a:ext cx="364399" cy="568463"/>
           </a:xfrm>
           <a:prstGeom prst="rect">
             <a:avLst/>
@@ -3266,8 +3266,8 @@
         </p:blipFill>
         <p:spPr>
           <a:xfrm>
-            <a:off x="4274001" y="1763693"/>
-            <a:ext cx="4270763" cy="2186397"/>
+            <a:off x="119846" y="5932425"/>
+            <a:ext cx="7994926" cy="794391"/>
           </a:xfrm>
           <a:prstGeom prst="rect">
             <a:avLst/>
@@ -3276,7 +3276,7 @@
       </p:pic>
       <p:pic>
         <p:nvPicPr>
-          <p:cNvPr id="8" name="Picture 7" descr="residual-94.png"/>
+          <p:cNvPr id="8" name="Picture 7" descr="image.png"/>
           <p:cNvPicPr>
             <a:picLocks noChangeAspect="1"/>
           </p:cNvPicPr>
@@ -3290,8 +3290,8 @@
         </p:blipFill>
         <p:spPr>
           <a:xfrm>
-            <a:off x="323910" y="2550797"/>
-            <a:ext cx="699647" cy="670495"/>
+            <a:off x="8384429" y="6107336"/>
+            <a:ext cx="371687" cy="422703"/>
           </a:xfrm>
           <a:prstGeom prst="rect">
             <a:avLst/>
@@ -3300,7 +3300,7 @@
       </p:pic>
       <p:pic>
         <p:nvPicPr>
-          <p:cNvPr id="9" name="Picture 8" descr="residual-81.png"/>
+          <p:cNvPr id="9" name="Picture 8" descr="residual-153.png"/>
           <p:cNvPicPr>
             <a:picLocks noChangeAspect="1"/>
           </p:cNvPicPr>
@@ -3314,8 +3314,8 @@
         </p:blipFill>
         <p:spPr>
           <a:xfrm>
-            <a:off x="323910" y="3330612"/>
-            <a:ext cx="699647" cy="714223"/>
+            <a:off x="8151213" y="0"/>
+            <a:ext cx="4037547" cy="6858000"/>
           </a:xfrm>
           <a:prstGeom prst="rect">
             <a:avLst/>
@@ -3324,7 +3324,7 @@
       </p:pic>
       <p:pic>
         <p:nvPicPr>
-          <p:cNvPr id="10" name="Picture 9" descr="image.png"/>
+          <p:cNvPr id="10" name="Picture 9" descr="residual-154.png"/>
           <p:cNvPicPr>
             <a:picLocks noChangeAspect="1"/>
           </p:cNvPicPr>
@@ -3338,8 +3338,8 @@
         </p:blipFill>
         <p:spPr>
           <a:xfrm>
-            <a:off x="4237562" y="4117715"/>
-            <a:ext cx="3920939" cy="1719965"/>
+            <a:off x="8712388" y="0"/>
+            <a:ext cx="597615" cy="947438"/>
           </a:xfrm>
           <a:prstGeom prst="rect">
             <a:avLst/>
@@ -3348,7 +3348,7 @@
       </p:pic>
       <p:pic>
         <p:nvPicPr>
-          <p:cNvPr id="11" name="Picture 10" descr="residual-48.png"/>
+          <p:cNvPr id="11" name="Picture 10" descr="residual-114.png"/>
           <p:cNvPicPr>
             <a:picLocks noChangeAspect="1"/>
           </p:cNvPicPr>
@@ -3362,8 +3362,8 @@
         </p:blipFill>
         <p:spPr>
           <a:xfrm>
-            <a:off x="323910" y="4205171"/>
-            <a:ext cx="685071" cy="663207"/>
+            <a:off x="323910" y="1676238"/>
+            <a:ext cx="685071" cy="736087"/>
           </a:xfrm>
           <a:prstGeom prst="rect">
             <a:avLst/>
@@ -3372,7 +3372,7 @@
       </p:pic>
       <p:pic>
         <p:nvPicPr>
-          <p:cNvPr id="12" name="Picture 11" descr="residual-28.png"/>
+          <p:cNvPr id="12" name="Picture 11" descr="image.png"/>
           <p:cNvPicPr>
             <a:picLocks noChangeAspect="1"/>
           </p:cNvPicPr>
@@ -3386,1961 +3386,17 @@
         </p:blipFill>
         <p:spPr>
           <a:xfrm>
-            <a:off x="323910" y="4977698"/>
-            <a:ext cx="692359" cy="728799"/>
+            <a:off x="4274001" y="1763693"/>
+            <a:ext cx="4270763" cy="2186397"/>
           </a:xfrm>
           <a:prstGeom prst="rect">
             <a:avLst/>
           </a:prstGeom>
         </p:spPr>
       </p:pic>
-      <p:sp>
-        <p:nvSpPr>
-          <p:cNvPr id="13" name="TextBox 12"/>
-          <p:cNvSpPr txBox="1"/>
-          <p:nvPr/>
-        </p:nvSpPr>
-        <p:spPr>
-          <a:xfrm>
-            <a:off x="148998" y="7287"/>
-            <a:ext cx="7958486" cy="983878"/>
-          </a:xfrm>
-          <a:prstGeom prst="rect">
-            <a:avLst/>
-          </a:prstGeom>
-          <a:noFill/>
-        </p:spPr>
-        <p:txBody>
-          <a:bodyPr wrap="none" lIns="0" rIns="0" tIns="0" bIns="0" anchor="ctr">
-            <a:spAutoFit/>
-          </a:bodyPr>
-          <a:lstStyle/>
-          <a:p>
-            <a:pPr>
-              <a:defRPr sz="5419" b="1" i="0">
-                <a:solidFill>
-                  <a:srgbClr val="030303"/>
-                </a:solidFill>
-                <a:latin typeface="Impact"/>
-              </a:defRPr>
-            </a:pPr>
-            <a:r>
-              <a:t>Why Is One Punch Man So Strong?</a:t>
-            </a:r>
-          </a:p>
-        </p:txBody>
-      </p:sp>
-      <p:sp>
-        <p:nvSpPr>
-          <p:cNvPr id="14" name="TextBox 13"/>
-          <p:cNvSpPr txBox="1"/>
-          <p:nvPr/>
-        </p:nvSpPr>
-        <p:spPr>
-          <a:xfrm>
-            <a:off x="294758" y="998454"/>
-            <a:ext cx="6777832" cy="218639"/>
-          </a:xfrm>
-          <a:prstGeom prst="rect">
-            <a:avLst/>
-          </a:prstGeom>
-          <a:noFill/>
-        </p:spPr>
-        <p:txBody>
-          <a:bodyPr wrap="none" lIns="0" rIns="0" tIns="0" bIns="0" anchor="ctr">
-            <a:spAutoFit/>
-          </a:bodyPr>
-          <a:lstStyle/>
-          <a:p>
-            <a:pPr>
-              <a:defRPr sz="1080" b="0" i="1">
-                <a:solidFill>
-                  <a:srgbClr val="000000"/>
-                </a:solidFill>
-                <a:latin typeface="Arial"/>
-              </a:defRPr>
-            </a:pPr>
-            <a:r>
-              <a:t>Narrative, psychological, and structural reasons behind Saitama's overwhelming power</a:t>
-            </a:r>
-          </a:p>
-        </p:txBody>
-      </p:sp>
-      <p:sp>
-        <p:nvSpPr>
-          <p:cNvPr id="15" name="TextBox 14"/>
-          <p:cNvSpPr txBox="1"/>
-          <p:nvPr/>
-        </p:nvSpPr>
-        <p:spPr>
-          <a:xfrm>
-            <a:off x="331198" y="1355566"/>
-            <a:ext cx="1486750" cy="225927"/>
-          </a:xfrm>
-          <a:prstGeom prst="rect">
-            <a:avLst/>
-          </a:prstGeom>
-          <a:noFill/>
-        </p:spPr>
-        <p:txBody>
-          <a:bodyPr wrap="none" lIns="0" rIns="0" tIns="0" bIns="0" anchor="ctr">
-            <a:spAutoFit/>
-          </a:bodyPr>
-          <a:lstStyle/>
-          <a:p>
-            <a:pPr>
-              <a:defRPr sz="1334" b="1" i="0">
-                <a:solidFill>
-                  <a:srgbClr val="FFFFFF"/>
-                </a:solidFill>
-                <a:latin typeface="Arial"/>
-              </a:defRPr>
-            </a:pPr>
-            <a:r>
-              <a:t>A) CORE REASONS</a:t>
-            </a:r>
-          </a:p>
-        </p:txBody>
-      </p:sp>
-      <p:sp>
-        <p:nvSpPr>
-          <p:cNvPr id="16" name="TextBox 15"/>
-          <p:cNvSpPr txBox="1"/>
-          <p:nvPr/>
-        </p:nvSpPr>
-        <p:spPr>
-          <a:xfrm>
-            <a:off x="4354169" y="1399294"/>
-            <a:ext cx="3316036" cy="201168"/>
-          </a:xfrm>
-          <a:prstGeom prst="rect">
-            <a:avLst/>
-          </a:prstGeom>
-          <a:noFill/>
-        </p:spPr>
-        <p:txBody>
-          <a:bodyPr wrap="none" lIns="0" rIns="0" tIns="0" bIns="0" anchor="ctr">
-            <a:spAutoFit/>
-          </a:bodyPr>
-          <a:lstStyle/>
-          <a:p>
-            <a:pPr>
-              <a:defRPr sz="1038" b="1" i="0">
-                <a:solidFill>
-                  <a:srgbClr val="F8D264"/>
-                </a:solidFill>
-                <a:latin typeface="Arial"/>
-              </a:defRPr>
-            </a:pPr>
-            <a:r>
-              <a:t>B) HOW HE DIFFERS FROM TYPICAL SHONEN HEROES</a:t>
-            </a:r>
-          </a:p>
-        </p:txBody>
-      </p:sp>
-      <p:sp>
-        <p:nvSpPr>
-          <p:cNvPr id="17" name="TextBox 16"/>
-          <p:cNvSpPr txBox="1"/>
-          <p:nvPr/>
-        </p:nvSpPr>
-        <p:spPr>
-          <a:xfrm>
-            <a:off x="1577445" y="1770981"/>
-            <a:ext cx="1340990" cy="201168"/>
-          </a:xfrm>
-          <a:prstGeom prst="rect">
-            <a:avLst/>
-          </a:prstGeom>
-          <a:noFill/>
-        </p:spPr>
-        <p:txBody>
-          <a:bodyPr wrap="none" lIns="0" rIns="0" tIns="0" bIns="0" anchor="ctr">
-            <a:spAutoFit/>
-          </a:bodyPr>
-          <a:lstStyle/>
-          <a:p>
-            <a:pPr>
-              <a:defRPr sz="946" b="1" i="0">
-                <a:solidFill>
-                  <a:srgbClr val="010101"/>
-                </a:solidFill>
-                <a:latin typeface="Arial"/>
-              </a:defRPr>
-            </a:pPr>
-            <a:r>
-              <a:t>BUILT AS A SATIRE</a:t>
-            </a:r>
-          </a:p>
-        </p:txBody>
-      </p:sp>
-      <p:sp>
-        <p:nvSpPr>
-          <p:cNvPr id="18" name="TextBox 17"/>
-          <p:cNvSpPr txBox="1"/>
-          <p:nvPr/>
-        </p:nvSpPr>
-        <p:spPr>
-          <a:xfrm>
-            <a:off x="1140165" y="1865725"/>
-            <a:ext cx="218639" cy="400839"/>
-          </a:xfrm>
-          <a:prstGeom prst="rect">
-            <a:avLst/>
-          </a:prstGeom>
-          <a:noFill/>
-        </p:spPr>
-        <p:txBody>
-          <a:bodyPr wrap="none" lIns="0" rIns="0" tIns="0" bIns="0" anchor="ctr">
-            <a:spAutoFit/>
-          </a:bodyPr>
-          <a:lstStyle/>
-          <a:p>
-            <a:pPr>
-              <a:defRPr sz="1687" b="0" i="0">
-                <a:solidFill>
-                  <a:srgbClr val="050400"/>
-                </a:solidFill>
-                <a:latin typeface="Arial"/>
-              </a:defRPr>
-            </a:pPr>
-            <a:r>
-              <a:t>1</a:t>
-            </a:r>
-          </a:p>
-        </p:txBody>
-      </p:sp>
-      <p:sp>
-        <p:nvSpPr>
-          <p:cNvPr id="19" name="TextBox 18"/>
-          <p:cNvSpPr txBox="1"/>
-          <p:nvPr/>
-        </p:nvSpPr>
-        <p:spPr>
-          <a:xfrm>
-            <a:off x="1562869" y="1967757"/>
-            <a:ext cx="2368597" cy="201168"/>
-          </a:xfrm>
-          <a:prstGeom prst="rect">
-            <a:avLst/>
-          </a:prstGeom>
-          <a:noFill/>
-        </p:spPr>
-        <p:txBody>
-          <a:bodyPr wrap="none" lIns="0" rIns="0" tIns="0" bIns="0" anchor="ctr">
-            <a:spAutoFit/>
-          </a:bodyPr>
-          <a:lstStyle/>
-          <a:p>
-            <a:pPr>
-              <a:defRPr sz="726" b="0" i="0">
-                <a:solidFill>
-                  <a:srgbClr val="040303"/>
-                </a:solidFill>
-                <a:latin typeface="Arial"/>
-              </a:defRPr>
-            </a:pPr>
-            <a:r>
-              <a:t>Saitama was designed to parody power-scaling</a:t>
-            </a:r>
-          </a:p>
-        </p:txBody>
-      </p:sp>
-      <p:sp>
-        <p:nvSpPr>
-          <p:cNvPr id="20" name="TextBox 19"/>
-          <p:cNvSpPr txBox="1"/>
-          <p:nvPr/>
-        </p:nvSpPr>
-        <p:spPr>
-          <a:xfrm>
-            <a:off x="4813313" y="1916741"/>
-            <a:ext cx="1319126" cy="201168"/>
-          </a:xfrm>
-          <a:prstGeom prst="rect">
-            <a:avLst/>
-          </a:prstGeom>
-          <a:noFill/>
-        </p:spPr>
-        <p:txBody>
-          <a:bodyPr wrap="none" lIns="0" rIns="0" tIns="0" bIns="0" anchor="ctr">
-            <a:spAutoFit/>
-          </a:bodyPr>
-          <a:lstStyle/>
-          <a:p>
-            <a:pPr>
-              <a:defRPr sz="903" b="1" i="0">
-                <a:solidFill>
-                  <a:srgbClr val="000000"/>
-                </a:solidFill>
-                <a:latin typeface="Arial"/>
-              </a:defRPr>
-            </a:pPr>
-            <a:r>
-              <a:t>TYPICAL SHONEN HERO</a:t>
-            </a:r>
-          </a:p>
-        </p:txBody>
-      </p:sp>
-      <p:sp>
-        <p:nvSpPr>
-          <p:cNvPr id="21" name="TextBox 20"/>
-          <p:cNvSpPr txBox="1"/>
-          <p:nvPr/>
-        </p:nvSpPr>
-        <p:spPr>
-          <a:xfrm>
-            <a:off x="6351079" y="1807421"/>
-            <a:ext cx="378975" cy="357111"/>
-          </a:xfrm>
-          <a:prstGeom prst="rect">
-            <a:avLst/>
-          </a:prstGeom>
-          <a:noFill/>
-        </p:spPr>
-        <p:txBody>
-          <a:bodyPr wrap="none" lIns="0" rIns="0" tIns="0" bIns="0" anchor="ctr">
-            <a:spAutoFit/>
-          </a:bodyPr>
-          <a:lstStyle/>
-          <a:p>
-            <a:pPr>
-              <a:defRPr sz="1624" b="1" i="0">
-                <a:solidFill>
-                  <a:srgbClr val="F7C403"/>
-                </a:solidFill>
-                <a:latin typeface="Arial"/>
-              </a:defRPr>
-            </a:pPr>
-            <a:r>
-              <a:t>VS.</a:t>
-            </a:r>
-          </a:p>
-        </p:txBody>
-      </p:sp>
-      <p:sp>
-        <p:nvSpPr>
-          <p:cNvPr id="22" name="TextBox 21"/>
-          <p:cNvSpPr txBox="1"/>
-          <p:nvPr/>
-        </p:nvSpPr>
-        <p:spPr>
-          <a:xfrm>
-            <a:off x="6985134" y="1902165"/>
-            <a:ext cx="612191" cy="201168"/>
-          </a:xfrm>
-          <a:prstGeom prst="rect">
-            <a:avLst/>
-          </a:prstGeom>
-          <a:noFill/>
-        </p:spPr>
-        <p:txBody>
-          <a:bodyPr wrap="none" lIns="0" rIns="0" tIns="0" bIns="0" anchor="ctr">
-            <a:spAutoFit/>
-          </a:bodyPr>
-          <a:lstStyle/>
-          <a:p>
-            <a:pPr>
-              <a:defRPr sz="1075" b="1" i="0">
-                <a:solidFill>
-                  <a:srgbClr val="FFFFFF"/>
-                </a:solidFill>
-                <a:latin typeface="Arial"/>
-              </a:defRPr>
-            </a:pPr>
-            <a:r>
-              <a:t>SAITAMA</a:t>
-            </a:r>
-          </a:p>
-        </p:txBody>
-      </p:sp>
-      <p:sp>
-        <p:nvSpPr>
-          <p:cNvPr id="23" name="TextBox 22"/>
-          <p:cNvSpPr txBox="1"/>
-          <p:nvPr/>
-        </p:nvSpPr>
-        <p:spPr>
-          <a:xfrm>
-            <a:off x="1577445" y="2142669"/>
-            <a:ext cx="2171821" cy="201168"/>
-          </a:xfrm>
-          <a:prstGeom prst="rect">
-            <a:avLst/>
-          </a:prstGeom>
-          <a:noFill/>
-        </p:spPr>
-        <p:txBody>
-          <a:bodyPr wrap="none" lIns="0" rIns="0" tIns="0" bIns="0" anchor="ctr">
-            <a:spAutoFit/>
-          </a:bodyPr>
-          <a:lstStyle/>
-          <a:p>
-            <a:pPr>
-              <a:defRPr sz="700" b="0" i="0">
-                <a:solidFill>
-                  <a:srgbClr val="040303"/>
-                </a:solidFill>
-                <a:latin typeface="Arial"/>
-              </a:defRPr>
-            </a:pPr>
-            <a:r>
-              <a:t>stories—his absurd strength is the premise</a:t>
-            </a:r>
-          </a:p>
-        </p:txBody>
-      </p:sp>
-      <p:sp>
-        <p:nvSpPr>
-          <p:cNvPr id="24" name="TextBox 23"/>
-          <p:cNvSpPr txBox="1"/>
-          <p:nvPr/>
-        </p:nvSpPr>
-        <p:spPr>
-          <a:xfrm>
-            <a:off x="1562869" y="2273853"/>
-            <a:ext cx="816255" cy="201168"/>
-          </a:xfrm>
-          <a:prstGeom prst="rect">
-            <a:avLst/>
-          </a:prstGeom>
-          <a:noFill/>
-        </p:spPr>
-        <p:txBody>
-          <a:bodyPr wrap="none" lIns="0" rIns="0" tIns="0" bIns="0" anchor="ctr">
-            <a:spAutoFit/>
-          </a:bodyPr>
-          <a:lstStyle/>
-          <a:p>
-            <a:pPr>
-              <a:defRPr sz="741" b="0" i="0">
-                <a:solidFill>
-                  <a:srgbClr val="000000"/>
-                </a:solidFill>
-                <a:latin typeface="Arial"/>
-              </a:defRPr>
-            </a:pPr>
-            <a:r>
-              <a:t>not the reward.</a:t>
-            </a:r>
-          </a:p>
-        </p:txBody>
-      </p:sp>
-      <p:sp>
-        <p:nvSpPr>
-          <p:cNvPr id="25" name="TextBox 24"/>
-          <p:cNvSpPr txBox="1"/>
-          <p:nvPr/>
-        </p:nvSpPr>
-        <p:spPr>
-          <a:xfrm>
-            <a:off x="5024665" y="2339445"/>
-            <a:ext cx="641343" cy="201168"/>
-          </a:xfrm>
-          <a:prstGeom prst="rect">
-            <a:avLst/>
-          </a:prstGeom>
-          <a:noFill/>
-        </p:spPr>
-        <p:txBody>
-          <a:bodyPr wrap="none" lIns="0" rIns="0" tIns="0" bIns="0" anchor="ctr">
-            <a:spAutoFit/>
-          </a:bodyPr>
-          <a:lstStyle/>
-          <a:p>
-            <a:pPr>
-              <a:defRPr sz="860" b="0" i="0">
-                <a:solidFill>
-                  <a:srgbClr val="000000"/>
-                </a:solidFill>
-                <a:latin typeface="Arial"/>
-              </a:defRPr>
-            </a:pPr>
-            <a:r>
-              <a:t>Growth arc</a:t>
-            </a:r>
-          </a:p>
-        </p:txBody>
-      </p:sp>
-      <p:sp>
-        <p:nvSpPr>
-          <p:cNvPr id="26" name="TextBox 25"/>
-          <p:cNvSpPr txBox="1"/>
-          <p:nvPr/>
-        </p:nvSpPr>
-        <p:spPr>
-          <a:xfrm>
-            <a:off x="6912254" y="2332157"/>
-            <a:ext cx="1034894" cy="201168"/>
-          </a:xfrm>
-          <a:prstGeom prst="rect">
-            <a:avLst/>
-          </a:prstGeom>
-          <a:noFill/>
-        </p:spPr>
-        <p:txBody>
-          <a:bodyPr wrap="none" lIns="0" rIns="0" tIns="0" bIns="0" anchor="ctr">
-            <a:spAutoFit/>
-          </a:bodyPr>
-          <a:lstStyle/>
-          <a:p>
-            <a:pPr>
-              <a:defRPr sz="854" b="0" i="0">
-                <a:solidFill>
-                  <a:srgbClr val="BB0000"/>
-                </a:solidFill>
-                <a:latin typeface="Arial"/>
-              </a:defRPr>
-            </a:pPr>
-            <a:r>
-              <a:t>Already complete</a:t>
-            </a:r>
-          </a:p>
-        </p:txBody>
-      </p:sp>
-      <p:sp>
-        <p:nvSpPr>
-          <p:cNvPr id="27" name="TextBox 26"/>
-          <p:cNvSpPr txBox="1"/>
-          <p:nvPr/>
-        </p:nvSpPr>
-        <p:spPr>
-          <a:xfrm>
-            <a:off x="1570157" y="2601812"/>
-            <a:ext cx="2040637" cy="201168"/>
-          </a:xfrm>
-          <a:prstGeom prst="rect">
-            <a:avLst/>
-          </a:prstGeom>
-          <a:noFill/>
-        </p:spPr>
-        <p:txBody>
-          <a:bodyPr wrap="none" lIns="0" rIns="0" tIns="0" bIns="0" anchor="ctr">
-            <a:spAutoFit/>
-          </a:bodyPr>
-          <a:lstStyle/>
-          <a:p>
-            <a:pPr>
-              <a:defRPr sz="989" b="1" i="0">
-                <a:solidFill>
-                  <a:srgbClr val="020202"/>
-                </a:solidFill>
-                <a:latin typeface="Arial"/>
-              </a:defRPr>
-            </a:pPr>
-            <a:r>
-              <a:t>ALREADY AT THE FINISH LINE</a:t>
-            </a:r>
-          </a:p>
-        </p:txBody>
-      </p:sp>
-      <p:sp>
-        <p:nvSpPr>
-          <p:cNvPr id="28" name="TextBox 27"/>
-          <p:cNvSpPr txBox="1"/>
-          <p:nvPr/>
-        </p:nvSpPr>
-        <p:spPr>
-          <a:xfrm>
-            <a:off x="1096437" y="2667404"/>
-            <a:ext cx="342535" cy="451855"/>
-          </a:xfrm>
-          <a:prstGeom prst="rect">
-            <a:avLst/>
-          </a:prstGeom>
-          <a:noFill/>
-        </p:spPr>
-        <p:txBody>
-          <a:bodyPr wrap="none" lIns="0" rIns="0" tIns="0" bIns="0" anchor="ctr">
-            <a:spAutoFit/>
-          </a:bodyPr>
-          <a:lstStyle/>
-          <a:p>
-            <a:pPr>
-              <a:defRPr sz="2643" b="0" i="0">
-                <a:solidFill>
-                  <a:srgbClr val="050400"/>
-                </a:solidFill>
-                <a:latin typeface="Arial"/>
-              </a:defRPr>
-            </a:pPr>
-            <a:r>
-              <a:t>2</a:t>
-            </a:r>
-          </a:p>
-        </p:txBody>
-      </p:sp>
-      <p:sp>
-        <p:nvSpPr>
-          <p:cNvPr id="29" name="TextBox 28"/>
-          <p:cNvSpPr txBox="1"/>
-          <p:nvPr/>
-        </p:nvSpPr>
-        <p:spPr>
-          <a:xfrm>
-            <a:off x="1562869" y="2798588"/>
-            <a:ext cx="2346733" cy="201168"/>
-          </a:xfrm>
-          <a:prstGeom prst="rect">
-            <a:avLst/>
-          </a:prstGeom>
-          <a:noFill/>
-        </p:spPr>
-        <p:txBody>
-          <a:bodyPr wrap="none" lIns="0" rIns="0" tIns="0" bIns="0" anchor="ctr">
-            <a:spAutoFit/>
-          </a:bodyPr>
-          <a:lstStyle/>
-          <a:p>
-            <a:pPr>
-              <a:defRPr sz="700" b="0" i="0">
-                <a:solidFill>
-                  <a:srgbClr val="030303"/>
-                </a:solidFill>
-                <a:latin typeface="Arial"/>
-              </a:defRPr>
-            </a:pPr>
-            <a:r>
-              <a:t>While others train and climb for years to reach</a:t>
-            </a:r>
-          </a:p>
-        </p:txBody>
-      </p:sp>
-      <p:sp>
-        <p:nvSpPr>
-          <p:cNvPr id="30" name="TextBox 29"/>
-          <p:cNvSpPr txBox="1"/>
-          <p:nvPr/>
-        </p:nvSpPr>
-        <p:spPr>
-          <a:xfrm>
-            <a:off x="5017377" y="2762148"/>
-            <a:ext cx="1217094" cy="201168"/>
-          </a:xfrm>
-          <a:prstGeom prst="rect">
-            <a:avLst/>
-          </a:prstGeom>
-          <a:noFill/>
-        </p:spPr>
-        <p:txBody>
-          <a:bodyPr wrap="none" lIns="0" rIns="0" tIns="0" bIns="0" anchor="ctr">
-            <a:spAutoFit/>
-          </a:bodyPr>
-          <a:lstStyle/>
-          <a:p>
-            <a:pPr>
-              <a:defRPr sz="776" b="0" i="0">
-                <a:solidFill>
-                  <a:srgbClr val="000000"/>
-                </a:solidFill>
-                <a:latin typeface="Arial"/>
-              </a:defRPr>
-            </a:pPr>
-            <a:r>
-              <a:t>Wins through struggle</a:t>
-            </a:r>
-          </a:p>
-        </p:txBody>
-      </p:sp>
-      <p:sp>
-        <p:nvSpPr>
-          <p:cNvPr id="31" name="TextBox 30"/>
-          <p:cNvSpPr txBox="1"/>
-          <p:nvPr/>
-        </p:nvSpPr>
-        <p:spPr>
-          <a:xfrm>
-            <a:off x="6912254" y="2769436"/>
-            <a:ext cx="816255" cy="201168"/>
-          </a:xfrm>
-          <a:prstGeom prst="rect">
-            <a:avLst/>
-          </a:prstGeom>
-          <a:noFill/>
-        </p:spPr>
-        <p:txBody>
-          <a:bodyPr wrap="none" lIns="0" rIns="0" tIns="0" bIns="0" anchor="ctr">
-            <a:spAutoFit/>
-          </a:bodyPr>
-          <a:lstStyle/>
-          <a:p>
-            <a:pPr>
-              <a:defRPr sz="772" b="0" i="0">
-                <a:solidFill>
-                  <a:srgbClr val="BA0000"/>
-                </a:solidFill>
-                <a:latin typeface="Arial"/>
-              </a:defRPr>
-            </a:pPr>
-            <a:r>
-              <a:t>Wins instantly</a:t>
-            </a:r>
-          </a:p>
-        </p:txBody>
-      </p:sp>
-      <p:sp>
-        <p:nvSpPr>
-          <p:cNvPr id="32" name="TextBox 31"/>
-          <p:cNvSpPr txBox="1"/>
-          <p:nvPr/>
-        </p:nvSpPr>
-        <p:spPr>
-          <a:xfrm>
-            <a:off x="1555581" y="2951636"/>
-            <a:ext cx="2215549" cy="201168"/>
-          </a:xfrm>
-          <a:prstGeom prst="rect">
-            <a:avLst/>
-          </a:prstGeom>
-          <a:noFill/>
-        </p:spPr>
-        <p:txBody>
-          <a:bodyPr wrap="none" lIns="0" rIns="0" tIns="0" bIns="0" anchor="ctr">
-            <a:spAutoFit/>
-          </a:bodyPr>
-          <a:lstStyle/>
-          <a:p>
-            <a:pPr>
-              <a:defRPr sz="721" b="0" i="0">
-                <a:solidFill>
-                  <a:srgbClr val="050404"/>
-                </a:solidFill>
-                <a:latin typeface="Arial"/>
-              </a:defRPr>
-            </a:pPr>
-            <a:r>
-              <a:t>the top, he begins where most protagonists</a:t>
-            </a:r>
-          </a:p>
-        </p:txBody>
-      </p:sp>
-      <p:sp>
-        <p:nvSpPr>
-          <p:cNvPr id="33" name="TextBox 32"/>
-          <p:cNvSpPr txBox="1"/>
-          <p:nvPr/>
-        </p:nvSpPr>
-        <p:spPr>
-          <a:xfrm>
-            <a:off x="1570157" y="3126548"/>
-            <a:ext cx="1078622" cy="201168"/>
-          </a:xfrm>
-          <a:prstGeom prst="rect">
-            <a:avLst/>
-          </a:prstGeom>
-          <a:noFill/>
-        </p:spPr>
-        <p:txBody>
-          <a:bodyPr wrap="none" lIns="0" rIns="0" tIns="0" bIns="0" anchor="ctr">
-            <a:spAutoFit/>
-          </a:bodyPr>
-          <a:lstStyle/>
-          <a:p>
-            <a:pPr>
-              <a:defRPr sz="731" b="0" i="0">
-                <a:solidFill>
-                  <a:srgbClr val="030302"/>
-                </a:solidFill>
-                <a:latin typeface="Arial"/>
-              </a:defRPr>
-            </a:pPr>
-            <a:r>
-              <a:t>are supposed to end.</a:t>
-            </a:r>
-          </a:p>
-        </p:txBody>
-      </p:sp>
-      <p:sp>
-        <p:nvSpPr>
-          <p:cNvPr id="34" name="TextBox 33"/>
-          <p:cNvSpPr txBox="1"/>
-          <p:nvPr/>
-        </p:nvSpPr>
-        <p:spPr>
-          <a:xfrm>
-            <a:off x="6904966" y="3126548"/>
-            <a:ext cx="750663" cy="201168"/>
-          </a:xfrm>
-          <a:prstGeom prst="rect">
-            <a:avLst/>
-          </a:prstGeom>
-          <a:noFill/>
-        </p:spPr>
-        <p:txBody>
-          <a:bodyPr wrap="none" lIns="0" rIns="0" tIns="0" bIns="0" anchor="ctr">
-            <a:spAutoFit/>
-          </a:bodyPr>
-          <a:lstStyle/>
-          <a:p>
-            <a:pPr>
-              <a:defRPr sz="864" b="0" i="0">
-                <a:solidFill>
-                  <a:srgbClr val="C50000"/>
-                </a:solidFill>
-                <a:latin typeface="Arial"/>
-              </a:defRPr>
-            </a:pPr>
-            <a:r>
-              <a:t>Power is the</a:t>
-            </a:r>
-          </a:p>
-        </p:txBody>
-      </p:sp>
-      <p:sp>
-        <p:nvSpPr>
-          <p:cNvPr id="35" name="TextBox 34"/>
-          <p:cNvSpPr txBox="1"/>
-          <p:nvPr/>
-        </p:nvSpPr>
-        <p:spPr>
-          <a:xfrm>
-            <a:off x="5010089" y="3214004"/>
-            <a:ext cx="867270" cy="201168"/>
-          </a:xfrm>
-          <a:prstGeom prst="rect">
-            <a:avLst/>
-          </a:prstGeom>
-          <a:noFill/>
-        </p:spPr>
-        <p:txBody>
-          <a:bodyPr wrap="none" lIns="0" rIns="0" tIns="0" bIns="0" anchor="ctr">
-            <a:spAutoFit/>
-          </a:bodyPr>
-          <a:lstStyle/>
-          <a:p>
-            <a:pPr>
-              <a:defRPr sz="811" b="0" i="0">
-                <a:solidFill>
-                  <a:srgbClr val="000000"/>
-                </a:solidFill>
-                <a:latin typeface="Arial"/>
-              </a:defRPr>
-            </a:pPr>
-            <a:r>
-              <a:t>Power is a goal</a:t>
-            </a:r>
-          </a:p>
-        </p:txBody>
-      </p:sp>
-      <p:sp>
-        <p:nvSpPr>
-          <p:cNvPr id="36" name="TextBox 35"/>
-          <p:cNvSpPr txBox="1"/>
-          <p:nvPr/>
-        </p:nvSpPr>
-        <p:spPr>
-          <a:xfrm>
-            <a:off x="6919542" y="3308748"/>
-            <a:ext cx="801679" cy="201168"/>
-          </a:xfrm>
-          <a:prstGeom prst="rect">
-            <a:avLst/>
-          </a:prstGeom>
-          <a:noFill/>
-        </p:spPr>
-        <p:txBody>
-          <a:bodyPr wrap="none" lIns="0" rIns="0" tIns="0" bIns="0" anchor="ctr">
-            <a:spAutoFit/>
-          </a:bodyPr>
-          <a:lstStyle/>
-          <a:p>
-            <a:pPr>
-              <a:defRPr sz="759" b="0" i="0">
-                <a:solidFill>
-                  <a:srgbClr val="C50102"/>
-                </a:solidFill>
-                <a:latin typeface="Arial"/>
-              </a:defRPr>
-            </a:pPr>
-            <a:r>
-              <a:t>starting point</a:t>
-            </a:r>
-          </a:p>
-        </p:txBody>
-      </p:sp>
-      <p:sp>
-        <p:nvSpPr>
-          <p:cNvPr id="37" name="TextBox 36"/>
-          <p:cNvSpPr txBox="1"/>
-          <p:nvPr/>
-        </p:nvSpPr>
-        <p:spPr>
-          <a:xfrm>
-            <a:off x="1562869" y="3418068"/>
-            <a:ext cx="1996909" cy="201168"/>
-          </a:xfrm>
-          <a:prstGeom prst="rect">
-            <a:avLst/>
-          </a:prstGeom>
-          <a:noFill/>
-        </p:spPr>
-        <p:txBody>
-          <a:bodyPr wrap="none" lIns="0" rIns="0" tIns="0" bIns="0" anchor="ctr">
-            <a:spAutoFit/>
-          </a:bodyPr>
-          <a:lstStyle/>
-          <a:p>
-            <a:pPr>
-              <a:defRPr sz="1032" b="1" i="0">
-                <a:solidFill>
-                  <a:srgbClr val="000000"/>
-                </a:solidFill>
-                <a:latin typeface="Arial"/>
-              </a:defRPr>
-            </a:pPr>
-            <a:r>
-              <a:t>LIMIT-BREAKING SIMPLICITY</a:t>
-            </a:r>
-          </a:p>
-        </p:txBody>
-      </p:sp>
-      <p:sp>
-        <p:nvSpPr>
-          <p:cNvPr id="38" name="TextBox 37"/>
-          <p:cNvSpPr txBox="1"/>
-          <p:nvPr/>
-        </p:nvSpPr>
-        <p:spPr>
-          <a:xfrm>
-            <a:off x="1132877" y="3512811"/>
-            <a:ext cx="269655" cy="400839"/>
-          </a:xfrm>
-          <a:prstGeom prst="rect">
-            <a:avLst/>
-          </a:prstGeom>
-          <a:noFill/>
-        </p:spPr>
-        <p:txBody>
-          <a:bodyPr wrap="none" lIns="0" rIns="0" tIns="0" bIns="0" anchor="ctr">
-            <a:spAutoFit/>
-          </a:bodyPr>
-          <a:lstStyle/>
-          <a:p>
-            <a:pPr>
-              <a:defRPr sz="2080" b="0" i="0">
-                <a:solidFill>
-                  <a:srgbClr val="050400"/>
-                </a:solidFill>
-                <a:latin typeface="Arial"/>
-              </a:defRPr>
-            </a:pPr>
-            <a:r>
-              <a:t>3</a:t>
-            </a:r>
-          </a:p>
-        </p:txBody>
-      </p:sp>
-      <p:sp>
-        <p:nvSpPr>
-          <p:cNvPr id="39" name="TextBox 38"/>
-          <p:cNvSpPr txBox="1"/>
-          <p:nvPr/>
-        </p:nvSpPr>
-        <p:spPr>
-          <a:xfrm>
-            <a:off x="1562869" y="3643995"/>
-            <a:ext cx="2470629" cy="201168"/>
-          </a:xfrm>
-          <a:prstGeom prst="rect">
-            <a:avLst/>
-          </a:prstGeom>
-          <a:noFill/>
-        </p:spPr>
-        <p:txBody>
-          <a:bodyPr wrap="none" lIns="0" rIns="0" tIns="0" bIns="0" anchor="ctr">
-            <a:spAutoFit/>
-          </a:bodyPr>
-          <a:lstStyle/>
-          <a:p>
-            <a:pPr>
-              <a:defRPr sz="700" b="0" i="0">
-                <a:solidFill>
-                  <a:srgbClr val="050504"/>
-                </a:solidFill>
-                <a:latin typeface="Arial"/>
-              </a:defRPr>
-            </a:pPr>
-            <a:r>
-              <a:t>His routine is both disciplined and comically extreme:</a:t>
-            </a:r>
-          </a:p>
-        </p:txBody>
-      </p:sp>
-      <p:sp>
-        <p:nvSpPr>
-          <p:cNvPr id="40" name="TextBox 39"/>
-          <p:cNvSpPr txBox="1"/>
-          <p:nvPr/>
-        </p:nvSpPr>
-        <p:spPr>
-          <a:xfrm>
-            <a:off x="5010089" y="3585691"/>
-            <a:ext cx="859982" cy="201168"/>
-          </a:xfrm>
-          <a:prstGeom prst="rect">
-            <a:avLst/>
-          </a:prstGeom>
-          <a:noFill/>
-        </p:spPr>
-        <p:txBody>
-          <a:bodyPr wrap="none" lIns="0" rIns="0" tIns="0" bIns="0" anchor="ctr">
-            <a:spAutoFit/>
-          </a:bodyPr>
-          <a:lstStyle/>
-          <a:p>
-            <a:pPr>
-              <a:defRPr sz="878" b="0" i="0">
-                <a:solidFill>
-                  <a:srgbClr val="000000"/>
-                </a:solidFill>
-                <a:latin typeface="Arial"/>
-              </a:defRPr>
-            </a:pPr>
-            <a:r>
-              <a:t>Tension comes</a:t>
-            </a:r>
-          </a:p>
-        </p:txBody>
-      </p:sp>
-      <p:sp>
-        <p:nvSpPr>
-          <p:cNvPr id="41" name="TextBox 40"/>
-          <p:cNvSpPr txBox="1"/>
-          <p:nvPr/>
-        </p:nvSpPr>
-        <p:spPr>
-          <a:xfrm>
-            <a:off x="6912254" y="3600267"/>
-            <a:ext cx="859982" cy="201168"/>
-          </a:xfrm>
-          <a:prstGeom prst="rect">
-            <a:avLst/>
-          </a:prstGeom>
-          <a:noFill/>
-        </p:spPr>
-        <p:txBody>
-          <a:bodyPr wrap="none" lIns="0" rIns="0" tIns="0" bIns="0" anchor="ctr">
-            <a:spAutoFit/>
-          </a:bodyPr>
-          <a:lstStyle/>
-          <a:p>
-            <a:pPr>
-              <a:defRPr sz="860" b="0" i="0">
-                <a:solidFill>
-                  <a:srgbClr val="BA0001"/>
-                </a:solidFill>
-                <a:latin typeface="Arial"/>
-              </a:defRPr>
-            </a:pPr>
-            <a:r>
-              <a:t>Tension comes</a:t>
-            </a:r>
-          </a:p>
-        </p:txBody>
-      </p:sp>
-      <p:sp>
-        <p:nvSpPr>
-          <p:cNvPr id="42" name="TextBox 41"/>
-          <p:cNvSpPr txBox="1"/>
-          <p:nvPr/>
-        </p:nvSpPr>
-        <p:spPr>
-          <a:xfrm>
-            <a:off x="1555581" y="3775179"/>
-            <a:ext cx="2011485" cy="201168"/>
-          </a:xfrm>
-          <a:prstGeom prst="rect">
-            <a:avLst/>
-          </a:prstGeom>
-          <a:noFill/>
-        </p:spPr>
-        <p:txBody>
-          <a:bodyPr wrap="none" lIns="0" rIns="0" tIns="0" bIns="0" anchor="ctr">
-            <a:spAutoFit/>
-          </a:bodyPr>
-          <a:lstStyle/>
-          <a:p>
-            <a:pPr>
-              <a:defRPr sz="720" b="0" i="0">
-                <a:solidFill>
-                  <a:srgbClr val="010101"/>
-                </a:solidFill>
-                <a:latin typeface="Arial"/>
-              </a:defRPr>
-            </a:pPr>
-            <a:r>
-              <a:t>100 push-ups, 100 sit-ups, 100 squats,</a:t>
-            </a:r>
-          </a:p>
-        </p:txBody>
-      </p:sp>
-      <p:sp>
-        <p:nvSpPr>
-          <p:cNvPr id="43" name="TextBox 42"/>
-          <p:cNvSpPr txBox="1"/>
-          <p:nvPr/>
-        </p:nvSpPr>
-        <p:spPr>
-          <a:xfrm>
-            <a:off x="5017377" y="3760603"/>
-            <a:ext cx="655919" cy="201168"/>
-          </a:xfrm>
-          <a:prstGeom prst="rect">
-            <a:avLst/>
-          </a:prstGeom>
-          <a:noFill/>
-        </p:spPr>
-        <p:txBody>
-          <a:bodyPr wrap="none" lIns="0" rIns="0" tIns="0" bIns="0" anchor="ctr">
-            <a:spAutoFit/>
-          </a:bodyPr>
-          <a:lstStyle/>
-          <a:p>
-            <a:pPr>
-              <a:defRPr sz="797" b="0" i="0">
-                <a:solidFill>
-                  <a:srgbClr val="000001"/>
-                </a:solidFill>
-                <a:latin typeface="Arial"/>
-              </a:defRPr>
-            </a:pPr>
-            <a:r>
-              <a:t>from battle</a:t>
-            </a:r>
-          </a:p>
-        </p:txBody>
-      </p:sp>
-      <p:sp>
-        <p:nvSpPr>
-          <p:cNvPr id="44" name="TextBox 43"/>
-          <p:cNvSpPr txBox="1"/>
-          <p:nvPr/>
-        </p:nvSpPr>
-        <p:spPr>
-          <a:xfrm>
-            <a:off x="6904966" y="3753315"/>
-            <a:ext cx="823543" cy="201168"/>
-          </a:xfrm>
-          <a:prstGeom prst="rect">
-            <a:avLst/>
-          </a:prstGeom>
-          <a:noFill/>
-        </p:spPr>
-        <p:txBody>
-          <a:bodyPr wrap="none" lIns="0" rIns="0" tIns="0" bIns="0" anchor="ctr">
-            <a:spAutoFit/>
-          </a:bodyPr>
-          <a:lstStyle/>
-          <a:p>
-            <a:pPr>
-              <a:defRPr sz="914" b="0" i="0">
-                <a:solidFill>
-                  <a:srgbClr val="BA0000"/>
-                </a:solidFill>
-                <a:latin typeface="Arial"/>
-              </a:defRPr>
-            </a:pPr>
-            <a:r>
-              <a:t>from meaning</a:t>
-            </a:r>
-          </a:p>
-        </p:txBody>
-      </p:sp>
-      <p:sp>
-        <p:nvSpPr>
-          <p:cNvPr id="45" name="TextBox 44"/>
-          <p:cNvSpPr txBox="1"/>
-          <p:nvPr/>
-        </p:nvSpPr>
-        <p:spPr>
-          <a:xfrm>
-            <a:off x="1562869" y="3942803"/>
-            <a:ext cx="1399294" cy="201168"/>
-          </a:xfrm>
-          <a:prstGeom prst="rect">
-            <a:avLst/>
-          </a:prstGeom>
-          <a:noFill/>
-        </p:spPr>
-        <p:txBody>
-          <a:bodyPr wrap="none" lIns="0" rIns="0" tIns="0" bIns="0" anchor="ctr">
-            <a:spAutoFit/>
-          </a:bodyPr>
-          <a:lstStyle/>
-          <a:p>
-            <a:pPr>
-              <a:defRPr sz="765" b="0" i="0">
-                <a:solidFill>
-                  <a:srgbClr val="020201"/>
-                </a:solidFill>
-                <a:latin typeface="Arial"/>
-              </a:defRPr>
-            </a:pPr>
-            <a:r>
-              <a:t>and a 10 km run every day.</a:t>
-            </a:r>
-          </a:p>
-        </p:txBody>
-      </p:sp>
-      <p:sp>
-        <p:nvSpPr>
-          <p:cNvPr id="46" name="TextBox 45"/>
-          <p:cNvSpPr txBox="1"/>
-          <p:nvPr/>
-        </p:nvSpPr>
-        <p:spPr>
-          <a:xfrm>
-            <a:off x="4303153" y="4117715"/>
-            <a:ext cx="1639798" cy="218639"/>
-          </a:xfrm>
-          <a:prstGeom prst="rect">
-            <a:avLst/>
-          </a:prstGeom>
-          <a:noFill/>
-        </p:spPr>
-        <p:txBody>
-          <a:bodyPr wrap="none" lIns="0" rIns="0" tIns="0" bIns="0" anchor="ctr">
-            <a:spAutoFit/>
-          </a:bodyPr>
-          <a:lstStyle/>
-          <a:p>
-            <a:pPr>
-              <a:defRPr sz="1160" b="1" i="0">
-                <a:solidFill>
-                  <a:srgbClr val="F7F7F7"/>
-                </a:solidFill>
-                <a:latin typeface="Arial"/>
-              </a:defRPr>
-            </a:pPr>
-            <a:r>
-              <a:t>C) NARRATIVE IMPACT</a:t>
-            </a:r>
-          </a:p>
-        </p:txBody>
-      </p:sp>
-      <p:sp>
-        <p:nvSpPr>
-          <p:cNvPr id="47" name="TextBox 46"/>
-          <p:cNvSpPr txBox="1"/>
-          <p:nvPr/>
-        </p:nvSpPr>
-        <p:spPr>
-          <a:xfrm>
-            <a:off x="1577445" y="4263475"/>
-            <a:ext cx="1792845" cy="201168"/>
-          </a:xfrm>
-          <a:prstGeom prst="rect">
-            <a:avLst/>
-          </a:prstGeom>
-          <a:noFill/>
-        </p:spPr>
-        <p:txBody>
-          <a:bodyPr wrap="none" lIns="0" rIns="0" tIns="0" bIns="0" anchor="ctr">
-            <a:spAutoFit/>
-          </a:bodyPr>
-          <a:lstStyle/>
-          <a:p>
-            <a:pPr>
-              <a:defRPr sz="903" b="1" i="0">
-                <a:solidFill>
-                  <a:srgbClr val="010101"/>
-                </a:solidFill>
-                <a:latin typeface="Arial"/>
-              </a:defRPr>
-            </a:pPr>
-            <a:r>
-              <a:t>EMOTIONALLY UNSHAKEN</a:t>
-            </a:r>
-          </a:p>
-        </p:txBody>
-      </p:sp>
-      <p:sp>
-        <p:nvSpPr>
-          <p:cNvPr id="48" name="TextBox 47"/>
-          <p:cNvSpPr txBox="1"/>
-          <p:nvPr/>
-        </p:nvSpPr>
-        <p:spPr>
-          <a:xfrm>
-            <a:off x="1103725" y="4299914"/>
-            <a:ext cx="327959" cy="466431"/>
-          </a:xfrm>
-          <a:prstGeom prst="rect">
-            <a:avLst/>
-          </a:prstGeom>
-          <a:noFill/>
-        </p:spPr>
-        <p:txBody>
-          <a:bodyPr wrap="none" lIns="0" rIns="0" tIns="0" bIns="0" anchor="ctr">
-            <a:spAutoFit/>
-          </a:bodyPr>
-          <a:lstStyle/>
-          <a:p>
-            <a:pPr>
-              <a:defRPr sz="2530" b="0" i="0">
-                <a:solidFill>
-                  <a:srgbClr val="040300"/>
-                </a:solidFill>
-                <a:latin typeface="Arial"/>
-              </a:defRPr>
-            </a:pPr>
-            <a:r>
-              <a:t>4</a:t>
-            </a:r>
-          </a:p>
-        </p:txBody>
-      </p:sp>
-      <p:sp>
-        <p:nvSpPr>
-          <p:cNvPr id="49" name="TextBox 48"/>
-          <p:cNvSpPr txBox="1"/>
-          <p:nvPr/>
-        </p:nvSpPr>
-        <p:spPr>
-          <a:xfrm>
-            <a:off x="1555581" y="4445674"/>
-            <a:ext cx="2062501" cy="201168"/>
-          </a:xfrm>
-          <a:prstGeom prst="rect">
-            <a:avLst/>
-          </a:prstGeom>
-          <a:noFill/>
-        </p:spPr>
-        <p:txBody>
-          <a:bodyPr wrap="none" lIns="0" rIns="0" tIns="0" bIns="0" anchor="ctr">
-            <a:spAutoFit/>
-          </a:bodyPr>
-          <a:lstStyle/>
-          <a:p>
-            <a:pPr>
-              <a:defRPr sz="700" b="0" i="0">
-                <a:solidFill>
-                  <a:srgbClr val="030303"/>
-                </a:solidFill>
-                <a:latin typeface="Arial"/>
-              </a:defRPr>
-            </a:pPr>
-            <a:r>
-              <a:t>He fights without fear, ego, or hesitation.</a:t>
-            </a:r>
-          </a:p>
-        </p:txBody>
-      </p:sp>
-      <p:sp>
-        <p:nvSpPr>
-          <p:cNvPr id="50" name="TextBox 49"/>
-          <p:cNvSpPr txBox="1"/>
-          <p:nvPr/>
-        </p:nvSpPr>
-        <p:spPr>
-          <a:xfrm>
-            <a:off x="5272456" y="4496690"/>
-            <a:ext cx="1158790" cy="201168"/>
-          </a:xfrm>
-          <a:prstGeom prst="rect">
-            <a:avLst/>
-          </a:prstGeom>
-          <a:noFill/>
-        </p:spPr>
-        <p:txBody>
-          <a:bodyPr wrap="none" lIns="0" rIns="0" tIns="0" bIns="0" anchor="ctr">
-            <a:spAutoFit/>
-          </a:bodyPr>
-          <a:lstStyle/>
-          <a:p>
-            <a:pPr>
-              <a:defRPr sz="1162" b="1" i="0">
-                <a:solidFill>
-                  <a:srgbClr val="020200"/>
-                </a:solidFill>
-                <a:latin typeface="Arial"/>
-              </a:defRPr>
-            </a:pPr>
-            <a:r>
-              <a:t>WHY IT WORKS</a:t>
-            </a:r>
-          </a:p>
-        </p:txBody>
-      </p:sp>
-      <p:sp>
-        <p:nvSpPr>
-          <p:cNvPr id="51" name="TextBox 50"/>
-          <p:cNvSpPr txBox="1"/>
-          <p:nvPr/>
-        </p:nvSpPr>
-        <p:spPr>
-          <a:xfrm>
-            <a:off x="1548293" y="4598722"/>
-            <a:ext cx="2033349" cy="201168"/>
-          </a:xfrm>
-          <a:prstGeom prst="rect">
-            <a:avLst/>
-          </a:prstGeom>
-          <a:noFill/>
-        </p:spPr>
-        <p:txBody>
-          <a:bodyPr wrap="none" lIns="0" rIns="0" tIns="0" bIns="0" anchor="ctr">
-            <a:spAutoFit/>
-          </a:bodyPr>
-          <a:lstStyle/>
-          <a:p>
-            <a:pPr>
-              <a:defRPr sz="748" b="0" i="0">
-                <a:solidFill>
-                  <a:srgbClr val="030303"/>
-                </a:solidFill>
-                <a:latin typeface="Arial"/>
-              </a:defRPr>
-            </a:pPr>
-            <a:r>
-              <a:t>No need to prove himself—he's already</a:t>
-            </a:r>
-          </a:p>
-        </p:txBody>
-      </p:sp>
-      <p:sp>
-        <p:nvSpPr>
-          <p:cNvPr id="52" name="TextBox 51"/>
-          <p:cNvSpPr txBox="1"/>
-          <p:nvPr/>
-        </p:nvSpPr>
-        <p:spPr>
-          <a:xfrm>
-            <a:off x="1562869" y="4766346"/>
-            <a:ext cx="1610646" cy="201168"/>
-          </a:xfrm>
-          <a:prstGeom prst="rect">
-            <a:avLst/>
-          </a:prstGeom>
-          <a:noFill/>
-        </p:spPr>
-        <p:txBody>
-          <a:bodyPr wrap="none" lIns="0" rIns="0" tIns="0" bIns="0" anchor="ctr">
-            <a:spAutoFit/>
-          </a:bodyPr>
-          <a:lstStyle/>
-          <a:p>
-            <a:pPr>
-              <a:defRPr sz="706" b="0" i="0">
-                <a:solidFill>
-                  <a:srgbClr val="040303"/>
-                </a:solidFill>
-                <a:latin typeface="Arial"/>
-              </a:defRPr>
-            </a:pPr>
-            <a:r>
-              <a:t>beyond the need for validation.</a:t>
-            </a:r>
-          </a:p>
-        </p:txBody>
-      </p:sp>
-      <p:sp>
-        <p:nvSpPr>
-          <p:cNvPr id="53" name="TextBox 52"/>
-          <p:cNvSpPr txBox="1"/>
-          <p:nvPr/>
-        </p:nvSpPr>
-        <p:spPr>
-          <a:xfrm>
-            <a:off x="5272456" y="4722618"/>
-            <a:ext cx="2579948" cy="201168"/>
-          </a:xfrm>
-          <a:prstGeom prst="rect">
-            <a:avLst/>
-          </a:prstGeom>
-          <a:noFill/>
-        </p:spPr>
-        <p:txBody>
-          <a:bodyPr wrap="none" lIns="0" rIns="0" tIns="0" bIns="0" anchor="ctr">
-            <a:spAutoFit/>
-          </a:bodyPr>
-          <a:lstStyle/>
-          <a:p>
-            <a:pPr>
-              <a:defRPr sz="759" b="0" i="0">
-                <a:solidFill>
-                  <a:srgbClr val="020100"/>
-                </a:solidFill>
-                <a:latin typeface="Arial"/>
-              </a:defRPr>
-            </a:pPr>
-            <a:r>
-              <a:t>Saitama is not just strong in a physical sense.</a:t>
-            </a:r>
-          </a:p>
-        </p:txBody>
-      </p:sp>
-      <p:sp>
-        <p:nvSpPr>
-          <p:cNvPr id="54" name="TextBox 53"/>
-          <p:cNvSpPr txBox="1"/>
-          <p:nvPr/>
-        </p:nvSpPr>
-        <p:spPr>
-          <a:xfrm>
-            <a:off x="5279744" y="4912106"/>
-            <a:ext cx="2485205" cy="201168"/>
-          </a:xfrm>
-          <a:prstGeom prst="rect">
-            <a:avLst/>
-          </a:prstGeom>
-          <a:noFill/>
-        </p:spPr>
-        <p:txBody>
-          <a:bodyPr wrap="none" lIns="0" rIns="0" tIns="0" bIns="0" anchor="ctr">
-            <a:spAutoFit/>
-          </a:bodyPr>
-          <a:lstStyle/>
-          <a:p>
-            <a:pPr>
-              <a:defRPr sz="817" b="0" i="0">
-                <a:solidFill>
-                  <a:srgbClr val="000000"/>
-                </a:solidFill>
-                <a:latin typeface="Arial"/>
-              </a:defRPr>
-            </a:pPr>
-            <a:r>
-              <a:t>He works because his power flips the usual</a:t>
-            </a:r>
-          </a:p>
-        </p:txBody>
-      </p:sp>
-      <p:sp>
-        <p:nvSpPr>
-          <p:cNvPr id="55" name="TextBox 54"/>
-          <p:cNvSpPr txBox="1"/>
-          <p:nvPr/>
-        </p:nvSpPr>
-        <p:spPr>
-          <a:xfrm>
-            <a:off x="1570157" y="5094306"/>
-            <a:ext cx="2434189" cy="201168"/>
-          </a:xfrm>
-          <a:prstGeom prst="rect">
-            <a:avLst/>
-          </a:prstGeom>
-          <a:noFill/>
-        </p:spPr>
-        <p:txBody>
-          <a:bodyPr wrap="none" lIns="0" rIns="0" tIns="0" bIns="0" anchor="ctr">
-            <a:spAutoFit/>
-          </a:bodyPr>
-          <a:lstStyle/>
-          <a:p>
-            <a:pPr>
-              <a:defRPr sz="980" b="1" i="0">
-                <a:solidFill>
-                  <a:srgbClr val="000000"/>
-                </a:solidFill>
-                <a:latin typeface="Arial"/>
-              </a:defRPr>
-            </a:pPr>
-            <a:r>
-              <a:t>THE STORY NEEDS AN UNBEATABLE HERO</a:t>
-            </a:r>
-          </a:p>
-        </p:txBody>
-      </p:sp>
-      <p:sp>
-        <p:nvSpPr>
-          <p:cNvPr id="56" name="TextBox 55"/>
-          <p:cNvSpPr txBox="1"/>
-          <p:nvPr/>
-        </p:nvSpPr>
-        <p:spPr>
-          <a:xfrm>
-            <a:off x="5279744" y="5101594"/>
-            <a:ext cx="2295717" cy="201168"/>
-          </a:xfrm>
-          <a:prstGeom prst="rect">
-            <a:avLst/>
-          </a:prstGeom>
-          <a:noFill/>
-        </p:spPr>
-        <p:txBody>
-          <a:bodyPr wrap="none" lIns="0" rIns="0" tIns="0" bIns="0" anchor="ctr">
-            <a:spAutoFit/>
-          </a:bodyPr>
-          <a:lstStyle/>
-          <a:p>
-            <a:pPr>
-              <a:defRPr sz="799" b="0" i="0">
-                <a:solidFill>
-                  <a:srgbClr val="020000"/>
-                </a:solidFill>
-                <a:latin typeface="Arial"/>
-              </a:defRPr>
-            </a:pPr>
-            <a:r>
-              <a:t>battle-anime formula and turns the real</a:t>
-            </a:r>
-          </a:p>
-        </p:txBody>
-      </p:sp>
-      <p:sp>
-        <p:nvSpPr>
-          <p:cNvPr id="57" name="TextBox 56"/>
-          <p:cNvSpPr txBox="1"/>
-          <p:nvPr/>
-        </p:nvSpPr>
-        <p:spPr>
-          <a:xfrm>
-            <a:off x="1111013" y="5145321"/>
-            <a:ext cx="298807" cy="429991"/>
-          </a:xfrm>
-          <a:prstGeom prst="rect">
-            <a:avLst/>
-          </a:prstGeom>
-          <a:noFill/>
-        </p:spPr>
-        <p:txBody>
-          <a:bodyPr wrap="none" lIns="0" rIns="0" tIns="0" bIns="0" anchor="ctr">
-            <a:spAutoFit/>
-          </a:bodyPr>
-          <a:lstStyle/>
-          <a:p>
-            <a:pPr>
-              <a:defRPr sz="2305" b="0" i="0">
-                <a:solidFill>
-                  <a:srgbClr val="040300"/>
-                </a:solidFill>
-                <a:latin typeface="Arial"/>
-              </a:defRPr>
-            </a:pPr>
-            <a:r>
-              <a:t>5</a:t>
-            </a:r>
-          </a:p>
-        </p:txBody>
-      </p:sp>
-      <p:sp>
-        <p:nvSpPr>
-          <p:cNvPr id="58" name="TextBox 57"/>
-          <p:cNvSpPr txBox="1"/>
-          <p:nvPr/>
-        </p:nvSpPr>
-        <p:spPr>
-          <a:xfrm>
-            <a:off x="1562869" y="5291081"/>
-            <a:ext cx="2222837" cy="201168"/>
-          </a:xfrm>
-          <a:prstGeom prst="rect">
-            <a:avLst/>
-          </a:prstGeom>
-          <a:noFill/>
-        </p:spPr>
-        <p:txBody>
-          <a:bodyPr wrap="none" lIns="0" rIns="0" tIns="0" bIns="0" anchor="ctr">
-            <a:spAutoFit/>
-          </a:bodyPr>
-          <a:lstStyle/>
-          <a:p>
-            <a:pPr>
-              <a:defRPr sz="713" b="0" i="0">
-                <a:solidFill>
-                  <a:srgbClr val="020102"/>
-                </a:solidFill>
-                <a:latin typeface="Arial"/>
-              </a:defRPr>
-            </a:pPr>
-            <a:r>
-              <a:t>His power lets the series go beyond battles</a:t>
-            </a:r>
-          </a:p>
-        </p:txBody>
-      </p:sp>
-      <p:sp>
-        <p:nvSpPr>
-          <p:cNvPr id="59" name="TextBox 58"/>
-          <p:cNvSpPr txBox="1"/>
-          <p:nvPr/>
-        </p:nvSpPr>
-        <p:spPr>
-          <a:xfrm>
-            <a:off x="5272456" y="5276505"/>
-            <a:ext cx="2244701" cy="201168"/>
-          </a:xfrm>
-          <a:prstGeom prst="rect">
-            <a:avLst/>
-          </a:prstGeom>
-          <a:noFill/>
-        </p:spPr>
-        <p:txBody>
-          <a:bodyPr wrap="none" lIns="0" rIns="0" tIns="0" bIns="0" anchor="ctr">
-            <a:spAutoFit/>
-          </a:bodyPr>
-          <a:lstStyle/>
-          <a:p>
-            <a:pPr>
-              <a:defRPr sz="855" b="0" i="0">
-                <a:solidFill>
-                  <a:srgbClr val="010000"/>
-                </a:solidFill>
-                <a:latin typeface="Arial"/>
-              </a:defRPr>
-            </a:pPr>
-            <a:r>
-              <a:t>conflict inward:: purpose, boredom,</a:t>
-            </a:r>
-          </a:p>
-        </p:txBody>
-      </p:sp>
-      <p:sp>
-        <p:nvSpPr>
-          <p:cNvPr id="60" name="TextBox 59"/>
-          <p:cNvSpPr txBox="1"/>
-          <p:nvPr/>
-        </p:nvSpPr>
-        <p:spPr>
-          <a:xfrm>
-            <a:off x="1548293" y="5444129"/>
-            <a:ext cx="2244701" cy="201168"/>
-          </a:xfrm>
-          <a:prstGeom prst="rect">
-            <a:avLst/>
-          </a:prstGeom>
-          <a:noFill/>
-        </p:spPr>
-        <p:txBody>
-          <a:bodyPr wrap="none" lIns="0" rIns="0" tIns="0" bIns="0" anchor="ctr">
-            <a:spAutoFit/>
-          </a:bodyPr>
-          <a:lstStyle/>
-          <a:p>
-            <a:pPr>
-              <a:defRPr sz="741" b="0" i="0">
-                <a:solidFill>
-                  <a:srgbClr val="010101"/>
-                </a:solidFill>
-                <a:latin typeface="Arial"/>
-              </a:defRPr>
-            </a:pPr>
-            <a:r>
-              <a:t>to explore boredom, meaning, and identity</a:t>
-            </a:r>
-          </a:p>
-        </p:txBody>
-      </p:sp>
-      <p:sp>
-        <p:nvSpPr>
-          <p:cNvPr id="61" name="TextBox 60"/>
-          <p:cNvSpPr txBox="1"/>
-          <p:nvPr/>
-        </p:nvSpPr>
-        <p:spPr>
-          <a:xfrm>
-            <a:off x="5265168" y="5451417"/>
-            <a:ext cx="1843861" cy="201168"/>
-          </a:xfrm>
-          <a:prstGeom prst="rect">
-            <a:avLst/>
-          </a:prstGeom>
-          <a:noFill/>
-        </p:spPr>
-        <p:txBody>
-          <a:bodyPr wrap="none" lIns="0" rIns="0" tIns="0" bIns="0" anchor="ctr">
-            <a:spAutoFit/>
-          </a:bodyPr>
-          <a:lstStyle/>
-          <a:p>
-            <a:pPr>
-              <a:defRPr sz="867" b="0" i="0">
-                <a:solidFill>
-                  <a:srgbClr val="000000"/>
-                </a:solidFill>
-                <a:latin typeface="Arial"/>
-              </a:defRPr>
-            </a:pPr>
-            <a:r>
-              <a:t>and the search for challenge.</a:t>
-            </a:r>
-          </a:p>
-        </p:txBody>
-      </p:sp>
-      <p:sp>
-        <p:nvSpPr>
-          <p:cNvPr id="62" name="TextBox 61"/>
-          <p:cNvSpPr txBox="1"/>
-          <p:nvPr/>
-        </p:nvSpPr>
-        <p:spPr>
-          <a:xfrm>
-            <a:off x="1562869" y="5589889"/>
-            <a:ext cx="1173366" cy="201168"/>
-          </a:xfrm>
-          <a:prstGeom prst="rect">
-            <a:avLst/>
-          </a:prstGeom>
-          <a:noFill/>
-        </p:spPr>
-        <p:txBody>
-          <a:bodyPr wrap="none" lIns="0" rIns="0" tIns="0" bIns="0" anchor="ctr">
-            <a:spAutoFit/>
-          </a:bodyPr>
-          <a:lstStyle/>
-          <a:p>
-            <a:pPr>
-              <a:defRPr sz="700" b="0" i="0">
-                <a:solidFill>
-                  <a:srgbClr val="020202"/>
-                </a:solidFill>
-                <a:latin typeface="Arial"/>
-              </a:defRPr>
-            </a:pPr>
-            <a:r>
-              <a:t>after absolute victory.</a:t>
-            </a:r>
-          </a:p>
-        </p:txBody>
-      </p:sp>
-      <p:sp>
-        <p:nvSpPr>
-          <p:cNvPr id="63" name="TextBox 62"/>
-          <p:cNvSpPr txBox="1"/>
-          <p:nvPr/>
-        </p:nvSpPr>
-        <p:spPr>
-          <a:xfrm>
-            <a:off x="9200684" y="4955834"/>
-            <a:ext cx="2820452" cy="1836573"/>
-          </a:xfrm>
-          <a:prstGeom prst="rect">
-            <a:avLst/>
-          </a:prstGeom>
-          <a:noFill/>
-        </p:spPr>
-        <p:txBody>
-          <a:bodyPr wrap="none" lIns="0" rIns="0" tIns="0" bIns="0" anchor="ctr">
-            <a:spAutoFit/>
-          </a:bodyPr>
-          <a:lstStyle/>
-          <a:p>
-            <a:pPr>
-              <a:defRPr sz="3400" b="1" i="0">
-                <a:solidFill>
-                  <a:srgbClr val="FEFEFE"/>
-                </a:solidFill>
-                <a:latin typeface="Arial"/>
-              </a:defRPr>
-            </a:pPr>
-            <a:r>
-              <a:t>BAM</a:t>
-            </a:r>
-          </a:p>
-        </p:txBody>
-      </p:sp>
-      <p:sp>
-        <p:nvSpPr>
-          <p:cNvPr id="64" name="TextBox 63"/>
-          <p:cNvSpPr txBox="1"/>
-          <p:nvPr/>
-        </p:nvSpPr>
-        <p:spPr>
-          <a:xfrm>
-            <a:off x="3384867" y="6070896"/>
-            <a:ext cx="4197883" cy="218639"/>
-          </a:xfrm>
-          <a:prstGeom prst="rect">
-            <a:avLst/>
-          </a:prstGeom>
-          <a:noFill/>
-        </p:spPr>
-        <p:txBody>
-          <a:bodyPr wrap="none" lIns="0" rIns="0" tIns="0" bIns="0" anchor="ctr">
-            <a:spAutoFit/>
-          </a:bodyPr>
-          <a:lstStyle/>
-          <a:p>
-            <a:pPr>
-              <a:defRPr sz="1208" b="0" i="0">
-                <a:solidFill>
-                  <a:srgbClr val="020202"/>
-                </a:solidFill>
-                <a:latin typeface="Arial"/>
-              </a:defRPr>
-            </a:pPr>
-            <a:r>
-              <a:t>One Punch Man is powerful as a character because</a:t>
-            </a:r>
-          </a:p>
-        </p:txBody>
-      </p:sp>
-      <p:sp>
-        <p:nvSpPr>
-          <p:cNvPr id="65" name="TextBox 64"/>
-          <p:cNvSpPr txBox="1"/>
-          <p:nvPr/>
-        </p:nvSpPr>
-        <p:spPr>
-          <a:xfrm>
-            <a:off x="1285925" y="6136488"/>
-            <a:ext cx="1596070" cy="357111"/>
-          </a:xfrm>
-          <a:prstGeom prst="rect">
-            <a:avLst/>
-          </a:prstGeom>
-          <a:noFill/>
-        </p:spPr>
-        <p:txBody>
-          <a:bodyPr wrap="none" lIns="0" rIns="0" tIns="0" bIns="0" anchor="ctr">
-            <a:spAutoFit/>
-          </a:bodyPr>
-          <a:lstStyle/>
-          <a:p>
-            <a:pPr>
-              <a:defRPr sz="2242" b="1" i="0">
-                <a:solidFill>
-                  <a:srgbClr val="FFFFFF"/>
-                </a:solidFill>
-                <a:latin typeface="Impact"/>
-              </a:defRPr>
-            </a:pPr>
-            <a:r>
-              <a:t>D) KEY TAKEAWAY</a:t>
-            </a:r>
-          </a:p>
-        </p:txBody>
-      </p:sp>
-      <p:sp>
-        <p:nvSpPr>
-          <p:cNvPr id="66" name="TextBox 65"/>
-          <p:cNvSpPr txBox="1"/>
-          <p:nvPr/>
-        </p:nvSpPr>
-        <p:spPr>
-          <a:xfrm>
-            <a:off x="3370291" y="6318688"/>
-            <a:ext cx="4256187" cy="240503"/>
-          </a:xfrm>
-          <a:prstGeom prst="rect">
-            <a:avLst/>
-          </a:prstGeom>
-          <a:noFill/>
-        </p:spPr>
-        <p:txBody>
-          <a:bodyPr wrap="none" lIns="0" rIns="0" tIns="0" bIns="0" anchor="ctr">
-            <a:spAutoFit/>
-          </a:bodyPr>
-          <a:lstStyle/>
-          <a:p>
-            <a:pPr>
-              <a:defRPr sz="1089" b="0" i="0">
-                <a:solidFill>
-                  <a:srgbClr val="020202"/>
-                </a:solidFill>
-                <a:latin typeface="Arial"/>
-              </a:defRPr>
-            </a:pPr>
-            <a:r>
-              <a:t>his strength is both a joke and a storytelling device.</a:t>
-            </a:r>
-          </a:p>
-        </p:txBody>
-      </p:sp>
       <p:pic>
         <p:nvPicPr>
-          <p:cNvPr id="67" name="Picture 66" descr="image.png"/>
+          <p:cNvPr id="13" name="Picture 12" descr="residual-94.png"/>
           <p:cNvPicPr>
             <a:picLocks noChangeAspect="1"/>
           </p:cNvPicPr>
@@ -5354,8 +3410,8 @@
         </p:blipFill>
         <p:spPr>
           <a:xfrm>
-            <a:off x="119846" y="5932425"/>
-            <a:ext cx="7994926" cy="794391"/>
+            <a:off x="323910" y="2550797"/>
+            <a:ext cx="699647" cy="670495"/>
           </a:xfrm>
           <a:prstGeom prst="rect">
             <a:avLst/>
@@ -5364,7 +3420,7 @@
       </p:pic>
       <p:pic>
         <p:nvPicPr>
-          <p:cNvPr id="68" name="Picture 67" descr="image.png"/>
+          <p:cNvPr id="14" name="Picture 13" descr="residual-81.png"/>
           <p:cNvPicPr>
             <a:picLocks noChangeAspect="1"/>
           </p:cNvPicPr>
@@ -5378,8 +3434,8 @@
         </p:blipFill>
         <p:spPr>
           <a:xfrm>
-            <a:off x="4237562" y="1355566"/>
-            <a:ext cx="3833483" cy="276943"/>
+            <a:off x="323910" y="3330612"/>
+            <a:ext cx="699647" cy="714223"/>
           </a:xfrm>
           <a:prstGeom prst="rect">
             <a:avLst/>
@@ -5388,7 +3444,7 @@
       </p:pic>
       <p:pic>
         <p:nvPicPr>
-          <p:cNvPr id="69" name="Picture 68" descr="image.png"/>
+          <p:cNvPr id="15" name="Picture 14" descr="image.png"/>
           <p:cNvPicPr>
             <a:picLocks noChangeAspect="1"/>
           </p:cNvPicPr>
@@ -5402,8 +3458,8 @@
         </p:blipFill>
         <p:spPr>
           <a:xfrm>
-            <a:off x="229166" y="1297262"/>
-            <a:ext cx="2368597" cy="393551"/>
+            <a:off x="4237562" y="4117715"/>
+            <a:ext cx="3920939" cy="1719965"/>
           </a:xfrm>
           <a:prstGeom prst="rect">
             <a:avLst/>
@@ -5412,7 +3468,7 @@
       </p:pic>
       <p:pic>
         <p:nvPicPr>
-          <p:cNvPr id="70" name="Picture 69" descr="image.png"/>
+          <p:cNvPr id="16" name="Picture 15" descr="residual-48.png"/>
           <p:cNvPicPr>
             <a:picLocks noChangeAspect="1"/>
           </p:cNvPicPr>
@@ -5426,8 +3482,8 @@
         </p:blipFill>
         <p:spPr>
           <a:xfrm>
-            <a:off x="1089149" y="1785557"/>
-            <a:ext cx="364399" cy="568463"/>
+            <a:off x="323910" y="4205171"/>
+            <a:ext cx="685071" cy="663207"/>
           </a:xfrm>
           <a:prstGeom prst="rect">
             <a:avLst/>
@@ -5436,7 +3492,7 @@
       </p:pic>
       <p:pic>
         <p:nvPicPr>
-          <p:cNvPr id="71" name="Picture 70" descr="image.png"/>
+          <p:cNvPr id="17" name="Picture 16" descr="residual-28.png"/>
           <p:cNvPicPr>
             <a:picLocks noChangeAspect="1"/>
           </p:cNvPicPr>
@@ -5450,8 +3506,8 @@
         </p:blipFill>
         <p:spPr>
           <a:xfrm>
-            <a:off x="8384429" y="6107336"/>
-            <a:ext cx="371687" cy="422703"/>
+            <a:off x="323910" y="4977698"/>
+            <a:ext cx="692359" cy="728799"/>
           </a:xfrm>
           <a:prstGeom prst="rect">
             <a:avLst/>
@@ -5460,7 +3516,7 @@
       </p:pic>
       <p:sp>
         <p:nvSpPr>
-          <p:cNvPr id="72" name="Rectangle 71"/>
+          <p:cNvPr id="18" name="Rectangle 17"/>
           <p:cNvSpPr/>
           <p:nvPr/>
         </p:nvSpPr>
@@ -5503,7 +3559,7 @@
       </p:sp>
       <p:sp>
         <p:nvSpPr>
-          <p:cNvPr id="73" name="Rectangle 72"/>
+          <p:cNvPr id="19" name="Rectangle 18"/>
           <p:cNvSpPr/>
           <p:nvPr/>
         </p:nvSpPr>
@@ -5546,7 +3602,7 @@
       </p:sp>
       <p:sp>
         <p:nvSpPr>
-          <p:cNvPr id="74" name="Rectangle 73"/>
+          <p:cNvPr id="20" name="Rectangle 19"/>
           <p:cNvSpPr/>
           <p:nvPr/>
         </p:nvSpPr>
@@ -5589,7 +3645,7 @@
       </p:sp>
       <p:sp>
         <p:nvSpPr>
-          <p:cNvPr id="75" name="Rectangle 74"/>
+          <p:cNvPr id="21" name="Rectangle 20"/>
           <p:cNvSpPr/>
           <p:nvPr/>
         </p:nvSpPr>
@@ -5632,7 +3688,7 @@
       </p:sp>
       <p:sp>
         <p:nvSpPr>
-          <p:cNvPr id="76" name="Rectangle 75"/>
+          <p:cNvPr id="22" name="Rectangle 21"/>
           <p:cNvSpPr/>
           <p:nvPr/>
         </p:nvSpPr>
@@ -5675,7 +3731,7 @@
       </p:sp>
       <p:sp>
         <p:nvSpPr>
-          <p:cNvPr id="77" name="Rectangle 76"/>
+          <p:cNvPr id="23" name="Rectangle 22"/>
           <p:cNvSpPr/>
           <p:nvPr/>
         </p:nvSpPr>
@@ -5718,14 +3774,14 @@
       </p:sp>
       <p:sp>
         <p:nvSpPr>
-          <p:cNvPr id="78" name="TextBox 77"/>
+          <p:cNvPr id="24" name="TextBox 23"/>
           <p:cNvSpPr txBox="1"/>
           <p:nvPr/>
         </p:nvSpPr>
         <p:spPr>
           <a:xfrm>
-            <a:off x="1196137" y="1967757"/>
-            <a:ext cx="96930" cy="201168"/>
+            <a:off x="148998" y="7287"/>
+            <a:ext cx="7958486" cy="983878"/>
           </a:xfrm>
           <a:prstGeom prst="rect">
             <a:avLst/>
@@ -5739,29 +3795,29 @@
           <a:lstStyle/>
           <a:p>
             <a:pPr>
-              <a:defRPr sz="747" b="0" i="0">
-                <a:solidFill>
-                  <a:srgbClr val="111111"/>
-                </a:solidFill>
-                <a:latin typeface="Malgun Gothic"/>
+              <a:defRPr sz="5419" b="1" i="0">
+                <a:solidFill>
+                  <a:srgbClr val="030303"/>
+                </a:solidFill>
+                <a:latin typeface="Impact"/>
               </a:defRPr>
             </a:pPr>
             <a:r>
-              <a:t>•</a:t>
-            </a:r>
-          </a:p>
-        </p:txBody>
-      </p:sp>
-      <p:sp>
-        <p:nvSpPr>
-          <p:cNvPr id="79" name="TextBox 78"/>
+              <a:t>Why Is One Punch Man So Strong?</a:t>
+            </a:r>
+          </a:p>
+        </p:txBody>
+      </p:sp>
+      <p:sp>
+        <p:nvSpPr>
+          <p:cNvPr id="25" name="TextBox 24"/>
           <p:cNvSpPr txBox="1"/>
           <p:nvPr/>
         </p:nvSpPr>
         <p:spPr>
           <a:xfrm>
-            <a:off x="1241322" y="2142669"/>
-            <a:ext cx="72879" cy="201168"/>
+            <a:off x="294758" y="998454"/>
+            <a:ext cx="6777832" cy="218639"/>
           </a:xfrm>
           <a:prstGeom prst="rect">
             <a:avLst/>
@@ -5775,29 +3831,29 @@
           <a:lstStyle/>
           <a:p>
             <a:pPr>
-              <a:defRPr sz="700" b="0" i="0">
-                <a:solidFill>
-                  <a:srgbClr val="111111"/>
-                </a:solidFill>
-                <a:latin typeface="Malgun Gothic"/>
+              <a:defRPr sz="1080" b="0" i="1">
+                <a:solidFill>
+                  <a:srgbClr val="000000"/>
+                </a:solidFill>
+                <a:latin typeface="Arial"/>
               </a:defRPr>
             </a:pPr>
             <a:r>
-              <a:t>•</a:t>
-            </a:r>
-          </a:p>
-        </p:txBody>
-      </p:sp>
-      <p:sp>
-        <p:nvSpPr>
-          <p:cNvPr id="80" name="TextBox 79"/>
+              <a:t>Narrative, psychological, and structural reasons behind Saitama's overwhelming power</a:t>
+            </a:r>
+          </a:p>
+        </p:txBody>
+      </p:sp>
+      <p:sp>
+        <p:nvSpPr>
+          <p:cNvPr id="26" name="TextBox 25"/>
           <p:cNvSpPr txBox="1"/>
           <p:nvPr/>
         </p:nvSpPr>
         <p:spPr>
           <a:xfrm>
-            <a:off x="6524825" y="3308748"/>
-            <a:ext cx="112235" cy="201168"/>
+            <a:off x="331198" y="1355566"/>
+            <a:ext cx="1486750" cy="225927"/>
           </a:xfrm>
           <a:prstGeom prst="rect">
             <a:avLst/>
@@ -5811,29 +3867,29 @@
           <a:lstStyle/>
           <a:p>
             <a:pPr>
-              <a:defRPr sz="866" b="0" i="0">
-                <a:solidFill>
-                  <a:srgbClr val="111111"/>
-                </a:solidFill>
-                <a:latin typeface="Malgun Gothic"/>
+              <a:defRPr sz="1334" b="1" i="0">
+                <a:solidFill>
+                  <a:srgbClr val="FFFFFF"/>
+                </a:solidFill>
+                <a:latin typeface="Arial"/>
               </a:defRPr>
             </a:pPr>
             <a:r>
-              <a:t>•</a:t>
-            </a:r>
-          </a:p>
-        </p:txBody>
-      </p:sp>
-      <p:sp>
-        <p:nvSpPr>
-          <p:cNvPr id="81" name="TextBox 80"/>
+              <a:t>A) CORE REASONS</a:t>
+            </a:r>
+          </a:p>
+        </p:txBody>
+      </p:sp>
+      <p:sp>
+        <p:nvSpPr>
+          <p:cNvPr id="27" name="TextBox 26"/>
           <p:cNvSpPr txBox="1"/>
           <p:nvPr/>
         </p:nvSpPr>
         <p:spPr>
           <a:xfrm>
-            <a:off x="1229370" y="3643995"/>
-            <a:ext cx="86727" cy="201168"/>
+            <a:off x="4354169" y="1399294"/>
+            <a:ext cx="3316036" cy="201168"/>
           </a:xfrm>
           <a:prstGeom prst="rect">
             <a:avLst/>
@@ -5847,29 +3903,29 @@
           <a:lstStyle/>
           <a:p>
             <a:pPr>
-              <a:defRPr sz="700" b="0" i="0">
-                <a:solidFill>
-                  <a:srgbClr val="111111"/>
-                </a:solidFill>
-                <a:latin typeface="Malgun Gothic"/>
+              <a:defRPr sz="1038" b="1" i="0">
+                <a:solidFill>
+                  <a:srgbClr val="F8D264"/>
+                </a:solidFill>
+                <a:latin typeface="Arial"/>
               </a:defRPr>
             </a:pPr>
             <a:r>
-              <a:t>•</a:t>
-            </a:r>
-          </a:p>
-        </p:txBody>
-      </p:sp>
-      <p:sp>
-        <p:nvSpPr>
-          <p:cNvPr id="82" name="TextBox 81"/>
+              <a:t>B) HOW HE DIFFERS FROM TYPICAL SHONEN HEROES</a:t>
+            </a:r>
+          </a:p>
+        </p:txBody>
+      </p:sp>
+      <p:sp>
+        <p:nvSpPr>
+          <p:cNvPr id="28" name="TextBox 27"/>
           <p:cNvSpPr txBox="1"/>
           <p:nvPr/>
         </p:nvSpPr>
         <p:spPr>
           <a:xfrm>
-            <a:off x="4515380" y="3760603"/>
-            <a:ext cx="107133" cy="201168"/>
+            <a:off x="1577445" y="1770981"/>
+            <a:ext cx="1340990" cy="201168"/>
           </a:xfrm>
           <a:prstGeom prst="rect">
             <a:avLst/>
@@ -5883,29 +3939,29 @@
           <a:lstStyle/>
           <a:p>
             <a:pPr>
-              <a:defRPr sz="826" b="0" i="0">
-                <a:solidFill>
-                  <a:srgbClr val="111111"/>
-                </a:solidFill>
-                <a:latin typeface="Malgun Gothic"/>
+              <a:defRPr sz="946" b="1" i="0">
+                <a:solidFill>
+                  <a:srgbClr val="010101"/>
+                </a:solidFill>
+                <a:latin typeface="Arial"/>
               </a:defRPr>
             </a:pPr>
             <a:r>
-              <a:t>•</a:t>
-            </a:r>
-          </a:p>
-        </p:txBody>
-      </p:sp>
-      <p:sp>
-        <p:nvSpPr>
-          <p:cNvPr id="83" name="TextBox 82"/>
+              <a:t>BUILT AS A SATIRE</a:t>
+            </a:r>
+          </a:p>
+        </p:txBody>
+      </p:sp>
+      <p:sp>
+        <p:nvSpPr>
+          <p:cNvPr id="29" name="TextBox 28"/>
           <p:cNvSpPr txBox="1"/>
           <p:nvPr/>
         </p:nvSpPr>
         <p:spPr>
           <a:xfrm>
-            <a:off x="6525991" y="3753315"/>
-            <a:ext cx="127539" cy="201168"/>
+            <a:off x="6351079" y="1807421"/>
+            <a:ext cx="378975" cy="357111"/>
           </a:xfrm>
           <a:prstGeom prst="rect">
             <a:avLst/>
@@ -5919,6 +3975,1014 @@
           <a:lstStyle/>
           <a:p>
             <a:pPr>
+              <a:defRPr sz="1624" b="1" i="0">
+                <a:solidFill>
+                  <a:srgbClr val="F7C403"/>
+                </a:solidFill>
+                <a:latin typeface="Arial"/>
+              </a:defRPr>
+            </a:pPr>
+            <a:r>
+              <a:t>VS.</a:t>
+            </a:r>
+          </a:p>
+        </p:txBody>
+      </p:sp>
+      <p:sp>
+        <p:nvSpPr>
+          <p:cNvPr id="30" name="TextBox 29"/>
+          <p:cNvSpPr txBox="1"/>
+          <p:nvPr/>
+        </p:nvSpPr>
+        <p:spPr>
+          <a:xfrm>
+            <a:off x="1140165" y="1865725"/>
+            <a:ext cx="218639" cy="400839"/>
+          </a:xfrm>
+          <a:prstGeom prst="rect">
+            <a:avLst/>
+          </a:prstGeom>
+          <a:noFill/>
+        </p:spPr>
+        <p:txBody>
+          <a:bodyPr wrap="none" lIns="0" rIns="0" tIns="0" bIns="0" anchor="ctr">
+            <a:spAutoFit/>
+          </a:bodyPr>
+          <a:lstStyle/>
+          <a:p>
+            <a:pPr>
+              <a:defRPr sz="1687" b="0" i="0">
+                <a:solidFill>
+                  <a:srgbClr val="050400"/>
+                </a:solidFill>
+                <a:latin typeface="Arial"/>
+              </a:defRPr>
+            </a:pPr>
+            <a:r>
+              <a:t>1</a:t>
+            </a:r>
+          </a:p>
+        </p:txBody>
+      </p:sp>
+      <p:sp>
+        <p:nvSpPr>
+          <p:cNvPr id="31" name="TextBox 30"/>
+          <p:cNvSpPr txBox="1"/>
+          <p:nvPr/>
+        </p:nvSpPr>
+        <p:spPr>
+          <a:xfrm>
+            <a:off x="6985134" y="1902165"/>
+            <a:ext cx="612191" cy="201168"/>
+          </a:xfrm>
+          <a:prstGeom prst="rect">
+            <a:avLst/>
+          </a:prstGeom>
+          <a:noFill/>
+        </p:spPr>
+        <p:txBody>
+          <a:bodyPr wrap="none" lIns="0" rIns="0" tIns="0" bIns="0" anchor="ctr">
+            <a:spAutoFit/>
+          </a:bodyPr>
+          <a:lstStyle/>
+          <a:p>
+            <a:pPr>
+              <a:defRPr sz="1075" b="1" i="0">
+                <a:solidFill>
+                  <a:srgbClr val="FFFFFF"/>
+                </a:solidFill>
+                <a:latin typeface="Arial"/>
+              </a:defRPr>
+            </a:pPr>
+            <a:r>
+              <a:t>SAITAMA</a:t>
+            </a:r>
+          </a:p>
+        </p:txBody>
+      </p:sp>
+      <p:sp>
+        <p:nvSpPr>
+          <p:cNvPr id="32" name="TextBox 31"/>
+          <p:cNvSpPr txBox="1"/>
+          <p:nvPr/>
+        </p:nvSpPr>
+        <p:spPr>
+          <a:xfrm>
+            <a:off x="4813313" y="1916741"/>
+            <a:ext cx="1319126" cy="201168"/>
+          </a:xfrm>
+          <a:prstGeom prst="rect">
+            <a:avLst/>
+          </a:prstGeom>
+          <a:noFill/>
+        </p:spPr>
+        <p:txBody>
+          <a:bodyPr wrap="none" lIns="0" rIns="0" tIns="0" bIns="0" anchor="ctr">
+            <a:spAutoFit/>
+          </a:bodyPr>
+          <a:lstStyle/>
+          <a:p>
+            <a:pPr>
+              <a:defRPr sz="903" b="1" i="0">
+                <a:solidFill>
+                  <a:srgbClr val="000000"/>
+                </a:solidFill>
+                <a:latin typeface="Arial"/>
+              </a:defRPr>
+            </a:pPr>
+            <a:r>
+              <a:t>TYPICAL SHONEN HERO</a:t>
+            </a:r>
+          </a:p>
+        </p:txBody>
+      </p:sp>
+      <p:sp>
+        <p:nvSpPr>
+          <p:cNvPr id="33" name="TextBox 32"/>
+          <p:cNvSpPr txBox="1"/>
+          <p:nvPr/>
+        </p:nvSpPr>
+        <p:spPr>
+          <a:xfrm>
+            <a:off x="1196137" y="1967757"/>
+            <a:ext cx="96930" cy="201168"/>
+          </a:xfrm>
+          <a:prstGeom prst="rect">
+            <a:avLst/>
+          </a:prstGeom>
+          <a:noFill/>
+        </p:spPr>
+        <p:txBody>
+          <a:bodyPr wrap="none" lIns="0" rIns="0" tIns="0" bIns="0" anchor="ctr">
+            <a:spAutoFit/>
+          </a:bodyPr>
+          <a:lstStyle/>
+          <a:p>
+            <a:pPr>
+              <a:defRPr sz="747" b="0" i="0">
+                <a:solidFill>
+                  <a:srgbClr val="111111"/>
+                </a:solidFill>
+                <a:latin typeface="Malgun Gothic"/>
+              </a:defRPr>
+            </a:pPr>
+            <a:r>
+              <a:t>•</a:t>
+            </a:r>
+          </a:p>
+        </p:txBody>
+      </p:sp>
+      <p:sp>
+        <p:nvSpPr>
+          <p:cNvPr id="34" name="TextBox 33"/>
+          <p:cNvSpPr txBox="1"/>
+          <p:nvPr/>
+        </p:nvSpPr>
+        <p:spPr>
+          <a:xfrm>
+            <a:off x="1562869" y="1967757"/>
+            <a:ext cx="2368597" cy="201168"/>
+          </a:xfrm>
+          <a:prstGeom prst="rect">
+            <a:avLst/>
+          </a:prstGeom>
+          <a:noFill/>
+        </p:spPr>
+        <p:txBody>
+          <a:bodyPr wrap="none" lIns="0" rIns="0" tIns="0" bIns="0" anchor="ctr">
+            <a:spAutoFit/>
+          </a:bodyPr>
+          <a:lstStyle/>
+          <a:p>
+            <a:pPr>
+              <a:defRPr sz="726" b="0" i="0">
+                <a:solidFill>
+                  <a:srgbClr val="040303"/>
+                </a:solidFill>
+                <a:latin typeface="Arial"/>
+              </a:defRPr>
+            </a:pPr>
+            <a:r>
+              <a:t>Saitama was designed to parody power-scaling</a:t>
+            </a:r>
+          </a:p>
+        </p:txBody>
+      </p:sp>
+      <p:sp>
+        <p:nvSpPr>
+          <p:cNvPr id="35" name="TextBox 34"/>
+          <p:cNvSpPr txBox="1"/>
+          <p:nvPr/>
+        </p:nvSpPr>
+        <p:spPr>
+          <a:xfrm>
+            <a:off x="1241322" y="2142669"/>
+            <a:ext cx="72879" cy="201168"/>
+          </a:xfrm>
+          <a:prstGeom prst="rect">
+            <a:avLst/>
+          </a:prstGeom>
+          <a:noFill/>
+        </p:spPr>
+        <p:txBody>
+          <a:bodyPr wrap="none" lIns="0" rIns="0" tIns="0" bIns="0" anchor="ctr">
+            <a:spAutoFit/>
+          </a:bodyPr>
+          <a:lstStyle/>
+          <a:p>
+            <a:pPr>
+              <a:defRPr sz="700" b="0" i="0">
+                <a:solidFill>
+                  <a:srgbClr val="111111"/>
+                </a:solidFill>
+                <a:latin typeface="Malgun Gothic"/>
+              </a:defRPr>
+            </a:pPr>
+            <a:r>
+              <a:t>•</a:t>
+            </a:r>
+          </a:p>
+        </p:txBody>
+      </p:sp>
+      <p:sp>
+        <p:nvSpPr>
+          <p:cNvPr id="36" name="TextBox 35"/>
+          <p:cNvSpPr txBox="1"/>
+          <p:nvPr/>
+        </p:nvSpPr>
+        <p:spPr>
+          <a:xfrm>
+            <a:off x="1577445" y="2142669"/>
+            <a:ext cx="2171821" cy="201168"/>
+          </a:xfrm>
+          <a:prstGeom prst="rect">
+            <a:avLst/>
+          </a:prstGeom>
+          <a:noFill/>
+        </p:spPr>
+        <p:txBody>
+          <a:bodyPr wrap="none" lIns="0" rIns="0" tIns="0" bIns="0" anchor="ctr">
+            <a:spAutoFit/>
+          </a:bodyPr>
+          <a:lstStyle/>
+          <a:p>
+            <a:pPr>
+              <a:defRPr sz="700" b="0" i="0">
+                <a:solidFill>
+                  <a:srgbClr val="040303"/>
+                </a:solidFill>
+                <a:latin typeface="Arial"/>
+              </a:defRPr>
+            </a:pPr>
+            <a:r>
+              <a:t>stories—his absurd strength is the premise</a:t>
+            </a:r>
+          </a:p>
+        </p:txBody>
+      </p:sp>
+      <p:sp>
+        <p:nvSpPr>
+          <p:cNvPr id="37" name="TextBox 36"/>
+          <p:cNvSpPr txBox="1"/>
+          <p:nvPr/>
+        </p:nvSpPr>
+        <p:spPr>
+          <a:xfrm>
+            <a:off x="1562869" y="2273853"/>
+            <a:ext cx="816255" cy="201168"/>
+          </a:xfrm>
+          <a:prstGeom prst="rect">
+            <a:avLst/>
+          </a:prstGeom>
+          <a:noFill/>
+        </p:spPr>
+        <p:txBody>
+          <a:bodyPr wrap="none" lIns="0" rIns="0" tIns="0" bIns="0" anchor="ctr">
+            <a:spAutoFit/>
+          </a:bodyPr>
+          <a:lstStyle/>
+          <a:p>
+            <a:pPr>
+              <a:defRPr sz="741" b="0" i="0">
+                <a:solidFill>
+                  <a:srgbClr val="000000"/>
+                </a:solidFill>
+                <a:latin typeface="Arial"/>
+              </a:defRPr>
+            </a:pPr>
+            <a:r>
+              <a:t>not the reward.</a:t>
+            </a:r>
+          </a:p>
+        </p:txBody>
+      </p:sp>
+      <p:sp>
+        <p:nvSpPr>
+          <p:cNvPr id="38" name="TextBox 37"/>
+          <p:cNvSpPr txBox="1"/>
+          <p:nvPr/>
+        </p:nvSpPr>
+        <p:spPr>
+          <a:xfrm>
+            <a:off x="6912254" y="2332157"/>
+            <a:ext cx="1034894" cy="201168"/>
+          </a:xfrm>
+          <a:prstGeom prst="rect">
+            <a:avLst/>
+          </a:prstGeom>
+          <a:noFill/>
+        </p:spPr>
+        <p:txBody>
+          <a:bodyPr wrap="none" lIns="0" rIns="0" tIns="0" bIns="0" anchor="ctr">
+            <a:spAutoFit/>
+          </a:bodyPr>
+          <a:lstStyle/>
+          <a:p>
+            <a:pPr>
+              <a:defRPr sz="854" b="0" i="0">
+                <a:solidFill>
+                  <a:srgbClr val="BB0000"/>
+                </a:solidFill>
+                <a:latin typeface="Arial"/>
+              </a:defRPr>
+            </a:pPr>
+            <a:r>
+              <a:t>Already complete</a:t>
+            </a:r>
+          </a:p>
+        </p:txBody>
+      </p:sp>
+      <p:sp>
+        <p:nvSpPr>
+          <p:cNvPr id="39" name="TextBox 38"/>
+          <p:cNvSpPr txBox="1"/>
+          <p:nvPr/>
+        </p:nvSpPr>
+        <p:spPr>
+          <a:xfrm>
+            <a:off x="5024665" y="2339445"/>
+            <a:ext cx="641343" cy="201168"/>
+          </a:xfrm>
+          <a:prstGeom prst="rect">
+            <a:avLst/>
+          </a:prstGeom>
+          <a:noFill/>
+        </p:spPr>
+        <p:txBody>
+          <a:bodyPr wrap="none" lIns="0" rIns="0" tIns="0" bIns="0" anchor="ctr">
+            <a:spAutoFit/>
+          </a:bodyPr>
+          <a:lstStyle/>
+          <a:p>
+            <a:pPr>
+              <a:defRPr sz="860" b="0" i="0">
+                <a:solidFill>
+                  <a:srgbClr val="000000"/>
+                </a:solidFill>
+                <a:latin typeface="Arial"/>
+              </a:defRPr>
+            </a:pPr>
+            <a:r>
+              <a:t>Growth arc</a:t>
+            </a:r>
+          </a:p>
+        </p:txBody>
+      </p:sp>
+      <p:sp>
+        <p:nvSpPr>
+          <p:cNvPr id="40" name="TextBox 39"/>
+          <p:cNvSpPr txBox="1"/>
+          <p:nvPr/>
+        </p:nvSpPr>
+        <p:spPr>
+          <a:xfrm>
+            <a:off x="1570157" y="2601812"/>
+            <a:ext cx="2040637" cy="201168"/>
+          </a:xfrm>
+          <a:prstGeom prst="rect">
+            <a:avLst/>
+          </a:prstGeom>
+          <a:noFill/>
+        </p:spPr>
+        <p:txBody>
+          <a:bodyPr wrap="none" lIns="0" rIns="0" tIns="0" bIns="0" anchor="ctr">
+            <a:spAutoFit/>
+          </a:bodyPr>
+          <a:lstStyle/>
+          <a:p>
+            <a:pPr>
+              <a:defRPr sz="989" b="1" i="0">
+                <a:solidFill>
+                  <a:srgbClr val="020202"/>
+                </a:solidFill>
+                <a:latin typeface="Arial"/>
+              </a:defRPr>
+            </a:pPr>
+            <a:r>
+              <a:t>ALREADY AT THE FINISH LINE</a:t>
+            </a:r>
+          </a:p>
+        </p:txBody>
+      </p:sp>
+      <p:sp>
+        <p:nvSpPr>
+          <p:cNvPr id="41" name="TextBox 40"/>
+          <p:cNvSpPr txBox="1"/>
+          <p:nvPr/>
+        </p:nvSpPr>
+        <p:spPr>
+          <a:xfrm>
+            <a:off x="1096437" y="2667404"/>
+            <a:ext cx="342535" cy="451855"/>
+          </a:xfrm>
+          <a:prstGeom prst="rect">
+            <a:avLst/>
+          </a:prstGeom>
+          <a:noFill/>
+        </p:spPr>
+        <p:txBody>
+          <a:bodyPr wrap="none" lIns="0" rIns="0" tIns="0" bIns="0" anchor="ctr">
+            <a:spAutoFit/>
+          </a:bodyPr>
+          <a:lstStyle/>
+          <a:p>
+            <a:pPr>
+              <a:defRPr sz="2643" b="0" i="0">
+                <a:solidFill>
+                  <a:srgbClr val="050400"/>
+                </a:solidFill>
+                <a:latin typeface="Arial"/>
+              </a:defRPr>
+            </a:pPr>
+            <a:r>
+              <a:t>2</a:t>
+            </a:r>
+          </a:p>
+        </p:txBody>
+      </p:sp>
+      <p:sp>
+        <p:nvSpPr>
+          <p:cNvPr id="42" name="TextBox 41"/>
+          <p:cNvSpPr txBox="1"/>
+          <p:nvPr/>
+        </p:nvSpPr>
+        <p:spPr>
+          <a:xfrm>
+            <a:off x="5017377" y="2762148"/>
+            <a:ext cx="1217094" cy="201168"/>
+          </a:xfrm>
+          <a:prstGeom prst="rect">
+            <a:avLst/>
+          </a:prstGeom>
+          <a:noFill/>
+        </p:spPr>
+        <p:txBody>
+          <a:bodyPr wrap="none" lIns="0" rIns="0" tIns="0" bIns="0" anchor="ctr">
+            <a:spAutoFit/>
+          </a:bodyPr>
+          <a:lstStyle/>
+          <a:p>
+            <a:pPr>
+              <a:defRPr sz="776" b="0" i="0">
+                <a:solidFill>
+                  <a:srgbClr val="000000"/>
+                </a:solidFill>
+                <a:latin typeface="Arial"/>
+              </a:defRPr>
+            </a:pPr>
+            <a:r>
+              <a:t>Wins through struggle</a:t>
+            </a:r>
+          </a:p>
+        </p:txBody>
+      </p:sp>
+      <p:sp>
+        <p:nvSpPr>
+          <p:cNvPr id="43" name="TextBox 42"/>
+          <p:cNvSpPr txBox="1"/>
+          <p:nvPr/>
+        </p:nvSpPr>
+        <p:spPr>
+          <a:xfrm>
+            <a:off x="6912254" y="2769436"/>
+            <a:ext cx="816255" cy="201168"/>
+          </a:xfrm>
+          <a:prstGeom prst="rect">
+            <a:avLst/>
+          </a:prstGeom>
+          <a:noFill/>
+        </p:spPr>
+        <p:txBody>
+          <a:bodyPr wrap="none" lIns="0" rIns="0" tIns="0" bIns="0" anchor="ctr">
+            <a:spAutoFit/>
+          </a:bodyPr>
+          <a:lstStyle/>
+          <a:p>
+            <a:pPr>
+              <a:defRPr sz="772" b="0" i="0">
+                <a:solidFill>
+                  <a:srgbClr val="BA0000"/>
+                </a:solidFill>
+                <a:latin typeface="Arial"/>
+              </a:defRPr>
+            </a:pPr>
+            <a:r>
+              <a:t>Wins instantly</a:t>
+            </a:r>
+          </a:p>
+        </p:txBody>
+      </p:sp>
+      <p:sp>
+        <p:nvSpPr>
+          <p:cNvPr id="44" name="TextBox 43"/>
+          <p:cNvSpPr txBox="1"/>
+          <p:nvPr/>
+        </p:nvSpPr>
+        <p:spPr>
+          <a:xfrm>
+            <a:off x="1562869" y="2798588"/>
+            <a:ext cx="2346733" cy="201168"/>
+          </a:xfrm>
+          <a:prstGeom prst="rect">
+            <a:avLst/>
+          </a:prstGeom>
+          <a:noFill/>
+        </p:spPr>
+        <p:txBody>
+          <a:bodyPr wrap="none" lIns="0" rIns="0" tIns="0" bIns="0" anchor="ctr">
+            <a:spAutoFit/>
+          </a:bodyPr>
+          <a:lstStyle/>
+          <a:p>
+            <a:pPr>
+              <a:defRPr sz="700" b="0" i="0">
+                <a:solidFill>
+                  <a:srgbClr val="030303"/>
+                </a:solidFill>
+                <a:latin typeface="Arial"/>
+              </a:defRPr>
+            </a:pPr>
+            <a:r>
+              <a:t>While others train and climb for years to reach</a:t>
+            </a:r>
+          </a:p>
+        </p:txBody>
+      </p:sp>
+      <p:sp>
+        <p:nvSpPr>
+          <p:cNvPr id="45" name="TextBox 44"/>
+          <p:cNvSpPr txBox="1"/>
+          <p:nvPr/>
+        </p:nvSpPr>
+        <p:spPr>
+          <a:xfrm>
+            <a:off x="1555581" y="2951636"/>
+            <a:ext cx="2215549" cy="201168"/>
+          </a:xfrm>
+          <a:prstGeom prst="rect">
+            <a:avLst/>
+          </a:prstGeom>
+          <a:noFill/>
+        </p:spPr>
+        <p:txBody>
+          <a:bodyPr wrap="none" lIns="0" rIns="0" tIns="0" bIns="0" anchor="ctr">
+            <a:spAutoFit/>
+          </a:bodyPr>
+          <a:lstStyle/>
+          <a:p>
+            <a:pPr>
+              <a:defRPr sz="721" b="0" i="0">
+                <a:solidFill>
+                  <a:srgbClr val="050404"/>
+                </a:solidFill>
+                <a:latin typeface="Arial"/>
+              </a:defRPr>
+            </a:pPr>
+            <a:r>
+              <a:t>the top, he begins where most protagonists</a:t>
+            </a:r>
+          </a:p>
+        </p:txBody>
+      </p:sp>
+      <p:sp>
+        <p:nvSpPr>
+          <p:cNvPr id="46" name="TextBox 45"/>
+          <p:cNvSpPr txBox="1"/>
+          <p:nvPr/>
+        </p:nvSpPr>
+        <p:spPr>
+          <a:xfrm>
+            <a:off x="1570157" y="3126548"/>
+            <a:ext cx="1078622" cy="201168"/>
+          </a:xfrm>
+          <a:prstGeom prst="rect">
+            <a:avLst/>
+          </a:prstGeom>
+          <a:noFill/>
+        </p:spPr>
+        <p:txBody>
+          <a:bodyPr wrap="none" lIns="0" rIns="0" tIns="0" bIns="0" anchor="ctr">
+            <a:spAutoFit/>
+          </a:bodyPr>
+          <a:lstStyle/>
+          <a:p>
+            <a:pPr>
+              <a:defRPr sz="731" b="0" i="0">
+                <a:solidFill>
+                  <a:srgbClr val="030302"/>
+                </a:solidFill>
+                <a:latin typeface="Arial"/>
+              </a:defRPr>
+            </a:pPr>
+            <a:r>
+              <a:t>are supposed to end.</a:t>
+            </a:r>
+          </a:p>
+        </p:txBody>
+      </p:sp>
+      <p:sp>
+        <p:nvSpPr>
+          <p:cNvPr id="47" name="TextBox 46"/>
+          <p:cNvSpPr txBox="1"/>
+          <p:nvPr/>
+        </p:nvSpPr>
+        <p:spPr>
+          <a:xfrm>
+            <a:off x="6904966" y="3126548"/>
+            <a:ext cx="750663" cy="201168"/>
+          </a:xfrm>
+          <a:prstGeom prst="rect">
+            <a:avLst/>
+          </a:prstGeom>
+          <a:noFill/>
+        </p:spPr>
+        <p:txBody>
+          <a:bodyPr wrap="none" lIns="0" rIns="0" tIns="0" bIns="0" anchor="ctr">
+            <a:spAutoFit/>
+          </a:bodyPr>
+          <a:lstStyle/>
+          <a:p>
+            <a:pPr>
+              <a:defRPr sz="864" b="0" i="0">
+                <a:solidFill>
+                  <a:srgbClr val="C50000"/>
+                </a:solidFill>
+                <a:latin typeface="Arial"/>
+              </a:defRPr>
+            </a:pPr>
+            <a:r>
+              <a:t>Power is the</a:t>
+            </a:r>
+          </a:p>
+        </p:txBody>
+      </p:sp>
+      <p:sp>
+        <p:nvSpPr>
+          <p:cNvPr id="48" name="TextBox 47"/>
+          <p:cNvSpPr txBox="1"/>
+          <p:nvPr/>
+        </p:nvSpPr>
+        <p:spPr>
+          <a:xfrm>
+            <a:off x="5010089" y="3214004"/>
+            <a:ext cx="867270" cy="201168"/>
+          </a:xfrm>
+          <a:prstGeom prst="rect">
+            <a:avLst/>
+          </a:prstGeom>
+          <a:noFill/>
+        </p:spPr>
+        <p:txBody>
+          <a:bodyPr wrap="none" lIns="0" rIns="0" tIns="0" bIns="0" anchor="ctr">
+            <a:spAutoFit/>
+          </a:bodyPr>
+          <a:lstStyle/>
+          <a:p>
+            <a:pPr>
+              <a:defRPr sz="811" b="0" i="0">
+                <a:solidFill>
+                  <a:srgbClr val="000000"/>
+                </a:solidFill>
+                <a:latin typeface="Arial"/>
+              </a:defRPr>
+            </a:pPr>
+            <a:r>
+              <a:t>Power is a goal</a:t>
+            </a:r>
+          </a:p>
+        </p:txBody>
+      </p:sp>
+      <p:sp>
+        <p:nvSpPr>
+          <p:cNvPr id="49" name="TextBox 48"/>
+          <p:cNvSpPr txBox="1"/>
+          <p:nvPr/>
+        </p:nvSpPr>
+        <p:spPr>
+          <a:xfrm>
+            <a:off x="6524825" y="3308748"/>
+            <a:ext cx="112235" cy="201168"/>
+          </a:xfrm>
+          <a:prstGeom prst="rect">
+            <a:avLst/>
+          </a:prstGeom>
+          <a:noFill/>
+        </p:spPr>
+        <p:txBody>
+          <a:bodyPr wrap="none" lIns="0" rIns="0" tIns="0" bIns="0" anchor="ctr">
+            <a:spAutoFit/>
+          </a:bodyPr>
+          <a:lstStyle/>
+          <a:p>
+            <a:pPr>
+              <a:defRPr sz="866" b="0" i="0">
+                <a:solidFill>
+                  <a:srgbClr val="111111"/>
+                </a:solidFill>
+                <a:latin typeface="Malgun Gothic"/>
+              </a:defRPr>
+            </a:pPr>
+            <a:r>
+              <a:t>•</a:t>
+            </a:r>
+          </a:p>
+        </p:txBody>
+      </p:sp>
+      <p:sp>
+        <p:nvSpPr>
+          <p:cNvPr id="50" name="TextBox 49"/>
+          <p:cNvSpPr txBox="1"/>
+          <p:nvPr/>
+        </p:nvSpPr>
+        <p:spPr>
+          <a:xfrm>
+            <a:off x="6919542" y="3308748"/>
+            <a:ext cx="801679" cy="201168"/>
+          </a:xfrm>
+          <a:prstGeom prst="rect">
+            <a:avLst/>
+          </a:prstGeom>
+          <a:noFill/>
+        </p:spPr>
+        <p:txBody>
+          <a:bodyPr wrap="none" lIns="0" rIns="0" tIns="0" bIns="0" anchor="ctr">
+            <a:spAutoFit/>
+          </a:bodyPr>
+          <a:lstStyle/>
+          <a:p>
+            <a:pPr>
+              <a:defRPr sz="759" b="0" i="0">
+                <a:solidFill>
+                  <a:srgbClr val="C50102"/>
+                </a:solidFill>
+                <a:latin typeface="Arial"/>
+              </a:defRPr>
+            </a:pPr>
+            <a:r>
+              <a:t>starting point</a:t>
+            </a:r>
+          </a:p>
+        </p:txBody>
+      </p:sp>
+      <p:sp>
+        <p:nvSpPr>
+          <p:cNvPr id="51" name="TextBox 50"/>
+          <p:cNvSpPr txBox="1"/>
+          <p:nvPr/>
+        </p:nvSpPr>
+        <p:spPr>
+          <a:xfrm>
+            <a:off x="1562869" y="3418068"/>
+            <a:ext cx="1996909" cy="201168"/>
+          </a:xfrm>
+          <a:prstGeom prst="rect">
+            <a:avLst/>
+          </a:prstGeom>
+          <a:noFill/>
+        </p:spPr>
+        <p:txBody>
+          <a:bodyPr wrap="none" lIns="0" rIns="0" tIns="0" bIns="0" anchor="ctr">
+            <a:spAutoFit/>
+          </a:bodyPr>
+          <a:lstStyle/>
+          <a:p>
+            <a:pPr>
+              <a:defRPr sz="1032" b="1" i="0">
+                <a:solidFill>
+                  <a:srgbClr val="000000"/>
+                </a:solidFill>
+                <a:latin typeface="Arial"/>
+              </a:defRPr>
+            </a:pPr>
+            <a:r>
+              <a:t>LIMIT-BREAKING SIMPLICITY</a:t>
+            </a:r>
+          </a:p>
+        </p:txBody>
+      </p:sp>
+      <p:sp>
+        <p:nvSpPr>
+          <p:cNvPr id="52" name="TextBox 51"/>
+          <p:cNvSpPr txBox="1"/>
+          <p:nvPr/>
+        </p:nvSpPr>
+        <p:spPr>
+          <a:xfrm>
+            <a:off x="1132877" y="3512811"/>
+            <a:ext cx="269655" cy="400839"/>
+          </a:xfrm>
+          <a:prstGeom prst="rect">
+            <a:avLst/>
+          </a:prstGeom>
+          <a:noFill/>
+        </p:spPr>
+        <p:txBody>
+          <a:bodyPr wrap="none" lIns="0" rIns="0" tIns="0" bIns="0" anchor="ctr">
+            <a:spAutoFit/>
+          </a:bodyPr>
+          <a:lstStyle/>
+          <a:p>
+            <a:pPr>
+              <a:defRPr sz="2080" b="0" i="0">
+                <a:solidFill>
+                  <a:srgbClr val="050400"/>
+                </a:solidFill>
+                <a:latin typeface="Arial"/>
+              </a:defRPr>
+            </a:pPr>
+            <a:r>
+              <a:t>3</a:t>
+            </a:r>
+          </a:p>
+        </p:txBody>
+      </p:sp>
+      <p:sp>
+        <p:nvSpPr>
+          <p:cNvPr id="53" name="TextBox 52"/>
+          <p:cNvSpPr txBox="1"/>
+          <p:nvPr/>
+        </p:nvSpPr>
+        <p:spPr>
+          <a:xfrm>
+            <a:off x="5010089" y="3585691"/>
+            <a:ext cx="859982" cy="201168"/>
+          </a:xfrm>
+          <a:prstGeom prst="rect">
+            <a:avLst/>
+          </a:prstGeom>
+          <a:noFill/>
+        </p:spPr>
+        <p:txBody>
+          <a:bodyPr wrap="none" lIns="0" rIns="0" tIns="0" bIns="0" anchor="ctr">
+            <a:spAutoFit/>
+          </a:bodyPr>
+          <a:lstStyle/>
+          <a:p>
+            <a:pPr>
+              <a:defRPr sz="878" b="0" i="0">
+                <a:solidFill>
+                  <a:srgbClr val="000000"/>
+                </a:solidFill>
+                <a:latin typeface="Arial"/>
+              </a:defRPr>
+            </a:pPr>
+            <a:r>
+              <a:t>Tension comes</a:t>
+            </a:r>
+          </a:p>
+        </p:txBody>
+      </p:sp>
+      <p:sp>
+        <p:nvSpPr>
+          <p:cNvPr id="54" name="TextBox 53"/>
+          <p:cNvSpPr txBox="1"/>
+          <p:nvPr/>
+        </p:nvSpPr>
+        <p:spPr>
+          <a:xfrm>
+            <a:off x="6912254" y="3600267"/>
+            <a:ext cx="859982" cy="201168"/>
+          </a:xfrm>
+          <a:prstGeom prst="rect">
+            <a:avLst/>
+          </a:prstGeom>
+          <a:noFill/>
+        </p:spPr>
+        <p:txBody>
+          <a:bodyPr wrap="none" lIns="0" rIns="0" tIns="0" bIns="0" anchor="ctr">
+            <a:spAutoFit/>
+          </a:bodyPr>
+          <a:lstStyle/>
+          <a:p>
+            <a:pPr>
+              <a:defRPr sz="860" b="0" i="0">
+                <a:solidFill>
+                  <a:srgbClr val="BA0001"/>
+                </a:solidFill>
+                <a:latin typeface="Arial"/>
+              </a:defRPr>
+            </a:pPr>
+            <a:r>
+              <a:t>Tension comes</a:t>
+            </a:r>
+          </a:p>
+        </p:txBody>
+      </p:sp>
+      <p:sp>
+        <p:nvSpPr>
+          <p:cNvPr id="55" name="TextBox 54"/>
+          <p:cNvSpPr txBox="1"/>
+          <p:nvPr/>
+        </p:nvSpPr>
+        <p:spPr>
+          <a:xfrm>
+            <a:off x="1229370" y="3643995"/>
+            <a:ext cx="86727" cy="201168"/>
+          </a:xfrm>
+          <a:prstGeom prst="rect">
+            <a:avLst/>
+          </a:prstGeom>
+          <a:noFill/>
+        </p:spPr>
+        <p:txBody>
+          <a:bodyPr wrap="none" lIns="0" rIns="0" tIns="0" bIns="0" anchor="ctr">
+            <a:spAutoFit/>
+          </a:bodyPr>
+          <a:lstStyle/>
+          <a:p>
+            <a:pPr>
+              <a:defRPr sz="700" b="0" i="0">
+                <a:solidFill>
+                  <a:srgbClr val="111111"/>
+                </a:solidFill>
+                <a:latin typeface="Malgun Gothic"/>
+              </a:defRPr>
+            </a:pPr>
+            <a:r>
+              <a:t>•</a:t>
+            </a:r>
+          </a:p>
+        </p:txBody>
+      </p:sp>
+      <p:sp>
+        <p:nvSpPr>
+          <p:cNvPr id="56" name="TextBox 55"/>
+          <p:cNvSpPr txBox="1"/>
+          <p:nvPr/>
+        </p:nvSpPr>
+        <p:spPr>
+          <a:xfrm>
+            <a:off x="1562869" y="3643995"/>
+            <a:ext cx="2470629" cy="201168"/>
+          </a:xfrm>
+          <a:prstGeom prst="rect">
+            <a:avLst/>
+          </a:prstGeom>
+          <a:noFill/>
+        </p:spPr>
+        <p:txBody>
+          <a:bodyPr wrap="none" lIns="0" rIns="0" tIns="0" bIns="0" anchor="ctr">
+            <a:spAutoFit/>
+          </a:bodyPr>
+          <a:lstStyle/>
+          <a:p>
+            <a:pPr>
+              <a:defRPr sz="700" b="0" i="0">
+                <a:solidFill>
+                  <a:srgbClr val="050504"/>
+                </a:solidFill>
+                <a:latin typeface="Arial"/>
+              </a:defRPr>
+            </a:pPr>
+            <a:r>
+              <a:t>His routine is both disciplined and comically extreme:</a:t>
+            </a:r>
+          </a:p>
+        </p:txBody>
+      </p:sp>
+      <p:sp>
+        <p:nvSpPr>
+          <p:cNvPr id="57" name="TextBox 56"/>
+          <p:cNvSpPr txBox="1"/>
+          <p:nvPr/>
+        </p:nvSpPr>
+        <p:spPr>
+          <a:xfrm>
+            <a:off x="6525991" y="3753315"/>
+            <a:ext cx="127539" cy="201168"/>
+          </a:xfrm>
+          <a:prstGeom prst="rect">
+            <a:avLst/>
+          </a:prstGeom>
+          <a:noFill/>
+        </p:spPr>
+        <p:txBody>
+          <a:bodyPr wrap="none" lIns="0" rIns="0" tIns="0" bIns="0" anchor="ctr">
+            <a:spAutoFit/>
+          </a:bodyPr>
+          <a:lstStyle/>
+          <a:p>
+            <a:pPr>
               <a:defRPr sz="984" b="0" i="0">
                 <a:solidFill>
                   <a:srgbClr val="111111"/>
@@ -5928,6 +4992,942 @@
             </a:pPr>
             <a:r>
               <a:t>•</a:t>
+            </a:r>
+          </a:p>
+        </p:txBody>
+      </p:sp>
+      <p:sp>
+        <p:nvSpPr>
+          <p:cNvPr id="58" name="TextBox 57"/>
+          <p:cNvSpPr txBox="1"/>
+          <p:nvPr/>
+        </p:nvSpPr>
+        <p:spPr>
+          <a:xfrm>
+            <a:off x="6904966" y="3753315"/>
+            <a:ext cx="823543" cy="201168"/>
+          </a:xfrm>
+          <a:prstGeom prst="rect">
+            <a:avLst/>
+          </a:prstGeom>
+          <a:noFill/>
+        </p:spPr>
+        <p:txBody>
+          <a:bodyPr wrap="none" lIns="0" rIns="0" tIns="0" bIns="0" anchor="ctr">
+            <a:spAutoFit/>
+          </a:bodyPr>
+          <a:lstStyle/>
+          <a:p>
+            <a:pPr>
+              <a:defRPr sz="914" b="0" i="0">
+                <a:solidFill>
+                  <a:srgbClr val="BA0000"/>
+                </a:solidFill>
+                <a:latin typeface="Arial"/>
+              </a:defRPr>
+            </a:pPr>
+            <a:r>
+              <a:t>from meaning</a:t>
+            </a:r>
+          </a:p>
+        </p:txBody>
+      </p:sp>
+      <p:sp>
+        <p:nvSpPr>
+          <p:cNvPr id="59" name="TextBox 58"/>
+          <p:cNvSpPr txBox="1"/>
+          <p:nvPr/>
+        </p:nvSpPr>
+        <p:spPr>
+          <a:xfrm>
+            <a:off x="4515380" y="3760603"/>
+            <a:ext cx="107133" cy="201168"/>
+          </a:xfrm>
+          <a:prstGeom prst="rect">
+            <a:avLst/>
+          </a:prstGeom>
+          <a:noFill/>
+        </p:spPr>
+        <p:txBody>
+          <a:bodyPr wrap="none" lIns="0" rIns="0" tIns="0" bIns="0" anchor="ctr">
+            <a:spAutoFit/>
+          </a:bodyPr>
+          <a:lstStyle/>
+          <a:p>
+            <a:pPr>
+              <a:defRPr sz="826" b="0" i="0">
+                <a:solidFill>
+                  <a:srgbClr val="111111"/>
+                </a:solidFill>
+                <a:latin typeface="Malgun Gothic"/>
+              </a:defRPr>
+            </a:pPr>
+            <a:r>
+              <a:t>•</a:t>
+            </a:r>
+          </a:p>
+        </p:txBody>
+      </p:sp>
+      <p:sp>
+        <p:nvSpPr>
+          <p:cNvPr id="60" name="TextBox 59"/>
+          <p:cNvSpPr txBox="1"/>
+          <p:nvPr/>
+        </p:nvSpPr>
+        <p:spPr>
+          <a:xfrm>
+            <a:off x="5017377" y="3760603"/>
+            <a:ext cx="655919" cy="201168"/>
+          </a:xfrm>
+          <a:prstGeom prst="rect">
+            <a:avLst/>
+          </a:prstGeom>
+          <a:noFill/>
+        </p:spPr>
+        <p:txBody>
+          <a:bodyPr wrap="none" lIns="0" rIns="0" tIns="0" bIns="0" anchor="ctr">
+            <a:spAutoFit/>
+          </a:bodyPr>
+          <a:lstStyle/>
+          <a:p>
+            <a:pPr>
+              <a:defRPr sz="797" b="0" i="0">
+                <a:solidFill>
+                  <a:srgbClr val="000001"/>
+                </a:solidFill>
+                <a:latin typeface="Arial"/>
+              </a:defRPr>
+            </a:pPr>
+            <a:r>
+              <a:t>from battle</a:t>
+            </a:r>
+          </a:p>
+        </p:txBody>
+      </p:sp>
+      <p:sp>
+        <p:nvSpPr>
+          <p:cNvPr id="61" name="TextBox 60"/>
+          <p:cNvSpPr txBox="1"/>
+          <p:nvPr/>
+        </p:nvSpPr>
+        <p:spPr>
+          <a:xfrm>
+            <a:off x="1555581" y="3775179"/>
+            <a:ext cx="2011485" cy="201168"/>
+          </a:xfrm>
+          <a:prstGeom prst="rect">
+            <a:avLst/>
+          </a:prstGeom>
+          <a:noFill/>
+        </p:spPr>
+        <p:txBody>
+          <a:bodyPr wrap="none" lIns="0" rIns="0" tIns="0" bIns="0" anchor="ctr">
+            <a:spAutoFit/>
+          </a:bodyPr>
+          <a:lstStyle/>
+          <a:p>
+            <a:pPr>
+              <a:defRPr sz="720" b="0" i="0">
+                <a:solidFill>
+                  <a:srgbClr val="010101"/>
+                </a:solidFill>
+                <a:latin typeface="Arial"/>
+              </a:defRPr>
+            </a:pPr>
+            <a:r>
+              <a:t>100 push-ups, 100 sit-ups, 100 squats,</a:t>
+            </a:r>
+          </a:p>
+        </p:txBody>
+      </p:sp>
+      <p:sp>
+        <p:nvSpPr>
+          <p:cNvPr id="62" name="TextBox 61"/>
+          <p:cNvSpPr txBox="1"/>
+          <p:nvPr/>
+        </p:nvSpPr>
+        <p:spPr>
+          <a:xfrm>
+            <a:off x="1562869" y="3942803"/>
+            <a:ext cx="1399294" cy="201168"/>
+          </a:xfrm>
+          <a:prstGeom prst="rect">
+            <a:avLst/>
+          </a:prstGeom>
+          <a:noFill/>
+        </p:spPr>
+        <p:txBody>
+          <a:bodyPr wrap="none" lIns="0" rIns="0" tIns="0" bIns="0" anchor="ctr">
+            <a:spAutoFit/>
+          </a:bodyPr>
+          <a:lstStyle/>
+          <a:p>
+            <a:pPr>
+              <a:defRPr sz="765" b="0" i="0">
+                <a:solidFill>
+                  <a:srgbClr val="020201"/>
+                </a:solidFill>
+                <a:latin typeface="Arial"/>
+              </a:defRPr>
+            </a:pPr>
+            <a:r>
+              <a:t>and a 10 km run every day.</a:t>
+            </a:r>
+          </a:p>
+        </p:txBody>
+      </p:sp>
+      <p:sp>
+        <p:nvSpPr>
+          <p:cNvPr id="63" name="TextBox 62"/>
+          <p:cNvSpPr txBox="1"/>
+          <p:nvPr/>
+        </p:nvSpPr>
+        <p:spPr>
+          <a:xfrm>
+            <a:off x="4303153" y="4117715"/>
+            <a:ext cx="1639798" cy="218639"/>
+          </a:xfrm>
+          <a:prstGeom prst="rect">
+            <a:avLst/>
+          </a:prstGeom>
+          <a:noFill/>
+        </p:spPr>
+        <p:txBody>
+          <a:bodyPr wrap="none" lIns="0" rIns="0" tIns="0" bIns="0" anchor="ctr">
+            <a:spAutoFit/>
+          </a:bodyPr>
+          <a:lstStyle/>
+          <a:p>
+            <a:pPr>
+              <a:defRPr sz="1160" b="1" i="0">
+                <a:solidFill>
+                  <a:srgbClr val="F7F7F7"/>
+                </a:solidFill>
+                <a:latin typeface="Arial"/>
+              </a:defRPr>
+            </a:pPr>
+            <a:r>
+              <a:t>C) NARRATIVE IMPACT</a:t>
+            </a:r>
+          </a:p>
+        </p:txBody>
+      </p:sp>
+      <p:sp>
+        <p:nvSpPr>
+          <p:cNvPr id="64" name="TextBox 63"/>
+          <p:cNvSpPr txBox="1"/>
+          <p:nvPr/>
+        </p:nvSpPr>
+        <p:spPr>
+          <a:xfrm>
+            <a:off x="1577445" y="4263475"/>
+            <a:ext cx="1792845" cy="201168"/>
+          </a:xfrm>
+          <a:prstGeom prst="rect">
+            <a:avLst/>
+          </a:prstGeom>
+          <a:noFill/>
+        </p:spPr>
+        <p:txBody>
+          <a:bodyPr wrap="none" lIns="0" rIns="0" tIns="0" bIns="0" anchor="ctr">
+            <a:spAutoFit/>
+          </a:bodyPr>
+          <a:lstStyle/>
+          <a:p>
+            <a:pPr>
+              <a:defRPr sz="903" b="1" i="0">
+                <a:solidFill>
+                  <a:srgbClr val="010101"/>
+                </a:solidFill>
+                <a:latin typeface="Arial"/>
+              </a:defRPr>
+            </a:pPr>
+            <a:r>
+              <a:t>EMOTIONALLY UNSHAKEN</a:t>
+            </a:r>
+          </a:p>
+        </p:txBody>
+      </p:sp>
+      <p:sp>
+        <p:nvSpPr>
+          <p:cNvPr id="65" name="TextBox 64"/>
+          <p:cNvSpPr txBox="1"/>
+          <p:nvPr/>
+        </p:nvSpPr>
+        <p:spPr>
+          <a:xfrm>
+            <a:off x="1103725" y="4299914"/>
+            <a:ext cx="327959" cy="466431"/>
+          </a:xfrm>
+          <a:prstGeom prst="rect">
+            <a:avLst/>
+          </a:prstGeom>
+          <a:noFill/>
+        </p:spPr>
+        <p:txBody>
+          <a:bodyPr wrap="none" lIns="0" rIns="0" tIns="0" bIns="0" anchor="ctr">
+            <a:spAutoFit/>
+          </a:bodyPr>
+          <a:lstStyle/>
+          <a:p>
+            <a:pPr>
+              <a:defRPr sz="2530" b="0" i="0">
+                <a:solidFill>
+                  <a:srgbClr val="040300"/>
+                </a:solidFill>
+                <a:latin typeface="Arial"/>
+              </a:defRPr>
+            </a:pPr>
+            <a:r>
+              <a:t>4</a:t>
+            </a:r>
+          </a:p>
+        </p:txBody>
+      </p:sp>
+      <p:sp>
+        <p:nvSpPr>
+          <p:cNvPr id="66" name="TextBox 65"/>
+          <p:cNvSpPr txBox="1"/>
+          <p:nvPr/>
+        </p:nvSpPr>
+        <p:spPr>
+          <a:xfrm>
+            <a:off x="1555581" y="4445674"/>
+            <a:ext cx="2062501" cy="201168"/>
+          </a:xfrm>
+          <a:prstGeom prst="rect">
+            <a:avLst/>
+          </a:prstGeom>
+          <a:noFill/>
+        </p:spPr>
+        <p:txBody>
+          <a:bodyPr wrap="none" lIns="0" rIns="0" tIns="0" bIns="0" anchor="ctr">
+            <a:spAutoFit/>
+          </a:bodyPr>
+          <a:lstStyle/>
+          <a:p>
+            <a:pPr>
+              <a:defRPr sz="700" b="0" i="0">
+                <a:solidFill>
+                  <a:srgbClr val="030303"/>
+                </a:solidFill>
+                <a:latin typeface="Arial"/>
+              </a:defRPr>
+            </a:pPr>
+            <a:r>
+              <a:t>He fights without fear, ego, or hesitation.</a:t>
+            </a:r>
+          </a:p>
+        </p:txBody>
+      </p:sp>
+      <p:sp>
+        <p:nvSpPr>
+          <p:cNvPr id="67" name="TextBox 66"/>
+          <p:cNvSpPr txBox="1"/>
+          <p:nvPr/>
+        </p:nvSpPr>
+        <p:spPr>
+          <a:xfrm>
+            <a:off x="5272456" y="4496690"/>
+            <a:ext cx="1158790" cy="201168"/>
+          </a:xfrm>
+          <a:prstGeom prst="rect">
+            <a:avLst/>
+          </a:prstGeom>
+          <a:noFill/>
+        </p:spPr>
+        <p:txBody>
+          <a:bodyPr wrap="none" lIns="0" rIns="0" tIns="0" bIns="0" anchor="ctr">
+            <a:spAutoFit/>
+          </a:bodyPr>
+          <a:lstStyle/>
+          <a:p>
+            <a:pPr>
+              <a:defRPr sz="1162" b="1" i="0">
+                <a:solidFill>
+                  <a:srgbClr val="020200"/>
+                </a:solidFill>
+                <a:latin typeface="Arial"/>
+              </a:defRPr>
+            </a:pPr>
+            <a:r>
+              <a:t>WHY IT WORKS</a:t>
+            </a:r>
+          </a:p>
+        </p:txBody>
+      </p:sp>
+      <p:sp>
+        <p:nvSpPr>
+          <p:cNvPr id="68" name="TextBox 67"/>
+          <p:cNvSpPr txBox="1"/>
+          <p:nvPr/>
+        </p:nvSpPr>
+        <p:spPr>
+          <a:xfrm>
+            <a:off x="1548293" y="4598722"/>
+            <a:ext cx="2033349" cy="201168"/>
+          </a:xfrm>
+          <a:prstGeom prst="rect">
+            <a:avLst/>
+          </a:prstGeom>
+          <a:noFill/>
+        </p:spPr>
+        <p:txBody>
+          <a:bodyPr wrap="none" lIns="0" rIns="0" tIns="0" bIns="0" anchor="ctr">
+            <a:spAutoFit/>
+          </a:bodyPr>
+          <a:lstStyle/>
+          <a:p>
+            <a:pPr>
+              <a:defRPr sz="748" b="0" i="0">
+                <a:solidFill>
+                  <a:srgbClr val="030303"/>
+                </a:solidFill>
+                <a:latin typeface="Arial"/>
+              </a:defRPr>
+            </a:pPr>
+            <a:r>
+              <a:t>No need to prove himself—he's already</a:t>
+            </a:r>
+          </a:p>
+        </p:txBody>
+      </p:sp>
+      <p:sp>
+        <p:nvSpPr>
+          <p:cNvPr id="69" name="TextBox 68"/>
+          <p:cNvSpPr txBox="1"/>
+          <p:nvPr/>
+        </p:nvSpPr>
+        <p:spPr>
+          <a:xfrm>
+            <a:off x="5272456" y="4722618"/>
+            <a:ext cx="2579948" cy="201168"/>
+          </a:xfrm>
+          <a:prstGeom prst="rect">
+            <a:avLst/>
+          </a:prstGeom>
+          <a:noFill/>
+        </p:spPr>
+        <p:txBody>
+          <a:bodyPr wrap="none" lIns="0" rIns="0" tIns="0" bIns="0" anchor="ctr">
+            <a:spAutoFit/>
+          </a:bodyPr>
+          <a:lstStyle/>
+          <a:p>
+            <a:pPr>
+              <a:defRPr sz="759" b="0" i="0">
+                <a:solidFill>
+                  <a:srgbClr val="020100"/>
+                </a:solidFill>
+                <a:latin typeface="Arial"/>
+              </a:defRPr>
+            </a:pPr>
+            <a:r>
+              <a:t>Saitama is not just strong in a physical sense.</a:t>
+            </a:r>
+          </a:p>
+        </p:txBody>
+      </p:sp>
+      <p:sp>
+        <p:nvSpPr>
+          <p:cNvPr id="70" name="TextBox 69"/>
+          <p:cNvSpPr txBox="1"/>
+          <p:nvPr/>
+        </p:nvSpPr>
+        <p:spPr>
+          <a:xfrm>
+            <a:off x="1562869" y="4766346"/>
+            <a:ext cx="1610646" cy="201168"/>
+          </a:xfrm>
+          <a:prstGeom prst="rect">
+            <a:avLst/>
+          </a:prstGeom>
+          <a:noFill/>
+        </p:spPr>
+        <p:txBody>
+          <a:bodyPr wrap="none" lIns="0" rIns="0" tIns="0" bIns="0" anchor="ctr">
+            <a:spAutoFit/>
+          </a:bodyPr>
+          <a:lstStyle/>
+          <a:p>
+            <a:pPr>
+              <a:defRPr sz="706" b="0" i="0">
+                <a:solidFill>
+                  <a:srgbClr val="040303"/>
+                </a:solidFill>
+                <a:latin typeface="Arial"/>
+              </a:defRPr>
+            </a:pPr>
+            <a:r>
+              <a:t>beyond the need for validation.</a:t>
+            </a:r>
+          </a:p>
+        </p:txBody>
+      </p:sp>
+      <p:sp>
+        <p:nvSpPr>
+          <p:cNvPr id="71" name="TextBox 70"/>
+          <p:cNvSpPr txBox="1"/>
+          <p:nvPr/>
+        </p:nvSpPr>
+        <p:spPr>
+          <a:xfrm>
+            <a:off x="5279744" y="4912106"/>
+            <a:ext cx="2485205" cy="201168"/>
+          </a:xfrm>
+          <a:prstGeom prst="rect">
+            <a:avLst/>
+          </a:prstGeom>
+          <a:noFill/>
+        </p:spPr>
+        <p:txBody>
+          <a:bodyPr wrap="none" lIns="0" rIns="0" tIns="0" bIns="0" anchor="ctr">
+            <a:spAutoFit/>
+          </a:bodyPr>
+          <a:lstStyle/>
+          <a:p>
+            <a:pPr>
+              <a:defRPr sz="817" b="0" i="0">
+                <a:solidFill>
+                  <a:srgbClr val="000000"/>
+                </a:solidFill>
+                <a:latin typeface="Arial"/>
+              </a:defRPr>
+            </a:pPr>
+            <a:r>
+              <a:t>He works because his power flips the usual</a:t>
+            </a:r>
+          </a:p>
+        </p:txBody>
+      </p:sp>
+      <p:sp>
+        <p:nvSpPr>
+          <p:cNvPr id="72" name="TextBox 71"/>
+          <p:cNvSpPr txBox="1"/>
+          <p:nvPr/>
+        </p:nvSpPr>
+        <p:spPr>
+          <a:xfrm>
+            <a:off x="9200684" y="4955834"/>
+            <a:ext cx="2820452" cy="1836573"/>
+          </a:xfrm>
+          <a:prstGeom prst="rect">
+            <a:avLst/>
+          </a:prstGeom>
+          <a:noFill/>
+        </p:spPr>
+        <p:txBody>
+          <a:bodyPr wrap="none" lIns="0" rIns="0" tIns="0" bIns="0" anchor="ctr">
+            <a:spAutoFit/>
+          </a:bodyPr>
+          <a:lstStyle/>
+          <a:p>
+            <a:pPr>
+              <a:defRPr sz="3400" b="1" i="0">
+                <a:solidFill>
+                  <a:srgbClr val="FEFEFE"/>
+                </a:solidFill>
+                <a:latin typeface="Arial"/>
+              </a:defRPr>
+            </a:pPr>
+            <a:r>
+              <a:t>BAM</a:t>
+            </a:r>
+          </a:p>
+        </p:txBody>
+      </p:sp>
+      <p:sp>
+        <p:nvSpPr>
+          <p:cNvPr id="73" name="TextBox 72"/>
+          <p:cNvSpPr txBox="1"/>
+          <p:nvPr/>
+        </p:nvSpPr>
+        <p:spPr>
+          <a:xfrm>
+            <a:off x="1570157" y="5094306"/>
+            <a:ext cx="2434189" cy="201168"/>
+          </a:xfrm>
+          <a:prstGeom prst="rect">
+            <a:avLst/>
+          </a:prstGeom>
+          <a:noFill/>
+        </p:spPr>
+        <p:txBody>
+          <a:bodyPr wrap="none" lIns="0" rIns="0" tIns="0" bIns="0" anchor="ctr">
+            <a:spAutoFit/>
+          </a:bodyPr>
+          <a:lstStyle/>
+          <a:p>
+            <a:pPr>
+              <a:defRPr sz="980" b="1" i="0">
+                <a:solidFill>
+                  <a:srgbClr val="000000"/>
+                </a:solidFill>
+                <a:latin typeface="Arial"/>
+              </a:defRPr>
+            </a:pPr>
+            <a:r>
+              <a:t>THE STORY NEEDS AN UNBEATABLE HERO</a:t>
+            </a:r>
+          </a:p>
+        </p:txBody>
+      </p:sp>
+      <p:sp>
+        <p:nvSpPr>
+          <p:cNvPr id="74" name="TextBox 73"/>
+          <p:cNvSpPr txBox="1"/>
+          <p:nvPr/>
+        </p:nvSpPr>
+        <p:spPr>
+          <a:xfrm>
+            <a:off x="5279744" y="5101594"/>
+            <a:ext cx="2295717" cy="201168"/>
+          </a:xfrm>
+          <a:prstGeom prst="rect">
+            <a:avLst/>
+          </a:prstGeom>
+          <a:noFill/>
+        </p:spPr>
+        <p:txBody>
+          <a:bodyPr wrap="none" lIns="0" rIns="0" tIns="0" bIns="0" anchor="ctr">
+            <a:spAutoFit/>
+          </a:bodyPr>
+          <a:lstStyle/>
+          <a:p>
+            <a:pPr>
+              <a:defRPr sz="799" b="0" i="0">
+                <a:solidFill>
+                  <a:srgbClr val="020000"/>
+                </a:solidFill>
+                <a:latin typeface="Arial"/>
+              </a:defRPr>
+            </a:pPr>
+            <a:r>
+              <a:t>battle-anime formula and turns the real</a:t>
+            </a:r>
+          </a:p>
+        </p:txBody>
+      </p:sp>
+      <p:sp>
+        <p:nvSpPr>
+          <p:cNvPr id="75" name="TextBox 74"/>
+          <p:cNvSpPr txBox="1"/>
+          <p:nvPr/>
+        </p:nvSpPr>
+        <p:spPr>
+          <a:xfrm>
+            <a:off x="1111013" y="5145321"/>
+            <a:ext cx="298807" cy="429991"/>
+          </a:xfrm>
+          <a:prstGeom prst="rect">
+            <a:avLst/>
+          </a:prstGeom>
+          <a:noFill/>
+        </p:spPr>
+        <p:txBody>
+          <a:bodyPr wrap="none" lIns="0" rIns="0" tIns="0" bIns="0" anchor="ctr">
+            <a:spAutoFit/>
+          </a:bodyPr>
+          <a:lstStyle/>
+          <a:p>
+            <a:pPr>
+              <a:defRPr sz="2305" b="0" i="0">
+                <a:solidFill>
+                  <a:srgbClr val="040300"/>
+                </a:solidFill>
+                <a:latin typeface="Arial"/>
+              </a:defRPr>
+            </a:pPr>
+            <a:r>
+              <a:t>5</a:t>
+            </a:r>
+          </a:p>
+        </p:txBody>
+      </p:sp>
+      <p:sp>
+        <p:nvSpPr>
+          <p:cNvPr id="76" name="TextBox 75"/>
+          <p:cNvSpPr txBox="1"/>
+          <p:nvPr/>
+        </p:nvSpPr>
+        <p:spPr>
+          <a:xfrm>
+            <a:off x="5272456" y="5276505"/>
+            <a:ext cx="2244701" cy="201168"/>
+          </a:xfrm>
+          <a:prstGeom prst="rect">
+            <a:avLst/>
+          </a:prstGeom>
+          <a:noFill/>
+        </p:spPr>
+        <p:txBody>
+          <a:bodyPr wrap="none" lIns="0" rIns="0" tIns="0" bIns="0" anchor="ctr">
+            <a:spAutoFit/>
+          </a:bodyPr>
+          <a:lstStyle/>
+          <a:p>
+            <a:pPr>
+              <a:defRPr sz="855" b="0" i="0">
+                <a:solidFill>
+                  <a:srgbClr val="010000"/>
+                </a:solidFill>
+                <a:latin typeface="Arial"/>
+              </a:defRPr>
+            </a:pPr>
+            <a:r>
+              <a:t>conflict inward:: purpose, boredom,</a:t>
+            </a:r>
+          </a:p>
+        </p:txBody>
+      </p:sp>
+      <p:sp>
+        <p:nvSpPr>
+          <p:cNvPr id="77" name="TextBox 76"/>
+          <p:cNvSpPr txBox="1"/>
+          <p:nvPr/>
+        </p:nvSpPr>
+        <p:spPr>
+          <a:xfrm>
+            <a:off x="1562869" y="5291081"/>
+            <a:ext cx="2222837" cy="201168"/>
+          </a:xfrm>
+          <a:prstGeom prst="rect">
+            <a:avLst/>
+          </a:prstGeom>
+          <a:noFill/>
+        </p:spPr>
+        <p:txBody>
+          <a:bodyPr wrap="none" lIns="0" rIns="0" tIns="0" bIns="0" anchor="ctr">
+            <a:spAutoFit/>
+          </a:bodyPr>
+          <a:lstStyle/>
+          <a:p>
+            <a:pPr>
+              <a:defRPr sz="713" b="0" i="0">
+                <a:solidFill>
+                  <a:srgbClr val="020102"/>
+                </a:solidFill>
+                <a:latin typeface="Arial"/>
+              </a:defRPr>
+            </a:pPr>
+            <a:r>
+              <a:t>His power lets the series go beyond battles</a:t>
+            </a:r>
+          </a:p>
+        </p:txBody>
+      </p:sp>
+      <p:sp>
+        <p:nvSpPr>
+          <p:cNvPr id="78" name="TextBox 77"/>
+          <p:cNvSpPr txBox="1"/>
+          <p:nvPr/>
+        </p:nvSpPr>
+        <p:spPr>
+          <a:xfrm>
+            <a:off x="1548293" y="5444129"/>
+            <a:ext cx="2244701" cy="201168"/>
+          </a:xfrm>
+          <a:prstGeom prst="rect">
+            <a:avLst/>
+          </a:prstGeom>
+          <a:noFill/>
+        </p:spPr>
+        <p:txBody>
+          <a:bodyPr wrap="none" lIns="0" rIns="0" tIns="0" bIns="0" anchor="ctr">
+            <a:spAutoFit/>
+          </a:bodyPr>
+          <a:lstStyle/>
+          <a:p>
+            <a:pPr>
+              <a:defRPr sz="741" b="0" i="0">
+                <a:solidFill>
+                  <a:srgbClr val="010101"/>
+                </a:solidFill>
+                <a:latin typeface="Arial"/>
+              </a:defRPr>
+            </a:pPr>
+            <a:r>
+              <a:t>to explore boredom, meaning, and identity</a:t>
+            </a:r>
+          </a:p>
+        </p:txBody>
+      </p:sp>
+      <p:sp>
+        <p:nvSpPr>
+          <p:cNvPr id="79" name="TextBox 78"/>
+          <p:cNvSpPr txBox="1"/>
+          <p:nvPr/>
+        </p:nvSpPr>
+        <p:spPr>
+          <a:xfrm>
+            <a:off x="5265168" y="5451417"/>
+            <a:ext cx="1843861" cy="201168"/>
+          </a:xfrm>
+          <a:prstGeom prst="rect">
+            <a:avLst/>
+          </a:prstGeom>
+          <a:noFill/>
+        </p:spPr>
+        <p:txBody>
+          <a:bodyPr wrap="none" lIns="0" rIns="0" tIns="0" bIns="0" anchor="ctr">
+            <a:spAutoFit/>
+          </a:bodyPr>
+          <a:lstStyle/>
+          <a:p>
+            <a:pPr>
+              <a:defRPr sz="867" b="0" i="0">
+                <a:solidFill>
+                  <a:srgbClr val="000000"/>
+                </a:solidFill>
+                <a:latin typeface="Arial"/>
+              </a:defRPr>
+            </a:pPr>
+            <a:r>
+              <a:t>and the search for challenge.</a:t>
+            </a:r>
+          </a:p>
+        </p:txBody>
+      </p:sp>
+      <p:sp>
+        <p:nvSpPr>
+          <p:cNvPr id="80" name="TextBox 79"/>
+          <p:cNvSpPr txBox="1"/>
+          <p:nvPr/>
+        </p:nvSpPr>
+        <p:spPr>
+          <a:xfrm>
+            <a:off x="1562869" y="5589889"/>
+            <a:ext cx="1173366" cy="201168"/>
+          </a:xfrm>
+          <a:prstGeom prst="rect">
+            <a:avLst/>
+          </a:prstGeom>
+          <a:noFill/>
+        </p:spPr>
+        <p:txBody>
+          <a:bodyPr wrap="none" lIns="0" rIns="0" tIns="0" bIns="0" anchor="ctr">
+            <a:spAutoFit/>
+          </a:bodyPr>
+          <a:lstStyle/>
+          <a:p>
+            <a:pPr>
+              <a:defRPr sz="700" b="0" i="0">
+                <a:solidFill>
+                  <a:srgbClr val="020202"/>
+                </a:solidFill>
+                <a:latin typeface="Arial"/>
+              </a:defRPr>
+            </a:pPr>
+            <a:r>
+              <a:t>after absolute victory.</a:t>
+            </a:r>
+          </a:p>
+        </p:txBody>
+      </p:sp>
+      <p:sp>
+        <p:nvSpPr>
+          <p:cNvPr id="81" name="TextBox 80"/>
+          <p:cNvSpPr txBox="1"/>
+          <p:nvPr/>
+        </p:nvSpPr>
+        <p:spPr>
+          <a:xfrm>
+            <a:off x="3384867" y="6070896"/>
+            <a:ext cx="4197883" cy="218639"/>
+          </a:xfrm>
+          <a:prstGeom prst="rect">
+            <a:avLst/>
+          </a:prstGeom>
+          <a:noFill/>
+        </p:spPr>
+        <p:txBody>
+          <a:bodyPr wrap="none" lIns="0" rIns="0" tIns="0" bIns="0" anchor="ctr">
+            <a:spAutoFit/>
+          </a:bodyPr>
+          <a:lstStyle/>
+          <a:p>
+            <a:pPr>
+              <a:defRPr sz="1208" b="0" i="0">
+                <a:solidFill>
+                  <a:srgbClr val="020202"/>
+                </a:solidFill>
+                <a:latin typeface="Arial"/>
+              </a:defRPr>
+            </a:pPr>
+            <a:r>
+              <a:t>One Punch Man is powerful as a character because</a:t>
+            </a:r>
+          </a:p>
+        </p:txBody>
+      </p:sp>
+      <p:sp>
+        <p:nvSpPr>
+          <p:cNvPr id="82" name="TextBox 81"/>
+          <p:cNvSpPr txBox="1"/>
+          <p:nvPr/>
+        </p:nvSpPr>
+        <p:spPr>
+          <a:xfrm>
+            <a:off x="1285925" y="6136488"/>
+            <a:ext cx="1596070" cy="357111"/>
+          </a:xfrm>
+          <a:prstGeom prst="rect">
+            <a:avLst/>
+          </a:prstGeom>
+          <a:noFill/>
+        </p:spPr>
+        <p:txBody>
+          <a:bodyPr wrap="none" lIns="0" rIns="0" tIns="0" bIns="0" anchor="ctr">
+            <a:spAutoFit/>
+          </a:bodyPr>
+          <a:lstStyle/>
+          <a:p>
+            <a:pPr>
+              <a:defRPr sz="2242" b="1" i="0">
+                <a:solidFill>
+                  <a:srgbClr val="FFFFFF"/>
+                </a:solidFill>
+                <a:latin typeface="Impact"/>
+              </a:defRPr>
+            </a:pPr>
+            <a:r>
+              <a:t>D) KEY TAKEAWAY</a:t>
+            </a:r>
+          </a:p>
+        </p:txBody>
+      </p:sp>
+      <p:sp>
+        <p:nvSpPr>
+          <p:cNvPr id="83" name="TextBox 82"/>
+          <p:cNvSpPr txBox="1"/>
+          <p:nvPr/>
+        </p:nvSpPr>
+        <p:spPr>
+          <a:xfrm>
+            <a:off x="3370291" y="6318688"/>
+            <a:ext cx="4256187" cy="240503"/>
+          </a:xfrm>
+          <a:prstGeom prst="rect">
+            <a:avLst/>
+          </a:prstGeom>
+          <a:noFill/>
+        </p:spPr>
+        <p:txBody>
+          <a:bodyPr wrap="none" lIns="0" rIns="0" tIns="0" bIns="0" anchor="ctr">
+            <a:spAutoFit/>
+          </a:bodyPr>
+          <a:lstStyle/>
+          <a:p>
+            <a:pPr>
+              <a:defRPr sz="1089" b="0" i="0">
+                <a:solidFill>
+                  <a:srgbClr val="020202"/>
+                </a:solidFill>
+                <a:latin typeface="Arial"/>
+              </a:defRPr>
+            </a:pPr>
+            <a:r>
+              <a:t>his strength is both a joke and a storytelling device.</a:t>
             </a:r>
           </a:p>
         </p:txBody>

</xml_diff>

<commit_message>
Preserve numbered badge backgrounds
</commit_message>
<xml_diff>
--- a/docs/examples/one-pun-editable.pptx
+++ b/docs/examples/one-pun-editable.pptx
@@ -3096,19 +3096,17 @@
         </p:nvSpPr>
         <p:spPr>
           <a:xfrm>
-            <a:off x="7349534" y="3979243"/>
-            <a:ext cx="736087" cy="58303"/>
+            <a:off x="1090242" y="2611287"/>
+            <a:ext cx="364399" cy="561175"/>
           </a:xfrm>
           <a:prstGeom prst="rect">
             <a:avLst/>
           </a:prstGeom>
           <a:solidFill>
-            <a:srgbClr val="FDFDFD"/>
+            <a:srgbClr val="FDC304"/>
           </a:solidFill>
-          <a:ln w="15875">
-            <a:solidFill>
-              <a:srgbClr val="ACADAD"/>
-            </a:solidFill>
+          <a:ln>
+            <a:noFill/>
           </a:ln>
         </p:spPr>
         <p:style>
@@ -3141,19 +3139,17 @@
         </p:nvSpPr>
         <p:spPr>
           <a:xfrm>
-            <a:off x="8355277" y="5932425"/>
-            <a:ext cx="313383" cy="240503"/>
+            <a:off x="1086598" y="3430821"/>
+            <a:ext cx="364399" cy="561175"/>
           </a:xfrm>
           <a:prstGeom prst="rect">
             <a:avLst/>
           </a:prstGeom>
           <a:solidFill>
-            <a:srgbClr val="FEFEFE"/>
+            <a:srgbClr val="FDC203"/>
           </a:solidFill>
-          <a:ln w="15875">
-            <a:solidFill>
-              <a:srgbClr val="252625"/>
-            </a:solidFill>
+          <a:ln>
+            <a:noFill/>
           </a:ln>
         </p:spPr>
         <p:style>
@@ -3178,358 +3174,22 @@
           </a:p>
         </p:txBody>
       </p:sp>
-      <p:pic>
-        <p:nvPicPr>
-          <p:cNvPr id="4" name="Picture 3" descr="image.png"/>
-          <p:cNvPicPr>
-            <a:picLocks noChangeAspect="1"/>
-          </p:cNvPicPr>
-          <p:nvPr/>
-        </p:nvPicPr>
-        <p:blipFill>
-          <a:blip r:embed="rId2"/>
-          <a:stretch>
-            <a:fillRect/>
-          </a:stretch>
-        </p:blipFill>
-        <p:spPr>
-          <a:xfrm>
-            <a:off x="229166" y="1297262"/>
-            <a:ext cx="2368597" cy="393551"/>
-          </a:xfrm>
-          <a:prstGeom prst="rect">
-            <a:avLst/>
-          </a:prstGeom>
-        </p:spPr>
-      </p:pic>
-      <p:pic>
-        <p:nvPicPr>
-          <p:cNvPr id="5" name="Picture 4" descr="image.png"/>
-          <p:cNvPicPr>
-            <a:picLocks noChangeAspect="1"/>
-          </p:cNvPicPr>
-          <p:nvPr/>
-        </p:nvPicPr>
-        <p:blipFill>
-          <a:blip r:embed="rId3"/>
-          <a:stretch>
-            <a:fillRect/>
-          </a:stretch>
-        </p:blipFill>
-        <p:spPr>
-          <a:xfrm>
-            <a:off x="4237562" y="1355566"/>
-            <a:ext cx="3833483" cy="276943"/>
-          </a:xfrm>
-          <a:prstGeom prst="rect">
-            <a:avLst/>
-          </a:prstGeom>
-        </p:spPr>
-      </p:pic>
-      <p:pic>
-        <p:nvPicPr>
-          <p:cNvPr id="6" name="Picture 5" descr="image.png"/>
-          <p:cNvPicPr>
-            <a:picLocks noChangeAspect="1"/>
-          </p:cNvPicPr>
-          <p:nvPr/>
-        </p:nvPicPr>
-        <p:blipFill>
-          <a:blip r:embed="rId4"/>
-          <a:stretch>
-            <a:fillRect/>
-          </a:stretch>
-        </p:blipFill>
-        <p:spPr>
-          <a:xfrm>
-            <a:off x="1089149" y="1785557"/>
-            <a:ext cx="364399" cy="568463"/>
-          </a:xfrm>
-          <a:prstGeom prst="rect">
-            <a:avLst/>
-          </a:prstGeom>
-        </p:spPr>
-      </p:pic>
-      <p:pic>
-        <p:nvPicPr>
-          <p:cNvPr id="7" name="Picture 6" descr="image.png"/>
-          <p:cNvPicPr>
-            <a:picLocks noChangeAspect="1"/>
-          </p:cNvPicPr>
-          <p:nvPr/>
-        </p:nvPicPr>
-        <p:blipFill>
-          <a:blip r:embed="rId5"/>
-          <a:stretch>
-            <a:fillRect/>
-          </a:stretch>
-        </p:blipFill>
-        <p:spPr>
-          <a:xfrm>
-            <a:off x="119846" y="5932425"/>
-            <a:ext cx="7994926" cy="794391"/>
-          </a:xfrm>
-          <a:prstGeom prst="rect">
-            <a:avLst/>
-          </a:prstGeom>
-        </p:spPr>
-      </p:pic>
-      <p:pic>
-        <p:nvPicPr>
-          <p:cNvPr id="8" name="Picture 7" descr="image.png"/>
-          <p:cNvPicPr>
-            <a:picLocks noChangeAspect="1"/>
-          </p:cNvPicPr>
-          <p:nvPr/>
-        </p:nvPicPr>
-        <p:blipFill>
-          <a:blip r:embed="rId6"/>
-          <a:stretch>
-            <a:fillRect/>
-          </a:stretch>
-        </p:blipFill>
-        <p:spPr>
-          <a:xfrm>
-            <a:off x="8384429" y="6107336"/>
-            <a:ext cx="371687" cy="422703"/>
-          </a:xfrm>
-          <a:prstGeom prst="rect">
-            <a:avLst/>
-          </a:prstGeom>
-        </p:spPr>
-      </p:pic>
-      <p:pic>
-        <p:nvPicPr>
-          <p:cNvPr id="9" name="Picture 8" descr="residual-153.png"/>
-          <p:cNvPicPr>
-            <a:picLocks noChangeAspect="1"/>
-          </p:cNvPicPr>
-          <p:nvPr/>
-        </p:nvPicPr>
-        <p:blipFill>
-          <a:blip r:embed="rId7"/>
-          <a:stretch>
-            <a:fillRect/>
-          </a:stretch>
-        </p:blipFill>
-        <p:spPr>
-          <a:xfrm>
-            <a:off x="8151213" y="0"/>
-            <a:ext cx="4037547" cy="6858000"/>
-          </a:xfrm>
-          <a:prstGeom prst="rect">
-            <a:avLst/>
-          </a:prstGeom>
-        </p:spPr>
-      </p:pic>
-      <p:pic>
-        <p:nvPicPr>
-          <p:cNvPr id="10" name="Picture 9" descr="residual-154.png"/>
-          <p:cNvPicPr>
-            <a:picLocks noChangeAspect="1"/>
-          </p:cNvPicPr>
-          <p:nvPr/>
-        </p:nvPicPr>
-        <p:blipFill>
-          <a:blip r:embed="rId8"/>
-          <a:stretch>
-            <a:fillRect/>
-          </a:stretch>
-        </p:blipFill>
-        <p:spPr>
-          <a:xfrm>
-            <a:off x="8712388" y="0"/>
-            <a:ext cx="597615" cy="947438"/>
-          </a:xfrm>
-          <a:prstGeom prst="rect">
-            <a:avLst/>
-          </a:prstGeom>
-        </p:spPr>
-      </p:pic>
-      <p:pic>
-        <p:nvPicPr>
-          <p:cNvPr id="11" name="Picture 10" descr="residual-114.png"/>
-          <p:cNvPicPr>
-            <a:picLocks noChangeAspect="1"/>
-          </p:cNvPicPr>
-          <p:nvPr/>
-        </p:nvPicPr>
-        <p:blipFill>
-          <a:blip r:embed="rId9"/>
-          <a:stretch>
-            <a:fillRect/>
-          </a:stretch>
-        </p:blipFill>
-        <p:spPr>
-          <a:xfrm>
-            <a:off x="323910" y="1676238"/>
-            <a:ext cx="685071" cy="736087"/>
-          </a:xfrm>
-          <a:prstGeom prst="rect">
-            <a:avLst/>
-          </a:prstGeom>
-        </p:spPr>
-      </p:pic>
-      <p:pic>
-        <p:nvPicPr>
-          <p:cNvPr id="12" name="Picture 11" descr="image.png"/>
-          <p:cNvPicPr>
-            <a:picLocks noChangeAspect="1"/>
-          </p:cNvPicPr>
-          <p:nvPr/>
-        </p:nvPicPr>
-        <p:blipFill>
-          <a:blip r:embed="rId10"/>
-          <a:stretch>
-            <a:fillRect/>
-          </a:stretch>
-        </p:blipFill>
-        <p:spPr>
-          <a:xfrm>
-            <a:off x="4274001" y="1763693"/>
-            <a:ext cx="4270763" cy="2186397"/>
-          </a:xfrm>
-          <a:prstGeom prst="rect">
-            <a:avLst/>
-          </a:prstGeom>
-        </p:spPr>
-      </p:pic>
-      <p:pic>
-        <p:nvPicPr>
-          <p:cNvPr id="13" name="Picture 12" descr="residual-94.png"/>
-          <p:cNvPicPr>
-            <a:picLocks noChangeAspect="1"/>
-          </p:cNvPicPr>
-          <p:nvPr/>
-        </p:nvPicPr>
-        <p:blipFill>
-          <a:blip r:embed="rId11"/>
-          <a:stretch>
-            <a:fillRect/>
-          </a:stretch>
-        </p:blipFill>
-        <p:spPr>
-          <a:xfrm>
-            <a:off x="323910" y="2550797"/>
-            <a:ext cx="699647" cy="670495"/>
-          </a:xfrm>
-          <a:prstGeom prst="rect">
-            <a:avLst/>
-          </a:prstGeom>
-        </p:spPr>
-      </p:pic>
-      <p:pic>
-        <p:nvPicPr>
-          <p:cNvPr id="14" name="Picture 13" descr="residual-81.png"/>
-          <p:cNvPicPr>
-            <a:picLocks noChangeAspect="1"/>
-          </p:cNvPicPr>
-          <p:nvPr/>
-        </p:nvPicPr>
-        <p:blipFill>
-          <a:blip r:embed="rId12"/>
-          <a:stretch>
-            <a:fillRect/>
-          </a:stretch>
-        </p:blipFill>
-        <p:spPr>
-          <a:xfrm>
-            <a:off x="323910" y="3330612"/>
-            <a:ext cx="699647" cy="714223"/>
-          </a:xfrm>
-          <a:prstGeom prst="rect">
-            <a:avLst/>
-          </a:prstGeom>
-        </p:spPr>
-      </p:pic>
-      <p:pic>
-        <p:nvPicPr>
-          <p:cNvPr id="15" name="Picture 14" descr="image.png"/>
-          <p:cNvPicPr>
-            <a:picLocks noChangeAspect="1"/>
-          </p:cNvPicPr>
-          <p:nvPr/>
-        </p:nvPicPr>
-        <p:blipFill>
-          <a:blip r:embed="rId13"/>
-          <a:stretch>
-            <a:fillRect/>
-          </a:stretch>
-        </p:blipFill>
-        <p:spPr>
-          <a:xfrm>
-            <a:off x="4237562" y="4117715"/>
-            <a:ext cx="3920939" cy="1719965"/>
-          </a:xfrm>
-          <a:prstGeom prst="rect">
-            <a:avLst/>
-          </a:prstGeom>
-        </p:spPr>
-      </p:pic>
-      <p:pic>
-        <p:nvPicPr>
-          <p:cNvPr id="16" name="Picture 15" descr="residual-48.png"/>
-          <p:cNvPicPr>
-            <a:picLocks noChangeAspect="1"/>
-          </p:cNvPicPr>
-          <p:nvPr/>
-        </p:nvPicPr>
-        <p:blipFill>
-          <a:blip r:embed="rId14"/>
-          <a:stretch>
-            <a:fillRect/>
-          </a:stretch>
-        </p:blipFill>
-        <p:spPr>
-          <a:xfrm>
-            <a:off x="323910" y="4205171"/>
-            <a:ext cx="685071" cy="663207"/>
-          </a:xfrm>
-          <a:prstGeom prst="rect">
-            <a:avLst/>
-          </a:prstGeom>
-        </p:spPr>
-      </p:pic>
-      <p:pic>
-        <p:nvPicPr>
-          <p:cNvPr id="17" name="Picture 16" descr="residual-28.png"/>
-          <p:cNvPicPr>
-            <a:picLocks noChangeAspect="1"/>
-          </p:cNvPicPr>
-          <p:nvPr/>
-        </p:nvPicPr>
-        <p:blipFill>
-          <a:blip r:embed="rId15"/>
-          <a:stretch>
-            <a:fillRect/>
-          </a:stretch>
-        </p:blipFill>
-        <p:spPr>
-          <a:xfrm>
-            <a:off x="323910" y="4977698"/>
-            <a:ext cx="692359" cy="728799"/>
-          </a:xfrm>
-          <a:prstGeom prst="rect">
-            <a:avLst/>
-          </a:prstGeom>
-        </p:spPr>
-      </p:pic>
-      <p:sp>
-        <p:nvSpPr>
-          <p:cNvPr id="18" name="Rectangle 17"/>
+      <p:sp>
+        <p:nvSpPr>
+          <p:cNvPr id="4" name="Rectangle 3"/>
           <p:cNvSpPr/>
           <p:nvPr/>
         </p:nvSpPr>
         <p:spPr>
           <a:xfrm>
-            <a:off x="236454" y="1333702"/>
-            <a:ext cx="1756405" cy="291519"/>
+            <a:off x="1090971" y="4260559"/>
+            <a:ext cx="364399" cy="561175"/>
           </a:xfrm>
           <a:prstGeom prst="rect">
             <a:avLst/>
           </a:prstGeom>
           <a:solidFill>
-            <a:srgbClr val="020201"/>
+            <a:srgbClr val="FDC203"/>
           </a:solidFill>
           <a:ln>
             <a:noFill/>
@@ -3559,20 +3219,20 @@
       </p:sp>
       <p:sp>
         <p:nvSpPr>
-          <p:cNvPr id="19" name="Rectangle 18"/>
+          <p:cNvPr id="5" name="Rectangle 4"/>
           <p:cNvSpPr/>
           <p:nvPr/>
         </p:nvSpPr>
         <p:spPr>
           <a:xfrm>
-            <a:off x="4244850" y="1377430"/>
-            <a:ext cx="3600267" cy="247791"/>
+            <a:off x="1092429" y="5082280"/>
+            <a:ext cx="364399" cy="568463"/>
           </a:xfrm>
           <a:prstGeom prst="rect">
             <a:avLst/>
           </a:prstGeom>
           <a:solidFill>
-            <a:srgbClr val="030303"/>
+            <a:srgbClr val="FDC204"/>
           </a:solidFill>
           <a:ln>
             <a:noFill/>
@@ -3602,20 +3262,20 @@
       </p:sp>
       <p:sp>
         <p:nvSpPr>
-          <p:cNvPr id="20" name="Rectangle 19"/>
+          <p:cNvPr id="6" name="Rectangle 5"/>
           <p:cNvSpPr/>
           <p:nvPr/>
         </p:nvSpPr>
         <p:spPr>
           <a:xfrm>
-            <a:off x="6219895" y="1734541"/>
-            <a:ext cx="685071" cy="502871"/>
+            <a:off x="1089149" y="1785557"/>
+            <a:ext cx="364399" cy="568463"/>
           </a:xfrm>
           <a:prstGeom prst="rect">
             <a:avLst/>
           </a:prstGeom>
           <a:solidFill>
-            <a:srgbClr val="020201"/>
+            <a:srgbClr val="FDC104"/>
           </a:solidFill>
           <a:ln>
             <a:noFill/>
@@ -3645,23 +3305,25 @@
       </p:sp>
       <p:sp>
         <p:nvSpPr>
-          <p:cNvPr id="21" name="Rectangle 20"/>
+          <p:cNvPr id="7" name="Rectangle 6"/>
           <p:cNvSpPr/>
           <p:nvPr/>
         </p:nvSpPr>
         <p:spPr>
           <a:xfrm>
-            <a:off x="6810223" y="1829285"/>
-            <a:ext cx="962014" cy="327959"/>
+            <a:off x="7349534" y="3979243"/>
+            <a:ext cx="736087" cy="58303"/>
           </a:xfrm>
           <a:prstGeom prst="rect">
             <a:avLst/>
           </a:prstGeom>
           <a:solidFill>
-            <a:srgbClr val="BC0F0E"/>
+            <a:srgbClr val="FDFDFD"/>
           </a:solidFill>
-          <a:ln>
-            <a:noFill/>
+          <a:ln w="15875">
+            <a:solidFill>
+              <a:srgbClr val="ACADAD"/>
+            </a:solidFill>
           </a:ln>
         </p:spPr>
         <p:style>
@@ -3688,23 +3350,25 @@
       </p:sp>
       <p:sp>
         <p:nvSpPr>
-          <p:cNvPr id="22" name="Rectangle 21"/>
+          <p:cNvPr id="8" name="Rectangle 7"/>
           <p:cNvSpPr/>
           <p:nvPr/>
         </p:nvSpPr>
         <p:spPr>
           <a:xfrm>
-            <a:off x="4230274" y="4103139"/>
-            <a:ext cx="1887589" cy="306095"/>
+            <a:off x="8355277" y="5932425"/>
+            <a:ext cx="313383" cy="240503"/>
           </a:xfrm>
           <a:prstGeom prst="rect">
             <a:avLst/>
           </a:prstGeom>
           <a:solidFill>
-            <a:srgbClr val="030202"/>
+            <a:srgbClr val="FEFEFE"/>
           </a:solidFill>
-          <a:ln>
-            <a:noFill/>
+          <a:ln w="15875">
+            <a:solidFill>
+              <a:srgbClr val="252625"/>
+            </a:solidFill>
           </a:ln>
         </p:spPr>
         <p:style>
@@ -3729,22 +3393,334 @@
           </a:p>
         </p:txBody>
       </p:sp>
-      <p:sp>
-        <p:nvSpPr>
-          <p:cNvPr id="23" name="Rectangle 22"/>
+      <p:pic>
+        <p:nvPicPr>
+          <p:cNvPr id="9" name="Picture 8" descr="image.png"/>
+          <p:cNvPicPr>
+            <a:picLocks noChangeAspect="1"/>
+          </p:cNvPicPr>
+          <p:nvPr/>
+        </p:nvPicPr>
+        <p:blipFill>
+          <a:blip r:embed="rId2"/>
+          <a:stretch>
+            <a:fillRect/>
+          </a:stretch>
+        </p:blipFill>
+        <p:spPr>
+          <a:xfrm>
+            <a:off x="229166" y="1297262"/>
+            <a:ext cx="2368597" cy="393551"/>
+          </a:xfrm>
+          <a:prstGeom prst="rect">
+            <a:avLst/>
+          </a:prstGeom>
+        </p:spPr>
+      </p:pic>
+      <p:pic>
+        <p:nvPicPr>
+          <p:cNvPr id="10" name="Picture 9" descr="image.png"/>
+          <p:cNvPicPr>
+            <a:picLocks noChangeAspect="1"/>
+          </p:cNvPicPr>
+          <p:nvPr/>
+        </p:nvPicPr>
+        <p:blipFill>
+          <a:blip r:embed="rId3"/>
+          <a:stretch>
+            <a:fillRect/>
+          </a:stretch>
+        </p:blipFill>
+        <p:spPr>
+          <a:xfrm>
+            <a:off x="4237562" y="1355566"/>
+            <a:ext cx="3833483" cy="276943"/>
+          </a:xfrm>
+          <a:prstGeom prst="rect">
+            <a:avLst/>
+          </a:prstGeom>
+        </p:spPr>
+      </p:pic>
+      <p:pic>
+        <p:nvPicPr>
+          <p:cNvPr id="11" name="Picture 10" descr="image.png"/>
+          <p:cNvPicPr>
+            <a:picLocks noChangeAspect="1"/>
+          </p:cNvPicPr>
+          <p:nvPr/>
+        </p:nvPicPr>
+        <p:blipFill>
+          <a:blip r:embed="rId4"/>
+          <a:stretch>
+            <a:fillRect/>
+          </a:stretch>
+        </p:blipFill>
+        <p:spPr>
+          <a:xfrm>
+            <a:off x="119846" y="5932425"/>
+            <a:ext cx="7994926" cy="794391"/>
+          </a:xfrm>
+          <a:prstGeom prst="rect">
+            <a:avLst/>
+          </a:prstGeom>
+        </p:spPr>
+      </p:pic>
+      <p:pic>
+        <p:nvPicPr>
+          <p:cNvPr id="12" name="Picture 11" descr="image.png"/>
+          <p:cNvPicPr>
+            <a:picLocks noChangeAspect="1"/>
+          </p:cNvPicPr>
+          <p:nvPr/>
+        </p:nvPicPr>
+        <p:blipFill>
+          <a:blip r:embed="rId5"/>
+          <a:stretch>
+            <a:fillRect/>
+          </a:stretch>
+        </p:blipFill>
+        <p:spPr>
+          <a:xfrm>
+            <a:off x="8384429" y="6107336"/>
+            <a:ext cx="371687" cy="422703"/>
+          </a:xfrm>
+          <a:prstGeom prst="rect">
+            <a:avLst/>
+          </a:prstGeom>
+        </p:spPr>
+      </p:pic>
+      <p:pic>
+        <p:nvPicPr>
+          <p:cNvPr id="13" name="Picture 12" descr="residual-153.png"/>
+          <p:cNvPicPr>
+            <a:picLocks noChangeAspect="1"/>
+          </p:cNvPicPr>
+          <p:nvPr/>
+        </p:nvPicPr>
+        <p:blipFill>
+          <a:blip r:embed="rId6"/>
+          <a:stretch>
+            <a:fillRect/>
+          </a:stretch>
+        </p:blipFill>
+        <p:spPr>
+          <a:xfrm>
+            <a:off x="8151213" y="0"/>
+            <a:ext cx="4037547" cy="6858000"/>
+          </a:xfrm>
+          <a:prstGeom prst="rect">
+            <a:avLst/>
+          </a:prstGeom>
+        </p:spPr>
+      </p:pic>
+      <p:pic>
+        <p:nvPicPr>
+          <p:cNvPr id="14" name="Picture 13" descr="residual-154.png"/>
+          <p:cNvPicPr>
+            <a:picLocks noChangeAspect="1"/>
+          </p:cNvPicPr>
+          <p:nvPr/>
+        </p:nvPicPr>
+        <p:blipFill>
+          <a:blip r:embed="rId7"/>
+          <a:stretch>
+            <a:fillRect/>
+          </a:stretch>
+        </p:blipFill>
+        <p:spPr>
+          <a:xfrm>
+            <a:off x="8712388" y="0"/>
+            <a:ext cx="597615" cy="947438"/>
+          </a:xfrm>
+          <a:prstGeom prst="rect">
+            <a:avLst/>
+          </a:prstGeom>
+        </p:spPr>
+      </p:pic>
+      <p:pic>
+        <p:nvPicPr>
+          <p:cNvPr id="15" name="Picture 14" descr="residual-114.png"/>
+          <p:cNvPicPr>
+            <a:picLocks noChangeAspect="1"/>
+          </p:cNvPicPr>
+          <p:nvPr/>
+        </p:nvPicPr>
+        <p:blipFill>
+          <a:blip r:embed="rId8"/>
+          <a:stretch>
+            <a:fillRect/>
+          </a:stretch>
+        </p:blipFill>
+        <p:spPr>
+          <a:xfrm>
+            <a:off x="323910" y="1676238"/>
+            <a:ext cx="685071" cy="736087"/>
+          </a:xfrm>
+          <a:prstGeom prst="rect">
+            <a:avLst/>
+          </a:prstGeom>
+        </p:spPr>
+      </p:pic>
+      <p:pic>
+        <p:nvPicPr>
+          <p:cNvPr id="16" name="Picture 15" descr="image.png"/>
+          <p:cNvPicPr>
+            <a:picLocks noChangeAspect="1"/>
+          </p:cNvPicPr>
+          <p:nvPr/>
+        </p:nvPicPr>
+        <p:blipFill>
+          <a:blip r:embed="rId9"/>
+          <a:stretch>
+            <a:fillRect/>
+          </a:stretch>
+        </p:blipFill>
+        <p:spPr>
+          <a:xfrm>
+            <a:off x="4274001" y="1763693"/>
+            <a:ext cx="4270763" cy="2186397"/>
+          </a:xfrm>
+          <a:prstGeom prst="rect">
+            <a:avLst/>
+          </a:prstGeom>
+        </p:spPr>
+      </p:pic>
+      <p:pic>
+        <p:nvPicPr>
+          <p:cNvPr id="17" name="Picture 16" descr="residual-94.png"/>
+          <p:cNvPicPr>
+            <a:picLocks noChangeAspect="1"/>
+          </p:cNvPicPr>
+          <p:nvPr/>
+        </p:nvPicPr>
+        <p:blipFill>
+          <a:blip r:embed="rId10"/>
+          <a:stretch>
+            <a:fillRect/>
+          </a:stretch>
+        </p:blipFill>
+        <p:spPr>
+          <a:xfrm>
+            <a:off x="323910" y="2550797"/>
+            <a:ext cx="699647" cy="670495"/>
+          </a:xfrm>
+          <a:prstGeom prst="rect">
+            <a:avLst/>
+          </a:prstGeom>
+        </p:spPr>
+      </p:pic>
+      <p:pic>
+        <p:nvPicPr>
+          <p:cNvPr id="18" name="Picture 17" descr="residual-81.png"/>
+          <p:cNvPicPr>
+            <a:picLocks noChangeAspect="1"/>
+          </p:cNvPicPr>
+          <p:nvPr/>
+        </p:nvPicPr>
+        <p:blipFill>
+          <a:blip r:embed="rId11"/>
+          <a:stretch>
+            <a:fillRect/>
+          </a:stretch>
+        </p:blipFill>
+        <p:spPr>
+          <a:xfrm>
+            <a:off x="323910" y="3330612"/>
+            <a:ext cx="699647" cy="714223"/>
+          </a:xfrm>
+          <a:prstGeom prst="rect">
+            <a:avLst/>
+          </a:prstGeom>
+        </p:spPr>
+      </p:pic>
+      <p:pic>
+        <p:nvPicPr>
+          <p:cNvPr id="19" name="Picture 18" descr="image.png"/>
+          <p:cNvPicPr>
+            <a:picLocks noChangeAspect="1"/>
+          </p:cNvPicPr>
+          <p:nvPr/>
+        </p:nvPicPr>
+        <p:blipFill>
+          <a:blip r:embed="rId12"/>
+          <a:stretch>
+            <a:fillRect/>
+          </a:stretch>
+        </p:blipFill>
+        <p:spPr>
+          <a:xfrm>
+            <a:off x="4237562" y="4117715"/>
+            <a:ext cx="3920939" cy="1719965"/>
+          </a:xfrm>
+          <a:prstGeom prst="rect">
+            <a:avLst/>
+          </a:prstGeom>
+        </p:spPr>
+      </p:pic>
+      <p:pic>
+        <p:nvPicPr>
+          <p:cNvPr id="20" name="Picture 19" descr="residual-48.png"/>
+          <p:cNvPicPr>
+            <a:picLocks noChangeAspect="1"/>
+          </p:cNvPicPr>
+          <p:nvPr/>
+        </p:nvPicPr>
+        <p:blipFill>
+          <a:blip r:embed="rId13"/>
+          <a:stretch>
+            <a:fillRect/>
+          </a:stretch>
+        </p:blipFill>
+        <p:spPr>
+          <a:xfrm>
+            <a:off x="323910" y="4205171"/>
+            <a:ext cx="685071" cy="663207"/>
+          </a:xfrm>
+          <a:prstGeom prst="rect">
+            <a:avLst/>
+          </a:prstGeom>
+        </p:spPr>
+      </p:pic>
+      <p:pic>
+        <p:nvPicPr>
+          <p:cNvPr id="21" name="Picture 20" descr="residual-28.png"/>
+          <p:cNvPicPr>
+            <a:picLocks noChangeAspect="1"/>
+          </p:cNvPicPr>
+          <p:nvPr/>
+        </p:nvPicPr>
+        <p:blipFill>
+          <a:blip r:embed="rId14"/>
+          <a:stretch>
+            <a:fillRect/>
+          </a:stretch>
+        </p:blipFill>
+        <p:spPr>
+          <a:xfrm>
+            <a:off x="323910" y="4977698"/>
+            <a:ext cx="692359" cy="728799"/>
+          </a:xfrm>
+          <a:prstGeom prst="rect">
+            <a:avLst/>
+          </a:prstGeom>
+        </p:spPr>
+      </p:pic>
+      <p:sp>
+        <p:nvSpPr>
+          <p:cNvPr id="22" name="Rectangle 21"/>
           <p:cNvSpPr/>
           <p:nvPr/>
         </p:nvSpPr>
         <p:spPr>
           <a:xfrm>
-            <a:off x="1111013" y="6063608"/>
-            <a:ext cx="1945893" cy="502871"/>
+            <a:off x="236454" y="1333702"/>
+            <a:ext cx="1756405" cy="291519"/>
           </a:xfrm>
           <a:prstGeom prst="rect">
             <a:avLst/>
           </a:prstGeom>
           <a:solidFill>
-            <a:srgbClr val="BD0F0E"/>
+            <a:srgbClr val="020201"/>
           </a:solidFill>
           <a:ln>
             <a:noFill/>
@@ -3774,7 +3750,222 @@
       </p:sp>
       <p:sp>
         <p:nvSpPr>
-          <p:cNvPr id="24" name="TextBox 23"/>
+          <p:cNvPr id="23" name="Rectangle 22"/>
+          <p:cNvSpPr/>
+          <p:nvPr/>
+        </p:nvSpPr>
+        <p:spPr>
+          <a:xfrm>
+            <a:off x="4244850" y="1377430"/>
+            <a:ext cx="3600267" cy="247791"/>
+          </a:xfrm>
+          <a:prstGeom prst="rect">
+            <a:avLst/>
+          </a:prstGeom>
+          <a:solidFill>
+            <a:srgbClr val="030303"/>
+          </a:solidFill>
+          <a:ln>
+            <a:noFill/>
+          </a:ln>
+        </p:spPr>
+        <p:style>
+          <a:lnRef idx="1">
+            <a:schemeClr val="accent1"/>
+          </a:lnRef>
+          <a:fillRef idx="3">
+            <a:schemeClr val="accent1"/>
+          </a:fillRef>
+          <a:effectRef idx="2">
+            <a:schemeClr val="accent1"/>
+          </a:effectRef>
+          <a:fontRef idx="minor">
+            <a:schemeClr val="lt1"/>
+          </a:fontRef>
+        </p:style>
+        <p:txBody>
+          <a:bodyPr rtlCol="0" anchor="ctr"/>
+          <a:lstStyle/>
+          <a:p>
+            <a:pPr algn="ctr"/>
+          </a:p>
+        </p:txBody>
+      </p:sp>
+      <p:sp>
+        <p:nvSpPr>
+          <p:cNvPr id="24" name="Rectangle 23"/>
+          <p:cNvSpPr/>
+          <p:nvPr/>
+        </p:nvSpPr>
+        <p:spPr>
+          <a:xfrm>
+            <a:off x="6219895" y="1734541"/>
+            <a:ext cx="685071" cy="502871"/>
+          </a:xfrm>
+          <a:prstGeom prst="rect">
+            <a:avLst/>
+          </a:prstGeom>
+          <a:solidFill>
+            <a:srgbClr val="020201"/>
+          </a:solidFill>
+          <a:ln>
+            <a:noFill/>
+          </a:ln>
+        </p:spPr>
+        <p:style>
+          <a:lnRef idx="1">
+            <a:schemeClr val="accent1"/>
+          </a:lnRef>
+          <a:fillRef idx="3">
+            <a:schemeClr val="accent1"/>
+          </a:fillRef>
+          <a:effectRef idx="2">
+            <a:schemeClr val="accent1"/>
+          </a:effectRef>
+          <a:fontRef idx="minor">
+            <a:schemeClr val="lt1"/>
+          </a:fontRef>
+        </p:style>
+        <p:txBody>
+          <a:bodyPr rtlCol="0" anchor="ctr"/>
+          <a:lstStyle/>
+          <a:p>
+            <a:pPr algn="ctr"/>
+          </a:p>
+        </p:txBody>
+      </p:sp>
+      <p:sp>
+        <p:nvSpPr>
+          <p:cNvPr id="25" name="Rectangle 24"/>
+          <p:cNvSpPr/>
+          <p:nvPr/>
+        </p:nvSpPr>
+        <p:spPr>
+          <a:xfrm>
+            <a:off x="6810223" y="1829285"/>
+            <a:ext cx="962014" cy="327959"/>
+          </a:xfrm>
+          <a:prstGeom prst="rect">
+            <a:avLst/>
+          </a:prstGeom>
+          <a:solidFill>
+            <a:srgbClr val="BC0F0E"/>
+          </a:solidFill>
+          <a:ln>
+            <a:noFill/>
+          </a:ln>
+        </p:spPr>
+        <p:style>
+          <a:lnRef idx="1">
+            <a:schemeClr val="accent1"/>
+          </a:lnRef>
+          <a:fillRef idx="3">
+            <a:schemeClr val="accent1"/>
+          </a:fillRef>
+          <a:effectRef idx="2">
+            <a:schemeClr val="accent1"/>
+          </a:effectRef>
+          <a:fontRef idx="minor">
+            <a:schemeClr val="lt1"/>
+          </a:fontRef>
+        </p:style>
+        <p:txBody>
+          <a:bodyPr rtlCol="0" anchor="ctr"/>
+          <a:lstStyle/>
+          <a:p>
+            <a:pPr algn="ctr"/>
+          </a:p>
+        </p:txBody>
+      </p:sp>
+      <p:sp>
+        <p:nvSpPr>
+          <p:cNvPr id="26" name="Rectangle 25"/>
+          <p:cNvSpPr/>
+          <p:nvPr/>
+        </p:nvSpPr>
+        <p:spPr>
+          <a:xfrm>
+            <a:off x="4230274" y="4103139"/>
+            <a:ext cx="1887589" cy="306095"/>
+          </a:xfrm>
+          <a:prstGeom prst="rect">
+            <a:avLst/>
+          </a:prstGeom>
+          <a:solidFill>
+            <a:srgbClr val="030202"/>
+          </a:solidFill>
+          <a:ln>
+            <a:noFill/>
+          </a:ln>
+        </p:spPr>
+        <p:style>
+          <a:lnRef idx="1">
+            <a:schemeClr val="accent1"/>
+          </a:lnRef>
+          <a:fillRef idx="3">
+            <a:schemeClr val="accent1"/>
+          </a:fillRef>
+          <a:effectRef idx="2">
+            <a:schemeClr val="accent1"/>
+          </a:effectRef>
+          <a:fontRef idx="minor">
+            <a:schemeClr val="lt1"/>
+          </a:fontRef>
+        </p:style>
+        <p:txBody>
+          <a:bodyPr rtlCol="0" anchor="ctr"/>
+          <a:lstStyle/>
+          <a:p>
+            <a:pPr algn="ctr"/>
+          </a:p>
+        </p:txBody>
+      </p:sp>
+      <p:sp>
+        <p:nvSpPr>
+          <p:cNvPr id="27" name="Rectangle 26"/>
+          <p:cNvSpPr/>
+          <p:nvPr/>
+        </p:nvSpPr>
+        <p:spPr>
+          <a:xfrm>
+            <a:off x="1111013" y="6063608"/>
+            <a:ext cx="1945893" cy="502871"/>
+          </a:xfrm>
+          <a:prstGeom prst="rect">
+            <a:avLst/>
+          </a:prstGeom>
+          <a:solidFill>
+            <a:srgbClr val="BD0F0E"/>
+          </a:solidFill>
+          <a:ln>
+            <a:noFill/>
+          </a:ln>
+        </p:spPr>
+        <p:style>
+          <a:lnRef idx="1">
+            <a:schemeClr val="accent1"/>
+          </a:lnRef>
+          <a:fillRef idx="3">
+            <a:schemeClr val="accent1"/>
+          </a:fillRef>
+          <a:effectRef idx="2">
+            <a:schemeClr val="accent1"/>
+          </a:effectRef>
+          <a:fontRef idx="minor">
+            <a:schemeClr val="lt1"/>
+          </a:fontRef>
+        </p:style>
+        <p:txBody>
+          <a:bodyPr rtlCol="0" anchor="ctr"/>
+          <a:lstStyle/>
+          <a:p>
+            <a:pPr algn="ctr"/>
+          </a:p>
+        </p:txBody>
+      </p:sp>
+      <p:sp>
+        <p:nvSpPr>
+          <p:cNvPr id="28" name="TextBox 27"/>
           <p:cNvSpPr txBox="1"/>
           <p:nvPr/>
         </p:nvSpPr>
@@ -3810,7 +4001,7 @@
       </p:sp>
       <p:sp>
         <p:nvSpPr>
-          <p:cNvPr id="25" name="TextBox 24"/>
+          <p:cNvPr id="29" name="TextBox 28"/>
           <p:cNvSpPr txBox="1"/>
           <p:nvPr/>
         </p:nvSpPr>
@@ -3846,7 +4037,7 @@
       </p:sp>
       <p:sp>
         <p:nvSpPr>
-          <p:cNvPr id="26" name="TextBox 25"/>
+          <p:cNvPr id="30" name="TextBox 29"/>
           <p:cNvSpPr txBox="1"/>
           <p:nvPr/>
         </p:nvSpPr>
@@ -3882,7 +4073,7 @@
       </p:sp>
       <p:sp>
         <p:nvSpPr>
-          <p:cNvPr id="27" name="TextBox 26"/>
+          <p:cNvPr id="31" name="TextBox 30"/>
           <p:cNvSpPr txBox="1"/>
           <p:nvPr/>
         </p:nvSpPr>
@@ -3918,7 +4109,7 @@
       </p:sp>
       <p:sp>
         <p:nvSpPr>
-          <p:cNvPr id="28" name="TextBox 27"/>
+          <p:cNvPr id="32" name="TextBox 31"/>
           <p:cNvSpPr txBox="1"/>
           <p:nvPr/>
         </p:nvSpPr>
@@ -3954,14 +4145,14 @@
       </p:sp>
       <p:sp>
         <p:nvSpPr>
-          <p:cNvPr id="29" name="TextBox 28"/>
+          <p:cNvPr id="33" name="TextBox 32"/>
           <p:cNvSpPr txBox="1"/>
           <p:nvPr/>
         </p:nvSpPr>
         <p:spPr>
           <a:xfrm>
-            <a:off x="6351079" y="1807421"/>
-            <a:ext cx="378975" cy="357111"/>
+            <a:off x="1089149" y="1785557"/>
+            <a:ext cx="364399" cy="568463"/>
           </a:xfrm>
           <a:prstGeom prst="rect">
             <a:avLst/>
@@ -3975,29 +4166,29 @@
           <a:lstStyle/>
           <a:p>
             <a:pPr>
-              <a:defRPr sz="1624" b="1" i="0">
-                <a:solidFill>
-                  <a:srgbClr val="F7C403"/>
+              <a:defRPr sz="2811" b="0" i="0">
+                <a:solidFill>
+                  <a:srgbClr val="050400"/>
                 </a:solidFill>
                 <a:latin typeface="Arial"/>
               </a:defRPr>
             </a:pPr>
             <a:r>
-              <a:t>VS.</a:t>
-            </a:r>
-          </a:p>
-        </p:txBody>
-      </p:sp>
-      <p:sp>
-        <p:nvSpPr>
-          <p:cNvPr id="30" name="TextBox 29"/>
+              <a:t>1</a:t>
+            </a:r>
+          </a:p>
+        </p:txBody>
+      </p:sp>
+      <p:sp>
+        <p:nvSpPr>
+          <p:cNvPr id="34" name="TextBox 33"/>
           <p:cNvSpPr txBox="1"/>
           <p:nvPr/>
         </p:nvSpPr>
         <p:spPr>
           <a:xfrm>
-            <a:off x="1140165" y="1865725"/>
-            <a:ext cx="218639" cy="400839"/>
+            <a:off x="6351079" y="1807421"/>
+            <a:ext cx="378975" cy="357111"/>
           </a:xfrm>
           <a:prstGeom prst="rect">
             <a:avLst/>
@@ -4011,22 +4202,22 @@
           <a:lstStyle/>
           <a:p>
             <a:pPr>
-              <a:defRPr sz="1687" b="0" i="0">
-                <a:solidFill>
-                  <a:srgbClr val="050400"/>
+              <a:defRPr sz="1624" b="1" i="0">
+                <a:solidFill>
+                  <a:srgbClr val="F7C403"/>
                 </a:solidFill>
                 <a:latin typeface="Arial"/>
               </a:defRPr>
             </a:pPr>
             <a:r>
-              <a:t>1</a:t>
-            </a:r>
-          </a:p>
-        </p:txBody>
-      </p:sp>
-      <p:sp>
-        <p:nvSpPr>
-          <p:cNvPr id="31" name="TextBox 30"/>
+              <a:t>VS.</a:t>
+            </a:r>
+          </a:p>
+        </p:txBody>
+      </p:sp>
+      <p:sp>
+        <p:nvSpPr>
+          <p:cNvPr id="35" name="TextBox 34"/>
           <p:cNvSpPr txBox="1"/>
           <p:nvPr/>
         </p:nvSpPr>
@@ -4062,7 +4253,7 @@
       </p:sp>
       <p:sp>
         <p:nvSpPr>
-          <p:cNvPr id="32" name="TextBox 31"/>
+          <p:cNvPr id="36" name="TextBox 35"/>
           <p:cNvSpPr txBox="1"/>
           <p:nvPr/>
         </p:nvSpPr>
@@ -4098,7 +4289,7 @@
       </p:sp>
       <p:sp>
         <p:nvSpPr>
-          <p:cNvPr id="33" name="TextBox 32"/>
+          <p:cNvPr id="37" name="TextBox 36"/>
           <p:cNvSpPr txBox="1"/>
           <p:nvPr/>
         </p:nvSpPr>
@@ -4134,7 +4325,7 @@
       </p:sp>
       <p:sp>
         <p:nvSpPr>
-          <p:cNvPr id="34" name="TextBox 33"/>
+          <p:cNvPr id="38" name="TextBox 37"/>
           <p:cNvSpPr txBox="1"/>
           <p:nvPr/>
         </p:nvSpPr>
@@ -4170,7 +4361,7 @@
       </p:sp>
       <p:sp>
         <p:nvSpPr>
-          <p:cNvPr id="35" name="TextBox 34"/>
+          <p:cNvPr id="39" name="TextBox 38"/>
           <p:cNvSpPr txBox="1"/>
           <p:nvPr/>
         </p:nvSpPr>
@@ -4206,7 +4397,7 @@
       </p:sp>
       <p:sp>
         <p:nvSpPr>
-          <p:cNvPr id="36" name="TextBox 35"/>
+          <p:cNvPr id="40" name="TextBox 39"/>
           <p:cNvSpPr txBox="1"/>
           <p:nvPr/>
         </p:nvSpPr>
@@ -4242,7 +4433,7 @@
       </p:sp>
       <p:sp>
         <p:nvSpPr>
-          <p:cNvPr id="37" name="TextBox 36"/>
+          <p:cNvPr id="41" name="TextBox 40"/>
           <p:cNvSpPr txBox="1"/>
           <p:nvPr/>
         </p:nvSpPr>
@@ -4278,7 +4469,7 @@
       </p:sp>
       <p:sp>
         <p:nvSpPr>
-          <p:cNvPr id="38" name="TextBox 37"/>
+          <p:cNvPr id="42" name="TextBox 41"/>
           <p:cNvSpPr txBox="1"/>
           <p:nvPr/>
         </p:nvSpPr>
@@ -4314,7 +4505,7 @@
       </p:sp>
       <p:sp>
         <p:nvSpPr>
-          <p:cNvPr id="39" name="TextBox 38"/>
+          <p:cNvPr id="43" name="TextBox 42"/>
           <p:cNvSpPr txBox="1"/>
           <p:nvPr/>
         </p:nvSpPr>
@@ -4350,7 +4541,7 @@
       </p:sp>
       <p:sp>
         <p:nvSpPr>
-          <p:cNvPr id="40" name="TextBox 39"/>
+          <p:cNvPr id="44" name="TextBox 43"/>
           <p:cNvSpPr txBox="1"/>
           <p:nvPr/>
         </p:nvSpPr>
@@ -4386,14 +4577,14 @@
       </p:sp>
       <p:sp>
         <p:nvSpPr>
-          <p:cNvPr id="41" name="TextBox 40"/>
+          <p:cNvPr id="45" name="TextBox 44"/>
           <p:cNvSpPr txBox="1"/>
           <p:nvPr/>
         </p:nvSpPr>
         <p:spPr>
           <a:xfrm>
-            <a:off x="1096437" y="2667404"/>
-            <a:ext cx="342535" cy="451855"/>
+            <a:off x="1090242" y="2611287"/>
+            <a:ext cx="364399" cy="561175"/>
           </a:xfrm>
           <a:prstGeom prst="rect">
             <a:avLst/>
@@ -4407,7 +4598,7 @@
           <a:lstStyle/>
           <a:p>
             <a:pPr>
-              <a:defRPr sz="2643" b="0" i="0">
+              <a:defRPr sz="2811" b="0" i="0">
                 <a:solidFill>
                   <a:srgbClr val="050400"/>
                 </a:solidFill>
@@ -4422,7 +4613,7 @@
       </p:sp>
       <p:sp>
         <p:nvSpPr>
-          <p:cNvPr id="42" name="TextBox 41"/>
+          <p:cNvPr id="46" name="TextBox 45"/>
           <p:cNvSpPr txBox="1"/>
           <p:nvPr/>
         </p:nvSpPr>
@@ -4458,7 +4649,7 @@
       </p:sp>
       <p:sp>
         <p:nvSpPr>
-          <p:cNvPr id="43" name="TextBox 42"/>
+          <p:cNvPr id="47" name="TextBox 46"/>
           <p:cNvSpPr txBox="1"/>
           <p:nvPr/>
         </p:nvSpPr>
@@ -4494,7 +4685,7 @@
       </p:sp>
       <p:sp>
         <p:nvSpPr>
-          <p:cNvPr id="44" name="TextBox 43"/>
+          <p:cNvPr id="48" name="TextBox 47"/>
           <p:cNvSpPr txBox="1"/>
           <p:nvPr/>
         </p:nvSpPr>
@@ -4530,7 +4721,7 @@
       </p:sp>
       <p:sp>
         <p:nvSpPr>
-          <p:cNvPr id="45" name="TextBox 44"/>
+          <p:cNvPr id="49" name="TextBox 48"/>
           <p:cNvSpPr txBox="1"/>
           <p:nvPr/>
         </p:nvSpPr>
@@ -4566,7 +4757,7 @@
       </p:sp>
       <p:sp>
         <p:nvSpPr>
-          <p:cNvPr id="46" name="TextBox 45"/>
+          <p:cNvPr id="50" name="TextBox 49"/>
           <p:cNvSpPr txBox="1"/>
           <p:nvPr/>
         </p:nvSpPr>
@@ -4602,7 +4793,7 @@
       </p:sp>
       <p:sp>
         <p:nvSpPr>
-          <p:cNvPr id="47" name="TextBox 46"/>
+          <p:cNvPr id="51" name="TextBox 50"/>
           <p:cNvSpPr txBox="1"/>
           <p:nvPr/>
         </p:nvSpPr>
@@ -4638,7 +4829,7 @@
       </p:sp>
       <p:sp>
         <p:nvSpPr>
-          <p:cNvPr id="48" name="TextBox 47"/>
+          <p:cNvPr id="52" name="TextBox 51"/>
           <p:cNvSpPr txBox="1"/>
           <p:nvPr/>
         </p:nvSpPr>
@@ -4674,7 +4865,7 @@
       </p:sp>
       <p:sp>
         <p:nvSpPr>
-          <p:cNvPr id="49" name="TextBox 48"/>
+          <p:cNvPr id="53" name="TextBox 52"/>
           <p:cNvSpPr txBox="1"/>
           <p:nvPr/>
         </p:nvSpPr>
@@ -4710,7 +4901,7 @@
       </p:sp>
       <p:sp>
         <p:nvSpPr>
-          <p:cNvPr id="50" name="TextBox 49"/>
+          <p:cNvPr id="54" name="TextBox 53"/>
           <p:cNvSpPr txBox="1"/>
           <p:nvPr/>
         </p:nvSpPr>
@@ -4746,7 +4937,7 @@
       </p:sp>
       <p:sp>
         <p:nvSpPr>
-          <p:cNvPr id="51" name="TextBox 50"/>
+          <p:cNvPr id="55" name="TextBox 54"/>
           <p:cNvSpPr txBox="1"/>
           <p:nvPr/>
         </p:nvSpPr>
@@ -4782,14 +4973,14 @@
       </p:sp>
       <p:sp>
         <p:nvSpPr>
-          <p:cNvPr id="52" name="TextBox 51"/>
+          <p:cNvPr id="56" name="TextBox 55"/>
           <p:cNvSpPr txBox="1"/>
           <p:nvPr/>
         </p:nvSpPr>
         <p:spPr>
           <a:xfrm>
-            <a:off x="1132877" y="3512811"/>
-            <a:ext cx="269655" cy="400839"/>
+            <a:off x="1086598" y="3430821"/>
+            <a:ext cx="364399" cy="561175"/>
           </a:xfrm>
           <a:prstGeom prst="rect">
             <a:avLst/>
@@ -4803,7 +4994,7 @@
           <a:lstStyle/>
           <a:p>
             <a:pPr>
-              <a:defRPr sz="2080" b="0" i="0">
+              <a:defRPr sz="2811" b="0" i="0">
                 <a:solidFill>
                   <a:srgbClr val="050400"/>
                 </a:solidFill>
@@ -4818,7 +5009,7 @@
       </p:sp>
       <p:sp>
         <p:nvSpPr>
-          <p:cNvPr id="53" name="TextBox 52"/>
+          <p:cNvPr id="57" name="TextBox 56"/>
           <p:cNvSpPr txBox="1"/>
           <p:nvPr/>
         </p:nvSpPr>
@@ -4854,7 +5045,7 @@
       </p:sp>
       <p:sp>
         <p:nvSpPr>
-          <p:cNvPr id="54" name="TextBox 53"/>
+          <p:cNvPr id="58" name="TextBox 57"/>
           <p:cNvSpPr txBox="1"/>
           <p:nvPr/>
         </p:nvSpPr>
@@ -4890,7 +5081,7 @@
       </p:sp>
       <p:sp>
         <p:nvSpPr>
-          <p:cNvPr id="55" name="TextBox 54"/>
+          <p:cNvPr id="59" name="TextBox 58"/>
           <p:cNvSpPr txBox="1"/>
           <p:nvPr/>
         </p:nvSpPr>
@@ -4926,7 +5117,7 @@
       </p:sp>
       <p:sp>
         <p:nvSpPr>
-          <p:cNvPr id="56" name="TextBox 55"/>
+          <p:cNvPr id="60" name="TextBox 59"/>
           <p:cNvSpPr txBox="1"/>
           <p:nvPr/>
         </p:nvSpPr>
@@ -4962,7 +5153,7 @@
       </p:sp>
       <p:sp>
         <p:nvSpPr>
-          <p:cNvPr id="57" name="TextBox 56"/>
+          <p:cNvPr id="61" name="TextBox 60"/>
           <p:cNvSpPr txBox="1"/>
           <p:nvPr/>
         </p:nvSpPr>
@@ -4998,7 +5189,7 @@
       </p:sp>
       <p:sp>
         <p:nvSpPr>
-          <p:cNvPr id="58" name="TextBox 57"/>
+          <p:cNvPr id="62" name="TextBox 61"/>
           <p:cNvSpPr txBox="1"/>
           <p:nvPr/>
         </p:nvSpPr>
@@ -5034,7 +5225,7 @@
       </p:sp>
       <p:sp>
         <p:nvSpPr>
-          <p:cNvPr id="59" name="TextBox 58"/>
+          <p:cNvPr id="63" name="TextBox 62"/>
           <p:cNvSpPr txBox="1"/>
           <p:nvPr/>
         </p:nvSpPr>
@@ -5070,7 +5261,7 @@
       </p:sp>
       <p:sp>
         <p:nvSpPr>
-          <p:cNvPr id="60" name="TextBox 59"/>
+          <p:cNvPr id="64" name="TextBox 63"/>
           <p:cNvSpPr txBox="1"/>
           <p:nvPr/>
         </p:nvSpPr>
@@ -5106,7 +5297,7 @@
       </p:sp>
       <p:sp>
         <p:nvSpPr>
-          <p:cNvPr id="61" name="TextBox 60"/>
+          <p:cNvPr id="65" name="TextBox 64"/>
           <p:cNvSpPr txBox="1"/>
           <p:nvPr/>
         </p:nvSpPr>
@@ -5142,7 +5333,7 @@
       </p:sp>
       <p:sp>
         <p:nvSpPr>
-          <p:cNvPr id="62" name="TextBox 61"/>
+          <p:cNvPr id="66" name="TextBox 65"/>
           <p:cNvSpPr txBox="1"/>
           <p:nvPr/>
         </p:nvSpPr>
@@ -5178,7 +5369,7 @@
       </p:sp>
       <p:sp>
         <p:nvSpPr>
-          <p:cNvPr id="63" name="TextBox 62"/>
+          <p:cNvPr id="67" name="TextBox 66"/>
           <p:cNvSpPr txBox="1"/>
           <p:nvPr/>
         </p:nvSpPr>
@@ -5214,14 +5405,14 @@
       </p:sp>
       <p:sp>
         <p:nvSpPr>
-          <p:cNvPr id="64" name="TextBox 63"/>
+          <p:cNvPr id="68" name="TextBox 67"/>
           <p:cNvSpPr txBox="1"/>
           <p:nvPr/>
         </p:nvSpPr>
         <p:spPr>
           <a:xfrm>
-            <a:off x="1577445" y="4263475"/>
-            <a:ext cx="1792845" cy="201168"/>
+            <a:off x="1090971" y="4260559"/>
+            <a:ext cx="364399" cy="561175"/>
           </a:xfrm>
           <a:prstGeom prst="rect">
             <a:avLst/>
@@ -5235,29 +5426,29 @@
           <a:lstStyle/>
           <a:p>
             <a:pPr>
-              <a:defRPr sz="903" b="1" i="0">
-                <a:solidFill>
-                  <a:srgbClr val="010101"/>
+              <a:defRPr sz="2811" b="0" i="0">
+                <a:solidFill>
+                  <a:srgbClr val="040300"/>
                 </a:solidFill>
                 <a:latin typeface="Arial"/>
               </a:defRPr>
             </a:pPr>
             <a:r>
-              <a:t>EMOTIONALLY UNSHAKEN</a:t>
-            </a:r>
-          </a:p>
-        </p:txBody>
-      </p:sp>
-      <p:sp>
-        <p:nvSpPr>
-          <p:cNvPr id="65" name="TextBox 64"/>
+              <a:t>4</a:t>
+            </a:r>
+          </a:p>
+        </p:txBody>
+      </p:sp>
+      <p:sp>
+        <p:nvSpPr>
+          <p:cNvPr id="69" name="TextBox 68"/>
           <p:cNvSpPr txBox="1"/>
           <p:nvPr/>
         </p:nvSpPr>
         <p:spPr>
           <a:xfrm>
-            <a:off x="1103725" y="4299914"/>
-            <a:ext cx="327959" cy="466431"/>
+            <a:off x="1577445" y="4263475"/>
+            <a:ext cx="1792845" cy="201168"/>
           </a:xfrm>
           <a:prstGeom prst="rect">
             <a:avLst/>
@@ -5271,22 +5462,22 @@
           <a:lstStyle/>
           <a:p>
             <a:pPr>
-              <a:defRPr sz="2530" b="0" i="0">
-                <a:solidFill>
-                  <a:srgbClr val="040300"/>
+              <a:defRPr sz="903" b="1" i="0">
+                <a:solidFill>
+                  <a:srgbClr val="010101"/>
                 </a:solidFill>
                 <a:latin typeface="Arial"/>
               </a:defRPr>
             </a:pPr>
             <a:r>
-              <a:t>4</a:t>
-            </a:r>
-          </a:p>
-        </p:txBody>
-      </p:sp>
-      <p:sp>
-        <p:nvSpPr>
-          <p:cNvPr id="66" name="TextBox 65"/>
+              <a:t>EMOTIONALLY UNSHAKEN</a:t>
+            </a:r>
+          </a:p>
+        </p:txBody>
+      </p:sp>
+      <p:sp>
+        <p:nvSpPr>
+          <p:cNvPr id="70" name="TextBox 69"/>
           <p:cNvSpPr txBox="1"/>
           <p:nvPr/>
         </p:nvSpPr>
@@ -5322,7 +5513,7 @@
       </p:sp>
       <p:sp>
         <p:nvSpPr>
-          <p:cNvPr id="67" name="TextBox 66"/>
+          <p:cNvPr id="71" name="TextBox 70"/>
           <p:cNvSpPr txBox="1"/>
           <p:nvPr/>
         </p:nvSpPr>
@@ -5358,7 +5549,7 @@
       </p:sp>
       <p:sp>
         <p:nvSpPr>
-          <p:cNvPr id="68" name="TextBox 67"/>
+          <p:cNvPr id="72" name="TextBox 71"/>
           <p:cNvSpPr txBox="1"/>
           <p:nvPr/>
         </p:nvSpPr>
@@ -5394,7 +5585,7 @@
       </p:sp>
       <p:sp>
         <p:nvSpPr>
-          <p:cNvPr id="69" name="TextBox 68"/>
+          <p:cNvPr id="73" name="TextBox 72"/>
           <p:cNvSpPr txBox="1"/>
           <p:nvPr/>
         </p:nvSpPr>
@@ -5430,7 +5621,7 @@
       </p:sp>
       <p:sp>
         <p:nvSpPr>
-          <p:cNvPr id="70" name="TextBox 69"/>
+          <p:cNvPr id="74" name="TextBox 73"/>
           <p:cNvSpPr txBox="1"/>
           <p:nvPr/>
         </p:nvSpPr>
@@ -5466,7 +5657,7 @@
       </p:sp>
       <p:sp>
         <p:nvSpPr>
-          <p:cNvPr id="71" name="TextBox 70"/>
+          <p:cNvPr id="75" name="TextBox 74"/>
           <p:cNvSpPr txBox="1"/>
           <p:nvPr/>
         </p:nvSpPr>
@@ -5502,7 +5693,7 @@
       </p:sp>
       <p:sp>
         <p:nvSpPr>
-          <p:cNvPr id="72" name="TextBox 71"/>
+          <p:cNvPr id="76" name="TextBox 75"/>
           <p:cNvSpPr txBox="1"/>
           <p:nvPr/>
         </p:nvSpPr>
@@ -5538,14 +5729,14 @@
       </p:sp>
       <p:sp>
         <p:nvSpPr>
-          <p:cNvPr id="73" name="TextBox 72"/>
+          <p:cNvPr id="77" name="TextBox 76"/>
           <p:cNvSpPr txBox="1"/>
           <p:nvPr/>
         </p:nvSpPr>
         <p:spPr>
           <a:xfrm>
-            <a:off x="1570157" y="5094306"/>
-            <a:ext cx="2434189" cy="201168"/>
+            <a:off x="1092429" y="5082280"/>
+            <a:ext cx="364399" cy="568463"/>
           </a:xfrm>
           <a:prstGeom prst="rect">
             <a:avLst/>
@@ -5559,29 +5750,29 @@
           <a:lstStyle/>
           <a:p>
             <a:pPr>
-              <a:defRPr sz="980" b="1" i="0">
-                <a:solidFill>
-                  <a:srgbClr val="000000"/>
+              <a:defRPr sz="2811" b="0" i="0">
+                <a:solidFill>
+                  <a:srgbClr val="040300"/>
                 </a:solidFill>
                 <a:latin typeface="Arial"/>
               </a:defRPr>
             </a:pPr>
             <a:r>
-              <a:t>THE STORY NEEDS AN UNBEATABLE HERO</a:t>
-            </a:r>
-          </a:p>
-        </p:txBody>
-      </p:sp>
-      <p:sp>
-        <p:nvSpPr>
-          <p:cNvPr id="74" name="TextBox 73"/>
+              <a:t>5</a:t>
+            </a:r>
+          </a:p>
+        </p:txBody>
+      </p:sp>
+      <p:sp>
+        <p:nvSpPr>
+          <p:cNvPr id="78" name="TextBox 77"/>
           <p:cNvSpPr txBox="1"/>
           <p:nvPr/>
         </p:nvSpPr>
         <p:spPr>
           <a:xfrm>
-            <a:off x="5279744" y="5101594"/>
-            <a:ext cx="2295717" cy="201168"/>
+            <a:off x="1570157" y="5094306"/>
+            <a:ext cx="2434189" cy="201168"/>
           </a:xfrm>
           <a:prstGeom prst="rect">
             <a:avLst/>
@@ -5595,29 +5786,29 @@
           <a:lstStyle/>
           <a:p>
             <a:pPr>
-              <a:defRPr sz="799" b="0" i="0">
-                <a:solidFill>
-                  <a:srgbClr val="020000"/>
+              <a:defRPr sz="980" b="1" i="0">
+                <a:solidFill>
+                  <a:srgbClr val="000000"/>
                 </a:solidFill>
                 <a:latin typeface="Arial"/>
               </a:defRPr>
             </a:pPr>
             <a:r>
-              <a:t>battle-anime formula and turns the real</a:t>
-            </a:r>
-          </a:p>
-        </p:txBody>
-      </p:sp>
-      <p:sp>
-        <p:nvSpPr>
-          <p:cNvPr id="75" name="TextBox 74"/>
+              <a:t>THE STORY NEEDS AN UNBEATABLE HERO</a:t>
+            </a:r>
+          </a:p>
+        </p:txBody>
+      </p:sp>
+      <p:sp>
+        <p:nvSpPr>
+          <p:cNvPr id="79" name="TextBox 78"/>
           <p:cNvSpPr txBox="1"/>
           <p:nvPr/>
         </p:nvSpPr>
         <p:spPr>
           <a:xfrm>
-            <a:off x="1111013" y="5145321"/>
-            <a:ext cx="298807" cy="429991"/>
+            <a:off x="5279744" y="5101594"/>
+            <a:ext cx="2295717" cy="201168"/>
           </a:xfrm>
           <a:prstGeom prst="rect">
             <a:avLst/>
@@ -5631,22 +5822,22 @@
           <a:lstStyle/>
           <a:p>
             <a:pPr>
-              <a:defRPr sz="2305" b="0" i="0">
-                <a:solidFill>
-                  <a:srgbClr val="040300"/>
+              <a:defRPr sz="799" b="0" i="0">
+                <a:solidFill>
+                  <a:srgbClr val="020000"/>
                 </a:solidFill>
                 <a:latin typeface="Arial"/>
               </a:defRPr>
             </a:pPr>
             <a:r>
-              <a:t>5</a:t>
-            </a:r>
-          </a:p>
-        </p:txBody>
-      </p:sp>
-      <p:sp>
-        <p:nvSpPr>
-          <p:cNvPr id="76" name="TextBox 75"/>
+              <a:t>battle-anime formula and turns the real</a:t>
+            </a:r>
+          </a:p>
+        </p:txBody>
+      </p:sp>
+      <p:sp>
+        <p:nvSpPr>
+          <p:cNvPr id="80" name="TextBox 79"/>
           <p:cNvSpPr txBox="1"/>
           <p:nvPr/>
         </p:nvSpPr>
@@ -5682,7 +5873,7 @@
       </p:sp>
       <p:sp>
         <p:nvSpPr>
-          <p:cNvPr id="77" name="TextBox 76"/>
+          <p:cNvPr id="81" name="TextBox 80"/>
           <p:cNvSpPr txBox="1"/>
           <p:nvPr/>
         </p:nvSpPr>
@@ -5718,7 +5909,7 @@
       </p:sp>
       <p:sp>
         <p:nvSpPr>
-          <p:cNvPr id="78" name="TextBox 77"/>
+          <p:cNvPr id="82" name="TextBox 81"/>
           <p:cNvSpPr txBox="1"/>
           <p:nvPr/>
         </p:nvSpPr>
@@ -5754,7 +5945,7 @@
       </p:sp>
       <p:sp>
         <p:nvSpPr>
-          <p:cNvPr id="79" name="TextBox 78"/>
+          <p:cNvPr id="83" name="TextBox 82"/>
           <p:cNvSpPr txBox="1"/>
           <p:nvPr/>
         </p:nvSpPr>
@@ -5790,7 +5981,7 @@
       </p:sp>
       <p:sp>
         <p:nvSpPr>
-          <p:cNvPr id="80" name="TextBox 79"/>
+          <p:cNvPr id="84" name="TextBox 83"/>
           <p:cNvSpPr txBox="1"/>
           <p:nvPr/>
         </p:nvSpPr>
@@ -5826,7 +6017,7 @@
       </p:sp>
       <p:sp>
         <p:nvSpPr>
-          <p:cNvPr id="81" name="TextBox 80"/>
+          <p:cNvPr id="85" name="TextBox 84"/>
           <p:cNvSpPr txBox="1"/>
           <p:nvPr/>
         </p:nvSpPr>
@@ -5862,7 +6053,7 @@
       </p:sp>
       <p:sp>
         <p:nvSpPr>
-          <p:cNvPr id="82" name="TextBox 81"/>
+          <p:cNvPr id="86" name="TextBox 85"/>
           <p:cNvSpPr txBox="1"/>
           <p:nvPr/>
         </p:nvSpPr>
@@ -5898,7 +6089,7 @@
       </p:sp>
       <p:sp>
         <p:nvSpPr>
-          <p:cNvPr id="83" name="TextBox 82"/>
+          <p:cNvPr id="87" name="TextBox 86"/>
           <p:cNvSpPr txBox="1"/>
           <p:nvPr/>
         </p:nvSpPr>

</xml_diff>

<commit_message>
Erase source text behind editable overlays
</commit_message>
<xml_diff>
--- a/docs/examples/one-pun-editable.pptx
+++ b/docs/examples/one-pun-editable.pptx
@@ -4043,8 +4043,8 @@
         </p:nvSpPr>
         <p:spPr>
           <a:xfrm>
-            <a:off x="331198" y="1355566"/>
-            <a:ext cx="1486750" cy="225927"/>
+            <a:off x="265606" y="1355566"/>
+            <a:ext cx="1698102" cy="225927"/>
           </a:xfrm>
           <a:prstGeom prst="rect">
             <a:avLst/>
@@ -4058,7 +4058,7 @@
           <a:lstStyle/>
           <a:p>
             <a:pPr>
-              <a:defRPr sz="1334" b="1" i="0">
+              <a:defRPr sz="1387" b="1" i="0">
                 <a:solidFill>
                   <a:srgbClr val="FFFFFF"/>
                 </a:solidFill>
@@ -4079,8 +4079,8 @@
         </p:nvSpPr>
         <p:spPr>
           <a:xfrm>
-            <a:off x="4354169" y="1399294"/>
-            <a:ext cx="3316036" cy="201168"/>
+            <a:off x="4274001" y="1399294"/>
+            <a:ext cx="3541963" cy="201168"/>
           </a:xfrm>
           <a:prstGeom prst="rect">
             <a:avLst/>
@@ -4094,7 +4094,7 @@
           <a:lstStyle/>
           <a:p>
             <a:pPr>
-              <a:defRPr sz="1038" b="1" i="0">
+              <a:defRPr sz="1208" b="1" i="0">
                 <a:solidFill>
                   <a:srgbClr val="F8D264"/>
                 </a:solidFill>
@@ -4187,8 +4187,8 @@
         </p:nvSpPr>
         <p:spPr>
           <a:xfrm>
-            <a:off x="6351079" y="1807421"/>
-            <a:ext cx="378975" cy="357111"/>
+            <a:off x="6260125" y="1807421"/>
+            <a:ext cx="604611" cy="357111"/>
           </a:xfrm>
           <a:prstGeom prst="rect">
             <a:avLst/>
@@ -4202,7 +4202,7 @@
           <a:lstStyle/>
           <a:p>
             <a:pPr>
-              <a:defRPr sz="1624" b="1" i="0">
+              <a:defRPr sz="2193" b="1" i="0">
                 <a:solidFill>
                   <a:srgbClr val="F7C403"/>
                 </a:solidFill>
@@ -4295,8 +4295,8 @@
         </p:nvSpPr>
         <p:spPr>
           <a:xfrm>
-            <a:off x="1196137" y="1967757"/>
-            <a:ext cx="96930" cy="201168"/>
+            <a:off x="1562869" y="1967757"/>
+            <a:ext cx="2368597" cy="201168"/>
           </a:xfrm>
           <a:prstGeom prst="rect">
             <a:avLst/>
@@ -4310,15 +4310,15 @@
           <a:lstStyle/>
           <a:p>
             <a:pPr>
-              <a:defRPr sz="747" b="0" i="0">
-                <a:solidFill>
-                  <a:srgbClr val="111111"/>
-                </a:solidFill>
-                <a:latin typeface="Malgun Gothic"/>
+              <a:defRPr sz="726" b="0" i="0">
+                <a:solidFill>
+                  <a:srgbClr val="040303"/>
+                </a:solidFill>
+                <a:latin typeface="Arial"/>
               </a:defRPr>
             </a:pPr>
             <a:r>
-              <a:t>•</a:t>
+              <a:t>Saitama was designed to parody power-scaling</a:t>
             </a:r>
           </a:p>
         </p:txBody>
@@ -4331,8 +4331,8 @@
         </p:nvSpPr>
         <p:spPr>
           <a:xfrm>
-            <a:off x="1562869" y="1967757"/>
-            <a:ext cx="2368597" cy="201168"/>
+            <a:off x="1577445" y="2142669"/>
+            <a:ext cx="2171821" cy="201168"/>
           </a:xfrm>
           <a:prstGeom prst="rect">
             <a:avLst/>
@@ -4346,7 +4346,7 @@
           <a:lstStyle/>
           <a:p>
             <a:pPr>
-              <a:defRPr sz="726" b="0" i="0">
+              <a:defRPr sz="700" b="0" i="0">
                 <a:solidFill>
                   <a:srgbClr val="040303"/>
                 </a:solidFill>
@@ -4354,7 +4354,7 @@
               </a:defRPr>
             </a:pPr>
             <a:r>
-              <a:t>Saitama was designed to parody power-scaling</a:t>
+              <a:t>stories—his absurd strength is the premise</a:t>
             </a:r>
           </a:p>
         </p:txBody>
@@ -4367,8 +4367,8 @@
         </p:nvSpPr>
         <p:spPr>
           <a:xfrm>
-            <a:off x="1241322" y="2142669"/>
-            <a:ext cx="72879" cy="201168"/>
+            <a:off x="1562869" y="2273853"/>
+            <a:ext cx="816255" cy="201168"/>
           </a:xfrm>
           <a:prstGeom prst="rect">
             <a:avLst/>
@@ -4382,15 +4382,15 @@
           <a:lstStyle/>
           <a:p>
             <a:pPr>
-              <a:defRPr sz="700" b="0" i="0">
-                <a:solidFill>
-                  <a:srgbClr val="111111"/>
-                </a:solidFill>
-                <a:latin typeface="Malgun Gothic"/>
+              <a:defRPr sz="741" b="0" i="0">
+                <a:solidFill>
+                  <a:srgbClr val="000000"/>
+                </a:solidFill>
+                <a:latin typeface="Arial"/>
               </a:defRPr>
             </a:pPr>
             <a:r>
-              <a:t>•</a:t>
+              <a:t>not the reward.</a:t>
             </a:r>
           </a:p>
         </p:txBody>
@@ -4403,8 +4403,8 @@
         </p:nvSpPr>
         <p:spPr>
           <a:xfrm>
-            <a:off x="1577445" y="2142669"/>
-            <a:ext cx="2171821" cy="201168"/>
+            <a:off x="6912254" y="2332157"/>
+            <a:ext cx="1034894" cy="201168"/>
           </a:xfrm>
           <a:prstGeom prst="rect">
             <a:avLst/>
@@ -4418,15 +4418,15 @@
           <a:lstStyle/>
           <a:p>
             <a:pPr>
-              <a:defRPr sz="700" b="0" i="0">
-                <a:solidFill>
-                  <a:srgbClr val="040303"/>
+              <a:defRPr sz="854" b="0" i="0">
+                <a:solidFill>
+                  <a:srgbClr val="BB0000"/>
                 </a:solidFill>
                 <a:latin typeface="Arial"/>
               </a:defRPr>
             </a:pPr>
             <a:r>
-              <a:t>stories—his absurd strength is the premise</a:t>
+              <a:t>Already complete</a:t>
             </a:r>
           </a:p>
         </p:txBody>
@@ -4439,8 +4439,8 @@
         </p:nvSpPr>
         <p:spPr>
           <a:xfrm>
-            <a:off x="1562869" y="2273853"/>
-            <a:ext cx="816255" cy="201168"/>
+            <a:off x="5024665" y="2339445"/>
+            <a:ext cx="641343" cy="201168"/>
           </a:xfrm>
           <a:prstGeom prst="rect">
             <a:avLst/>
@@ -4454,7 +4454,7 @@
           <a:lstStyle/>
           <a:p>
             <a:pPr>
-              <a:defRPr sz="741" b="0" i="0">
+              <a:defRPr sz="860" b="0" i="0">
                 <a:solidFill>
                   <a:srgbClr val="000000"/>
                 </a:solidFill>
@@ -4462,7 +4462,7 @@
               </a:defRPr>
             </a:pPr>
             <a:r>
-              <a:t>not the reward.</a:t>
+              <a:t>Growth arc</a:t>
             </a:r>
           </a:p>
         </p:txBody>
@@ -4475,8 +4475,8 @@
         </p:nvSpPr>
         <p:spPr>
           <a:xfrm>
-            <a:off x="6912254" y="2332157"/>
-            <a:ext cx="1034894" cy="201168"/>
+            <a:off x="1570157" y="2601812"/>
+            <a:ext cx="2040637" cy="201168"/>
           </a:xfrm>
           <a:prstGeom prst="rect">
             <a:avLst/>
@@ -4490,15 +4490,15 @@
           <a:lstStyle/>
           <a:p>
             <a:pPr>
-              <a:defRPr sz="854" b="0" i="0">
-                <a:solidFill>
-                  <a:srgbClr val="BB0000"/>
+              <a:defRPr sz="989" b="1" i="0">
+                <a:solidFill>
+                  <a:srgbClr val="020202"/>
                 </a:solidFill>
                 <a:latin typeface="Arial"/>
               </a:defRPr>
             </a:pPr>
             <a:r>
-              <a:t>Already complete</a:t>
+              <a:t>ALREADY AT THE FINISH LINE</a:t>
             </a:r>
           </a:p>
         </p:txBody>
@@ -4511,8 +4511,8 @@
         </p:nvSpPr>
         <p:spPr>
           <a:xfrm>
-            <a:off x="5024665" y="2339445"/>
-            <a:ext cx="641343" cy="201168"/>
+            <a:off x="1090242" y="2611287"/>
+            <a:ext cx="364399" cy="561175"/>
           </a:xfrm>
           <a:prstGeom prst="rect">
             <a:avLst/>
@@ -4526,15 +4526,15 @@
           <a:lstStyle/>
           <a:p>
             <a:pPr>
-              <a:defRPr sz="860" b="0" i="0">
-                <a:solidFill>
-                  <a:srgbClr val="000000"/>
+              <a:defRPr sz="2811" b="0" i="0">
+                <a:solidFill>
+                  <a:srgbClr val="050400"/>
                 </a:solidFill>
                 <a:latin typeface="Arial"/>
               </a:defRPr>
             </a:pPr>
             <a:r>
-              <a:t>Growth arc</a:t>
+              <a:t>2</a:t>
             </a:r>
           </a:p>
         </p:txBody>
@@ -4547,8 +4547,8 @@
         </p:nvSpPr>
         <p:spPr>
           <a:xfrm>
-            <a:off x="1570157" y="2601812"/>
-            <a:ext cx="2040637" cy="201168"/>
+            <a:off x="5017377" y="2762148"/>
+            <a:ext cx="1217094" cy="201168"/>
           </a:xfrm>
           <a:prstGeom prst="rect">
             <a:avLst/>
@@ -4562,15 +4562,15 @@
           <a:lstStyle/>
           <a:p>
             <a:pPr>
-              <a:defRPr sz="989" b="1" i="0">
-                <a:solidFill>
-                  <a:srgbClr val="020202"/>
+              <a:defRPr sz="776" b="0" i="0">
+                <a:solidFill>
+                  <a:srgbClr val="000000"/>
                 </a:solidFill>
                 <a:latin typeface="Arial"/>
               </a:defRPr>
             </a:pPr>
             <a:r>
-              <a:t>ALREADY AT THE FINISH LINE</a:t>
+              <a:t>Wins through struggle</a:t>
             </a:r>
           </a:p>
         </p:txBody>
@@ -4583,8 +4583,8 @@
         </p:nvSpPr>
         <p:spPr>
           <a:xfrm>
-            <a:off x="1090242" y="2611287"/>
-            <a:ext cx="364399" cy="561175"/>
+            <a:off x="6912254" y="2769436"/>
+            <a:ext cx="816255" cy="201168"/>
           </a:xfrm>
           <a:prstGeom prst="rect">
             <a:avLst/>
@@ -4598,15 +4598,15 @@
           <a:lstStyle/>
           <a:p>
             <a:pPr>
-              <a:defRPr sz="2811" b="0" i="0">
-                <a:solidFill>
-                  <a:srgbClr val="050400"/>
+              <a:defRPr sz="772" b="0" i="0">
+                <a:solidFill>
+                  <a:srgbClr val="BA0000"/>
                 </a:solidFill>
                 <a:latin typeface="Arial"/>
               </a:defRPr>
             </a:pPr>
             <a:r>
-              <a:t>2</a:t>
+              <a:t>Wins instantly</a:t>
             </a:r>
           </a:p>
         </p:txBody>
@@ -4619,8 +4619,8 @@
         </p:nvSpPr>
         <p:spPr>
           <a:xfrm>
-            <a:off x="5017377" y="2762148"/>
-            <a:ext cx="1217094" cy="201168"/>
+            <a:off x="1562869" y="2798588"/>
+            <a:ext cx="2346733" cy="201168"/>
           </a:xfrm>
           <a:prstGeom prst="rect">
             <a:avLst/>
@@ -4634,15 +4634,15 @@
           <a:lstStyle/>
           <a:p>
             <a:pPr>
-              <a:defRPr sz="776" b="0" i="0">
-                <a:solidFill>
-                  <a:srgbClr val="000000"/>
+              <a:defRPr sz="700" b="0" i="0">
+                <a:solidFill>
+                  <a:srgbClr val="030303"/>
                 </a:solidFill>
                 <a:latin typeface="Arial"/>
               </a:defRPr>
             </a:pPr>
             <a:r>
-              <a:t>Wins through struggle</a:t>
+              <a:t>While others train and climb for years to reach</a:t>
             </a:r>
           </a:p>
         </p:txBody>
@@ -4655,8 +4655,8 @@
         </p:nvSpPr>
         <p:spPr>
           <a:xfrm>
-            <a:off x="6912254" y="2769436"/>
-            <a:ext cx="816255" cy="201168"/>
+            <a:off x="1555581" y="2951636"/>
+            <a:ext cx="2215549" cy="201168"/>
           </a:xfrm>
           <a:prstGeom prst="rect">
             <a:avLst/>
@@ -4670,15 +4670,15 @@
           <a:lstStyle/>
           <a:p>
             <a:pPr>
-              <a:defRPr sz="772" b="0" i="0">
-                <a:solidFill>
-                  <a:srgbClr val="BA0000"/>
+              <a:defRPr sz="721" b="0" i="0">
+                <a:solidFill>
+                  <a:srgbClr val="050404"/>
                 </a:solidFill>
                 <a:latin typeface="Arial"/>
               </a:defRPr>
             </a:pPr>
             <a:r>
-              <a:t>Wins instantly</a:t>
+              <a:t>the top, he begins where most protagonists</a:t>
             </a:r>
           </a:p>
         </p:txBody>
@@ -4691,8 +4691,8 @@
         </p:nvSpPr>
         <p:spPr>
           <a:xfrm>
-            <a:off x="1562869" y="2798588"/>
-            <a:ext cx="2346733" cy="201168"/>
+            <a:off x="1570157" y="3126548"/>
+            <a:ext cx="1078622" cy="201168"/>
           </a:xfrm>
           <a:prstGeom prst="rect">
             <a:avLst/>
@@ -4706,15 +4706,15 @@
           <a:lstStyle/>
           <a:p>
             <a:pPr>
-              <a:defRPr sz="700" b="0" i="0">
-                <a:solidFill>
-                  <a:srgbClr val="030303"/>
+              <a:defRPr sz="731" b="0" i="0">
+                <a:solidFill>
+                  <a:srgbClr val="030302"/>
                 </a:solidFill>
                 <a:latin typeface="Arial"/>
               </a:defRPr>
             </a:pPr>
             <a:r>
-              <a:t>While others train and climb for years to reach</a:t>
+              <a:t>are supposed to end.</a:t>
             </a:r>
           </a:p>
         </p:txBody>
@@ -4727,8 +4727,8 @@
         </p:nvSpPr>
         <p:spPr>
           <a:xfrm>
-            <a:off x="1555581" y="2951636"/>
-            <a:ext cx="2215549" cy="201168"/>
+            <a:off x="6904966" y="3126548"/>
+            <a:ext cx="750663" cy="201168"/>
           </a:xfrm>
           <a:prstGeom prst="rect">
             <a:avLst/>
@@ -4742,15 +4742,15 @@
           <a:lstStyle/>
           <a:p>
             <a:pPr>
-              <a:defRPr sz="721" b="0" i="0">
-                <a:solidFill>
-                  <a:srgbClr val="050404"/>
+              <a:defRPr sz="864" b="0" i="0">
+                <a:solidFill>
+                  <a:srgbClr val="C50000"/>
                 </a:solidFill>
                 <a:latin typeface="Arial"/>
               </a:defRPr>
             </a:pPr>
             <a:r>
-              <a:t>the top, he begins where most protagonists</a:t>
+              <a:t>Power is the</a:t>
             </a:r>
           </a:p>
         </p:txBody>
@@ -4763,8 +4763,8 @@
         </p:nvSpPr>
         <p:spPr>
           <a:xfrm>
-            <a:off x="1570157" y="3126548"/>
-            <a:ext cx="1078622" cy="201168"/>
+            <a:off x="5010089" y="3214004"/>
+            <a:ext cx="867270" cy="201168"/>
           </a:xfrm>
           <a:prstGeom prst="rect">
             <a:avLst/>
@@ -4778,15 +4778,15 @@
           <a:lstStyle/>
           <a:p>
             <a:pPr>
-              <a:defRPr sz="731" b="0" i="0">
-                <a:solidFill>
-                  <a:srgbClr val="030302"/>
+              <a:defRPr sz="811" b="0" i="0">
+                <a:solidFill>
+                  <a:srgbClr val="000000"/>
                 </a:solidFill>
                 <a:latin typeface="Arial"/>
               </a:defRPr>
             </a:pPr>
             <a:r>
-              <a:t>are supposed to end.</a:t>
+              <a:t>Power is a goal</a:t>
             </a:r>
           </a:p>
         </p:txBody>
@@ -4799,8 +4799,8 @@
         </p:nvSpPr>
         <p:spPr>
           <a:xfrm>
-            <a:off x="6904966" y="3126548"/>
-            <a:ext cx="750663" cy="201168"/>
+            <a:off x="6919542" y="3308748"/>
+            <a:ext cx="801679" cy="201168"/>
           </a:xfrm>
           <a:prstGeom prst="rect">
             <a:avLst/>
@@ -4814,15 +4814,15 @@
           <a:lstStyle/>
           <a:p>
             <a:pPr>
-              <a:defRPr sz="864" b="0" i="0">
-                <a:solidFill>
-                  <a:srgbClr val="C50000"/>
+              <a:defRPr sz="759" b="0" i="0">
+                <a:solidFill>
+                  <a:srgbClr val="C50102"/>
                 </a:solidFill>
                 <a:latin typeface="Arial"/>
               </a:defRPr>
             </a:pPr>
             <a:r>
-              <a:t>Power is the</a:t>
+              <a:t>starting point</a:t>
             </a:r>
           </a:p>
         </p:txBody>
@@ -4835,8 +4835,8 @@
         </p:nvSpPr>
         <p:spPr>
           <a:xfrm>
-            <a:off x="5010089" y="3214004"/>
-            <a:ext cx="867270" cy="201168"/>
+            <a:off x="1562869" y="3418068"/>
+            <a:ext cx="1996909" cy="201168"/>
           </a:xfrm>
           <a:prstGeom prst="rect">
             <a:avLst/>
@@ -4850,7 +4850,7 @@
           <a:lstStyle/>
           <a:p>
             <a:pPr>
-              <a:defRPr sz="811" b="0" i="0">
+              <a:defRPr sz="1032" b="1" i="0">
                 <a:solidFill>
                   <a:srgbClr val="000000"/>
                 </a:solidFill>
@@ -4858,7 +4858,7 @@
               </a:defRPr>
             </a:pPr>
             <a:r>
-              <a:t>Power is a goal</a:t>
+              <a:t>LIMIT-BREAKING SIMPLICITY</a:t>
             </a:r>
           </a:p>
         </p:txBody>
@@ -4871,8 +4871,8 @@
         </p:nvSpPr>
         <p:spPr>
           <a:xfrm>
-            <a:off x="6524825" y="3308748"/>
-            <a:ext cx="112235" cy="201168"/>
+            <a:off x="1086598" y="3430821"/>
+            <a:ext cx="364399" cy="561175"/>
           </a:xfrm>
           <a:prstGeom prst="rect">
             <a:avLst/>
@@ -4886,15 +4886,15 @@
           <a:lstStyle/>
           <a:p>
             <a:pPr>
-              <a:defRPr sz="866" b="0" i="0">
-                <a:solidFill>
-                  <a:srgbClr val="111111"/>
-                </a:solidFill>
-                <a:latin typeface="Malgun Gothic"/>
+              <a:defRPr sz="2811" b="0" i="0">
+                <a:solidFill>
+                  <a:srgbClr val="050400"/>
+                </a:solidFill>
+                <a:latin typeface="Arial"/>
               </a:defRPr>
             </a:pPr>
             <a:r>
-              <a:t>•</a:t>
+              <a:t>3</a:t>
             </a:r>
           </a:p>
         </p:txBody>
@@ -4907,8 +4907,8 @@
         </p:nvSpPr>
         <p:spPr>
           <a:xfrm>
-            <a:off x="6919542" y="3308748"/>
-            <a:ext cx="801679" cy="201168"/>
+            <a:off x="5010089" y="3585691"/>
+            <a:ext cx="859982" cy="201168"/>
           </a:xfrm>
           <a:prstGeom prst="rect">
             <a:avLst/>
@@ -4922,15 +4922,15 @@
           <a:lstStyle/>
           <a:p>
             <a:pPr>
-              <a:defRPr sz="759" b="0" i="0">
-                <a:solidFill>
-                  <a:srgbClr val="C50102"/>
+              <a:defRPr sz="878" b="0" i="0">
+                <a:solidFill>
+                  <a:srgbClr val="000000"/>
                 </a:solidFill>
                 <a:latin typeface="Arial"/>
               </a:defRPr>
             </a:pPr>
             <a:r>
-              <a:t>starting point</a:t>
+              <a:t>Tension comes</a:t>
             </a:r>
           </a:p>
         </p:txBody>
@@ -4943,8 +4943,8 @@
         </p:nvSpPr>
         <p:spPr>
           <a:xfrm>
-            <a:off x="1562869" y="3418068"/>
-            <a:ext cx="1996909" cy="201168"/>
+            <a:off x="6912254" y="3600267"/>
+            <a:ext cx="859982" cy="201168"/>
           </a:xfrm>
           <a:prstGeom prst="rect">
             <a:avLst/>
@@ -4958,15 +4958,15 @@
           <a:lstStyle/>
           <a:p>
             <a:pPr>
-              <a:defRPr sz="1032" b="1" i="0">
-                <a:solidFill>
-                  <a:srgbClr val="000000"/>
+              <a:defRPr sz="860" b="0" i="0">
+                <a:solidFill>
+                  <a:srgbClr val="BA0001"/>
                 </a:solidFill>
                 <a:latin typeface="Arial"/>
               </a:defRPr>
             </a:pPr>
             <a:r>
-              <a:t>LIMIT-BREAKING SIMPLICITY</a:t>
+              <a:t>Tension comes</a:t>
             </a:r>
           </a:p>
         </p:txBody>
@@ -4979,8 +4979,8 @@
         </p:nvSpPr>
         <p:spPr>
           <a:xfrm>
-            <a:off x="1086598" y="3430821"/>
-            <a:ext cx="364399" cy="561175"/>
+            <a:off x="1562869" y="3643995"/>
+            <a:ext cx="2470629" cy="201168"/>
           </a:xfrm>
           <a:prstGeom prst="rect">
             <a:avLst/>
@@ -4994,15 +4994,15 @@
           <a:lstStyle/>
           <a:p>
             <a:pPr>
-              <a:defRPr sz="2811" b="0" i="0">
-                <a:solidFill>
-                  <a:srgbClr val="050400"/>
+              <a:defRPr sz="700" b="0" i="0">
+                <a:solidFill>
+                  <a:srgbClr val="050504"/>
                 </a:solidFill>
                 <a:latin typeface="Arial"/>
               </a:defRPr>
             </a:pPr>
             <a:r>
-              <a:t>3</a:t>
+              <a:t>His routine is both disciplined and comically extreme:</a:t>
             </a:r>
           </a:p>
         </p:txBody>
@@ -5015,8 +5015,8 @@
         </p:nvSpPr>
         <p:spPr>
           <a:xfrm>
-            <a:off x="5010089" y="3585691"/>
-            <a:ext cx="859982" cy="201168"/>
+            <a:off x="6904966" y="3753315"/>
+            <a:ext cx="823543" cy="201168"/>
           </a:xfrm>
           <a:prstGeom prst="rect">
             <a:avLst/>
@@ -5030,15 +5030,15 @@
           <a:lstStyle/>
           <a:p>
             <a:pPr>
-              <a:defRPr sz="878" b="0" i="0">
-                <a:solidFill>
-                  <a:srgbClr val="000000"/>
+              <a:defRPr sz="914" b="0" i="0">
+                <a:solidFill>
+                  <a:srgbClr val="BA0000"/>
                 </a:solidFill>
                 <a:latin typeface="Arial"/>
               </a:defRPr>
             </a:pPr>
             <a:r>
-              <a:t>Tension comes</a:t>
+              <a:t>from meaning</a:t>
             </a:r>
           </a:p>
         </p:txBody>
@@ -5051,8 +5051,8 @@
         </p:nvSpPr>
         <p:spPr>
           <a:xfrm>
-            <a:off x="6912254" y="3600267"/>
-            <a:ext cx="859982" cy="201168"/>
+            <a:off x="5017377" y="3760603"/>
+            <a:ext cx="655919" cy="201168"/>
           </a:xfrm>
           <a:prstGeom prst="rect">
             <a:avLst/>
@@ -5066,15 +5066,15 @@
           <a:lstStyle/>
           <a:p>
             <a:pPr>
-              <a:defRPr sz="860" b="0" i="0">
-                <a:solidFill>
-                  <a:srgbClr val="BA0001"/>
+              <a:defRPr sz="797" b="0" i="0">
+                <a:solidFill>
+                  <a:srgbClr val="000001"/>
                 </a:solidFill>
                 <a:latin typeface="Arial"/>
               </a:defRPr>
             </a:pPr>
             <a:r>
-              <a:t>Tension comes</a:t>
+              <a:t>from battle</a:t>
             </a:r>
           </a:p>
         </p:txBody>
@@ -5087,8 +5087,8 @@
         </p:nvSpPr>
         <p:spPr>
           <a:xfrm>
-            <a:off x="1229370" y="3643995"/>
-            <a:ext cx="86727" cy="201168"/>
+            <a:off x="1555581" y="3775179"/>
+            <a:ext cx="2011485" cy="201168"/>
           </a:xfrm>
           <a:prstGeom prst="rect">
             <a:avLst/>
@@ -5102,15 +5102,15 @@
           <a:lstStyle/>
           <a:p>
             <a:pPr>
-              <a:defRPr sz="700" b="0" i="0">
-                <a:solidFill>
-                  <a:srgbClr val="111111"/>
-                </a:solidFill>
-                <a:latin typeface="Malgun Gothic"/>
+              <a:defRPr sz="720" b="0" i="0">
+                <a:solidFill>
+                  <a:srgbClr val="010101"/>
+                </a:solidFill>
+                <a:latin typeface="Arial"/>
               </a:defRPr>
             </a:pPr>
             <a:r>
-              <a:t>•</a:t>
+              <a:t>100 push-ups, 100 sit-ups, 100 squats,</a:t>
             </a:r>
           </a:p>
         </p:txBody>
@@ -5123,8 +5123,8 @@
         </p:nvSpPr>
         <p:spPr>
           <a:xfrm>
-            <a:off x="1562869" y="3643995"/>
-            <a:ext cx="2470629" cy="201168"/>
+            <a:off x="1562869" y="3942803"/>
+            <a:ext cx="1399294" cy="201168"/>
           </a:xfrm>
           <a:prstGeom prst="rect">
             <a:avLst/>
@@ -5138,15 +5138,15 @@
           <a:lstStyle/>
           <a:p>
             <a:pPr>
-              <a:defRPr sz="700" b="0" i="0">
-                <a:solidFill>
-                  <a:srgbClr val="050504"/>
+              <a:defRPr sz="765" b="0" i="0">
+                <a:solidFill>
+                  <a:srgbClr val="020201"/>
                 </a:solidFill>
                 <a:latin typeface="Arial"/>
               </a:defRPr>
             </a:pPr>
             <a:r>
-              <a:t>His routine is both disciplined and comically extreme:</a:t>
+              <a:t>and a 10 km run every day.</a:t>
             </a:r>
           </a:p>
         </p:txBody>
@@ -5159,8 +5159,8 @@
         </p:nvSpPr>
         <p:spPr>
           <a:xfrm>
-            <a:off x="6525991" y="3753315"/>
-            <a:ext cx="127539" cy="201168"/>
+            <a:off x="4259425" y="4117715"/>
+            <a:ext cx="1829285" cy="218639"/>
           </a:xfrm>
           <a:prstGeom prst="rect">
             <a:avLst/>
@@ -5174,15 +5174,15 @@
           <a:lstStyle/>
           <a:p>
             <a:pPr>
-              <a:defRPr sz="984" b="0" i="0">
-                <a:solidFill>
-                  <a:srgbClr val="111111"/>
-                </a:solidFill>
-                <a:latin typeface="Malgun Gothic"/>
+              <a:defRPr sz="1342" b="1" i="0">
+                <a:solidFill>
+                  <a:srgbClr val="F7F7F7"/>
+                </a:solidFill>
+                <a:latin typeface="Arial"/>
               </a:defRPr>
             </a:pPr>
             <a:r>
-              <a:t>•</a:t>
+              <a:t>C) NARRATIVE IMPACT</a:t>
             </a:r>
           </a:p>
         </p:txBody>
@@ -5195,8 +5195,8 @@
         </p:nvSpPr>
         <p:spPr>
           <a:xfrm>
-            <a:off x="6904966" y="3753315"/>
-            <a:ext cx="823543" cy="201168"/>
+            <a:off x="1090971" y="4260559"/>
+            <a:ext cx="364399" cy="561175"/>
           </a:xfrm>
           <a:prstGeom prst="rect">
             <a:avLst/>
@@ -5210,15 +5210,15 @@
           <a:lstStyle/>
           <a:p>
             <a:pPr>
-              <a:defRPr sz="914" b="0" i="0">
-                <a:solidFill>
-                  <a:srgbClr val="BA0000"/>
+              <a:defRPr sz="2811" b="0" i="0">
+                <a:solidFill>
+                  <a:srgbClr val="040300"/>
                 </a:solidFill>
                 <a:latin typeface="Arial"/>
               </a:defRPr>
             </a:pPr>
             <a:r>
-              <a:t>from meaning</a:t>
+              <a:t>4</a:t>
             </a:r>
           </a:p>
         </p:txBody>
@@ -5231,8 +5231,8 @@
         </p:nvSpPr>
         <p:spPr>
           <a:xfrm>
-            <a:off x="4515380" y="3760603"/>
-            <a:ext cx="107133" cy="201168"/>
+            <a:off x="1577445" y="4263475"/>
+            <a:ext cx="1792845" cy="201168"/>
           </a:xfrm>
           <a:prstGeom prst="rect">
             <a:avLst/>
@@ -5246,15 +5246,15 @@
           <a:lstStyle/>
           <a:p>
             <a:pPr>
-              <a:defRPr sz="826" b="0" i="0">
-                <a:solidFill>
-                  <a:srgbClr val="111111"/>
-                </a:solidFill>
-                <a:latin typeface="Malgun Gothic"/>
+              <a:defRPr sz="903" b="1" i="0">
+                <a:solidFill>
+                  <a:srgbClr val="010101"/>
+                </a:solidFill>
+                <a:latin typeface="Arial"/>
               </a:defRPr>
             </a:pPr>
             <a:r>
-              <a:t>•</a:t>
+              <a:t>EMOTIONALLY UNSHAKEN</a:t>
             </a:r>
           </a:p>
         </p:txBody>
@@ -5267,8 +5267,8 @@
         </p:nvSpPr>
         <p:spPr>
           <a:xfrm>
-            <a:off x="5017377" y="3760603"/>
-            <a:ext cx="655919" cy="201168"/>
+            <a:off x="1555581" y="4445674"/>
+            <a:ext cx="2062501" cy="201168"/>
           </a:xfrm>
           <a:prstGeom prst="rect">
             <a:avLst/>
@@ -5282,15 +5282,15 @@
           <a:lstStyle/>
           <a:p>
             <a:pPr>
-              <a:defRPr sz="797" b="0" i="0">
-                <a:solidFill>
-                  <a:srgbClr val="000001"/>
+              <a:defRPr sz="700" b="0" i="0">
+                <a:solidFill>
+                  <a:srgbClr val="030303"/>
                 </a:solidFill>
                 <a:latin typeface="Arial"/>
               </a:defRPr>
             </a:pPr>
             <a:r>
-              <a:t>from battle</a:t>
+              <a:t>He fights without fear, ego, or hesitation.</a:t>
             </a:r>
           </a:p>
         </p:txBody>
@@ -5303,8 +5303,8 @@
         </p:nvSpPr>
         <p:spPr>
           <a:xfrm>
-            <a:off x="1555581" y="3775179"/>
-            <a:ext cx="2011485" cy="201168"/>
+            <a:off x="5272456" y="4496690"/>
+            <a:ext cx="1158790" cy="201168"/>
           </a:xfrm>
           <a:prstGeom prst="rect">
             <a:avLst/>
@@ -5318,15 +5318,15 @@
           <a:lstStyle/>
           <a:p>
             <a:pPr>
-              <a:defRPr sz="720" b="0" i="0">
-                <a:solidFill>
-                  <a:srgbClr val="010101"/>
+              <a:defRPr sz="1162" b="1" i="0">
+                <a:solidFill>
+                  <a:srgbClr val="020200"/>
                 </a:solidFill>
                 <a:latin typeface="Arial"/>
               </a:defRPr>
             </a:pPr>
             <a:r>
-              <a:t>100 push-ups, 100 sit-ups, 100 squats,</a:t>
+              <a:t>WHY IT WORKS</a:t>
             </a:r>
           </a:p>
         </p:txBody>
@@ -5339,8 +5339,8 @@
         </p:nvSpPr>
         <p:spPr>
           <a:xfrm>
-            <a:off x="1562869" y="3942803"/>
-            <a:ext cx="1399294" cy="201168"/>
+            <a:off x="1548293" y="4598722"/>
+            <a:ext cx="2033349" cy="201168"/>
           </a:xfrm>
           <a:prstGeom prst="rect">
             <a:avLst/>
@@ -5354,15 +5354,15 @@
           <a:lstStyle/>
           <a:p>
             <a:pPr>
-              <a:defRPr sz="765" b="0" i="0">
-                <a:solidFill>
-                  <a:srgbClr val="020201"/>
+              <a:defRPr sz="748" b="0" i="0">
+                <a:solidFill>
+                  <a:srgbClr val="030303"/>
                 </a:solidFill>
                 <a:latin typeface="Arial"/>
               </a:defRPr>
             </a:pPr>
             <a:r>
-              <a:t>and a 10 km run every day.</a:t>
+              <a:t>No need to prove himself—he's already</a:t>
             </a:r>
           </a:p>
         </p:txBody>
@@ -5375,8 +5375,8 @@
         </p:nvSpPr>
         <p:spPr>
           <a:xfrm>
-            <a:off x="4303153" y="4117715"/>
-            <a:ext cx="1639798" cy="218639"/>
+            <a:off x="5272456" y="4722618"/>
+            <a:ext cx="2579948" cy="201168"/>
           </a:xfrm>
           <a:prstGeom prst="rect">
             <a:avLst/>
@@ -5390,15 +5390,15 @@
           <a:lstStyle/>
           <a:p>
             <a:pPr>
-              <a:defRPr sz="1160" b="1" i="0">
-                <a:solidFill>
-                  <a:srgbClr val="F7F7F7"/>
+              <a:defRPr sz="759" b="0" i="0">
+                <a:solidFill>
+                  <a:srgbClr val="020100"/>
                 </a:solidFill>
                 <a:latin typeface="Arial"/>
               </a:defRPr>
             </a:pPr>
             <a:r>
-              <a:t>C) NARRATIVE IMPACT</a:t>
+              <a:t>Saitama is not just strong in a physical sense.</a:t>
             </a:r>
           </a:p>
         </p:txBody>
@@ -5411,8 +5411,8 @@
         </p:nvSpPr>
         <p:spPr>
           <a:xfrm>
-            <a:off x="1090971" y="4260559"/>
-            <a:ext cx="364399" cy="561175"/>
+            <a:off x="1562869" y="4766346"/>
+            <a:ext cx="1610646" cy="201168"/>
           </a:xfrm>
           <a:prstGeom prst="rect">
             <a:avLst/>
@@ -5426,15 +5426,15 @@
           <a:lstStyle/>
           <a:p>
             <a:pPr>
-              <a:defRPr sz="2811" b="0" i="0">
-                <a:solidFill>
-                  <a:srgbClr val="040300"/>
+              <a:defRPr sz="706" b="0" i="0">
+                <a:solidFill>
+                  <a:srgbClr val="040303"/>
                 </a:solidFill>
                 <a:latin typeface="Arial"/>
               </a:defRPr>
             </a:pPr>
             <a:r>
-              <a:t>4</a:t>
+              <a:t>beyond the need for validation.</a:t>
             </a:r>
           </a:p>
         </p:txBody>
@@ -5447,8 +5447,8 @@
         </p:nvSpPr>
         <p:spPr>
           <a:xfrm>
-            <a:off x="1577445" y="4263475"/>
-            <a:ext cx="1792845" cy="201168"/>
+            <a:off x="5279744" y="4912106"/>
+            <a:ext cx="2485205" cy="201168"/>
           </a:xfrm>
           <a:prstGeom prst="rect">
             <a:avLst/>
@@ -5462,15 +5462,15 @@
           <a:lstStyle/>
           <a:p>
             <a:pPr>
-              <a:defRPr sz="903" b="1" i="0">
-                <a:solidFill>
-                  <a:srgbClr val="010101"/>
+              <a:defRPr sz="817" b="0" i="0">
+                <a:solidFill>
+                  <a:srgbClr val="000000"/>
                 </a:solidFill>
                 <a:latin typeface="Arial"/>
               </a:defRPr>
             </a:pPr>
             <a:r>
-              <a:t>EMOTIONALLY UNSHAKEN</a:t>
+              <a:t>He works because his power flips the usual</a:t>
             </a:r>
           </a:p>
         </p:txBody>
@@ -5483,8 +5483,8 @@
         </p:nvSpPr>
         <p:spPr>
           <a:xfrm>
-            <a:off x="1555581" y="4445674"/>
-            <a:ext cx="2062501" cy="201168"/>
+            <a:off x="9200684" y="4955834"/>
+            <a:ext cx="2820452" cy="1836573"/>
           </a:xfrm>
           <a:prstGeom prst="rect">
             <a:avLst/>
@@ -5498,15 +5498,15 @@
           <a:lstStyle/>
           <a:p>
             <a:pPr>
-              <a:defRPr sz="700" b="0" i="0">
-                <a:solidFill>
-                  <a:srgbClr val="030303"/>
+              <a:defRPr sz="3400" b="1" i="0">
+                <a:solidFill>
+                  <a:srgbClr val="FEFEFE"/>
                 </a:solidFill>
                 <a:latin typeface="Arial"/>
               </a:defRPr>
             </a:pPr>
             <a:r>
-              <a:t>He fights without fear, ego, or hesitation.</a:t>
+              <a:t>BAM</a:t>
             </a:r>
           </a:p>
         </p:txBody>
@@ -5519,8 +5519,8 @@
         </p:nvSpPr>
         <p:spPr>
           <a:xfrm>
-            <a:off x="5272456" y="4496690"/>
-            <a:ext cx="1158790" cy="201168"/>
+            <a:off x="1092429" y="5082280"/>
+            <a:ext cx="364399" cy="568463"/>
           </a:xfrm>
           <a:prstGeom prst="rect">
             <a:avLst/>
@@ -5534,15 +5534,15 @@
           <a:lstStyle/>
           <a:p>
             <a:pPr>
-              <a:defRPr sz="1162" b="1" i="0">
-                <a:solidFill>
-                  <a:srgbClr val="020200"/>
+              <a:defRPr sz="2811" b="0" i="0">
+                <a:solidFill>
+                  <a:srgbClr val="040300"/>
                 </a:solidFill>
                 <a:latin typeface="Arial"/>
               </a:defRPr>
             </a:pPr>
             <a:r>
-              <a:t>WHY IT WORKS</a:t>
+              <a:t>5</a:t>
             </a:r>
           </a:p>
         </p:txBody>
@@ -5555,8 +5555,8 @@
         </p:nvSpPr>
         <p:spPr>
           <a:xfrm>
-            <a:off x="1548293" y="4598722"/>
-            <a:ext cx="2033349" cy="201168"/>
+            <a:off x="1570157" y="5094306"/>
+            <a:ext cx="2434189" cy="201168"/>
           </a:xfrm>
           <a:prstGeom prst="rect">
             <a:avLst/>
@@ -5570,15 +5570,15 @@
           <a:lstStyle/>
           <a:p>
             <a:pPr>
-              <a:defRPr sz="748" b="0" i="0">
-                <a:solidFill>
-                  <a:srgbClr val="030303"/>
+              <a:defRPr sz="980" b="1" i="0">
+                <a:solidFill>
+                  <a:srgbClr val="000000"/>
                 </a:solidFill>
                 <a:latin typeface="Arial"/>
               </a:defRPr>
             </a:pPr>
             <a:r>
-              <a:t>No need to prove himself—he's already</a:t>
+              <a:t>THE STORY NEEDS AN UNBEATABLE HERO</a:t>
             </a:r>
           </a:p>
         </p:txBody>
@@ -5591,8 +5591,8 @@
         </p:nvSpPr>
         <p:spPr>
           <a:xfrm>
-            <a:off x="5272456" y="4722618"/>
-            <a:ext cx="2579948" cy="201168"/>
+            <a:off x="5279744" y="5101594"/>
+            <a:ext cx="2295717" cy="201168"/>
           </a:xfrm>
           <a:prstGeom prst="rect">
             <a:avLst/>
@@ -5606,15 +5606,15 @@
           <a:lstStyle/>
           <a:p>
             <a:pPr>
-              <a:defRPr sz="759" b="0" i="0">
-                <a:solidFill>
-                  <a:srgbClr val="020100"/>
+              <a:defRPr sz="799" b="0" i="0">
+                <a:solidFill>
+                  <a:srgbClr val="020000"/>
                 </a:solidFill>
                 <a:latin typeface="Arial"/>
               </a:defRPr>
             </a:pPr>
             <a:r>
-              <a:t>Saitama is not just strong in a physical sense.</a:t>
+              <a:t>battle-anime formula and turns the real</a:t>
             </a:r>
           </a:p>
         </p:txBody>
@@ -5627,8 +5627,8 @@
         </p:nvSpPr>
         <p:spPr>
           <a:xfrm>
-            <a:off x="1562869" y="4766346"/>
-            <a:ext cx="1610646" cy="201168"/>
+            <a:off x="5272456" y="5276505"/>
+            <a:ext cx="2244701" cy="201168"/>
           </a:xfrm>
           <a:prstGeom prst="rect">
             <a:avLst/>
@@ -5642,15 +5642,15 @@
           <a:lstStyle/>
           <a:p>
             <a:pPr>
-              <a:defRPr sz="706" b="0" i="0">
-                <a:solidFill>
-                  <a:srgbClr val="040303"/>
+              <a:defRPr sz="855" b="0" i="0">
+                <a:solidFill>
+                  <a:srgbClr val="010000"/>
                 </a:solidFill>
                 <a:latin typeface="Arial"/>
               </a:defRPr>
             </a:pPr>
             <a:r>
-              <a:t>beyond the need for validation.</a:t>
+              <a:t>conflict inward:: purpose, boredom,</a:t>
             </a:r>
           </a:p>
         </p:txBody>
@@ -5663,8 +5663,8 @@
         </p:nvSpPr>
         <p:spPr>
           <a:xfrm>
-            <a:off x="5279744" y="4912106"/>
-            <a:ext cx="2485205" cy="201168"/>
+            <a:off x="1562869" y="5291081"/>
+            <a:ext cx="2222837" cy="201168"/>
           </a:xfrm>
           <a:prstGeom prst="rect">
             <a:avLst/>
@@ -5678,15 +5678,15 @@
           <a:lstStyle/>
           <a:p>
             <a:pPr>
-              <a:defRPr sz="817" b="0" i="0">
-                <a:solidFill>
-                  <a:srgbClr val="000000"/>
+              <a:defRPr sz="713" b="0" i="0">
+                <a:solidFill>
+                  <a:srgbClr val="020102"/>
                 </a:solidFill>
                 <a:latin typeface="Arial"/>
               </a:defRPr>
             </a:pPr>
             <a:r>
-              <a:t>He works because his power flips the usual</a:t>
+              <a:t>His power lets the series go beyond battles</a:t>
             </a:r>
           </a:p>
         </p:txBody>
@@ -5699,8 +5699,8 @@
         </p:nvSpPr>
         <p:spPr>
           <a:xfrm>
-            <a:off x="9200684" y="4955834"/>
-            <a:ext cx="2820452" cy="1836573"/>
+            <a:off x="1548293" y="5444129"/>
+            <a:ext cx="2244701" cy="201168"/>
           </a:xfrm>
           <a:prstGeom prst="rect">
             <a:avLst/>
@@ -5714,15 +5714,15 @@
           <a:lstStyle/>
           <a:p>
             <a:pPr>
-              <a:defRPr sz="3400" b="1" i="0">
-                <a:solidFill>
-                  <a:srgbClr val="FEFEFE"/>
+              <a:defRPr sz="741" b="0" i="0">
+                <a:solidFill>
+                  <a:srgbClr val="010101"/>
                 </a:solidFill>
                 <a:latin typeface="Arial"/>
               </a:defRPr>
             </a:pPr>
             <a:r>
-              <a:t>BAM</a:t>
+              <a:t>to explore boredom, meaning, and identity</a:t>
             </a:r>
           </a:p>
         </p:txBody>
@@ -5735,8 +5735,8 @@
         </p:nvSpPr>
         <p:spPr>
           <a:xfrm>
-            <a:off x="1092429" y="5082280"/>
-            <a:ext cx="364399" cy="568463"/>
+            <a:off x="5265168" y="5451417"/>
+            <a:ext cx="1843861" cy="201168"/>
           </a:xfrm>
           <a:prstGeom prst="rect">
             <a:avLst/>
@@ -5750,15 +5750,15 @@
           <a:lstStyle/>
           <a:p>
             <a:pPr>
-              <a:defRPr sz="2811" b="0" i="0">
-                <a:solidFill>
-                  <a:srgbClr val="040300"/>
+              <a:defRPr sz="867" b="0" i="0">
+                <a:solidFill>
+                  <a:srgbClr val="000000"/>
                 </a:solidFill>
                 <a:latin typeface="Arial"/>
               </a:defRPr>
             </a:pPr>
             <a:r>
-              <a:t>5</a:t>
+              <a:t>and the search for challenge.</a:t>
             </a:r>
           </a:p>
         </p:txBody>
@@ -5771,8 +5771,8 @@
         </p:nvSpPr>
         <p:spPr>
           <a:xfrm>
-            <a:off x="1570157" y="5094306"/>
-            <a:ext cx="2434189" cy="201168"/>
+            <a:off x="1562869" y="5589889"/>
+            <a:ext cx="1173366" cy="201168"/>
           </a:xfrm>
           <a:prstGeom prst="rect">
             <a:avLst/>
@@ -5786,15 +5786,15 @@
           <a:lstStyle/>
           <a:p>
             <a:pPr>
-              <a:defRPr sz="980" b="1" i="0">
-                <a:solidFill>
-                  <a:srgbClr val="000000"/>
+              <a:defRPr sz="700" b="0" i="0">
+                <a:solidFill>
+                  <a:srgbClr val="020202"/>
                 </a:solidFill>
                 <a:latin typeface="Arial"/>
               </a:defRPr>
             </a:pPr>
             <a:r>
-              <a:t>THE STORY NEEDS AN UNBEATABLE HERO</a:t>
+              <a:t>after absolute victory.</a:t>
             </a:r>
           </a:p>
         </p:txBody>
@@ -5807,8 +5807,8 @@
         </p:nvSpPr>
         <p:spPr>
           <a:xfrm>
-            <a:off x="5279744" y="5101594"/>
-            <a:ext cx="2295717" cy="201168"/>
+            <a:off x="3384867" y="6070896"/>
+            <a:ext cx="4197883" cy="218639"/>
           </a:xfrm>
           <a:prstGeom prst="rect">
             <a:avLst/>
@@ -5822,15 +5822,15 @@
           <a:lstStyle/>
           <a:p>
             <a:pPr>
-              <a:defRPr sz="799" b="0" i="0">
-                <a:solidFill>
-                  <a:srgbClr val="020000"/>
+              <a:defRPr sz="1208" b="0" i="0">
+                <a:solidFill>
+                  <a:srgbClr val="020202"/>
                 </a:solidFill>
                 <a:latin typeface="Arial"/>
               </a:defRPr>
             </a:pPr>
             <a:r>
-              <a:t>battle-anime formula and turns the real</a:t>
+              <a:t>One Punch Man is powerful as a character because</a:t>
             </a:r>
           </a:p>
         </p:txBody>
@@ -5843,8 +5843,8 @@
         </p:nvSpPr>
         <p:spPr>
           <a:xfrm>
-            <a:off x="5272456" y="5276505"/>
-            <a:ext cx="2244701" cy="201168"/>
+            <a:off x="1151243" y="6136488"/>
+            <a:ext cx="1865434" cy="357111"/>
           </a:xfrm>
           <a:prstGeom prst="rect">
             <a:avLst/>
@@ -5858,15 +5858,15 @@
           <a:lstStyle/>
           <a:p>
             <a:pPr>
-              <a:defRPr sz="855" b="0" i="0">
-                <a:solidFill>
-                  <a:srgbClr val="010000"/>
-                </a:solidFill>
-                <a:latin typeface="Arial"/>
+              <a:defRPr sz="1958" b="1" i="0">
+                <a:solidFill>
+                  <a:srgbClr val="FFFFFF"/>
+                </a:solidFill>
+                <a:latin typeface="Impact"/>
               </a:defRPr>
             </a:pPr>
             <a:r>
-              <a:t>conflict inward:: purpose, boredom,</a:t>
+              <a:t>D) KEY TAKEAWAY</a:t>
             </a:r>
           </a:p>
         </p:txBody>
@@ -5874,222 +5874,6 @@
       <p:sp>
         <p:nvSpPr>
           <p:cNvPr id="81" name="TextBox 80"/>
-          <p:cNvSpPr txBox="1"/>
-          <p:nvPr/>
-        </p:nvSpPr>
-        <p:spPr>
-          <a:xfrm>
-            <a:off x="1562869" y="5291081"/>
-            <a:ext cx="2222837" cy="201168"/>
-          </a:xfrm>
-          <a:prstGeom prst="rect">
-            <a:avLst/>
-          </a:prstGeom>
-          <a:noFill/>
-        </p:spPr>
-        <p:txBody>
-          <a:bodyPr wrap="none" lIns="0" rIns="0" tIns="0" bIns="0" anchor="ctr">
-            <a:spAutoFit/>
-          </a:bodyPr>
-          <a:lstStyle/>
-          <a:p>
-            <a:pPr>
-              <a:defRPr sz="713" b="0" i="0">
-                <a:solidFill>
-                  <a:srgbClr val="020102"/>
-                </a:solidFill>
-                <a:latin typeface="Arial"/>
-              </a:defRPr>
-            </a:pPr>
-            <a:r>
-              <a:t>His power lets the series go beyond battles</a:t>
-            </a:r>
-          </a:p>
-        </p:txBody>
-      </p:sp>
-      <p:sp>
-        <p:nvSpPr>
-          <p:cNvPr id="82" name="TextBox 81"/>
-          <p:cNvSpPr txBox="1"/>
-          <p:nvPr/>
-        </p:nvSpPr>
-        <p:spPr>
-          <a:xfrm>
-            <a:off x="1548293" y="5444129"/>
-            <a:ext cx="2244701" cy="201168"/>
-          </a:xfrm>
-          <a:prstGeom prst="rect">
-            <a:avLst/>
-          </a:prstGeom>
-          <a:noFill/>
-        </p:spPr>
-        <p:txBody>
-          <a:bodyPr wrap="none" lIns="0" rIns="0" tIns="0" bIns="0" anchor="ctr">
-            <a:spAutoFit/>
-          </a:bodyPr>
-          <a:lstStyle/>
-          <a:p>
-            <a:pPr>
-              <a:defRPr sz="741" b="0" i="0">
-                <a:solidFill>
-                  <a:srgbClr val="010101"/>
-                </a:solidFill>
-                <a:latin typeface="Arial"/>
-              </a:defRPr>
-            </a:pPr>
-            <a:r>
-              <a:t>to explore boredom, meaning, and identity</a:t>
-            </a:r>
-          </a:p>
-        </p:txBody>
-      </p:sp>
-      <p:sp>
-        <p:nvSpPr>
-          <p:cNvPr id="83" name="TextBox 82"/>
-          <p:cNvSpPr txBox="1"/>
-          <p:nvPr/>
-        </p:nvSpPr>
-        <p:spPr>
-          <a:xfrm>
-            <a:off x="5265168" y="5451417"/>
-            <a:ext cx="1843861" cy="201168"/>
-          </a:xfrm>
-          <a:prstGeom prst="rect">
-            <a:avLst/>
-          </a:prstGeom>
-          <a:noFill/>
-        </p:spPr>
-        <p:txBody>
-          <a:bodyPr wrap="none" lIns="0" rIns="0" tIns="0" bIns="0" anchor="ctr">
-            <a:spAutoFit/>
-          </a:bodyPr>
-          <a:lstStyle/>
-          <a:p>
-            <a:pPr>
-              <a:defRPr sz="867" b="0" i="0">
-                <a:solidFill>
-                  <a:srgbClr val="000000"/>
-                </a:solidFill>
-                <a:latin typeface="Arial"/>
-              </a:defRPr>
-            </a:pPr>
-            <a:r>
-              <a:t>and the search for challenge.</a:t>
-            </a:r>
-          </a:p>
-        </p:txBody>
-      </p:sp>
-      <p:sp>
-        <p:nvSpPr>
-          <p:cNvPr id="84" name="TextBox 83"/>
-          <p:cNvSpPr txBox="1"/>
-          <p:nvPr/>
-        </p:nvSpPr>
-        <p:spPr>
-          <a:xfrm>
-            <a:off x="1562869" y="5589889"/>
-            <a:ext cx="1173366" cy="201168"/>
-          </a:xfrm>
-          <a:prstGeom prst="rect">
-            <a:avLst/>
-          </a:prstGeom>
-          <a:noFill/>
-        </p:spPr>
-        <p:txBody>
-          <a:bodyPr wrap="none" lIns="0" rIns="0" tIns="0" bIns="0" anchor="ctr">
-            <a:spAutoFit/>
-          </a:bodyPr>
-          <a:lstStyle/>
-          <a:p>
-            <a:pPr>
-              <a:defRPr sz="700" b="0" i="0">
-                <a:solidFill>
-                  <a:srgbClr val="020202"/>
-                </a:solidFill>
-                <a:latin typeface="Arial"/>
-              </a:defRPr>
-            </a:pPr>
-            <a:r>
-              <a:t>after absolute victory.</a:t>
-            </a:r>
-          </a:p>
-        </p:txBody>
-      </p:sp>
-      <p:sp>
-        <p:nvSpPr>
-          <p:cNvPr id="85" name="TextBox 84"/>
-          <p:cNvSpPr txBox="1"/>
-          <p:nvPr/>
-        </p:nvSpPr>
-        <p:spPr>
-          <a:xfrm>
-            <a:off x="3384867" y="6070896"/>
-            <a:ext cx="4197883" cy="218639"/>
-          </a:xfrm>
-          <a:prstGeom prst="rect">
-            <a:avLst/>
-          </a:prstGeom>
-          <a:noFill/>
-        </p:spPr>
-        <p:txBody>
-          <a:bodyPr wrap="none" lIns="0" rIns="0" tIns="0" bIns="0" anchor="ctr">
-            <a:spAutoFit/>
-          </a:bodyPr>
-          <a:lstStyle/>
-          <a:p>
-            <a:pPr>
-              <a:defRPr sz="1208" b="0" i="0">
-                <a:solidFill>
-                  <a:srgbClr val="020202"/>
-                </a:solidFill>
-                <a:latin typeface="Arial"/>
-              </a:defRPr>
-            </a:pPr>
-            <a:r>
-              <a:t>One Punch Man is powerful as a character because</a:t>
-            </a:r>
-          </a:p>
-        </p:txBody>
-      </p:sp>
-      <p:sp>
-        <p:nvSpPr>
-          <p:cNvPr id="86" name="TextBox 85"/>
-          <p:cNvSpPr txBox="1"/>
-          <p:nvPr/>
-        </p:nvSpPr>
-        <p:spPr>
-          <a:xfrm>
-            <a:off x="1285925" y="6136488"/>
-            <a:ext cx="1596070" cy="357111"/>
-          </a:xfrm>
-          <a:prstGeom prst="rect">
-            <a:avLst/>
-          </a:prstGeom>
-          <a:noFill/>
-        </p:spPr>
-        <p:txBody>
-          <a:bodyPr wrap="none" lIns="0" rIns="0" tIns="0" bIns="0" anchor="ctr">
-            <a:spAutoFit/>
-          </a:bodyPr>
-          <a:lstStyle/>
-          <a:p>
-            <a:pPr>
-              <a:defRPr sz="2242" b="1" i="0">
-                <a:solidFill>
-                  <a:srgbClr val="FFFFFF"/>
-                </a:solidFill>
-                <a:latin typeface="Impact"/>
-              </a:defRPr>
-            </a:pPr>
-            <a:r>
-              <a:t>D) KEY TAKEAWAY</a:t>
-            </a:r>
-          </a:p>
-        </p:txBody>
-      </p:sp>
-      <p:sp>
-        <p:nvSpPr>
-          <p:cNvPr id="87" name="TextBox 86"/>
           <p:cNvSpPr txBox="1"/>
           <p:nvPr/>
         </p:nvSpPr>

</xml_diff>

<commit_message>
Improve artwork and label reconstruction
</commit_message>
<xml_diff>
--- a/docs/examples/one-pun-editable.pptx
+++ b/docs/examples/one-pun-editable.pptx
@@ -3972,7 +3972,7 @@
         <p:spPr>
           <a:xfrm>
             <a:off x="148998" y="7287"/>
-            <a:ext cx="7958486" cy="983878"/>
+            <a:ext cx="8279158" cy="983878"/>
           </a:xfrm>
           <a:prstGeom prst="rect">
             <a:avLst/>
@@ -3986,7 +3986,7 @@
           <a:lstStyle/>
           <a:p>
             <a:pPr>
-              <a:defRPr sz="5419" b="1" i="0">
+              <a:defRPr sz="5638" b="1" i="0">
                 <a:solidFill>
                   <a:srgbClr val="030303"/>
                 </a:solidFill>
@@ -4043,8 +4043,8 @@
         </p:nvSpPr>
         <p:spPr>
           <a:xfrm>
-            <a:off x="265606" y="1355566"/>
-            <a:ext cx="1698102" cy="225927"/>
+            <a:off x="331198" y="1355566"/>
+            <a:ext cx="1486750" cy="225927"/>
           </a:xfrm>
           <a:prstGeom prst="rect">
             <a:avLst/>
@@ -4058,7 +4058,7 @@
           <a:lstStyle/>
           <a:p>
             <a:pPr>
-              <a:defRPr sz="1387" b="1" i="0">
+              <a:defRPr sz="1280" b="1" i="0">
                 <a:solidFill>
                   <a:srgbClr val="FFFFFF"/>
                 </a:solidFill>
@@ -4079,8 +4079,8 @@
         </p:nvSpPr>
         <p:spPr>
           <a:xfrm>
-            <a:off x="4274001" y="1399294"/>
-            <a:ext cx="3541963" cy="201168"/>
+            <a:off x="4354169" y="1399294"/>
+            <a:ext cx="3316036" cy="201168"/>
           </a:xfrm>
           <a:prstGeom prst="rect">
             <a:avLst/>
@@ -4094,9 +4094,9 @@
           <a:lstStyle/>
           <a:p>
             <a:pPr>
-              <a:defRPr sz="1208" b="1" i="0">
-                <a:solidFill>
-                  <a:srgbClr val="F8D264"/>
+              <a:defRPr sz="1000" b="1" i="0">
+                <a:solidFill>
+                  <a:srgbClr val="FFFFFF"/>
                 </a:solidFill>
                 <a:latin typeface="Arial"/>
               </a:defRPr>
@@ -5159,8 +5159,8 @@
         </p:nvSpPr>
         <p:spPr>
           <a:xfrm>
-            <a:off x="4259425" y="4117715"/>
-            <a:ext cx="1829285" cy="218639"/>
+            <a:off x="4303153" y="4117715"/>
+            <a:ext cx="1639798" cy="218639"/>
           </a:xfrm>
           <a:prstGeom prst="rect">
             <a:avLst/>
@@ -5174,9 +5174,9 @@
           <a:lstStyle/>
           <a:p>
             <a:pPr>
-              <a:defRPr sz="1342" b="1" i="0">
-                <a:solidFill>
-                  <a:srgbClr val="F7F7F7"/>
+              <a:defRPr sz="1102" b="1" i="0">
+                <a:solidFill>
+                  <a:srgbClr val="FFFFFF"/>
                 </a:solidFill>
                 <a:latin typeface="Arial"/>
               </a:defRPr>
@@ -5483,8 +5483,8 @@
         </p:nvSpPr>
         <p:spPr>
           <a:xfrm>
-            <a:off x="9200684" y="4955834"/>
-            <a:ext cx="2820452" cy="1836573"/>
+            <a:off x="1092429" y="5082280"/>
+            <a:ext cx="364399" cy="568463"/>
           </a:xfrm>
           <a:prstGeom prst="rect">
             <a:avLst/>
@@ -5498,15 +5498,15 @@
           <a:lstStyle/>
           <a:p>
             <a:pPr>
-              <a:defRPr sz="3400" b="1" i="0">
-                <a:solidFill>
-                  <a:srgbClr val="FEFEFE"/>
+              <a:defRPr sz="2811" b="0" i="0">
+                <a:solidFill>
+                  <a:srgbClr val="040300"/>
                 </a:solidFill>
                 <a:latin typeface="Arial"/>
               </a:defRPr>
             </a:pPr>
             <a:r>
-              <a:t>BAM</a:t>
+              <a:t>5</a:t>
             </a:r>
           </a:p>
         </p:txBody>
@@ -5519,8 +5519,8 @@
         </p:nvSpPr>
         <p:spPr>
           <a:xfrm>
-            <a:off x="1092429" y="5082280"/>
-            <a:ext cx="364399" cy="568463"/>
+            <a:off x="1570157" y="5094306"/>
+            <a:ext cx="2434189" cy="201168"/>
           </a:xfrm>
           <a:prstGeom prst="rect">
             <a:avLst/>
@@ -5534,15 +5534,15 @@
           <a:lstStyle/>
           <a:p>
             <a:pPr>
-              <a:defRPr sz="2811" b="0" i="0">
-                <a:solidFill>
-                  <a:srgbClr val="040300"/>
+              <a:defRPr sz="980" b="1" i="0">
+                <a:solidFill>
+                  <a:srgbClr val="000000"/>
                 </a:solidFill>
                 <a:latin typeface="Arial"/>
               </a:defRPr>
             </a:pPr>
             <a:r>
-              <a:t>5</a:t>
+              <a:t>THE STORY NEEDS AN UNBEATABLE HERO</a:t>
             </a:r>
           </a:p>
         </p:txBody>
@@ -5555,8 +5555,8 @@
         </p:nvSpPr>
         <p:spPr>
           <a:xfrm>
-            <a:off x="1570157" y="5094306"/>
-            <a:ext cx="2434189" cy="201168"/>
+            <a:off x="5279744" y="5101594"/>
+            <a:ext cx="2295717" cy="201168"/>
           </a:xfrm>
           <a:prstGeom prst="rect">
             <a:avLst/>
@@ -5570,15 +5570,15 @@
           <a:lstStyle/>
           <a:p>
             <a:pPr>
-              <a:defRPr sz="980" b="1" i="0">
-                <a:solidFill>
-                  <a:srgbClr val="000000"/>
+              <a:defRPr sz="799" b="0" i="0">
+                <a:solidFill>
+                  <a:srgbClr val="020000"/>
                 </a:solidFill>
                 <a:latin typeface="Arial"/>
               </a:defRPr>
             </a:pPr>
             <a:r>
-              <a:t>THE STORY NEEDS AN UNBEATABLE HERO</a:t>
+              <a:t>battle-anime formula and turns the real</a:t>
             </a:r>
           </a:p>
         </p:txBody>
@@ -5591,8 +5591,8 @@
         </p:nvSpPr>
         <p:spPr>
           <a:xfrm>
-            <a:off x="5279744" y="5101594"/>
-            <a:ext cx="2295717" cy="201168"/>
+            <a:off x="5272456" y="5276505"/>
+            <a:ext cx="2244701" cy="201168"/>
           </a:xfrm>
           <a:prstGeom prst="rect">
             <a:avLst/>
@@ -5606,15 +5606,15 @@
           <a:lstStyle/>
           <a:p>
             <a:pPr>
-              <a:defRPr sz="799" b="0" i="0">
-                <a:solidFill>
-                  <a:srgbClr val="020000"/>
+              <a:defRPr sz="855" b="0" i="0">
+                <a:solidFill>
+                  <a:srgbClr val="010000"/>
                 </a:solidFill>
                 <a:latin typeface="Arial"/>
               </a:defRPr>
             </a:pPr>
             <a:r>
-              <a:t>battle-anime formula and turns the real</a:t>
+              <a:t>conflict inward:: purpose, boredom,</a:t>
             </a:r>
           </a:p>
         </p:txBody>
@@ -5627,8 +5627,8 @@
         </p:nvSpPr>
         <p:spPr>
           <a:xfrm>
-            <a:off x="5272456" y="5276505"/>
-            <a:ext cx="2244701" cy="201168"/>
+            <a:off x="1562869" y="5291081"/>
+            <a:ext cx="2222837" cy="201168"/>
           </a:xfrm>
           <a:prstGeom prst="rect">
             <a:avLst/>
@@ -5642,15 +5642,15 @@
           <a:lstStyle/>
           <a:p>
             <a:pPr>
-              <a:defRPr sz="855" b="0" i="0">
-                <a:solidFill>
-                  <a:srgbClr val="010000"/>
+              <a:defRPr sz="713" b="0" i="0">
+                <a:solidFill>
+                  <a:srgbClr val="020102"/>
                 </a:solidFill>
                 <a:latin typeface="Arial"/>
               </a:defRPr>
             </a:pPr>
             <a:r>
-              <a:t>conflict inward:: purpose, boredom,</a:t>
+              <a:t>His power lets the series go beyond battles</a:t>
             </a:r>
           </a:p>
         </p:txBody>
@@ -5663,8 +5663,8 @@
         </p:nvSpPr>
         <p:spPr>
           <a:xfrm>
-            <a:off x="1562869" y="5291081"/>
-            <a:ext cx="2222837" cy="201168"/>
+            <a:off x="1548293" y="5444129"/>
+            <a:ext cx="2244701" cy="201168"/>
           </a:xfrm>
           <a:prstGeom prst="rect">
             <a:avLst/>
@@ -5678,15 +5678,15 @@
           <a:lstStyle/>
           <a:p>
             <a:pPr>
-              <a:defRPr sz="713" b="0" i="0">
-                <a:solidFill>
-                  <a:srgbClr val="020102"/>
+              <a:defRPr sz="741" b="0" i="0">
+                <a:solidFill>
+                  <a:srgbClr val="010101"/>
                 </a:solidFill>
                 <a:latin typeface="Arial"/>
               </a:defRPr>
             </a:pPr>
             <a:r>
-              <a:t>His power lets the series go beyond battles</a:t>
+              <a:t>to explore boredom, meaning, and identity</a:t>
             </a:r>
           </a:p>
         </p:txBody>
@@ -5699,8 +5699,8 @@
         </p:nvSpPr>
         <p:spPr>
           <a:xfrm>
-            <a:off x="1548293" y="5444129"/>
-            <a:ext cx="2244701" cy="201168"/>
+            <a:off x="5265168" y="5451417"/>
+            <a:ext cx="1843861" cy="201168"/>
           </a:xfrm>
           <a:prstGeom prst="rect">
             <a:avLst/>
@@ -5714,15 +5714,15 @@
           <a:lstStyle/>
           <a:p>
             <a:pPr>
-              <a:defRPr sz="741" b="0" i="0">
-                <a:solidFill>
-                  <a:srgbClr val="010101"/>
+              <a:defRPr sz="867" b="0" i="0">
+                <a:solidFill>
+                  <a:srgbClr val="000000"/>
                 </a:solidFill>
                 <a:latin typeface="Arial"/>
               </a:defRPr>
             </a:pPr>
             <a:r>
-              <a:t>to explore boredom, meaning, and identity</a:t>
+              <a:t>and the search for challenge.</a:t>
             </a:r>
           </a:p>
         </p:txBody>
@@ -5735,8 +5735,8 @@
         </p:nvSpPr>
         <p:spPr>
           <a:xfrm>
-            <a:off x="5265168" y="5451417"/>
-            <a:ext cx="1843861" cy="201168"/>
+            <a:off x="1562869" y="5589889"/>
+            <a:ext cx="1173366" cy="201168"/>
           </a:xfrm>
           <a:prstGeom prst="rect">
             <a:avLst/>
@@ -5750,15 +5750,15 @@
           <a:lstStyle/>
           <a:p>
             <a:pPr>
-              <a:defRPr sz="867" b="0" i="0">
-                <a:solidFill>
-                  <a:srgbClr val="000000"/>
+              <a:defRPr sz="700" b="0" i="0">
+                <a:solidFill>
+                  <a:srgbClr val="020202"/>
                 </a:solidFill>
                 <a:latin typeface="Arial"/>
               </a:defRPr>
             </a:pPr>
             <a:r>
-              <a:t>and the search for challenge.</a:t>
+              <a:t>after absolute victory.</a:t>
             </a:r>
           </a:p>
         </p:txBody>
@@ -5771,8 +5771,8 @@
         </p:nvSpPr>
         <p:spPr>
           <a:xfrm>
-            <a:off x="1562869" y="5589889"/>
-            <a:ext cx="1173366" cy="201168"/>
+            <a:off x="3384867" y="6070896"/>
+            <a:ext cx="4197883" cy="218639"/>
           </a:xfrm>
           <a:prstGeom prst="rect">
             <a:avLst/>
@@ -5786,7 +5786,7 @@
           <a:lstStyle/>
           <a:p>
             <a:pPr>
-              <a:defRPr sz="700" b="0" i="0">
+              <a:defRPr sz="1208" b="0" i="0">
                 <a:solidFill>
                   <a:srgbClr val="020202"/>
                 </a:solidFill>
@@ -5794,7 +5794,7 @@
               </a:defRPr>
             </a:pPr>
             <a:r>
-              <a:t>after absolute victory.</a:t>
+              <a:t>One Punch Man is powerful as a character because</a:t>
             </a:r>
           </a:p>
         </p:txBody>
@@ -5807,8 +5807,8 @@
         </p:nvSpPr>
         <p:spPr>
           <a:xfrm>
-            <a:off x="3384867" y="6070896"/>
-            <a:ext cx="4197883" cy="218639"/>
+            <a:off x="1285925" y="6136488"/>
+            <a:ext cx="1596070" cy="357111"/>
           </a:xfrm>
           <a:prstGeom prst="rect">
             <a:avLst/>
@@ -5822,15 +5822,15 @@
           <a:lstStyle/>
           <a:p>
             <a:pPr>
-              <a:defRPr sz="1208" b="0" i="0">
-                <a:solidFill>
-                  <a:srgbClr val="020202"/>
+              <a:defRPr sz="1377" b="1" i="0">
+                <a:solidFill>
+                  <a:srgbClr val="FFFFFF"/>
                 </a:solidFill>
                 <a:latin typeface="Arial"/>
               </a:defRPr>
             </a:pPr>
             <a:r>
-              <a:t>One Punch Man is powerful as a character because</a:t>
+              <a:t>D) KEY TAKEAWAY</a:t>
             </a:r>
           </a:p>
         </p:txBody>
@@ -5838,42 +5838,6 @@
       <p:sp>
         <p:nvSpPr>
           <p:cNvPr id="80" name="TextBox 79"/>
-          <p:cNvSpPr txBox="1"/>
-          <p:nvPr/>
-        </p:nvSpPr>
-        <p:spPr>
-          <a:xfrm>
-            <a:off x="1151243" y="6136488"/>
-            <a:ext cx="1865434" cy="357111"/>
-          </a:xfrm>
-          <a:prstGeom prst="rect">
-            <a:avLst/>
-          </a:prstGeom>
-          <a:noFill/>
-        </p:spPr>
-        <p:txBody>
-          <a:bodyPr wrap="none" lIns="0" rIns="0" tIns="0" bIns="0" anchor="ctr">
-            <a:spAutoFit/>
-          </a:bodyPr>
-          <a:lstStyle/>
-          <a:p>
-            <a:pPr>
-              <a:defRPr sz="1958" b="1" i="0">
-                <a:solidFill>
-                  <a:srgbClr val="FFFFFF"/>
-                </a:solidFill>
-                <a:latin typeface="Impact"/>
-              </a:defRPr>
-            </a:pPr>
-            <a:r>
-              <a:t>D) KEY TAKEAWAY</a:t>
-            </a:r>
-          </a:p>
-        </p:txBody>
-      </p:sp>
-      <p:sp>
-        <p:nvSpPr>
-          <p:cNvPr id="81" name="TextBox 80"/>
           <p:cNvSpPr txBox="1"/>
           <p:nvPr/>
         </p:nvSpPr>

</xml_diff>